<commit_message>
June schedule: trim to 30 days, drop ethics, clearer topic names
Compresses to fit all four blocks inside June:
- Cardiovascular 10 days (Jun 1–10) — folds orientation into Day 1
- Respiratory 8 days (Jun 11–18) — drops the standalone review day
- Epi & Biostats 4 days (Jun 19–22) — drops the ethics/QI day
- General Pathology 8 days (Jun 23–30)

Topic names rewritten in plain language ('Cardiac output and pressure-
volume loops' instead of 'Pump physiology · PV'). Flyer switches to
2×2 grid so cards are wide enough to spell topics out clearly.

Co-Authored-By: Claude Opus 4.7 (1M context) <noreply@anthropic.com>
</commit_message>
<xml_diff>
--- a/outputs/flyers/USMLE_June_Advert.pptx
+++ b/outputs/flyers/USMLE_June_Advert.pptx
@@ -884,7 +884,7 @@
         <p:spPr>
           <a:xfrm>
             <a:off x="0" y="0"/>
-            <a:ext cx="8229600" cy="2011680"/>
+            <a:ext cx="8229600" cy="1828800"/>
           </a:xfrm>
           <a:prstGeom prst="rect">
             <a:avLst/>
@@ -908,7 +908,7 @@
         </p:nvSpPr>
         <p:spPr>
           <a:xfrm>
-            <a:off x="0" y="1847088"/>
+            <a:off x="0" y="1664208"/>
             <a:ext cx="8229600" cy="164592"/>
           </a:xfrm>
           <a:prstGeom prst="rect">
@@ -1105,7 +1105,7 @@
         </p:nvSpPr>
         <p:spPr>
           <a:xfrm>
-            <a:off x="6163056" y="150876"/>
+            <a:off x="6163056" y="59436"/>
             <a:ext cx="1618488" cy="1618488"/>
           </a:xfrm>
           <a:prstGeom prst="ellipse">
@@ -1138,7 +1138,7 @@
         </p:blipFill>
         <p:spPr>
           <a:xfrm>
-            <a:off x="6217920" y="205740"/>
+            <a:off x="6217920" y="114300"/>
             <a:ext cx="1508760" cy="1508760"/>
           </a:xfrm>
           <a:prstGeom prst="rect">
@@ -1154,8 +1154,8 @@
         </p:nvSpPr>
         <p:spPr>
           <a:xfrm>
-            <a:off x="502920" y="2231136"/>
-            <a:ext cx="7223760" cy="256032"/>
+            <a:off x="502920" y="2029968"/>
+            <a:ext cx="7223760" cy="237744"/>
           </a:xfrm>
           <a:prstGeom prst="rect">
             <a:avLst/>
@@ -1193,7 +1193,7 @@
         </p:nvSpPr>
         <p:spPr>
           <a:xfrm>
-            <a:off x="502920" y="2542032"/>
+            <a:off x="502920" y="2331720"/>
             <a:ext cx="1005840" cy="0"/>
           </a:xfrm>
           <a:prstGeom prst="line">
@@ -1216,12 +1216,12 @@
         </p:nvSpPr>
         <p:spPr>
           <a:xfrm>
-            <a:off x="502920" y="2697480"/>
-            <a:ext cx="1723644" cy="4526280"/>
+            <a:off x="502920" y="2331720"/>
+            <a:ext cx="3543300" cy="2377440"/>
           </a:xfrm>
           <a:prstGeom prst="roundRect">
             <a:avLst>
-              <a:gd name="adj" fmla="val 5305"/>
+              <a:gd name="adj" fmla="val 3846"/>
             </a:avLst>
           </a:prstGeom>
           <a:solidFill>
@@ -1243,8 +1243,8 @@
         </p:nvSpPr>
         <p:spPr>
           <a:xfrm>
-            <a:off x="502920" y="2788920"/>
-            <a:ext cx="1723644" cy="621792"/>
+            <a:off x="502920" y="2404872"/>
+            <a:ext cx="3543300" cy="493776"/>
           </a:xfrm>
           <a:prstGeom prst="rect">
             <a:avLst/>
@@ -1268,12 +1268,12 @@
         </p:nvSpPr>
         <p:spPr>
           <a:xfrm>
-            <a:off x="502920" y="2697480"/>
-            <a:ext cx="1723644" cy="713232"/>
+            <a:off x="502920" y="2331720"/>
+            <a:ext cx="3543300" cy="566928"/>
           </a:xfrm>
           <a:prstGeom prst="roundRect">
             <a:avLst>
-              <a:gd name="adj" fmla="val 12821"/>
+              <a:gd name="adj" fmla="val 16129"/>
             </a:avLst>
           </a:prstGeom>
           <a:solidFill>
@@ -1295,24 +1295,24 @@
         </p:nvSpPr>
         <p:spPr>
           <a:xfrm>
-            <a:off x="594360" y="2788920"/>
-            <a:ext cx="1540764" cy="274320"/>
-          </a:xfrm>
-          <a:prstGeom prst="rect">
-            <a:avLst/>
-          </a:prstGeom>
-          <a:noFill/>
-          <a:ln/>
-        </p:spPr>
-        <p:txBody>
-          <a:bodyPr wrap="square" lIns="0" tIns="0" rIns="0" bIns="0" rtlCol="0" anchor="ctr"/>
-          <a:lstStyle/>
-          <a:p>
-            <a:pPr indent="0" marL="0">
-              <a:buNone/>
-            </a:pPr>
-            <a:r>
-              <a:rPr lang="en-US" sz="1100" b="1" spc="100" kern="0" dirty="0">
+            <a:off x="630936" y="2386584"/>
+            <a:ext cx="3287268" cy="256032"/>
+          </a:xfrm>
+          <a:prstGeom prst="rect">
+            <a:avLst/>
+          </a:prstGeom>
+          <a:noFill/>
+          <a:ln/>
+        </p:spPr>
+        <p:txBody>
+          <a:bodyPr wrap="square" lIns="0" tIns="0" rIns="0" bIns="0" rtlCol="0" anchor="ctr"/>
+          <a:lstStyle/>
+          <a:p>
+            <a:pPr indent="0" marL="0">
+              <a:buNone/>
+            </a:pPr>
+            <a:r>
+              <a:rPr lang="en-US" sz="1300" b="1" spc="100" kern="0" dirty="0">
                 <a:solidFill>
                   <a:srgbClr val="FFFFFF"/>
                 </a:solidFill>
@@ -1322,7 +1322,7 @@
               </a:rPr>
               <a:t>CARDIOVASCULAR</a:t>
             </a:r>
-            <a:endParaRPr lang="en-US" sz="1100" dirty="0"/>
+            <a:endParaRPr lang="en-US" sz="1300" dirty="0"/>
           </a:p>
         </p:txBody>
       </p:sp>
@@ -1334,32 +1334,85 @@
         </p:nvSpPr>
         <p:spPr>
           <a:xfrm>
-            <a:off x="594360" y="3081528"/>
-            <a:ext cx="1540764" cy="256032"/>
-          </a:xfrm>
-          <a:prstGeom prst="rect">
-            <a:avLst/>
-          </a:prstGeom>
-          <a:noFill/>
-          <a:ln/>
-        </p:spPr>
-        <p:txBody>
-          <a:bodyPr wrap="square" lIns="0" tIns="0" rIns="0" bIns="0" rtlCol="0" anchor="ctr"/>
-          <a:lstStyle/>
-          <a:p>
+            <a:off x="630936" y="2642616"/>
+            <a:ext cx="3287268" cy="219456"/>
+          </a:xfrm>
+          <a:prstGeom prst="rect">
+            <a:avLst/>
+          </a:prstGeom>
+          <a:noFill/>
+          <a:ln/>
+        </p:spPr>
+        <p:txBody>
+          <a:bodyPr wrap="square" lIns="0" tIns="0" rIns="0" bIns="0" rtlCol="0" anchor="ctr"/>
+          <a:lstStyle/>
+          <a:p>
+            <a:pPr indent="0" marL="0">
+              <a:buNone/>
+            </a:pPr>
+            <a:r>
+              <a:rPr lang="en-US" sz="1000" dirty="0">
+                <a:solidFill>
+                  <a:srgbClr val="FFFFFF"/>
+                </a:solidFill>
+                <a:latin typeface="Calibri" pitchFamily="34" charset="0"/>
+                <a:ea typeface="Calibri" pitchFamily="34" charset="-122"/>
+                <a:cs typeface="Calibri" pitchFamily="34" charset="-120"/>
+              </a:rPr>
+              <a:t>10 days  ·  Jun 1 – 10</a:t>
+            </a:r>
+            <a:endParaRPr lang="en-US" sz="1000" dirty="0"/>
+          </a:p>
+        </p:txBody>
+      </p:sp>
+      <p:sp>
+        <p:nvSpPr>
+          <p:cNvPr id="17" name="Text 14"/>
+          <p:cNvSpPr/>
+          <p:nvPr/>
+        </p:nvSpPr>
+        <p:spPr>
+          <a:xfrm>
+            <a:off x="630936" y="2990088"/>
+            <a:ext cx="3287268" cy="173736"/>
+          </a:xfrm>
+          <a:prstGeom prst="rect">
+            <a:avLst/>
+          </a:prstGeom>
+          <a:noFill/>
+          <a:ln/>
+        </p:spPr>
+        <p:txBody>
+          <a:bodyPr wrap="square" lIns="0" tIns="0" rIns="0" bIns="0" rtlCol="0" anchor="ctr"/>
+          <a:lstStyle/>
+          <a:p>
+            <a:pPr indent="0" marL="0">
+              <a:buNone/>
+            </a:pPr>
+            <a:r>
+              <a:rPr lang="en-US" sz="950" b="1" dirty="0">
+                <a:solidFill>
+                  <a:srgbClr val="0284C7"/>
+                </a:solidFill>
+                <a:latin typeface="Calibri" pitchFamily="34" charset="0"/>
+                <a:ea typeface="Calibri" pitchFamily="34" charset="-122"/>
+                <a:cs typeface="Calibri" pitchFamily="34" charset="-120"/>
+              </a:rPr>
+              <a:t>01  </a:t>
+            </a:r>
             <a:pPr indent="0" marL="0">
               <a:buNone/>
             </a:pPr>
             <a:r>
               <a:rPr lang="en-US" sz="950" dirty="0">
                 <a:solidFill>
-                  <a:srgbClr val="FFFFFF"/>
-                </a:solidFill>
-                <a:latin typeface="Calibri" pitchFamily="34" charset="0"/>
-                <a:ea typeface="Calibri" pitchFamily="34" charset="-122"/>
-                <a:cs typeface="Calibri" pitchFamily="34" charset="-120"/>
-              </a:rPr>
-              <a:t>11 days  ·  Jun 1 – 11</a:t>
+                  <a:srgbClr val="345671"/>
+                </a:solidFill>
+                <a:latin typeface="Calibri" pitchFamily="34" charset="0"/>
+                <a:ea typeface="Calibri" pitchFamily="34" charset="-122"/>
+                <a:cs typeface="Calibri" pitchFamily="34" charset="-120"/>
+              </a:rPr>
+              <a:t>Orientation, embryology &amp; congenital</a:t>
             </a:r>
             <a:endParaRPr lang="en-US" sz="950" dirty="0"/>
           </a:p>
@@ -1367,30 +1420,30 @@
       </p:sp>
       <p:sp>
         <p:nvSpPr>
-          <p:cNvPr id="17" name="Text 14"/>
-          <p:cNvSpPr/>
-          <p:nvPr/>
-        </p:nvSpPr>
-        <p:spPr>
-          <a:xfrm>
-            <a:off x="594360" y="3502152"/>
-            <a:ext cx="1540764" cy="274320"/>
-          </a:xfrm>
-          <a:prstGeom prst="rect">
-            <a:avLst/>
-          </a:prstGeom>
-          <a:noFill/>
-          <a:ln/>
-        </p:spPr>
-        <p:txBody>
-          <a:bodyPr wrap="square" lIns="0" tIns="0" rIns="0" bIns="0" rtlCol="0" anchor="ctr"/>
-          <a:lstStyle/>
-          <a:p>
-            <a:pPr indent="0" marL="0">
-              <a:buNone/>
-            </a:pPr>
-            <a:r>
-              <a:rPr lang="en-US" sz="850" b="1" dirty="0">
+          <p:cNvPr id="18" name="Text 15"/>
+          <p:cNvSpPr/>
+          <p:nvPr/>
+        </p:nvSpPr>
+        <p:spPr>
+          <a:xfrm>
+            <a:off x="630936" y="3163824"/>
+            <a:ext cx="3287268" cy="173736"/>
+          </a:xfrm>
+          <a:prstGeom prst="rect">
+            <a:avLst/>
+          </a:prstGeom>
+          <a:noFill/>
+          <a:ln/>
+        </p:spPr>
+        <p:txBody>
+          <a:bodyPr wrap="square" lIns="0" tIns="0" rIns="0" bIns="0" rtlCol="0" anchor="ctr"/>
+          <a:lstStyle/>
+          <a:p>
+            <a:pPr indent="0" marL="0">
+              <a:buNone/>
+            </a:pPr>
+            <a:r>
+              <a:rPr lang="en-US" sz="950" b="1" dirty="0">
                 <a:solidFill>
                   <a:srgbClr val="0284C7"/>
                 </a:solidFill>
@@ -1398,13 +1451,13 @@
                 <a:ea typeface="Calibri" pitchFamily="34" charset="-122"/>
                 <a:cs typeface="Calibri" pitchFamily="34" charset="-120"/>
               </a:rPr>
-              <a:t>01  </a:t>
-            </a:r>
-            <a:pPr indent="0" marL="0">
-              <a:buNone/>
-            </a:pPr>
-            <a:r>
-              <a:rPr lang="en-US" sz="850" dirty="0">
+              <a:t>02  </a:t>
+            </a:r>
+            <a:pPr indent="0" marL="0">
+              <a:buNone/>
+            </a:pPr>
+            <a:r>
+              <a:rPr lang="en-US" sz="950" dirty="0">
                 <a:solidFill>
                   <a:srgbClr val="345671"/>
                 </a:solidFill>
@@ -1412,38 +1465,38 @@
                 <a:ea typeface="Calibri" pitchFamily="34" charset="-122"/>
                 <a:cs typeface="Calibri" pitchFamily="34" charset="-120"/>
               </a:rPr>
-              <a:t>Orientation &amp; overview</a:t>
-            </a:r>
-            <a:endParaRPr lang="en-US" sz="850" dirty="0"/>
-          </a:p>
-        </p:txBody>
-      </p:sp>
-      <p:sp>
-        <p:nvSpPr>
-          <p:cNvPr id="18" name="Text 15"/>
-          <p:cNvSpPr/>
-          <p:nvPr/>
-        </p:nvSpPr>
-        <p:spPr>
-          <a:xfrm>
-            <a:off x="594360" y="3776472"/>
-            <a:ext cx="1540764" cy="274320"/>
-          </a:xfrm>
-          <a:prstGeom prst="rect">
-            <a:avLst/>
-          </a:prstGeom>
-          <a:noFill/>
-          <a:ln/>
-        </p:spPr>
-        <p:txBody>
-          <a:bodyPr wrap="square" lIns="0" tIns="0" rIns="0" bIns="0" rtlCol="0" anchor="ctr"/>
-          <a:lstStyle/>
-          <a:p>
-            <a:pPr indent="0" marL="0">
-              <a:buNone/>
-            </a:pPr>
-            <a:r>
-              <a:rPr lang="en-US" sz="850" b="1" dirty="0">
+              <a:t>Anatomy &amp; cardiac imaging</a:t>
+            </a:r>
+            <a:endParaRPr lang="en-US" sz="950" dirty="0"/>
+          </a:p>
+        </p:txBody>
+      </p:sp>
+      <p:sp>
+        <p:nvSpPr>
+          <p:cNvPr id="19" name="Text 16"/>
+          <p:cNvSpPr/>
+          <p:nvPr/>
+        </p:nvSpPr>
+        <p:spPr>
+          <a:xfrm>
+            <a:off x="630936" y="3337560"/>
+            <a:ext cx="3287268" cy="173736"/>
+          </a:xfrm>
+          <a:prstGeom prst="rect">
+            <a:avLst/>
+          </a:prstGeom>
+          <a:noFill/>
+          <a:ln/>
+        </p:spPr>
+        <p:txBody>
+          <a:bodyPr wrap="square" lIns="0" tIns="0" rIns="0" bIns="0" rtlCol="0" anchor="ctr"/>
+          <a:lstStyle/>
+          <a:p>
+            <a:pPr indent="0" marL="0">
+              <a:buNone/>
+            </a:pPr>
+            <a:r>
+              <a:rPr lang="en-US" sz="950" b="1" dirty="0">
                 <a:solidFill>
                   <a:srgbClr val="0284C7"/>
                 </a:solidFill>
@@ -1451,13 +1504,13 @@
                 <a:ea typeface="Calibri" pitchFamily="34" charset="-122"/>
                 <a:cs typeface="Calibri" pitchFamily="34" charset="-120"/>
               </a:rPr>
-              <a:t>02  </a:t>
-            </a:r>
-            <a:pPr indent="0" marL="0">
-              <a:buNone/>
-            </a:pPr>
-            <a:r>
-              <a:rPr lang="en-US" sz="850" dirty="0">
+              <a:t>03  </a:t>
+            </a:r>
+            <a:pPr indent="0" marL="0">
+              <a:buNone/>
+            </a:pPr>
+            <a:r>
+              <a:rPr lang="en-US" sz="950" dirty="0">
                 <a:solidFill>
                   <a:srgbClr val="345671"/>
                 </a:solidFill>
@@ -1465,38 +1518,38 @@
                 <a:ea typeface="Calibri" pitchFamily="34" charset="-122"/>
                 <a:cs typeface="Calibri" pitchFamily="34" charset="-120"/>
               </a:rPr>
-              <a:t>Embryology · congenital</a:t>
-            </a:r>
-            <a:endParaRPr lang="en-US" sz="850" dirty="0"/>
-          </a:p>
-        </p:txBody>
-      </p:sp>
-      <p:sp>
-        <p:nvSpPr>
-          <p:cNvPr id="19" name="Text 16"/>
-          <p:cNvSpPr/>
-          <p:nvPr/>
-        </p:nvSpPr>
-        <p:spPr>
-          <a:xfrm>
-            <a:off x="594360" y="4050792"/>
-            <a:ext cx="1540764" cy="274320"/>
-          </a:xfrm>
-          <a:prstGeom prst="rect">
-            <a:avLst/>
-          </a:prstGeom>
-          <a:noFill/>
-          <a:ln/>
-        </p:spPr>
-        <p:txBody>
-          <a:bodyPr wrap="square" lIns="0" tIns="0" rIns="0" bIns="0" rtlCol="0" anchor="ctr"/>
-          <a:lstStyle/>
-          <a:p>
-            <a:pPr indent="0" marL="0">
-              <a:buNone/>
-            </a:pPr>
-            <a:r>
-              <a:rPr lang="en-US" sz="850" b="1" dirty="0">
+              <a:t>Cardiac output &amp; PV loops</a:t>
+            </a:r>
+            <a:endParaRPr lang="en-US" sz="950" dirty="0"/>
+          </a:p>
+        </p:txBody>
+      </p:sp>
+      <p:sp>
+        <p:nvSpPr>
+          <p:cNvPr id="20" name="Text 17"/>
+          <p:cNvSpPr/>
+          <p:nvPr/>
+        </p:nvSpPr>
+        <p:spPr>
+          <a:xfrm>
+            <a:off x="630936" y="3511296"/>
+            <a:ext cx="3287268" cy="173736"/>
+          </a:xfrm>
+          <a:prstGeom prst="rect">
+            <a:avLst/>
+          </a:prstGeom>
+          <a:noFill/>
+          <a:ln/>
+        </p:spPr>
+        <p:txBody>
+          <a:bodyPr wrap="square" lIns="0" tIns="0" rIns="0" bIns="0" rtlCol="0" anchor="ctr"/>
+          <a:lstStyle/>
+          <a:p>
+            <a:pPr indent="0" marL="0">
+              <a:buNone/>
+            </a:pPr>
+            <a:r>
+              <a:rPr lang="en-US" sz="950" b="1" dirty="0">
                 <a:solidFill>
                   <a:srgbClr val="0284C7"/>
                 </a:solidFill>
@@ -1504,13 +1557,13 @@
                 <a:ea typeface="Calibri" pitchFamily="34" charset="-122"/>
                 <a:cs typeface="Calibri" pitchFamily="34" charset="-120"/>
               </a:rPr>
-              <a:t>03  </a:t>
-            </a:r>
-            <a:pPr indent="0" marL="0">
-              <a:buNone/>
-            </a:pPr>
-            <a:r>
-              <a:rPr lang="en-US" sz="850" dirty="0">
+              <a:t>04  </a:t>
+            </a:r>
+            <a:pPr indent="0" marL="0">
+              <a:buNone/>
+            </a:pPr>
+            <a:r>
+              <a:rPr lang="en-US" sz="950" dirty="0">
                 <a:solidFill>
                   <a:srgbClr val="345671"/>
                 </a:solidFill>
@@ -1518,38 +1571,38 @@
                 <a:ea typeface="Calibri" pitchFamily="34" charset="-122"/>
                 <a:cs typeface="Calibri" pitchFamily="34" charset="-120"/>
               </a:rPr>
-              <a:t>Anatomy · pericardium</a:t>
-            </a:r>
-            <a:endParaRPr lang="en-US" sz="850" dirty="0"/>
-          </a:p>
-        </p:txBody>
-      </p:sp>
-      <p:sp>
-        <p:nvSpPr>
-          <p:cNvPr id="20" name="Text 17"/>
-          <p:cNvSpPr/>
-          <p:nvPr/>
-        </p:nvSpPr>
-        <p:spPr>
-          <a:xfrm>
-            <a:off x="594360" y="4325112"/>
-            <a:ext cx="1540764" cy="274320"/>
-          </a:xfrm>
-          <a:prstGeom prst="rect">
-            <a:avLst/>
-          </a:prstGeom>
-          <a:noFill/>
-          <a:ln/>
-        </p:spPr>
-        <p:txBody>
-          <a:bodyPr wrap="square" lIns="0" tIns="0" rIns="0" bIns="0" rtlCol="0" anchor="ctr"/>
-          <a:lstStyle/>
-          <a:p>
-            <a:pPr indent="0" marL="0">
-              <a:buNone/>
-            </a:pPr>
-            <a:r>
-              <a:rPr lang="en-US" sz="850" b="1" dirty="0">
+              <a:t>Heart sounds &amp; murmurs</a:t>
+            </a:r>
+            <a:endParaRPr lang="en-US" sz="950" dirty="0"/>
+          </a:p>
+        </p:txBody>
+      </p:sp>
+      <p:sp>
+        <p:nvSpPr>
+          <p:cNvPr id="21" name="Text 18"/>
+          <p:cNvSpPr/>
+          <p:nvPr/>
+        </p:nvSpPr>
+        <p:spPr>
+          <a:xfrm>
+            <a:off x="630936" y="3685032"/>
+            <a:ext cx="3287268" cy="173736"/>
+          </a:xfrm>
+          <a:prstGeom prst="rect">
+            <a:avLst/>
+          </a:prstGeom>
+          <a:noFill/>
+          <a:ln/>
+        </p:spPr>
+        <p:txBody>
+          <a:bodyPr wrap="square" lIns="0" tIns="0" rIns="0" bIns="0" rtlCol="0" anchor="ctr"/>
+          <a:lstStyle/>
+          <a:p>
+            <a:pPr indent="0" marL="0">
+              <a:buNone/>
+            </a:pPr>
+            <a:r>
+              <a:rPr lang="en-US" sz="950" b="1" dirty="0">
                 <a:solidFill>
                   <a:srgbClr val="0284C7"/>
                 </a:solidFill>
@@ -1557,13 +1610,13 @@
                 <a:ea typeface="Calibri" pitchFamily="34" charset="-122"/>
                 <a:cs typeface="Calibri" pitchFamily="34" charset="-120"/>
               </a:rPr>
-              <a:t>04  </a:t>
-            </a:r>
-            <a:pPr indent="0" marL="0">
-              <a:buNone/>
-            </a:pPr>
-            <a:r>
-              <a:rPr lang="en-US" sz="850" dirty="0">
+              <a:t>05  </a:t>
+            </a:r>
+            <a:pPr indent="0" marL="0">
+              <a:buNone/>
+            </a:pPr>
+            <a:r>
+              <a:rPr lang="en-US" sz="950" dirty="0">
                 <a:solidFill>
                   <a:srgbClr val="345671"/>
                 </a:solidFill>
@@ -1571,38 +1624,38 @@
                 <a:ea typeface="Calibri" pitchFamily="34" charset="-122"/>
                 <a:cs typeface="Calibri" pitchFamily="34" charset="-120"/>
               </a:rPr>
-              <a:t>Pump physiology · PV</a:t>
-            </a:r>
-            <a:endParaRPr lang="en-US" sz="850" dirty="0"/>
-          </a:p>
-        </p:txBody>
-      </p:sp>
-      <p:sp>
-        <p:nvSpPr>
-          <p:cNvPr id="21" name="Text 18"/>
-          <p:cNvSpPr/>
-          <p:nvPr/>
-        </p:nvSpPr>
-        <p:spPr>
-          <a:xfrm>
-            <a:off x="594360" y="4599432"/>
-            <a:ext cx="1540764" cy="274320"/>
-          </a:xfrm>
-          <a:prstGeom prst="rect">
-            <a:avLst/>
-          </a:prstGeom>
-          <a:noFill/>
-          <a:ln/>
-        </p:spPr>
-        <p:txBody>
-          <a:bodyPr wrap="square" lIns="0" tIns="0" rIns="0" bIns="0" rtlCol="0" anchor="ctr"/>
-          <a:lstStyle/>
-          <a:p>
-            <a:pPr indent="0" marL="0">
-              <a:buNone/>
-            </a:pPr>
-            <a:r>
-              <a:rPr lang="en-US" sz="850" b="1" dirty="0">
+              <a:t>ECG &amp; action potentials</a:t>
+            </a:r>
+            <a:endParaRPr lang="en-US" sz="950" dirty="0"/>
+          </a:p>
+        </p:txBody>
+      </p:sp>
+      <p:sp>
+        <p:nvSpPr>
+          <p:cNvPr id="22" name="Text 19"/>
+          <p:cNvSpPr/>
+          <p:nvPr/>
+        </p:nvSpPr>
+        <p:spPr>
+          <a:xfrm>
+            <a:off x="630936" y="3858768"/>
+            <a:ext cx="3287268" cy="173736"/>
+          </a:xfrm>
+          <a:prstGeom prst="rect">
+            <a:avLst/>
+          </a:prstGeom>
+          <a:noFill/>
+          <a:ln/>
+        </p:spPr>
+        <p:txBody>
+          <a:bodyPr wrap="square" lIns="0" tIns="0" rIns="0" bIns="0" rtlCol="0" anchor="ctr"/>
+          <a:lstStyle/>
+          <a:p>
+            <a:pPr indent="0" marL="0">
+              <a:buNone/>
+            </a:pPr>
+            <a:r>
+              <a:rPr lang="en-US" sz="950" b="1" dirty="0">
                 <a:solidFill>
                   <a:srgbClr val="0284C7"/>
                 </a:solidFill>
@@ -1610,13 +1663,13 @@
                 <a:ea typeface="Calibri" pitchFamily="34" charset="-122"/>
                 <a:cs typeface="Calibri" pitchFamily="34" charset="-120"/>
               </a:rPr>
-              <a:t>05  </a:t>
-            </a:r>
-            <a:pPr indent="0" marL="0">
-              <a:buNone/>
-            </a:pPr>
-            <a:r>
-              <a:rPr lang="en-US" sz="850" dirty="0">
+              <a:t>06  </a:t>
+            </a:r>
+            <a:pPr indent="0" marL="0">
+              <a:buNone/>
+            </a:pPr>
+            <a:r>
+              <a:rPr lang="en-US" sz="950" dirty="0">
                 <a:solidFill>
                   <a:srgbClr val="345671"/>
                 </a:solidFill>
@@ -1624,38 +1677,38 @@
                 <a:ea typeface="Calibri" pitchFamily="34" charset="-122"/>
                 <a:cs typeface="Calibri" pitchFamily="34" charset="-120"/>
               </a:rPr>
-              <a:t>Heart sounds · murmurs</a:t>
-            </a:r>
-            <a:endParaRPr lang="en-US" sz="850" dirty="0"/>
-          </a:p>
-        </p:txBody>
-      </p:sp>
-      <p:sp>
-        <p:nvSpPr>
-          <p:cNvPr id="22" name="Text 19"/>
-          <p:cNvSpPr/>
-          <p:nvPr/>
-        </p:nvSpPr>
-        <p:spPr>
-          <a:xfrm>
-            <a:off x="594360" y="4873752"/>
-            <a:ext cx="1540764" cy="274320"/>
-          </a:xfrm>
-          <a:prstGeom prst="rect">
-            <a:avLst/>
-          </a:prstGeom>
-          <a:noFill/>
-          <a:ln/>
-        </p:spPr>
-        <p:txBody>
-          <a:bodyPr wrap="square" lIns="0" tIns="0" rIns="0" bIns="0" rtlCol="0" anchor="ctr"/>
-          <a:lstStyle/>
-          <a:p>
-            <a:pPr indent="0" marL="0">
-              <a:buNone/>
-            </a:pPr>
-            <a:r>
-              <a:rPr lang="en-US" sz="850" b="1" dirty="0">
+              <a:t>CAD, IHD &amp; myocardial infarction</a:t>
+            </a:r>
+            <a:endParaRPr lang="en-US" sz="950" dirty="0"/>
+          </a:p>
+        </p:txBody>
+      </p:sp>
+      <p:sp>
+        <p:nvSpPr>
+          <p:cNvPr id="23" name="Text 20"/>
+          <p:cNvSpPr/>
+          <p:nvPr/>
+        </p:nvSpPr>
+        <p:spPr>
+          <a:xfrm>
+            <a:off x="630936" y="4032504"/>
+            <a:ext cx="3287268" cy="173736"/>
+          </a:xfrm>
+          <a:prstGeom prst="rect">
+            <a:avLst/>
+          </a:prstGeom>
+          <a:noFill/>
+          <a:ln/>
+        </p:spPr>
+        <p:txBody>
+          <a:bodyPr wrap="square" lIns="0" tIns="0" rIns="0" bIns="0" rtlCol="0" anchor="ctr"/>
+          <a:lstStyle/>
+          <a:p>
+            <a:pPr indent="0" marL="0">
+              <a:buNone/>
+            </a:pPr>
+            <a:r>
+              <a:rPr lang="en-US" sz="950" b="1" dirty="0">
                 <a:solidFill>
                   <a:srgbClr val="0284C7"/>
                 </a:solidFill>
@@ -1663,13 +1716,13 @@
                 <a:ea typeface="Calibri" pitchFamily="34" charset="-122"/>
                 <a:cs typeface="Calibri" pitchFamily="34" charset="-120"/>
               </a:rPr>
-              <a:t>06  </a:t>
-            </a:r>
-            <a:pPr indent="0" marL="0">
-              <a:buNone/>
-            </a:pPr>
-            <a:r>
-              <a:rPr lang="en-US" sz="850" dirty="0">
+              <a:t>07  </a:t>
+            </a:r>
+            <a:pPr indent="0" marL="0">
+              <a:buNone/>
+            </a:pPr>
+            <a:r>
+              <a:rPr lang="en-US" sz="950" dirty="0">
                 <a:solidFill>
                   <a:srgbClr val="345671"/>
                 </a:solidFill>
@@ -1677,38 +1730,38 @@
                 <a:ea typeface="Calibri" pitchFamily="34" charset="-122"/>
                 <a:cs typeface="Calibri" pitchFamily="34" charset="-120"/>
               </a:rPr>
-              <a:t>ECG · action potentials</a:t>
-            </a:r>
-            <a:endParaRPr lang="en-US" sz="850" dirty="0"/>
-          </a:p>
-        </p:txBody>
-      </p:sp>
-      <p:sp>
-        <p:nvSpPr>
-          <p:cNvPr id="23" name="Text 20"/>
-          <p:cNvSpPr/>
-          <p:nvPr/>
-        </p:nvSpPr>
-        <p:spPr>
-          <a:xfrm>
-            <a:off x="594360" y="5148072"/>
-            <a:ext cx="1540764" cy="274320"/>
-          </a:xfrm>
-          <a:prstGeom prst="rect">
-            <a:avLst/>
-          </a:prstGeom>
-          <a:noFill/>
-          <a:ln/>
-        </p:spPr>
-        <p:txBody>
-          <a:bodyPr wrap="square" lIns="0" tIns="0" rIns="0" bIns="0" rtlCol="0" anchor="ctr"/>
-          <a:lstStyle/>
-          <a:p>
-            <a:pPr indent="0" marL="0">
-              <a:buNone/>
-            </a:pPr>
-            <a:r>
-              <a:rPr lang="en-US" sz="850" b="1" dirty="0">
+              <a:t>Hypertension &amp; atherosclerosis</a:t>
+            </a:r>
+            <a:endParaRPr lang="en-US" sz="950" dirty="0"/>
+          </a:p>
+        </p:txBody>
+      </p:sp>
+      <p:sp>
+        <p:nvSpPr>
+          <p:cNvPr id="24" name="Text 21"/>
+          <p:cNvSpPr/>
+          <p:nvPr/>
+        </p:nvSpPr>
+        <p:spPr>
+          <a:xfrm>
+            <a:off x="630936" y="4206240"/>
+            <a:ext cx="3287268" cy="173736"/>
+          </a:xfrm>
+          <a:prstGeom prst="rect">
+            <a:avLst/>
+          </a:prstGeom>
+          <a:noFill/>
+          <a:ln/>
+        </p:spPr>
+        <p:txBody>
+          <a:bodyPr wrap="square" lIns="0" tIns="0" rIns="0" bIns="0" rtlCol="0" anchor="ctr"/>
+          <a:lstStyle/>
+          <a:p>
+            <a:pPr indent="0" marL="0">
+              <a:buNone/>
+            </a:pPr>
+            <a:r>
+              <a:rPr lang="en-US" sz="950" b="1" dirty="0">
                 <a:solidFill>
                   <a:srgbClr val="0284C7"/>
                 </a:solidFill>
@@ -1716,13 +1769,13 @@
                 <a:ea typeface="Calibri" pitchFamily="34" charset="-122"/>
                 <a:cs typeface="Calibri" pitchFamily="34" charset="-120"/>
               </a:rPr>
-              <a:t>07  </a:t>
-            </a:r>
-            <a:pPr indent="0" marL="0">
-              <a:buNone/>
-            </a:pPr>
-            <a:r>
-              <a:rPr lang="en-US" sz="850" dirty="0">
+              <a:t>08  </a:t>
+            </a:r>
+            <a:pPr indent="0" marL="0">
+              <a:buNone/>
+            </a:pPr>
+            <a:r>
+              <a:rPr lang="en-US" sz="950" dirty="0">
                 <a:solidFill>
                   <a:srgbClr val="345671"/>
                 </a:solidFill>
@@ -1730,38 +1783,38 @@
                 <a:ea typeface="Calibri" pitchFamily="34" charset="-122"/>
                 <a:cs typeface="Calibri" pitchFamily="34" charset="-120"/>
               </a:rPr>
-              <a:t>CAD · IHD · MI</a:t>
-            </a:r>
-            <a:endParaRPr lang="en-US" sz="850" dirty="0"/>
-          </a:p>
-        </p:txBody>
-      </p:sp>
-      <p:sp>
-        <p:nvSpPr>
-          <p:cNvPr id="24" name="Text 21"/>
-          <p:cNvSpPr/>
-          <p:nvPr/>
-        </p:nvSpPr>
-        <p:spPr>
-          <a:xfrm>
-            <a:off x="594360" y="5422392"/>
-            <a:ext cx="1540764" cy="274320"/>
-          </a:xfrm>
-          <a:prstGeom prst="rect">
-            <a:avLst/>
-          </a:prstGeom>
-          <a:noFill/>
-          <a:ln/>
-        </p:spPr>
-        <p:txBody>
-          <a:bodyPr wrap="square" lIns="0" tIns="0" rIns="0" bIns="0" rtlCol="0" anchor="ctr"/>
-          <a:lstStyle/>
-          <a:p>
-            <a:pPr indent="0" marL="0">
-              <a:buNone/>
-            </a:pPr>
-            <a:r>
-              <a:rPr lang="en-US" sz="850" b="1" dirty="0">
+              <a:t>Heart failure &amp; cardiomyopathies</a:t>
+            </a:r>
+            <a:endParaRPr lang="en-US" sz="950" dirty="0"/>
+          </a:p>
+        </p:txBody>
+      </p:sp>
+      <p:sp>
+        <p:nvSpPr>
+          <p:cNvPr id="25" name="Text 22"/>
+          <p:cNvSpPr/>
+          <p:nvPr/>
+        </p:nvSpPr>
+        <p:spPr>
+          <a:xfrm>
+            <a:off x="630936" y="4379976"/>
+            <a:ext cx="3287268" cy="173736"/>
+          </a:xfrm>
+          <a:prstGeom prst="rect">
+            <a:avLst/>
+          </a:prstGeom>
+          <a:noFill/>
+          <a:ln/>
+        </p:spPr>
+        <p:txBody>
+          <a:bodyPr wrap="square" lIns="0" tIns="0" rIns="0" bIns="0" rtlCol="0" anchor="ctr"/>
+          <a:lstStyle/>
+          <a:p>
+            <a:pPr indent="0" marL="0">
+              <a:buNone/>
+            </a:pPr>
+            <a:r>
+              <a:rPr lang="en-US" sz="950" b="1" dirty="0">
                 <a:solidFill>
                   <a:srgbClr val="0284C7"/>
                 </a:solidFill>
@@ -1769,13 +1822,13 @@
                 <a:ea typeface="Calibri" pitchFamily="34" charset="-122"/>
                 <a:cs typeface="Calibri" pitchFamily="34" charset="-120"/>
               </a:rPr>
-              <a:t>08  </a:t>
-            </a:r>
-            <a:pPr indent="0" marL="0">
-              <a:buNone/>
-            </a:pPr>
-            <a:r>
-              <a:rPr lang="en-US" sz="850" dirty="0">
+              <a:t>09  </a:t>
+            </a:r>
+            <a:pPr indent="0" marL="0">
+              <a:buNone/>
+            </a:pPr>
+            <a:r>
+              <a:rPr lang="en-US" sz="950" dirty="0">
                 <a:solidFill>
                   <a:srgbClr val="345671"/>
                 </a:solidFill>
@@ -1783,38 +1836,38 @@
                 <a:ea typeface="Calibri" pitchFamily="34" charset="-122"/>
                 <a:cs typeface="Calibri" pitchFamily="34" charset="-120"/>
               </a:rPr>
-              <a:t>HTN · atherosclerosis</a:t>
-            </a:r>
-            <a:endParaRPr lang="en-US" sz="850" dirty="0"/>
-          </a:p>
-        </p:txBody>
-      </p:sp>
-      <p:sp>
-        <p:nvSpPr>
-          <p:cNvPr id="25" name="Text 22"/>
-          <p:cNvSpPr/>
-          <p:nvPr/>
-        </p:nvSpPr>
-        <p:spPr>
-          <a:xfrm>
-            <a:off x="594360" y="5696712"/>
-            <a:ext cx="1540764" cy="274320"/>
-          </a:xfrm>
-          <a:prstGeom prst="rect">
-            <a:avLst/>
-          </a:prstGeom>
-          <a:noFill/>
-          <a:ln/>
-        </p:spPr>
-        <p:txBody>
-          <a:bodyPr wrap="square" lIns="0" tIns="0" rIns="0" bIns="0" rtlCol="0" anchor="ctr"/>
-          <a:lstStyle/>
-          <a:p>
-            <a:pPr indent="0" marL="0">
-              <a:buNone/>
-            </a:pPr>
-            <a:r>
-              <a:rPr lang="en-US" sz="850" b="1" dirty="0">
+              <a:t>Endocarditis, myocarditis &amp; vasculitis</a:t>
+            </a:r>
+            <a:endParaRPr lang="en-US" sz="950" dirty="0"/>
+          </a:p>
+        </p:txBody>
+      </p:sp>
+      <p:sp>
+        <p:nvSpPr>
+          <p:cNvPr id="26" name="Text 23"/>
+          <p:cNvSpPr/>
+          <p:nvPr/>
+        </p:nvSpPr>
+        <p:spPr>
+          <a:xfrm>
+            <a:off x="630936" y="4553712"/>
+            <a:ext cx="3287268" cy="173736"/>
+          </a:xfrm>
+          <a:prstGeom prst="rect">
+            <a:avLst/>
+          </a:prstGeom>
+          <a:noFill/>
+          <a:ln/>
+        </p:spPr>
+        <p:txBody>
+          <a:bodyPr wrap="square" lIns="0" tIns="0" rIns="0" bIns="0" rtlCol="0" anchor="ctr"/>
+          <a:lstStyle/>
+          <a:p>
+            <a:pPr indent="0" marL="0">
+              <a:buNone/>
+            </a:pPr>
+            <a:r>
+              <a:rPr lang="en-US" sz="950" b="1" dirty="0">
                 <a:solidFill>
                   <a:srgbClr val="0284C7"/>
                 </a:solidFill>
@@ -1822,13 +1875,13 @@
                 <a:ea typeface="Calibri" pitchFamily="34" charset="-122"/>
                 <a:cs typeface="Calibri" pitchFamily="34" charset="-120"/>
               </a:rPr>
-              <a:t>09  </a:t>
-            </a:r>
-            <a:pPr indent="0" marL="0">
-              <a:buNone/>
-            </a:pPr>
-            <a:r>
-              <a:rPr lang="en-US" sz="850" dirty="0">
+              <a:t>10  </a:t>
+            </a:r>
+            <a:pPr indent="0" marL="0">
+              <a:buNone/>
+            </a:pPr>
+            <a:r>
+              <a:rPr lang="en-US" sz="950" dirty="0">
                 <a:solidFill>
                   <a:srgbClr val="345671"/>
                 </a:solidFill>
@@ -1836,132 +1889,26 @@
                 <a:ea typeface="Calibri" pitchFamily="34" charset="-122"/>
                 <a:cs typeface="Calibri" pitchFamily="34" charset="-120"/>
               </a:rPr>
-              <a:t>HF · cardiomyopathies</a:t>
-            </a:r>
-            <a:endParaRPr lang="en-US" sz="850" dirty="0"/>
-          </a:p>
-        </p:txBody>
-      </p:sp>
-      <p:sp>
-        <p:nvSpPr>
-          <p:cNvPr id="26" name="Text 23"/>
-          <p:cNvSpPr/>
-          <p:nvPr/>
-        </p:nvSpPr>
-        <p:spPr>
-          <a:xfrm>
-            <a:off x="594360" y="5971032"/>
-            <a:ext cx="1540764" cy="274320"/>
-          </a:xfrm>
-          <a:prstGeom prst="rect">
-            <a:avLst/>
-          </a:prstGeom>
-          <a:noFill/>
-          <a:ln/>
-        </p:spPr>
-        <p:txBody>
-          <a:bodyPr wrap="square" lIns="0" tIns="0" rIns="0" bIns="0" rtlCol="0" anchor="ctr"/>
-          <a:lstStyle/>
-          <a:p>
-            <a:pPr indent="0" marL="0">
-              <a:buNone/>
-            </a:pPr>
-            <a:r>
-              <a:rPr lang="en-US" sz="850" b="1" dirty="0">
-                <a:solidFill>
-                  <a:srgbClr val="0284C7"/>
-                </a:solidFill>
-                <a:latin typeface="Calibri" pitchFamily="34" charset="0"/>
-                <a:ea typeface="Calibri" pitchFamily="34" charset="-122"/>
-                <a:cs typeface="Calibri" pitchFamily="34" charset="-120"/>
-              </a:rPr>
-              <a:t>10  </a:t>
-            </a:r>
-            <a:pPr indent="0" marL="0">
-              <a:buNone/>
-            </a:pPr>
-            <a:r>
-              <a:rPr lang="en-US" sz="850" dirty="0">
-                <a:solidFill>
-                  <a:srgbClr val="345671"/>
-                </a:solidFill>
-                <a:latin typeface="Calibri" pitchFamily="34" charset="0"/>
-                <a:ea typeface="Calibri" pitchFamily="34" charset="-122"/>
-                <a:cs typeface="Calibri" pitchFamily="34" charset="-120"/>
-              </a:rPr>
-              <a:t>Rheumatic · IE · vasc</a:t>
-            </a:r>
-            <a:endParaRPr lang="en-US" sz="850" dirty="0"/>
-          </a:p>
-        </p:txBody>
-      </p:sp>
-      <p:sp>
-        <p:nvSpPr>
-          <p:cNvPr id="27" name="Text 24"/>
-          <p:cNvSpPr/>
-          <p:nvPr/>
-        </p:nvSpPr>
-        <p:spPr>
-          <a:xfrm>
-            <a:off x="594360" y="6245352"/>
-            <a:ext cx="1540764" cy="274320"/>
-          </a:xfrm>
-          <a:prstGeom prst="rect">
-            <a:avLst/>
-          </a:prstGeom>
-          <a:noFill/>
-          <a:ln/>
-        </p:spPr>
-        <p:txBody>
-          <a:bodyPr wrap="square" lIns="0" tIns="0" rIns="0" bIns="0" rtlCol="0" anchor="ctr"/>
-          <a:lstStyle/>
-          <a:p>
-            <a:pPr indent="0" marL="0">
-              <a:buNone/>
-            </a:pPr>
-            <a:r>
-              <a:rPr lang="en-US" sz="850" b="1" dirty="0">
-                <a:solidFill>
-                  <a:srgbClr val="0284C7"/>
-                </a:solidFill>
-                <a:latin typeface="Calibri" pitchFamily="34" charset="0"/>
-                <a:ea typeface="Calibri" pitchFamily="34" charset="-122"/>
-                <a:cs typeface="Calibri" pitchFamily="34" charset="-120"/>
-              </a:rPr>
-              <a:t>11  </a:t>
-            </a:r>
-            <a:pPr indent="0" marL="0">
-              <a:buNone/>
-            </a:pPr>
-            <a:r>
-              <a:rPr lang="en-US" sz="850" dirty="0">
-                <a:solidFill>
-                  <a:srgbClr val="345671"/>
-                </a:solidFill>
-                <a:latin typeface="Calibri" pitchFamily="34" charset="0"/>
-                <a:ea typeface="Calibri" pitchFamily="34" charset="-122"/>
-                <a:cs typeface="Calibri" pitchFamily="34" charset="-120"/>
-              </a:rPr>
-              <a:t>CV pharmacology</a:t>
-            </a:r>
-            <a:endParaRPr lang="en-US" sz="850" dirty="0"/>
-          </a:p>
-        </p:txBody>
-      </p:sp>
-      <p:sp>
-        <p:nvSpPr>
-          <p:cNvPr id="28" name="Shape 25"/>
-          <p:cNvSpPr/>
-          <p:nvPr/>
-        </p:nvSpPr>
-        <p:spPr>
-          <a:xfrm>
-            <a:off x="2336292" y="2697480"/>
-            <a:ext cx="1723644" cy="4526280"/>
+              <a:t>Cardiovascular pharmacology</a:t>
+            </a:r>
+            <a:endParaRPr lang="en-US" sz="950" dirty="0"/>
+          </a:p>
+        </p:txBody>
+      </p:sp>
+      <p:sp>
+        <p:nvSpPr>
+          <p:cNvPr id="27" name="Shape 24"/>
+          <p:cNvSpPr/>
+          <p:nvPr/>
+        </p:nvSpPr>
+        <p:spPr>
+          <a:xfrm>
+            <a:off x="4183380" y="2331720"/>
+            <a:ext cx="3543300" cy="2377440"/>
           </a:xfrm>
           <a:prstGeom prst="roundRect">
             <a:avLst>
-              <a:gd name="adj" fmla="val 5305"/>
+              <a:gd name="adj" fmla="val 3846"/>
             </a:avLst>
           </a:prstGeom>
           <a:solidFill>
@@ -1977,14 +1924,14 @@
       </p:sp>
       <p:sp>
         <p:nvSpPr>
-          <p:cNvPr id="29" name="Shape 26"/>
-          <p:cNvSpPr/>
-          <p:nvPr/>
-        </p:nvSpPr>
-        <p:spPr>
-          <a:xfrm>
-            <a:off x="2336292" y="2788920"/>
-            <a:ext cx="1723644" cy="621792"/>
+          <p:cNvPr id="28" name="Shape 25"/>
+          <p:cNvSpPr/>
+          <p:nvPr/>
+        </p:nvSpPr>
+        <p:spPr>
+          <a:xfrm>
+            <a:off x="4183380" y="2404872"/>
+            <a:ext cx="3543300" cy="493776"/>
           </a:xfrm>
           <a:prstGeom prst="rect">
             <a:avLst/>
@@ -2002,18 +1949,18 @@
       </p:sp>
       <p:sp>
         <p:nvSpPr>
-          <p:cNvPr id="30" name="Shape 27"/>
-          <p:cNvSpPr/>
-          <p:nvPr/>
-        </p:nvSpPr>
-        <p:spPr>
-          <a:xfrm>
-            <a:off x="2336292" y="2697480"/>
-            <a:ext cx="1723644" cy="713232"/>
+          <p:cNvPr id="29" name="Shape 26"/>
+          <p:cNvSpPr/>
+          <p:nvPr/>
+        </p:nvSpPr>
+        <p:spPr>
+          <a:xfrm>
+            <a:off x="4183380" y="2331720"/>
+            <a:ext cx="3543300" cy="566928"/>
           </a:xfrm>
           <a:prstGeom prst="roundRect">
             <a:avLst>
-              <a:gd name="adj" fmla="val 12821"/>
+              <a:gd name="adj" fmla="val 16129"/>
             </a:avLst>
           </a:prstGeom>
           <a:solidFill>
@@ -2029,30 +1976,69 @@
       </p:sp>
       <p:sp>
         <p:nvSpPr>
+          <p:cNvPr id="30" name="Text 27"/>
+          <p:cNvSpPr/>
+          <p:nvPr/>
+        </p:nvSpPr>
+        <p:spPr>
+          <a:xfrm>
+            <a:off x="4311396" y="2386584"/>
+            <a:ext cx="3287268" cy="256032"/>
+          </a:xfrm>
+          <a:prstGeom prst="rect">
+            <a:avLst/>
+          </a:prstGeom>
+          <a:noFill/>
+          <a:ln/>
+        </p:spPr>
+        <p:txBody>
+          <a:bodyPr wrap="square" lIns="0" tIns="0" rIns="0" bIns="0" rtlCol="0" anchor="ctr"/>
+          <a:lstStyle/>
+          <a:p>
+            <a:pPr indent="0" marL="0">
+              <a:buNone/>
+            </a:pPr>
+            <a:r>
+              <a:rPr lang="en-US" sz="1300" b="1" spc="100" kern="0" dirty="0">
+                <a:solidFill>
+                  <a:srgbClr val="FFFFFF"/>
+                </a:solidFill>
+                <a:latin typeface="Calibri" pitchFamily="34" charset="0"/>
+                <a:ea typeface="Calibri" pitchFamily="34" charset="-122"/>
+                <a:cs typeface="Calibri" pitchFamily="34" charset="-120"/>
+              </a:rPr>
+              <a:t>RESPIRATORY</a:t>
+            </a:r>
+            <a:endParaRPr lang="en-US" sz="1300" dirty="0"/>
+          </a:p>
+        </p:txBody>
+      </p:sp>
+      <p:sp>
+        <p:nvSpPr>
           <p:cNvPr id="31" name="Text 28"/>
           <p:cNvSpPr/>
           <p:nvPr/>
         </p:nvSpPr>
         <p:spPr>
           <a:xfrm>
-            <a:off x="2427732" y="2788920"/>
-            <a:ext cx="1540764" cy="274320"/>
-          </a:xfrm>
-          <a:prstGeom prst="rect">
-            <a:avLst/>
-          </a:prstGeom>
-          <a:noFill/>
-          <a:ln/>
-        </p:spPr>
-        <p:txBody>
-          <a:bodyPr wrap="square" lIns="0" tIns="0" rIns="0" bIns="0" rtlCol="0" anchor="ctr"/>
-          <a:lstStyle/>
-          <a:p>
-            <a:pPr indent="0" marL="0">
-              <a:buNone/>
-            </a:pPr>
-            <a:r>
-              <a:rPr lang="en-US" sz="1100" b="1" spc="100" kern="0" dirty="0">
+            <a:off x="4311396" y="2642616"/>
+            <a:ext cx="3287268" cy="219456"/>
+          </a:xfrm>
+          <a:prstGeom prst="rect">
+            <a:avLst/>
+          </a:prstGeom>
+          <a:noFill/>
+          <a:ln/>
+        </p:spPr>
+        <p:txBody>
+          <a:bodyPr wrap="square" lIns="0" tIns="0" rIns="0" bIns="0" rtlCol="0" anchor="ctr"/>
+          <a:lstStyle/>
+          <a:p>
+            <a:pPr indent="0" marL="0">
+              <a:buNone/>
+            </a:pPr>
+            <a:r>
+              <a:rPr lang="en-US" sz="1000" dirty="0">
                 <a:solidFill>
                   <a:srgbClr val="FFFFFF"/>
                 </a:solidFill>
@@ -2060,9 +2046,9 @@
                 <a:ea typeface="Calibri" pitchFamily="34" charset="-122"/>
                 <a:cs typeface="Calibri" pitchFamily="34" charset="-120"/>
               </a:rPr>
-              <a:t>RESPIRATORY</a:t>
-            </a:r>
-            <a:endParaRPr lang="en-US" sz="1100" dirty="0"/>
+              <a:t>8 days  ·  Jun 11 – 18</a:t>
+            </a:r>
+            <a:endParaRPr lang="en-US" sz="1000" dirty="0"/>
           </a:p>
         </p:txBody>
       </p:sp>
@@ -2074,32 +2060,46 @@
         </p:nvSpPr>
         <p:spPr>
           <a:xfrm>
-            <a:off x="2427732" y="3081528"/>
-            <a:ext cx="1540764" cy="256032"/>
-          </a:xfrm>
-          <a:prstGeom prst="rect">
-            <a:avLst/>
-          </a:prstGeom>
-          <a:noFill/>
-          <a:ln/>
-        </p:spPr>
-        <p:txBody>
-          <a:bodyPr wrap="square" lIns="0" tIns="0" rIns="0" bIns="0" rtlCol="0" anchor="ctr"/>
-          <a:lstStyle/>
-          <a:p>
+            <a:off x="4311396" y="2990088"/>
+            <a:ext cx="3287268" cy="173736"/>
+          </a:xfrm>
+          <a:prstGeom prst="rect">
+            <a:avLst/>
+          </a:prstGeom>
+          <a:noFill/>
+          <a:ln/>
+        </p:spPr>
+        <p:txBody>
+          <a:bodyPr wrap="square" lIns="0" tIns="0" rIns="0" bIns="0" rtlCol="0" anchor="ctr"/>
+          <a:lstStyle/>
+          <a:p>
+            <a:pPr indent="0" marL="0">
+              <a:buNone/>
+            </a:pPr>
+            <a:r>
+              <a:rPr lang="en-US" sz="950" b="1" dirty="0">
+                <a:solidFill>
+                  <a:srgbClr val="059669"/>
+                </a:solidFill>
+                <a:latin typeface="Calibri" pitchFamily="34" charset="0"/>
+                <a:ea typeface="Calibri" pitchFamily="34" charset="-122"/>
+                <a:cs typeface="Calibri" pitchFamily="34" charset="-120"/>
+              </a:rPr>
+              <a:t>01  </a:t>
+            </a:r>
             <a:pPr indent="0" marL="0">
               <a:buNone/>
             </a:pPr>
             <a:r>
               <a:rPr lang="en-US" sz="950" dirty="0">
                 <a:solidFill>
-                  <a:srgbClr val="FFFFFF"/>
-                </a:solidFill>
-                <a:latin typeface="Calibri" pitchFamily="34" charset="0"/>
-                <a:ea typeface="Calibri" pitchFamily="34" charset="-122"/>
-                <a:cs typeface="Calibri" pitchFamily="34" charset="-120"/>
-              </a:rPr>
-              <a:t>9 days  ·  Jun 12 – 20</a:t>
+                  <a:srgbClr val="345671"/>
+                </a:solidFill>
+                <a:latin typeface="Calibri" pitchFamily="34" charset="0"/>
+                <a:ea typeface="Calibri" pitchFamily="34" charset="-122"/>
+                <a:cs typeface="Calibri" pitchFamily="34" charset="-120"/>
+              </a:rPr>
+              <a:t>Embryology, surfactant &amp; congenital</a:t>
             </a:r>
             <a:endParaRPr lang="en-US" sz="950" dirty="0"/>
           </a:p>
@@ -2113,24 +2113,24 @@
         </p:nvSpPr>
         <p:spPr>
           <a:xfrm>
-            <a:off x="2427732" y="3502152"/>
-            <a:ext cx="1540764" cy="274320"/>
-          </a:xfrm>
-          <a:prstGeom prst="rect">
-            <a:avLst/>
-          </a:prstGeom>
-          <a:noFill/>
-          <a:ln/>
-        </p:spPr>
-        <p:txBody>
-          <a:bodyPr wrap="square" lIns="0" tIns="0" rIns="0" bIns="0" rtlCol="0" anchor="ctr"/>
-          <a:lstStyle/>
-          <a:p>
-            <a:pPr indent="0" marL="0">
-              <a:buNone/>
-            </a:pPr>
-            <a:r>
-              <a:rPr lang="en-US" sz="850" b="1" dirty="0">
+            <a:off x="4311396" y="3163824"/>
+            <a:ext cx="3287268" cy="173736"/>
+          </a:xfrm>
+          <a:prstGeom prst="rect">
+            <a:avLst/>
+          </a:prstGeom>
+          <a:noFill/>
+          <a:ln/>
+        </p:spPr>
+        <p:txBody>
+          <a:bodyPr wrap="square" lIns="0" tIns="0" rIns="0" bIns="0" rtlCol="0" anchor="ctr"/>
+          <a:lstStyle/>
+          <a:p>
+            <a:pPr indent="0" marL="0">
+              <a:buNone/>
+            </a:pPr>
+            <a:r>
+              <a:rPr lang="en-US" sz="950" b="1" dirty="0">
                 <a:solidFill>
                   <a:srgbClr val="059669"/>
                 </a:solidFill>
@@ -2138,13 +2138,13 @@
                 <a:ea typeface="Calibri" pitchFamily="34" charset="-122"/>
                 <a:cs typeface="Calibri" pitchFamily="34" charset="-120"/>
               </a:rPr>
-              <a:t>01  </a:t>
-            </a:r>
-            <a:pPr indent="0" marL="0">
-              <a:buNone/>
-            </a:pPr>
-            <a:r>
-              <a:rPr lang="en-US" sz="850" dirty="0">
+              <a:t>02  </a:t>
+            </a:r>
+            <a:pPr indent="0" marL="0">
+              <a:buNone/>
+            </a:pPr>
+            <a:r>
+              <a:rPr lang="en-US" sz="950" dirty="0">
                 <a:solidFill>
                   <a:srgbClr val="345671"/>
                 </a:solidFill>
@@ -2152,9 +2152,9 @@
                 <a:ea typeface="Calibri" pitchFamily="34" charset="-122"/>
                 <a:cs typeface="Calibri" pitchFamily="34" charset="-120"/>
               </a:rPr>
-              <a:t>Embryology · surfactant</a:t>
-            </a:r>
-            <a:endParaRPr lang="en-US" sz="850" dirty="0"/>
+              <a:t>Anatomy &amp; muscles of breathing</a:t>
+            </a:r>
+            <a:endParaRPr lang="en-US" sz="950" dirty="0"/>
           </a:p>
         </p:txBody>
       </p:sp>
@@ -2166,24 +2166,24 @@
         </p:nvSpPr>
         <p:spPr>
           <a:xfrm>
-            <a:off x="2427732" y="3776472"/>
-            <a:ext cx="1540764" cy="274320"/>
-          </a:xfrm>
-          <a:prstGeom prst="rect">
-            <a:avLst/>
-          </a:prstGeom>
-          <a:noFill/>
-          <a:ln/>
-        </p:spPr>
-        <p:txBody>
-          <a:bodyPr wrap="square" lIns="0" tIns="0" rIns="0" bIns="0" rtlCol="0" anchor="ctr"/>
-          <a:lstStyle/>
-          <a:p>
-            <a:pPr indent="0" marL="0">
-              <a:buNone/>
-            </a:pPr>
-            <a:r>
-              <a:rPr lang="en-US" sz="850" b="1" dirty="0">
+            <a:off x="4311396" y="3337560"/>
+            <a:ext cx="3287268" cy="173736"/>
+          </a:xfrm>
+          <a:prstGeom prst="rect">
+            <a:avLst/>
+          </a:prstGeom>
+          <a:noFill/>
+          <a:ln/>
+        </p:spPr>
+        <p:txBody>
+          <a:bodyPr wrap="square" lIns="0" tIns="0" rIns="0" bIns="0" rtlCol="0" anchor="ctr"/>
+          <a:lstStyle/>
+          <a:p>
+            <a:pPr indent="0" marL="0">
+              <a:buNone/>
+            </a:pPr>
+            <a:r>
+              <a:rPr lang="en-US" sz="950" b="1" dirty="0">
                 <a:solidFill>
                   <a:srgbClr val="059669"/>
                 </a:solidFill>
@@ -2191,13 +2191,13 @@
                 <a:ea typeface="Calibri" pitchFamily="34" charset="-122"/>
                 <a:cs typeface="Calibri" pitchFamily="34" charset="-120"/>
               </a:rPr>
-              <a:t>02  </a:t>
-            </a:r>
-            <a:pPr indent="0" marL="0">
-              <a:buNone/>
-            </a:pPr>
-            <a:r>
-              <a:rPr lang="en-US" sz="850" dirty="0">
+              <a:t>03  </a:t>
+            </a:r>
+            <a:pPr indent="0" marL="0">
+              <a:buNone/>
+            </a:pPr>
+            <a:r>
+              <a:rPr lang="en-US" sz="950" dirty="0">
                 <a:solidFill>
                   <a:srgbClr val="345671"/>
                 </a:solidFill>
@@ -2205,9 +2205,9 @@
                 <a:ea typeface="Calibri" pitchFamily="34" charset="-122"/>
                 <a:cs typeface="Calibri" pitchFamily="34" charset="-120"/>
               </a:rPr>
-              <a:t>Anatomy · diaphragm</a:t>
-            </a:r>
-            <a:endParaRPr lang="en-US" sz="850" dirty="0"/>
+              <a:t>Lung volumes &amp; ventilation</a:t>
+            </a:r>
+            <a:endParaRPr lang="en-US" sz="950" dirty="0"/>
           </a:p>
         </p:txBody>
       </p:sp>
@@ -2219,24 +2219,24 @@
         </p:nvSpPr>
         <p:spPr>
           <a:xfrm>
-            <a:off x="2427732" y="4050792"/>
-            <a:ext cx="1540764" cy="274320"/>
-          </a:xfrm>
-          <a:prstGeom prst="rect">
-            <a:avLst/>
-          </a:prstGeom>
-          <a:noFill/>
-          <a:ln/>
-        </p:spPr>
-        <p:txBody>
-          <a:bodyPr wrap="square" lIns="0" tIns="0" rIns="0" bIns="0" rtlCol="0" anchor="ctr"/>
-          <a:lstStyle/>
-          <a:p>
-            <a:pPr indent="0" marL="0">
-              <a:buNone/>
-            </a:pPr>
-            <a:r>
-              <a:rPr lang="en-US" sz="850" b="1" dirty="0">
+            <a:off x="4311396" y="3511296"/>
+            <a:ext cx="3287268" cy="173736"/>
+          </a:xfrm>
+          <a:prstGeom prst="rect">
+            <a:avLst/>
+          </a:prstGeom>
+          <a:noFill/>
+          <a:ln/>
+        </p:spPr>
+        <p:txBody>
+          <a:bodyPr wrap="square" lIns="0" tIns="0" rIns="0" bIns="0" rtlCol="0" anchor="ctr"/>
+          <a:lstStyle/>
+          <a:p>
+            <a:pPr indent="0" marL="0">
+              <a:buNone/>
+            </a:pPr>
+            <a:r>
+              <a:rPr lang="en-US" sz="950" b="1" dirty="0">
                 <a:solidFill>
                   <a:srgbClr val="059669"/>
                 </a:solidFill>
@@ -2244,13 +2244,13 @@
                 <a:ea typeface="Calibri" pitchFamily="34" charset="-122"/>
                 <a:cs typeface="Calibri" pitchFamily="34" charset="-120"/>
               </a:rPr>
-              <a:t>03  </a:t>
-            </a:r>
-            <a:pPr indent="0" marL="0">
-              <a:buNone/>
-            </a:pPr>
-            <a:r>
-              <a:rPr lang="en-US" sz="850" dirty="0">
+              <a:t>04  </a:t>
+            </a:r>
+            <a:pPr indent="0" marL="0">
+              <a:buNone/>
+            </a:pPr>
+            <a:r>
+              <a:rPr lang="en-US" sz="950" dirty="0">
                 <a:solidFill>
                   <a:srgbClr val="345671"/>
                 </a:solidFill>
@@ -2258,9 +2258,9 @@
                 <a:ea typeface="Calibri" pitchFamily="34" charset="-122"/>
                 <a:cs typeface="Calibri" pitchFamily="34" charset="-120"/>
               </a:rPr>
-              <a:t>Volumes · mechanics</a:t>
-            </a:r>
-            <a:endParaRPr lang="en-US" sz="850" dirty="0"/>
+              <a:t>Gas exchange &amp; V/Q mismatch</a:t>
+            </a:r>
+            <a:endParaRPr lang="en-US" sz="950" dirty="0"/>
           </a:p>
         </p:txBody>
       </p:sp>
@@ -2272,24 +2272,24 @@
         </p:nvSpPr>
         <p:spPr>
           <a:xfrm>
-            <a:off x="2427732" y="4325112"/>
-            <a:ext cx="1540764" cy="274320"/>
-          </a:xfrm>
-          <a:prstGeom prst="rect">
-            <a:avLst/>
-          </a:prstGeom>
-          <a:noFill/>
-          <a:ln/>
-        </p:spPr>
-        <p:txBody>
-          <a:bodyPr wrap="square" lIns="0" tIns="0" rIns="0" bIns="0" rtlCol="0" anchor="ctr"/>
-          <a:lstStyle/>
-          <a:p>
-            <a:pPr indent="0" marL="0">
-              <a:buNone/>
-            </a:pPr>
-            <a:r>
-              <a:rPr lang="en-US" sz="850" b="1" dirty="0">
+            <a:off x="4311396" y="3685032"/>
+            <a:ext cx="3287268" cy="173736"/>
+          </a:xfrm>
+          <a:prstGeom prst="rect">
+            <a:avLst/>
+          </a:prstGeom>
+          <a:noFill/>
+          <a:ln/>
+        </p:spPr>
+        <p:txBody>
+          <a:bodyPr wrap="square" lIns="0" tIns="0" rIns="0" bIns="0" rtlCol="0" anchor="ctr"/>
+          <a:lstStyle/>
+          <a:p>
+            <a:pPr indent="0" marL="0">
+              <a:buNone/>
+            </a:pPr>
+            <a:r>
+              <a:rPr lang="en-US" sz="950" b="1" dirty="0">
                 <a:solidFill>
                   <a:srgbClr val="059669"/>
                 </a:solidFill>
@@ -2297,13 +2297,13 @@
                 <a:ea typeface="Calibri" pitchFamily="34" charset="-122"/>
                 <a:cs typeface="Calibri" pitchFamily="34" charset="-120"/>
               </a:rPr>
-              <a:t>04  </a:t>
-            </a:r>
-            <a:pPr indent="0" marL="0">
-              <a:buNone/>
-            </a:pPr>
-            <a:r>
-              <a:rPr lang="en-US" sz="850" dirty="0">
+              <a:t>05  </a:t>
+            </a:r>
+            <a:pPr indent="0" marL="0">
+              <a:buNone/>
+            </a:pPr>
+            <a:r>
+              <a:rPr lang="en-US" sz="950" dirty="0">
                 <a:solidFill>
                   <a:srgbClr val="345671"/>
                 </a:solidFill>
@@ -2311,9 +2311,9 @@
                 <a:ea typeface="Calibri" pitchFamily="34" charset="-122"/>
                 <a:cs typeface="Calibri" pitchFamily="34" charset="-120"/>
               </a:rPr>
-              <a:t>V/Q · A–a · pulm circ</a:t>
-            </a:r>
-            <a:endParaRPr lang="en-US" sz="850" dirty="0"/>
+              <a:t>Control of breathing &amp; sleep apnea</a:t>
+            </a:r>
+            <a:endParaRPr lang="en-US" sz="950" dirty="0"/>
           </a:p>
         </p:txBody>
       </p:sp>
@@ -2325,24 +2325,24 @@
         </p:nvSpPr>
         <p:spPr>
           <a:xfrm>
-            <a:off x="2427732" y="4599432"/>
-            <a:ext cx="1540764" cy="274320"/>
-          </a:xfrm>
-          <a:prstGeom prst="rect">
-            <a:avLst/>
-          </a:prstGeom>
-          <a:noFill/>
-          <a:ln/>
-        </p:spPr>
-        <p:txBody>
-          <a:bodyPr wrap="square" lIns="0" tIns="0" rIns="0" bIns="0" rtlCol="0" anchor="ctr"/>
-          <a:lstStyle/>
-          <a:p>
-            <a:pPr indent="0" marL="0">
-              <a:buNone/>
-            </a:pPr>
-            <a:r>
-              <a:rPr lang="en-US" sz="850" b="1" dirty="0">
+            <a:off x="4311396" y="3858768"/>
+            <a:ext cx="3287268" cy="173736"/>
+          </a:xfrm>
+          <a:prstGeom prst="rect">
+            <a:avLst/>
+          </a:prstGeom>
+          <a:noFill/>
+          <a:ln/>
+        </p:spPr>
+        <p:txBody>
+          <a:bodyPr wrap="square" lIns="0" tIns="0" rIns="0" bIns="0" rtlCol="0" anchor="ctr"/>
+          <a:lstStyle/>
+          <a:p>
+            <a:pPr indent="0" marL="0">
+              <a:buNone/>
+            </a:pPr>
+            <a:r>
+              <a:rPr lang="en-US" sz="950" b="1" dirty="0">
                 <a:solidFill>
                   <a:srgbClr val="059669"/>
                 </a:solidFill>
@@ -2350,13 +2350,13 @@
                 <a:ea typeface="Calibri" pitchFamily="34" charset="-122"/>
                 <a:cs typeface="Calibri" pitchFamily="34" charset="-120"/>
               </a:rPr>
-              <a:t>05  </a:t>
-            </a:r>
-            <a:pPr indent="0" marL="0">
-              <a:buNone/>
-            </a:pPr>
-            <a:r>
-              <a:rPr lang="en-US" sz="850" dirty="0">
+              <a:t>06  </a:t>
+            </a:r>
+            <a:pPr indent="0" marL="0">
+              <a:buNone/>
+            </a:pPr>
+            <a:r>
+              <a:rPr lang="en-US" sz="950" dirty="0">
                 <a:solidFill>
                   <a:srgbClr val="345671"/>
                 </a:solidFill>
@@ -2364,9 +2364,9 @@
                 <a:ea typeface="Calibri" pitchFamily="34" charset="-122"/>
                 <a:cs typeface="Calibri" pitchFamily="34" charset="-120"/>
               </a:rPr>
-              <a:t>Control · sleep apnea</a:t>
-            </a:r>
-            <a:endParaRPr lang="en-US" sz="850" dirty="0"/>
+              <a:t>Asthma &amp; COPD</a:t>
+            </a:r>
+            <a:endParaRPr lang="en-US" sz="950" dirty="0"/>
           </a:p>
         </p:txBody>
       </p:sp>
@@ -2378,24 +2378,24 @@
         </p:nvSpPr>
         <p:spPr>
           <a:xfrm>
-            <a:off x="2427732" y="4873752"/>
-            <a:ext cx="1540764" cy="274320"/>
-          </a:xfrm>
-          <a:prstGeom prst="rect">
-            <a:avLst/>
-          </a:prstGeom>
-          <a:noFill/>
-          <a:ln/>
-        </p:spPr>
-        <p:txBody>
-          <a:bodyPr wrap="square" lIns="0" tIns="0" rIns="0" bIns="0" rtlCol="0" anchor="ctr"/>
-          <a:lstStyle/>
-          <a:p>
-            <a:pPr indent="0" marL="0">
-              <a:buNone/>
-            </a:pPr>
-            <a:r>
-              <a:rPr lang="en-US" sz="850" b="1" dirty="0">
+            <a:off x="4311396" y="4032504"/>
+            <a:ext cx="3287268" cy="173736"/>
+          </a:xfrm>
+          <a:prstGeom prst="rect">
+            <a:avLst/>
+          </a:prstGeom>
+          <a:noFill/>
+          <a:ln/>
+        </p:spPr>
+        <p:txBody>
+          <a:bodyPr wrap="square" lIns="0" tIns="0" rIns="0" bIns="0" rtlCol="0" anchor="ctr"/>
+          <a:lstStyle/>
+          <a:p>
+            <a:pPr indent="0" marL="0">
+              <a:buNone/>
+            </a:pPr>
+            <a:r>
+              <a:rPr lang="en-US" sz="950" b="1" dirty="0">
                 <a:solidFill>
                   <a:srgbClr val="059669"/>
                 </a:solidFill>
@@ -2403,13 +2403,13 @@
                 <a:ea typeface="Calibri" pitchFamily="34" charset="-122"/>
                 <a:cs typeface="Calibri" pitchFamily="34" charset="-120"/>
               </a:rPr>
-              <a:t>06  </a:t>
-            </a:r>
-            <a:pPr indent="0" marL="0">
-              <a:buNone/>
-            </a:pPr>
-            <a:r>
-              <a:rPr lang="en-US" sz="850" dirty="0">
+              <a:t>07  </a:t>
+            </a:r>
+            <a:pPr indent="0" marL="0">
+              <a:buNone/>
+            </a:pPr>
+            <a:r>
+              <a:rPr lang="en-US" sz="950" dirty="0">
                 <a:solidFill>
                   <a:srgbClr val="345671"/>
                 </a:solidFill>
@@ -2417,9 +2417,9 @@
                 <a:ea typeface="Calibri" pitchFamily="34" charset="-122"/>
                 <a:cs typeface="Calibri" pitchFamily="34" charset="-120"/>
               </a:rPr>
-              <a:t>Upper airway · obstr</a:t>
-            </a:r>
-            <a:endParaRPr lang="en-US" sz="850" dirty="0"/>
+              <a:t>Restrictive disease, ARDS, pneumonia</a:t>
+            </a:r>
+            <a:endParaRPr lang="en-US" sz="950" dirty="0"/>
           </a:p>
         </p:txBody>
       </p:sp>
@@ -2431,24 +2431,24 @@
         </p:nvSpPr>
         <p:spPr>
           <a:xfrm>
-            <a:off x="2427732" y="5148072"/>
-            <a:ext cx="1540764" cy="274320"/>
-          </a:xfrm>
-          <a:prstGeom prst="rect">
-            <a:avLst/>
-          </a:prstGeom>
-          <a:noFill/>
-          <a:ln/>
-        </p:spPr>
-        <p:txBody>
-          <a:bodyPr wrap="square" lIns="0" tIns="0" rIns="0" bIns="0" rtlCol="0" anchor="ctr"/>
-          <a:lstStyle/>
-          <a:p>
-            <a:pPr indent="0" marL="0">
-              <a:buNone/>
-            </a:pPr>
-            <a:r>
-              <a:rPr lang="en-US" sz="850" b="1" dirty="0">
+            <a:off x="4311396" y="4206240"/>
+            <a:ext cx="3287268" cy="173736"/>
+          </a:xfrm>
+          <a:prstGeom prst="rect">
+            <a:avLst/>
+          </a:prstGeom>
+          <a:noFill/>
+          <a:ln/>
+        </p:spPr>
+        <p:txBody>
+          <a:bodyPr wrap="square" lIns="0" tIns="0" rIns="0" bIns="0" rtlCol="0" anchor="ctr"/>
+          <a:lstStyle/>
+          <a:p>
+            <a:pPr indent="0" marL="0">
+              <a:buNone/>
+            </a:pPr>
+            <a:r>
+              <a:rPr lang="en-US" sz="950" b="1" dirty="0">
                 <a:solidFill>
                   <a:srgbClr val="059669"/>
                 </a:solidFill>
@@ -2456,13 +2456,13 @@
                 <a:ea typeface="Calibri" pitchFamily="34" charset="-122"/>
                 <a:cs typeface="Calibri" pitchFamily="34" charset="-120"/>
               </a:rPr>
-              <a:t>07  </a:t>
-            </a:r>
-            <a:pPr indent="0" marL="0">
-              <a:buNone/>
-            </a:pPr>
-            <a:r>
-              <a:rPr lang="en-US" sz="850" dirty="0">
+              <a:t>08  </a:t>
+            </a:r>
+            <a:pPr indent="0" marL="0">
+              <a:buNone/>
+            </a:pPr>
+            <a:r>
+              <a:rPr lang="en-US" sz="950" dirty="0">
                 <a:solidFill>
                   <a:srgbClr val="345671"/>
                 </a:solidFill>
@@ -2470,132 +2470,26 @@
                 <a:ea typeface="Calibri" pitchFamily="34" charset="-122"/>
                 <a:cs typeface="Calibri" pitchFamily="34" charset="-120"/>
               </a:rPr>
-              <a:t>Restrictive · ARDS</a:t>
-            </a:r>
-            <a:endParaRPr lang="en-US" sz="850" dirty="0"/>
-          </a:p>
-        </p:txBody>
-      </p:sp>
-      <p:sp>
-        <p:nvSpPr>
-          <p:cNvPr id="40" name="Text 37"/>
-          <p:cNvSpPr/>
-          <p:nvPr/>
-        </p:nvSpPr>
-        <p:spPr>
-          <a:xfrm>
-            <a:off x="2427732" y="5422392"/>
-            <a:ext cx="1540764" cy="274320"/>
-          </a:xfrm>
-          <a:prstGeom prst="rect">
-            <a:avLst/>
-          </a:prstGeom>
-          <a:noFill/>
-          <a:ln/>
-        </p:spPr>
-        <p:txBody>
-          <a:bodyPr wrap="square" lIns="0" tIns="0" rIns="0" bIns="0" rtlCol="0" anchor="ctr"/>
-          <a:lstStyle/>
-          <a:p>
-            <a:pPr indent="0" marL="0">
-              <a:buNone/>
-            </a:pPr>
-            <a:r>
-              <a:rPr lang="en-US" sz="850" b="1" dirty="0">
-                <a:solidFill>
-                  <a:srgbClr val="059669"/>
-                </a:solidFill>
-                <a:latin typeface="Calibri" pitchFamily="34" charset="0"/>
-                <a:ea typeface="Calibri" pitchFamily="34" charset="-122"/>
-                <a:cs typeface="Calibri" pitchFamily="34" charset="-120"/>
-              </a:rPr>
-              <a:t>08  </a:t>
-            </a:r>
-            <a:pPr indent="0" marL="0">
-              <a:buNone/>
-            </a:pPr>
-            <a:r>
-              <a:rPr lang="en-US" sz="850" dirty="0">
-                <a:solidFill>
-                  <a:srgbClr val="345671"/>
-                </a:solidFill>
-                <a:latin typeface="Calibri" pitchFamily="34" charset="0"/>
-                <a:ea typeface="Calibri" pitchFamily="34" charset="-122"/>
-                <a:cs typeface="Calibri" pitchFamily="34" charset="-120"/>
-              </a:rPr>
-              <a:t>TB · pleural · cancer</a:t>
-            </a:r>
-            <a:endParaRPr lang="en-US" sz="850" dirty="0"/>
-          </a:p>
-        </p:txBody>
-      </p:sp>
-      <p:sp>
-        <p:nvSpPr>
-          <p:cNvPr id="41" name="Text 38"/>
-          <p:cNvSpPr/>
-          <p:nvPr/>
-        </p:nvSpPr>
-        <p:spPr>
-          <a:xfrm>
-            <a:off x="2427732" y="5696712"/>
-            <a:ext cx="1540764" cy="274320"/>
-          </a:xfrm>
-          <a:prstGeom prst="rect">
-            <a:avLst/>
-          </a:prstGeom>
-          <a:noFill/>
-          <a:ln/>
-        </p:spPr>
-        <p:txBody>
-          <a:bodyPr wrap="square" lIns="0" tIns="0" rIns="0" bIns="0" rtlCol="0" anchor="ctr"/>
-          <a:lstStyle/>
-          <a:p>
-            <a:pPr indent="0" marL="0">
-              <a:buNone/>
-            </a:pPr>
-            <a:r>
-              <a:rPr lang="en-US" sz="850" b="1" dirty="0">
-                <a:solidFill>
-                  <a:srgbClr val="059669"/>
-                </a:solidFill>
-                <a:latin typeface="Calibri" pitchFamily="34" charset="0"/>
-                <a:ea typeface="Calibri" pitchFamily="34" charset="-122"/>
-                <a:cs typeface="Calibri" pitchFamily="34" charset="-120"/>
-              </a:rPr>
-              <a:t>09  </a:t>
-            </a:r>
-            <a:pPr indent="0" marL="0">
-              <a:buNone/>
-            </a:pPr>
-            <a:r>
-              <a:rPr lang="en-US" sz="850" dirty="0">
-                <a:solidFill>
-                  <a:srgbClr val="345671"/>
-                </a:solidFill>
-                <a:latin typeface="Calibri" pitchFamily="34" charset="0"/>
-                <a:ea typeface="Calibri" pitchFamily="34" charset="-122"/>
-                <a:cs typeface="Calibri" pitchFamily="34" charset="-120"/>
-              </a:rPr>
-              <a:t>Chapter review</a:t>
-            </a:r>
-            <a:endParaRPr lang="en-US" sz="850" dirty="0"/>
-          </a:p>
-        </p:txBody>
-      </p:sp>
-      <p:sp>
-        <p:nvSpPr>
-          <p:cNvPr id="42" name="Shape 39"/>
-          <p:cNvSpPr/>
-          <p:nvPr/>
-        </p:nvSpPr>
-        <p:spPr>
-          <a:xfrm>
-            <a:off x="4169664" y="2697480"/>
-            <a:ext cx="1723644" cy="4526280"/>
+              <a:t>TB, lung cancer &amp; pharmacology</a:t>
+            </a:r>
+            <a:endParaRPr lang="en-US" sz="950" dirty="0"/>
+          </a:p>
+        </p:txBody>
+      </p:sp>
+      <p:sp>
+        <p:nvSpPr>
+          <p:cNvPr id="40" name="Shape 37"/>
+          <p:cNvSpPr/>
+          <p:nvPr/>
+        </p:nvSpPr>
+        <p:spPr>
+          <a:xfrm>
+            <a:off x="502920" y="4846320"/>
+            <a:ext cx="3543300" cy="2377440"/>
           </a:xfrm>
           <a:prstGeom prst="roundRect">
             <a:avLst>
-              <a:gd name="adj" fmla="val 5305"/>
+              <a:gd name="adj" fmla="val 3846"/>
             </a:avLst>
           </a:prstGeom>
           <a:solidFill>
@@ -2611,14 +2505,14 @@
       </p:sp>
       <p:sp>
         <p:nvSpPr>
-          <p:cNvPr id="43" name="Shape 40"/>
-          <p:cNvSpPr/>
-          <p:nvPr/>
-        </p:nvSpPr>
-        <p:spPr>
-          <a:xfrm>
-            <a:off x="4169664" y="2788920"/>
-            <a:ext cx="1723644" cy="621792"/>
+          <p:cNvPr id="41" name="Shape 38"/>
+          <p:cNvSpPr/>
+          <p:nvPr/>
+        </p:nvSpPr>
+        <p:spPr>
+          <a:xfrm>
+            <a:off x="502920" y="4919472"/>
+            <a:ext cx="3543300" cy="493776"/>
           </a:xfrm>
           <a:prstGeom prst="rect">
             <a:avLst/>
@@ -2636,18 +2530,18 @@
       </p:sp>
       <p:sp>
         <p:nvSpPr>
-          <p:cNvPr id="44" name="Shape 41"/>
-          <p:cNvSpPr/>
-          <p:nvPr/>
-        </p:nvSpPr>
-        <p:spPr>
-          <a:xfrm>
-            <a:off x="4169664" y="2697480"/>
-            <a:ext cx="1723644" cy="713232"/>
+          <p:cNvPr id="42" name="Shape 39"/>
+          <p:cNvSpPr/>
+          <p:nvPr/>
+        </p:nvSpPr>
+        <p:spPr>
+          <a:xfrm>
+            <a:off x="502920" y="4846320"/>
+            <a:ext cx="3543300" cy="566928"/>
           </a:xfrm>
           <a:prstGeom prst="roundRect">
             <a:avLst>
-              <a:gd name="adj" fmla="val 12821"/>
+              <a:gd name="adj" fmla="val 16129"/>
             </a:avLst>
           </a:prstGeom>
           <a:solidFill>
@@ -2663,38 +2557,130 @@
       </p:sp>
       <p:sp>
         <p:nvSpPr>
+          <p:cNvPr id="43" name="Text 40"/>
+          <p:cNvSpPr/>
+          <p:nvPr/>
+        </p:nvSpPr>
+        <p:spPr>
+          <a:xfrm>
+            <a:off x="630936" y="4901184"/>
+            <a:ext cx="3287268" cy="256032"/>
+          </a:xfrm>
+          <a:prstGeom prst="rect">
+            <a:avLst/>
+          </a:prstGeom>
+          <a:noFill/>
+          <a:ln/>
+        </p:spPr>
+        <p:txBody>
+          <a:bodyPr wrap="square" lIns="0" tIns="0" rIns="0" bIns="0" rtlCol="0" anchor="ctr"/>
+          <a:lstStyle/>
+          <a:p>
+            <a:pPr indent="0" marL="0">
+              <a:buNone/>
+            </a:pPr>
+            <a:r>
+              <a:rPr lang="en-US" sz="1300" b="1" spc="100" kern="0" dirty="0">
+                <a:solidFill>
+                  <a:srgbClr val="FFFFFF"/>
+                </a:solidFill>
+                <a:latin typeface="Calibri" pitchFamily="34" charset="0"/>
+                <a:ea typeface="Calibri" pitchFamily="34" charset="-122"/>
+                <a:cs typeface="Calibri" pitchFamily="34" charset="-120"/>
+              </a:rPr>
+              <a:t>EPI &amp; BIOSTATS</a:t>
+            </a:r>
+            <a:endParaRPr lang="en-US" sz="1300" dirty="0"/>
+          </a:p>
+        </p:txBody>
+      </p:sp>
+      <p:sp>
+        <p:nvSpPr>
+          <p:cNvPr id="44" name="Text 41"/>
+          <p:cNvSpPr/>
+          <p:nvPr/>
+        </p:nvSpPr>
+        <p:spPr>
+          <a:xfrm>
+            <a:off x="630936" y="5157216"/>
+            <a:ext cx="3287268" cy="219456"/>
+          </a:xfrm>
+          <a:prstGeom prst="rect">
+            <a:avLst/>
+          </a:prstGeom>
+          <a:noFill/>
+          <a:ln/>
+        </p:spPr>
+        <p:txBody>
+          <a:bodyPr wrap="square" lIns="0" tIns="0" rIns="0" bIns="0" rtlCol="0" anchor="ctr"/>
+          <a:lstStyle/>
+          <a:p>
+            <a:pPr indent="0" marL="0">
+              <a:buNone/>
+            </a:pPr>
+            <a:r>
+              <a:rPr lang="en-US" sz="1000" dirty="0">
+                <a:solidFill>
+                  <a:srgbClr val="FFFFFF"/>
+                </a:solidFill>
+                <a:latin typeface="Calibri" pitchFamily="34" charset="0"/>
+                <a:ea typeface="Calibri" pitchFamily="34" charset="-122"/>
+                <a:cs typeface="Calibri" pitchFamily="34" charset="-120"/>
+              </a:rPr>
+              <a:t>4 days  ·  Jun 19 – 22</a:t>
+            </a:r>
+            <a:endParaRPr lang="en-US" sz="1000" dirty="0"/>
+          </a:p>
+        </p:txBody>
+      </p:sp>
+      <p:sp>
+        <p:nvSpPr>
           <p:cNvPr id="45" name="Text 42"/>
           <p:cNvSpPr/>
           <p:nvPr/>
         </p:nvSpPr>
         <p:spPr>
           <a:xfrm>
-            <a:off x="4261104" y="2788920"/>
-            <a:ext cx="1540764" cy="274320"/>
-          </a:xfrm>
-          <a:prstGeom prst="rect">
-            <a:avLst/>
-          </a:prstGeom>
-          <a:noFill/>
-          <a:ln/>
-        </p:spPr>
-        <p:txBody>
-          <a:bodyPr wrap="square" lIns="0" tIns="0" rIns="0" bIns="0" rtlCol="0" anchor="ctr"/>
-          <a:lstStyle/>
-          <a:p>
-            <a:pPr indent="0" marL="0">
-              <a:buNone/>
-            </a:pPr>
-            <a:r>
-              <a:rPr lang="en-US" sz="1100" b="1" spc="100" kern="0" dirty="0">
-                <a:solidFill>
-                  <a:srgbClr val="FFFFFF"/>
-                </a:solidFill>
-                <a:latin typeface="Calibri" pitchFamily="34" charset="0"/>
-                <a:ea typeface="Calibri" pitchFamily="34" charset="-122"/>
-                <a:cs typeface="Calibri" pitchFamily="34" charset="-120"/>
-              </a:rPr>
-              <a:t>EPI / BIOSTATS</a:t>
+            <a:off x="630936" y="5596128"/>
+            <a:ext cx="3287268" cy="384048"/>
+          </a:xfrm>
+          <a:prstGeom prst="rect">
+            <a:avLst/>
+          </a:prstGeom>
+          <a:noFill/>
+          <a:ln/>
+        </p:spPr>
+        <p:txBody>
+          <a:bodyPr wrap="square" lIns="0" tIns="0" rIns="0" bIns="0" rtlCol="0" anchor="ctr"/>
+          <a:lstStyle/>
+          <a:p>
+            <a:pPr indent="0" marL="0">
+              <a:buNone/>
+            </a:pPr>
+            <a:r>
+              <a:rPr lang="en-US" sz="1100" b="1" dirty="0">
+                <a:solidFill>
+                  <a:srgbClr val="D97706"/>
+                </a:solidFill>
+                <a:latin typeface="Calibri" pitchFamily="34" charset="0"/>
+                <a:ea typeface="Calibri" pitchFamily="34" charset="-122"/>
+                <a:cs typeface="Calibri" pitchFamily="34" charset="-120"/>
+              </a:rPr>
+              <a:t>01  </a:t>
+            </a:r>
+            <a:pPr indent="0" marL="0">
+              <a:buNone/>
+            </a:pPr>
+            <a:r>
+              <a:rPr lang="en-US" sz="1100" dirty="0">
+                <a:solidFill>
+                  <a:srgbClr val="345671"/>
+                </a:solidFill>
+                <a:latin typeface="Calibri" pitchFamily="34" charset="0"/>
+                <a:ea typeface="Calibri" pitchFamily="34" charset="-122"/>
+                <a:cs typeface="Calibri" pitchFamily="34" charset="-120"/>
+              </a:rPr>
+              <a:t>Study designs &amp; levels of evidence</a:t>
             </a:r>
             <a:endParaRPr lang="en-US" sz="1100" dirty="0"/>
           </a:p>
@@ -2708,34 +2694,48 @@
         </p:nvSpPr>
         <p:spPr>
           <a:xfrm>
-            <a:off x="4261104" y="3081528"/>
-            <a:ext cx="1540764" cy="256032"/>
-          </a:xfrm>
-          <a:prstGeom prst="rect">
-            <a:avLst/>
-          </a:prstGeom>
-          <a:noFill/>
-          <a:ln/>
-        </p:spPr>
-        <p:txBody>
-          <a:bodyPr wrap="square" lIns="0" tIns="0" rIns="0" bIns="0" rtlCol="0" anchor="ctr"/>
-          <a:lstStyle/>
-          <a:p>
-            <a:pPr indent="0" marL="0">
-              <a:buNone/>
-            </a:pPr>
-            <a:r>
-              <a:rPr lang="en-US" sz="950" dirty="0">
-                <a:solidFill>
-                  <a:srgbClr val="FFFFFF"/>
-                </a:solidFill>
-                <a:latin typeface="Calibri" pitchFamily="34" charset="0"/>
-                <a:ea typeface="Calibri" pitchFamily="34" charset="-122"/>
-                <a:cs typeface="Calibri" pitchFamily="34" charset="-120"/>
-              </a:rPr>
-              <a:t>4 days  ·  Jun 21 – 24</a:t>
-            </a:r>
-            <a:endParaRPr lang="en-US" sz="950" dirty="0"/>
+            <a:off x="630936" y="5980176"/>
+            <a:ext cx="3287268" cy="384048"/>
+          </a:xfrm>
+          <a:prstGeom prst="rect">
+            <a:avLst/>
+          </a:prstGeom>
+          <a:noFill/>
+          <a:ln/>
+        </p:spPr>
+        <p:txBody>
+          <a:bodyPr wrap="square" lIns="0" tIns="0" rIns="0" bIns="0" rtlCol="0" anchor="ctr"/>
+          <a:lstStyle/>
+          <a:p>
+            <a:pPr indent="0" marL="0">
+              <a:buNone/>
+            </a:pPr>
+            <a:r>
+              <a:rPr lang="en-US" sz="1100" b="1" dirty="0">
+                <a:solidFill>
+                  <a:srgbClr val="D97706"/>
+                </a:solidFill>
+                <a:latin typeface="Calibri" pitchFamily="34" charset="0"/>
+                <a:ea typeface="Calibri" pitchFamily="34" charset="-122"/>
+                <a:cs typeface="Calibri" pitchFamily="34" charset="-120"/>
+              </a:rPr>
+              <a:t>02  </a:t>
+            </a:r>
+            <a:pPr indent="0" marL="0">
+              <a:buNone/>
+            </a:pPr>
+            <a:r>
+              <a:rPr lang="en-US" sz="1100" dirty="0">
+                <a:solidFill>
+                  <a:srgbClr val="345671"/>
+                </a:solidFill>
+                <a:latin typeface="Calibri" pitchFamily="34" charset="0"/>
+                <a:ea typeface="Calibri" pitchFamily="34" charset="-122"/>
+                <a:cs typeface="Calibri" pitchFamily="34" charset="-120"/>
+              </a:rPr>
+              <a:t>Sensitivity, specificity &amp; predictive values</a:t>
+            </a:r>
+            <a:endParaRPr lang="en-US" sz="1100" dirty="0"/>
           </a:p>
         </p:txBody>
       </p:sp>
@@ -2747,24 +2747,24 @@
         </p:nvSpPr>
         <p:spPr>
           <a:xfrm>
-            <a:off x="4261104" y="3502152"/>
-            <a:ext cx="1540764" cy="274320"/>
-          </a:xfrm>
-          <a:prstGeom prst="rect">
-            <a:avLst/>
-          </a:prstGeom>
-          <a:noFill/>
-          <a:ln/>
-        </p:spPr>
-        <p:txBody>
-          <a:bodyPr wrap="square" lIns="0" tIns="0" rIns="0" bIns="0" rtlCol="0" anchor="ctr"/>
-          <a:lstStyle/>
-          <a:p>
-            <a:pPr indent="0" marL="0">
-              <a:buNone/>
-            </a:pPr>
-            <a:r>
-              <a:rPr lang="en-US" sz="850" b="1" dirty="0">
+            <a:off x="630936" y="6364224"/>
+            <a:ext cx="3287268" cy="384048"/>
+          </a:xfrm>
+          <a:prstGeom prst="rect">
+            <a:avLst/>
+          </a:prstGeom>
+          <a:noFill/>
+          <a:ln/>
+        </p:spPr>
+        <p:txBody>
+          <a:bodyPr wrap="square" lIns="0" tIns="0" rIns="0" bIns="0" rtlCol="0" anchor="ctr"/>
+          <a:lstStyle/>
+          <a:p>
+            <a:pPr indent="0" marL="0">
+              <a:buNone/>
+            </a:pPr>
+            <a:r>
+              <a:rPr lang="en-US" sz="1100" b="1" dirty="0">
                 <a:solidFill>
                   <a:srgbClr val="D97706"/>
                 </a:solidFill>
@@ -2772,13 +2772,13 @@
                 <a:ea typeface="Calibri" pitchFamily="34" charset="-122"/>
                 <a:cs typeface="Calibri" pitchFamily="34" charset="-120"/>
               </a:rPr>
-              <a:t>01  </a:t>
-            </a:r>
-            <a:pPr indent="0" marL="0">
-              <a:buNone/>
-            </a:pPr>
-            <a:r>
-              <a:rPr lang="en-US" sz="850" dirty="0">
+              <a:t>03  </a:t>
+            </a:r>
+            <a:pPr indent="0" marL="0">
+              <a:buNone/>
+            </a:pPr>
+            <a:r>
+              <a:rPr lang="en-US" sz="1100" dirty="0">
                 <a:solidFill>
                   <a:srgbClr val="345671"/>
                 </a:solidFill>
@@ -2786,9 +2786,9 @@
                 <a:ea typeface="Calibri" pitchFamily="34" charset="-122"/>
                 <a:cs typeface="Calibri" pitchFamily="34" charset="-120"/>
               </a:rPr>
-              <a:t>Study design · trials</a:t>
-            </a:r>
-            <a:endParaRPr lang="en-US" sz="850" dirty="0"/>
+              <a:t>Risk measures, bias &amp; confounding</a:t>
+            </a:r>
+            <a:endParaRPr lang="en-US" sz="1100" dirty="0"/>
           </a:p>
         </p:txBody>
       </p:sp>
@@ -2800,24 +2800,24 @@
         </p:nvSpPr>
         <p:spPr>
           <a:xfrm>
-            <a:off x="4261104" y="3776472"/>
-            <a:ext cx="1540764" cy="274320"/>
-          </a:xfrm>
-          <a:prstGeom prst="rect">
-            <a:avLst/>
-          </a:prstGeom>
-          <a:noFill/>
-          <a:ln/>
-        </p:spPr>
-        <p:txBody>
-          <a:bodyPr wrap="square" lIns="0" tIns="0" rIns="0" bIns="0" rtlCol="0" anchor="ctr"/>
-          <a:lstStyle/>
-          <a:p>
-            <a:pPr indent="0" marL="0">
-              <a:buNone/>
-            </a:pPr>
-            <a:r>
-              <a:rPr lang="en-US" sz="850" b="1" dirty="0">
+            <a:off x="630936" y="6748272"/>
+            <a:ext cx="3287268" cy="384048"/>
+          </a:xfrm>
+          <a:prstGeom prst="rect">
+            <a:avLst/>
+          </a:prstGeom>
+          <a:noFill/>
+          <a:ln/>
+        </p:spPr>
+        <p:txBody>
+          <a:bodyPr wrap="square" lIns="0" tIns="0" rIns="0" bIns="0" rtlCol="0" anchor="ctr"/>
+          <a:lstStyle/>
+          <a:p>
+            <a:pPr indent="0" marL="0">
+              <a:buNone/>
+            </a:pPr>
+            <a:r>
+              <a:rPr lang="en-US" sz="1100" b="1" dirty="0">
                 <a:solidFill>
                   <a:srgbClr val="D97706"/>
                 </a:solidFill>
@@ -2825,13 +2825,13 @@
                 <a:ea typeface="Calibri" pitchFamily="34" charset="-122"/>
                 <a:cs typeface="Calibri" pitchFamily="34" charset="-120"/>
               </a:rPr>
-              <a:t>02  </a:t>
-            </a:r>
-            <a:pPr indent="0" marL="0">
-              <a:buNone/>
-            </a:pPr>
-            <a:r>
-              <a:rPr lang="en-US" sz="850" dirty="0">
+              <a:t>04  </a:t>
+            </a:r>
+            <a:pPr indent="0" marL="0">
+              <a:buNone/>
+            </a:pPr>
+            <a:r>
+              <a:rPr lang="en-US" sz="1100" dirty="0">
                 <a:solidFill>
                   <a:srgbClr val="345671"/>
                 </a:solidFill>
@@ -2839,132 +2839,26 @@
                 <a:ea typeface="Calibri" pitchFamily="34" charset="-122"/>
                 <a:cs typeface="Calibri" pitchFamily="34" charset="-120"/>
               </a:rPr>
-              <a:t>Sens/spec · PPV/NPV</a:t>
-            </a:r>
-            <a:endParaRPr lang="en-US" sz="850" dirty="0"/>
-          </a:p>
-        </p:txBody>
-      </p:sp>
-      <p:sp>
-        <p:nvSpPr>
-          <p:cNvPr id="49" name="Text 46"/>
-          <p:cNvSpPr/>
-          <p:nvPr/>
-        </p:nvSpPr>
-        <p:spPr>
-          <a:xfrm>
-            <a:off x="4261104" y="4050792"/>
-            <a:ext cx="1540764" cy="274320"/>
-          </a:xfrm>
-          <a:prstGeom prst="rect">
-            <a:avLst/>
-          </a:prstGeom>
-          <a:noFill/>
-          <a:ln/>
-        </p:spPr>
-        <p:txBody>
-          <a:bodyPr wrap="square" lIns="0" tIns="0" rIns="0" bIns="0" rtlCol="0" anchor="ctr"/>
-          <a:lstStyle/>
-          <a:p>
-            <a:pPr indent="0" marL="0">
-              <a:buNone/>
-            </a:pPr>
-            <a:r>
-              <a:rPr lang="en-US" sz="850" b="1" dirty="0">
-                <a:solidFill>
-                  <a:srgbClr val="D97706"/>
-                </a:solidFill>
-                <a:latin typeface="Calibri" pitchFamily="34" charset="0"/>
-                <a:ea typeface="Calibri" pitchFamily="34" charset="-122"/>
-                <a:cs typeface="Calibri" pitchFamily="34" charset="-120"/>
-              </a:rPr>
-              <a:t>03  </a:t>
-            </a:r>
-            <a:pPr indent="0" marL="0">
-              <a:buNone/>
-            </a:pPr>
-            <a:r>
-              <a:rPr lang="en-US" sz="850" dirty="0">
-                <a:solidFill>
-                  <a:srgbClr val="345671"/>
-                </a:solidFill>
-                <a:latin typeface="Calibri" pitchFamily="34" charset="0"/>
-                <a:ea typeface="Calibri" pitchFamily="34" charset="-122"/>
-                <a:cs typeface="Calibri" pitchFamily="34" charset="-120"/>
-              </a:rPr>
-              <a:t>Bias · confounding</a:t>
-            </a:r>
-            <a:endParaRPr lang="en-US" sz="850" dirty="0"/>
-          </a:p>
-        </p:txBody>
-      </p:sp>
-      <p:sp>
-        <p:nvSpPr>
-          <p:cNvPr id="50" name="Text 47"/>
-          <p:cNvSpPr/>
-          <p:nvPr/>
-        </p:nvSpPr>
-        <p:spPr>
-          <a:xfrm>
-            <a:off x="4261104" y="4325112"/>
-            <a:ext cx="1540764" cy="274320"/>
-          </a:xfrm>
-          <a:prstGeom prst="rect">
-            <a:avLst/>
-          </a:prstGeom>
-          <a:noFill/>
-          <a:ln/>
-        </p:spPr>
-        <p:txBody>
-          <a:bodyPr wrap="square" lIns="0" tIns="0" rIns="0" bIns="0" rtlCol="0" anchor="ctr"/>
-          <a:lstStyle/>
-          <a:p>
-            <a:pPr indent="0" marL="0">
-              <a:buNone/>
-            </a:pPr>
-            <a:r>
-              <a:rPr lang="en-US" sz="850" b="1" dirty="0">
-                <a:solidFill>
-                  <a:srgbClr val="D97706"/>
-                </a:solidFill>
-                <a:latin typeface="Calibri" pitchFamily="34" charset="0"/>
-                <a:ea typeface="Calibri" pitchFamily="34" charset="-122"/>
-                <a:cs typeface="Calibri" pitchFamily="34" charset="-120"/>
-              </a:rPr>
-              <a:t>04  </a:t>
-            </a:r>
-            <a:pPr indent="0" marL="0">
-              <a:buNone/>
-            </a:pPr>
-            <a:r>
-              <a:rPr lang="en-US" sz="850" dirty="0">
-                <a:solidFill>
-                  <a:srgbClr val="345671"/>
-                </a:solidFill>
-                <a:latin typeface="Calibri" pitchFamily="34" charset="0"/>
-                <a:ea typeface="Calibri" pitchFamily="34" charset="-122"/>
-                <a:cs typeface="Calibri" pitchFamily="34" charset="-120"/>
-              </a:rPr>
-              <a:t>Ethics · health policy</a:t>
-            </a:r>
-            <a:endParaRPr lang="en-US" sz="850" dirty="0"/>
-          </a:p>
-        </p:txBody>
-      </p:sp>
-      <p:sp>
-        <p:nvSpPr>
-          <p:cNvPr id="51" name="Shape 48"/>
-          <p:cNvSpPr/>
-          <p:nvPr/>
-        </p:nvSpPr>
-        <p:spPr>
-          <a:xfrm>
-            <a:off x="6003036" y="2697480"/>
-            <a:ext cx="1723644" cy="4526280"/>
+              <a:t>Statistical tests &amp; confidence intervals</a:t>
+            </a:r>
+            <a:endParaRPr lang="en-US" sz="1100" dirty="0"/>
+          </a:p>
+        </p:txBody>
+      </p:sp>
+      <p:sp>
+        <p:nvSpPr>
+          <p:cNvPr id="49" name="Shape 46"/>
+          <p:cNvSpPr/>
+          <p:nvPr/>
+        </p:nvSpPr>
+        <p:spPr>
+          <a:xfrm>
+            <a:off x="4183380" y="4846320"/>
+            <a:ext cx="3543300" cy="2377440"/>
           </a:xfrm>
           <a:prstGeom prst="roundRect">
             <a:avLst>
-              <a:gd name="adj" fmla="val 5305"/>
+              <a:gd name="adj" fmla="val 3846"/>
             </a:avLst>
           </a:prstGeom>
           <a:solidFill>
@@ -2980,14 +2874,14 @@
       </p:sp>
       <p:sp>
         <p:nvSpPr>
-          <p:cNvPr id="52" name="Shape 49"/>
-          <p:cNvSpPr/>
-          <p:nvPr/>
-        </p:nvSpPr>
-        <p:spPr>
-          <a:xfrm>
-            <a:off x="6003036" y="2788920"/>
-            <a:ext cx="1723644" cy="621792"/>
+          <p:cNvPr id="50" name="Shape 47"/>
+          <p:cNvSpPr/>
+          <p:nvPr/>
+        </p:nvSpPr>
+        <p:spPr>
+          <a:xfrm>
+            <a:off x="4183380" y="4919472"/>
+            <a:ext cx="3543300" cy="493776"/>
           </a:xfrm>
           <a:prstGeom prst="rect">
             <a:avLst/>
@@ -3005,18 +2899,18 @@
       </p:sp>
       <p:sp>
         <p:nvSpPr>
-          <p:cNvPr id="53" name="Shape 50"/>
-          <p:cNvSpPr/>
-          <p:nvPr/>
-        </p:nvSpPr>
-        <p:spPr>
-          <a:xfrm>
-            <a:off x="6003036" y="2697480"/>
-            <a:ext cx="1723644" cy="713232"/>
+          <p:cNvPr id="51" name="Shape 48"/>
+          <p:cNvSpPr/>
+          <p:nvPr/>
+        </p:nvSpPr>
+        <p:spPr>
+          <a:xfrm>
+            <a:off x="4183380" y="4846320"/>
+            <a:ext cx="3543300" cy="566928"/>
           </a:xfrm>
           <a:prstGeom prst="roundRect">
             <a:avLst>
-              <a:gd name="adj" fmla="val 12821"/>
+              <a:gd name="adj" fmla="val 16129"/>
             </a:avLst>
           </a:prstGeom>
           <a:solidFill>
@@ -3032,40 +2926,132 @@
       </p:sp>
       <p:sp>
         <p:nvSpPr>
+          <p:cNvPr id="52" name="Text 49"/>
+          <p:cNvSpPr/>
+          <p:nvPr/>
+        </p:nvSpPr>
+        <p:spPr>
+          <a:xfrm>
+            <a:off x="4311396" y="4901184"/>
+            <a:ext cx="3287268" cy="256032"/>
+          </a:xfrm>
+          <a:prstGeom prst="rect">
+            <a:avLst/>
+          </a:prstGeom>
+          <a:noFill/>
+          <a:ln/>
+        </p:spPr>
+        <p:txBody>
+          <a:bodyPr wrap="square" lIns="0" tIns="0" rIns="0" bIns="0" rtlCol="0" anchor="ctr"/>
+          <a:lstStyle/>
+          <a:p>
+            <a:pPr indent="0" marL="0">
+              <a:buNone/>
+            </a:pPr>
+            <a:r>
+              <a:rPr lang="en-US" sz="1300" b="1" spc="100" kern="0" dirty="0">
+                <a:solidFill>
+                  <a:srgbClr val="FFFFFF"/>
+                </a:solidFill>
+                <a:latin typeface="Calibri" pitchFamily="34" charset="0"/>
+                <a:ea typeface="Calibri" pitchFamily="34" charset="-122"/>
+                <a:cs typeface="Calibri" pitchFamily="34" charset="-120"/>
+              </a:rPr>
+              <a:t>GENERAL PATHOLOGY</a:t>
+            </a:r>
+            <a:endParaRPr lang="en-US" sz="1300" dirty="0"/>
+          </a:p>
+        </p:txBody>
+      </p:sp>
+      <p:sp>
+        <p:nvSpPr>
+          <p:cNvPr id="53" name="Text 50"/>
+          <p:cNvSpPr/>
+          <p:nvPr/>
+        </p:nvSpPr>
+        <p:spPr>
+          <a:xfrm>
+            <a:off x="4311396" y="5157216"/>
+            <a:ext cx="3287268" cy="219456"/>
+          </a:xfrm>
+          <a:prstGeom prst="rect">
+            <a:avLst/>
+          </a:prstGeom>
+          <a:noFill/>
+          <a:ln/>
+        </p:spPr>
+        <p:txBody>
+          <a:bodyPr wrap="square" lIns="0" tIns="0" rIns="0" bIns="0" rtlCol="0" anchor="ctr"/>
+          <a:lstStyle/>
+          <a:p>
+            <a:pPr indent="0" marL="0">
+              <a:buNone/>
+            </a:pPr>
+            <a:r>
+              <a:rPr lang="en-US" sz="1000" dirty="0">
+                <a:solidFill>
+                  <a:srgbClr val="FFFFFF"/>
+                </a:solidFill>
+                <a:latin typeface="Calibri" pitchFamily="34" charset="0"/>
+                <a:ea typeface="Calibri" pitchFamily="34" charset="-122"/>
+                <a:cs typeface="Calibri" pitchFamily="34" charset="-120"/>
+              </a:rPr>
+              <a:t>8 days  ·  Jun 23 – 30</a:t>
+            </a:r>
+            <a:endParaRPr lang="en-US" sz="1000" dirty="0"/>
+          </a:p>
+        </p:txBody>
+      </p:sp>
+      <p:sp>
+        <p:nvSpPr>
           <p:cNvPr id="54" name="Text 51"/>
           <p:cNvSpPr/>
           <p:nvPr/>
         </p:nvSpPr>
         <p:spPr>
           <a:xfrm>
-            <a:off x="6094476" y="2788920"/>
-            <a:ext cx="1540764" cy="274320"/>
-          </a:xfrm>
-          <a:prstGeom prst="rect">
-            <a:avLst/>
-          </a:prstGeom>
-          <a:noFill/>
-          <a:ln/>
-        </p:spPr>
-        <p:txBody>
-          <a:bodyPr wrap="square" lIns="0" tIns="0" rIns="0" bIns="0" rtlCol="0" anchor="ctr"/>
-          <a:lstStyle/>
-          <a:p>
-            <a:pPr indent="0" marL="0">
-              <a:buNone/>
-            </a:pPr>
-            <a:r>
-              <a:rPr lang="en-US" sz="1100" b="1" spc="100" kern="0" dirty="0">
-                <a:solidFill>
-                  <a:srgbClr val="FFFFFF"/>
-                </a:solidFill>
-                <a:latin typeface="Calibri" pitchFamily="34" charset="0"/>
-                <a:ea typeface="Calibri" pitchFamily="34" charset="-122"/>
-                <a:cs typeface="Calibri" pitchFamily="34" charset="-120"/>
-              </a:rPr>
-              <a:t>GEN. PATHOLOGY</a:t>
-            </a:r>
-            <a:endParaRPr lang="en-US" sz="1100" dirty="0"/>
+            <a:off x="4311396" y="5504688"/>
+            <a:ext cx="3287268" cy="173736"/>
+          </a:xfrm>
+          <a:prstGeom prst="rect">
+            <a:avLst/>
+          </a:prstGeom>
+          <a:noFill/>
+          <a:ln/>
+        </p:spPr>
+        <p:txBody>
+          <a:bodyPr wrap="square" lIns="0" tIns="0" rIns="0" bIns="0" rtlCol="0" anchor="ctr"/>
+          <a:lstStyle/>
+          <a:p>
+            <a:pPr indent="0" marL="0">
+              <a:buNone/>
+            </a:pPr>
+            <a:r>
+              <a:rPr lang="en-US" sz="950" b="1" dirty="0">
+                <a:solidFill>
+                  <a:srgbClr val="7C3AED"/>
+                </a:solidFill>
+                <a:latin typeface="Calibri" pitchFamily="34" charset="0"/>
+                <a:ea typeface="Calibri" pitchFamily="34" charset="-122"/>
+                <a:cs typeface="Calibri" pitchFamily="34" charset="-120"/>
+              </a:rPr>
+              <a:t>01  </a:t>
+            </a:r>
+            <a:pPr indent="0" marL="0">
+              <a:buNone/>
+            </a:pPr>
+            <a:r>
+              <a:rPr lang="en-US" sz="950" dirty="0">
+                <a:solidFill>
+                  <a:srgbClr val="345671"/>
+                </a:solidFill>
+                <a:latin typeface="Calibri" pitchFamily="34" charset="0"/>
+                <a:ea typeface="Calibri" pitchFamily="34" charset="-122"/>
+                <a:cs typeface="Calibri" pitchFamily="34" charset="-120"/>
+              </a:rPr>
+              <a:t>Cellular adaptations &amp; apoptosis</a:t>
+            </a:r>
+            <a:endParaRPr lang="en-US" sz="950" dirty="0"/>
           </a:p>
         </p:txBody>
       </p:sp>
@@ -3077,32 +3063,46 @@
         </p:nvSpPr>
         <p:spPr>
           <a:xfrm>
-            <a:off x="6094476" y="3081528"/>
-            <a:ext cx="1540764" cy="256032"/>
-          </a:xfrm>
-          <a:prstGeom prst="rect">
-            <a:avLst/>
-          </a:prstGeom>
-          <a:noFill/>
-          <a:ln/>
-        </p:spPr>
-        <p:txBody>
-          <a:bodyPr wrap="square" lIns="0" tIns="0" rIns="0" bIns="0" rtlCol="0" anchor="ctr"/>
-          <a:lstStyle/>
-          <a:p>
+            <a:off x="4311396" y="5678424"/>
+            <a:ext cx="3287268" cy="173736"/>
+          </a:xfrm>
+          <a:prstGeom prst="rect">
+            <a:avLst/>
+          </a:prstGeom>
+          <a:noFill/>
+          <a:ln/>
+        </p:spPr>
+        <p:txBody>
+          <a:bodyPr wrap="square" lIns="0" tIns="0" rIns="0" bIns="0" rtlCol="0" anchor="ctr"/>
+          <a:lstStyle/>
+          <a:p>
+            <a:pPr indent="0" marL="0">
+              <a:buNone/>
+            </a:pPr>
+            <a:r>
+              <a:rPr lang="en-US" sz="950" b="1" dirty="0">
+                <a:solidFill>
+                  <a:srgbClr val="7C3AED"/>
+                </a:solidFill>
+                <a:latin typeface="Calibri" pitchFamily="34" charset="0"/>
+                <a:ea typeface="Calibri" pitchFamily="34" charset="-122"/>
+                <a:cs typeface="Calibri" pitchFamily="34" charset="-120"/>
+              </a:rPr>
+              <a:t>02  </a:t>
+            </a:r>
             <a:pPr indent="0" marL="0">
               <a:buNone/>
             </a:pPr>
             <a:r>
               <a:rPr lang="en-US" sz="950" dirty="0">
                 <a:solidFill>
-                  <a:srgbClr val="FFFFFF"/>
-                </a:solidFill>
-                <a:latin typeface="Calibri" pitchFamily="34" charset="0"/>
-                <a:ea typeface="Calibri" pitchFamily="34" charset="-122"/>
-                <a:cs typeface="Calibri" pitchFamily="34" charset="-120"/>
-              </a:rPr>
-              <a:t>8 days  ·  Jun 25 – Jul 2</a:t>
+                  <a:srgbClr val="345671"/>
+                </a:solidFill>
+                <a:latin typeface="Calibri" pitchFamily="34" charset="0"/>
+                <a:ea typeface="Calibri" pitchFamily="34" charset="-122"/>
+                <a:cs typeface="Calibri" pitchFamily="34" charset="-120"/>
+              </a:rPr>
+              <a:t>Necrosis, ischemia &amp; free radicals</a:t>
             </a:r>
             <a:endParaRPr lang="en-US" sz="950" dirty="0"/>
           </a:p>
@@ -3116,24 +3116,24 @@
         </p:nvSpPr>
         <p:spPr>
           <a:xfrm>
-            <a:off x="6094476" y="3502152"/>
-            <a:ext cx="1540764" cy="274320"/>
-          </a:xfrm>
-          <a:prstGeom prst="rect">
-            <a:avLst/>
-          </a:prstGeom>
-          <a:noFill/>
-          <a:ln/>
-        </p:spPr>
-        <p:txBody>
-          <a:bodyPr wrap="square" lIns="0" tIns="0" rIns="0" bIns="0" rtlCol="0" anchor="ctr"/>
-          <a:lstStyle/>
-          <a:p>
-            <a:pPr indent="0" marL="0">
-              <a:buNone/>
-            </a:pPr>
-            <a:r>
-              <a:rPr lang="en-US" sz="850" b="1" dirty="0">
+            <a:off x="4311396" y="5852160"/>
+            <a:ext cx="3287268" cy="173736"/>
+          </a:xfrm>
+          <a:prstGeom prst="rect">
+            <a:avLst/>
+          </a:prstGeom>
+          <a:noFill/>
+          <a:ln/>
+        </p:spPr>
+        <p:txBody>
+          <a:bodyPr wrap="square" lIns="0" tIns="0" rIns="0" bIns="0" rtlCol="0" anchor="ctr"/>
+          <a:lstStyle/>
+          <a:p>
+            <a:pPr indent="0" marL="0">
+              <a:buNone/>
+            </a:pPr>
+            <a:r>
+              <a:rPr lang="en-US" sz="950" b="1" dirty="0">
                 <a:solidFill>
                   <a:srgbClr val="7C3AED"/>
                 </a:solidFill>
@@ -3141,13 +3141,13 @@
                 <a:ea typeface="Calibri" pitchFamily="34" charset="-122"/>
                 <a:cs typeface="Calibri" pitchFamily="34" charset="-120"/>
               </a:rPr>
-              <a:t>01  </a:t>
-            </a:r>
-            <a:pPr indent="0" marL="0">
-              <a:buNone/>
-            </a:pPr>
-            <a:r>
-              <a:rPr lang="en-US" sz="850" dirty="0">
+              <a:t>03  </a:t>
+            </a:r>
+            <a:pPr indent="0" marL="0">
+              <a:buNone/>
+            </a:pPr>
+            <a:r>
+              <a:rPr lang="en-US" sz="950" dirty="0">
                 <a:solidFill>
                   <a:srgbClr val="345671"/>
                 </a:solidFill>
@@ -3155,9 +3155,9 @@
                 <a:ea typeface="Calibri" pitchFamily="34" charset="-122"/>
                 <a:cs typeface="Calibri" pitchFamily="34" charset="-120"/>
               </a:rPr>
-              <a:t>Adaptations · apoptosis</a:t>
-            </a:r>
-            <a:endParaRPr lang="en-US" sz="850" dirty="0"/>
+              <a:t>Acute inflammation</a:t>
+            </a:r>
+            <a:endParaRPr lang="en-US" sz="950" dirty="0"/>
           </a:p>
         </p:txBody>
       </p:sp>
@@ -3169,24 +3169,24 @@
         </p:nvSpPr>
         <p:spPr>
           <a:xfrm>
-            <a:off x="6094476" y="3776472"/>
-            <a:ext cx="1540764" cy="274320"/>
-          </a:xfrm>
-          <a:prstGeom prst="rect">
-            <a:avLst/>
-          </a:prstGeom>
-          <a:noFill/>
-          <a:ln/>
-        </p:spPr>
-        <p:txBody>
-          <a:bodyPr wrap="square" lIns="0" tIns="0" rIns="0" bIns="0" rtlCol="0" anchor="ctr"/>
-          <a:lstStyle/>
-          <a:p>
-            <a:pPr indent="0" marL="0">
-              <a:buNone/>
-            </a:pPr>
-            <a:r>
-              <a:rPr lang="en-US" sz="850" b="1" dirty="0">
+            <a:off x="4311396" y="6025896"/>
+            <a:ext cx="3287268" cy="173736"/>
+          </a:xfrm>
+          <a:prstGeom prst="rect">
+            <a:avLst/>
+          </a:prstGeom>
+          <a:noFill/>
+          <a:ln/>
+        </p:spPr>
+        <p:txBody>
+          <a:bodyPr wrap="square" lIns="0" tIns="0" rIns="0" bIns="0" rtlCol="0" anchor="ctr"/>
+          <a:lstStyle/>
+          <a:p>
+            <a:pPr indent="0" marL="0">
+              <a:buNone/>
+            </a:pPr>
+            <a:r>
+              <a:rPr lang="en-US" sz="950" b="1" dirty="0">
                 <a:solidFill>
                   <a:srgbClr val="7C3AED"/>
                 </a:solidFill>
@@ -3194,13 +3194,13 @@
                 <a:ea typeface="Calibri" pitchFamily="34" charset="-122"/>
                 <a:cs typeface="Calibri" pitchFamily="34" charset="-120"/>
               </a:rPr>
-              <a:t>02  </a:t>
-            </a:r>
-            <a:pPr indent="0" marL="0">
-              <a:buNone/>
-            </a:pPr>
-            <a:r>
-              <a:rPr lang="en-US" sz="850" dirty="0">
+              <a:t>04  </a:t>
+            </a:r>
+            <a:pPr indent="0" marL="0">
+              <a:buNone/>
+            </a:pPr>
+            <a:r>
+              <a:rPr lang="en-US" sz="950" dirty="0">
                 <a:solidFill>
                   <a:srgbClr val="345671"/>
                 </a:solidFill>
@@ -3208,9 +3208,9 @@
                 <a:ea typeface="Calibri" pitchFamily="34" charset="-122"/>
                 <a:cs typeface="Calibri" pitchFamily="34" charset="-120"/>
               </a:rPr>
-              <a:t>Necrosis · free radicals</a:t>
-            </a:r>
-            <a:endParaRPr lang="en-US" sz="850" dirty="0"/>
+              <a:t>Chronic inflammation &amp; repair</a:t>
+            </a:r>
+            <a:endParaRPr lang="en-US" sz="950" dirty="0"/>
           </a:p>
         </p:txBody>
       </p:sp>
@@ -3222,24 +3222,24 @@
         </p:nvSpPr>
         <p:spPr>
           <a:xfrm>
-            <a:off x="6094476" y="4050792"/>
-            <a:ext cx="1540764" cy="274320"/>
-          </a:xfrm>
-          <a:prstGeom prst="rect">
-            <a:avLst/>
-          </a:prstGeom>
-          <a:noFill/>
-          <a:ln/>
-        </p:spPr>
-        <p:txBody>
-          <a:bodyPr wrap="square" lIns="0" tIns="0" rIns="0" bIns="0" rtlCol="0" anchor="ctr"/>
-          <a:lstStyle/>
-          <a:p>
-            <a:pPr indent="0" marL="0">
-              <a:buNone/>
-            </a:pPr>
-            <a:r>
-              <a:rPr lang="en-US" sz="850" b="1" dirty="0">
+            <a:off x="4311396" y="6199632"/>
+            <a:ext cx="3287268" cy="173736"/>
+          </a:xfrm>
+          <a:prstGeom prst="rect">
+            <a:avLst/>
+          </a:prstGeom>
+          <a:noFill/>
+          <a:ln/>
+        </p:spPr>
+        <p:txBody>
+          <a:bodyPr wrap="square" lIns="0" tIns="0" rIns="0" bIns="0" rtlCol="0" anchor="ctr"/>
+          <a:lstStyle/>
+          <a:p>
+            <a:pPr indent="0" marL="0">
+              <a:buNone/>
+            </a:pPr>
+            <a:r>
+              <a:rPr lang="en-US" sz="950" b="1" dirty="0">
                 <a:solidFill>
                   <a:srgbClr val="7C3AED"/>
                 </a:solidFill>
@@ -3247,13 +3247,13 @@
                 <a:ea typeface="Calibri" pitchFamily="34" charset="-122"/>
                 <a:cs typeface="Calibri" pitchFamily="34" charset="-120"/>
               </a:rPr>
-              <a:t>03  </a:t>
-            </a:r>
-            <a:pPr indent="0" marL="0">
-              <a:buNone/>
-            </a:pPr>
-            <a:r>
-              <a:rPr lang="en-US" sz="850" dirty="0">
+              <a:t>05  </a:t>
+            </a:r>
+            <a:pPr indent="0" marL="0">
+              <a:buNone/>
+            </a:pPr>
+            <a:r>
+              <a:rPr lang="en-US" sz="950" dirty="0">
                 <a:solidFill>
                   <a:srgbClr val="345671"/>
                 </a:solidFill>
@@ -3261,9 +3261,9 @@
                 <a:ea typeface="Calibri" pitchFamily="34" charset="-122"/>
                 <a:cs typeface="Calibri" pitchFamily="34" charset="-120"/>
               </a:rPr>
-              <a:t>Acute inflammation</a:t>
-            </a:r>
-            <a:endParaRPr lang="en-US" sz="850" dirty="0"/>
+              <a:t>Neoplasia I — hallmarks &amp; metastases</a:t>
+            </a:r>
+            <a:endParaRPr lang="en-US" sz="950" dirty="0"/>
           </a:p>
         </p:txBody>
       </p:sp>
@@ -3275,24 +3275,24 @@
         </p:nvSpPr>
         <p:spPr>
           <a:xfrm>
-            <a:off x="6094476" y="4325112"/>
-            <a:ext cx="1540764" cy="274320"/>
-          </a:xfrm>
-          <a:prstGeom prst="rect">
-            <a:avLst/>
-          </a:prstGeom>
-          <a:noFill/>
-          <a:ln/>
-        </p:spPr>
-        <p:txBody>
-          <a:bodyPr wrap="square" lIns="0" tIns="0" rIns="0" bIns="0" rtlCol="0" anchor="ctr"/>
-          <a:lstStyle/>
-          <a:p>
-            <a:pPr indent="0" marL="0">
-              <a:buNone/>
-            </a:pPr>
-            <a:r>
-              <a:rPr lang="en-US" sz="850" b="1" dirty="0">
+            <a:off x="4311396" y="6373368"/>
+            <a:ext cx="3287268" cy="173736"/>
+          </a:xfrm>
+          <a:prstGeom prst="rect">
+            <a:avLst/>
+          </a:prstGeom>
+          <a:noFill/>
+          <a:ln/>
+        </p:spPr>
+        <p:txBody>
+          <a:bodyPr wrap="square" lIns="0" tIns="0" rIns="0" bIns="0" rtlCol="0" anchor="ctr"/>
+          <a:lstStyle/>
+          <a:p>
+            <a:pPr indent="0" marL="0">
+              <a:buNone/>
+            </a:pPr>
+            <a:r>
+              <a:rPr lang="en-US" sz="950" b="1" dirty="0">
                 <a:solidFill>
                   <a:srgbClr val="7C3AED"/>
                 </a:solidFill>
@@ -3300,13 +3300,13 @@
                 <a:ea typeface="Calibri" pitchFamily="34" charset="-122"/>
                 <a:cs typeface="Calibri" pitchFamily="34" charset="-120"/>
               </a:rPr>
-              <a:t>04  </a:t>
-            </a:r>
-            <a:pPr indent="0" marL="0">
-              <a:buNone/>
-            </a:pPr>
-            <a:r>
-              <a:rPr lang="en-US" sz="850" dirty="0">
+              <a:t>06  </a:t>
+            </a:r>
+            <a:pPr indent="0" marL="0">
+              <a:buNone/>
+            </a:pPr>
+            <a:r>
+              <a:rPr lang="en-US" sz="950" dirty="0">
                 <a:solidFill>
                   <a:srgbClr val="345671"/>
                 </a:solidFill>
@@ -3314,9 +3314,9 @@
                 <a:ea typeface="Calibri" pitchFamily="34" charset="-122"/>
                 <a:cs typeface="Calibri" pitchFamily="34" charset="-120"/>
               </a:rPr>
-              <a:t>Chronic inflam · repair</a:t>
-            </a:r>
-            <a:endParaRPr lang="en-US" sz="850" dirty="0"/>
+              <a:t>Neoplasia II — oncogenes &amp; TSGs</a:t>
+            </a:r>
+            <a:endParaRPr lang="en-US" sz="950" dirty="0"/>
           </a:p>
         </p:txBody>
       </p:sp>
@@ -3328,24 +3328,24 @@
         </p:nvSpPr>
         <p:spPr>
           <a:xfrm>
-            <a:off x="6094476" y="4599432"/>
-            <a:ext cx="1540764" cy="274320"/>
-          </a:xfrm>
-          <a:prstGeom prst="rect">
-            <a:avLst/>
-          </a:prstGeom>
-          <a:noFill/>
-          <a:ln/>
-        </p:spPr>
-        <p:txBody>
-          <a:bodyPr wrap="square" lIns="0" tIns="0" rIns="0" bIns="0" rtlCol="0" anchor="ctr"/>
-          <a:lstStyle/>
-          <a:p>
-            <a:pPr indent="0" marL="0">
-              <a:buNone/>
-            </a:pPr>
-            <a:r>
-              <a:rPr lang="en-US" sz="850" b="1" dirty="0">
+            <a:off x="4311396" y="6547104"/>
+            <a:ext cx="3287268" cy="173736"/>
+          </a:xfrm>
+          <a:prstGeom prst="rect">
+            <a:avLst/>
+          </a:prstGeom>
+          <a:noFill/>
+          <a:ln/>
+        </p:spPr>
+        <p:txBody>
+          <a:bodyPr wrap="square" lIns="0" tIns="0" rIns="0" bIns="0" rtlCol="0" anchor="ctr"/>
+          <a:lstStyle/>
+          <a:p>
+            <a:pPr indent="0" marL="0">
+              <a:buNone/>
+            </a:pPr>
+            <a:r>
+              <a:rPr lang="en-US" sz="950" b="1" dirty="0">
                 <a:solidFill>
                   <a:srgbClr val="7C3AED"/>
                 </a:solidFill>
@@ -3353,13 +3353,13 @@
                 <a:ea typeface="Calibri" pitchFamily="34" charset="-122"/>
                 <a:cs typeface="Calibri" pitchFamily="34" charset="-120"/>
               </a:rPr>
-              <a:t>05  </a:t>
-            </a:r>
-            <a:pPr indent="0" marL="0">
-              <a:buNone/>
-            </a:pPr>
-            <a:r>
-              <a:rPr lang="en-US" sz="850" dirty="0">
+              <a:t>07  </a:t>
+            </a:r>
+            <a:pPr indent="0" marL="0">
+              <a:buNone/>
+            </a:pPr>
+            <a:r>
+              <a:rPr lang="en-US" sz="950" dirty="0">
                 <a:solidFill>
                   <a:srgbClr val="345671"/>
                 </a:solidFill>
@@ -3367,9 +3367,9 @@
                 <a:ea typeface="Calibri" pitchFamily="34" charset="-122"/>
                 <a:cs typeface="Calibri" pitchFamily="34" charset="-120"/>
               </a:rPr>
-              <a:t>Neoplasia I · hallmarks</a:t>
-            </a:r>
-            <a:endParaRPr lang="en-US" sz="850" dirty="0"/>
+              <a:t>Neoplasia III — markers &amp; aging</a:t>
+            </a:r>
+            <a:endParaRPr lang="en-US" sz="950" dirty="0"/>
           </a:p>
         </p:txBody>
       </p:sp>
@@ -3381,24 +3381,24 @@
         </p:nvSpPr>
         <p:spPr>
           <a:xfrm>
-            <a:off x="6094476" y="4873752"/>
-            <a:ext cx="1540764" cy="274320"/>
-          </a:xfrm>
-          <a:prstGeom prst="rect">
-            <a:avLst/>
-          </a:prstGeom>
-          <a:noFill/>
-          <a:ln/>
-        </p:spPr>
-        <p:txBody>
-          <a:bodyPr wrap="square" lIns="0" tIns="0" rIns="0" bIns="0" rtlCol="0" anchor="ctr"/>
-          <a:lstStyle/>
-          <a:p>
-            <a:pPr indent="0" marL="0">
-              <a:buNone/>
-            </a:pPr>
-            <a:r>
-              <a:rPr lang="en-US" sz="850" b="1" dirty="0">
+            <a:off x="4311396" y="6720840"/>
+            <a:ext cx="3287268" cy="173736"/>
+          </a:xfrm>
+          <a:prstGeom prst="rect">
+            <a:avLst/>
+          </a:prstGeom>
+          <a:noFill/>
+          <a:ln/>
+        </p:spPr>
+        <p:txBody>
+          <a:bodyPr wrap="square" lIns="0" tIns="0" rIns="0" bIns="0" rtlCol="0" anchor="ctr"/>
+          <a:lstStyle/>
+          <a:p>
+            <a:pPr indent="0" marL="0">
+              <a:buNone/>
+            </a:pPr>
+            <a:r>
+              <a:rPr lang="en-US" sz="950" b="1" dirty="0">
                 <a:solidFill>
                   <a:srgbClr val="7C3AED"/>
                 </a:solidFill>
@@ -3406,13 +3406,13 @@
                 <a:ea typeface="Calibri" pitchFamily="34" charset="-122"/>
                 <a:cs typeface="Calibri" pitchFamily="34" charset="-120"/>
               </a:rPr>
-              <a:t>06  </a:t>
-            </a:r>
-            <a:pPr indent="0" marL="0">
-              <a:buNone/>
-            </a:pPr>
-            <a:r>
-              <a:rPr lang="en-US" sz="850" dirty="0">
+              <a:t>08  </a:t>
+            </a:r>
+            <a:pPr indent="0" marL="0">
+              <a:buNone/>
+            </a:pPr>
+            <a:r>
+              <a:rPr lang="en-US" sz="950" dirty="0">
                 <a:solidFill>
                   <a:srgbClr val="345671"/>
                 </a:solidFill>
@@ -3420,121 +3420,15 @@
                 <a:ea typeface="Calibri" pitchFamily="34" charset="-122"/>
                 <a:cs typeface="Calibri" pitchFamily="34" charset="-120"/>
               </a:rPr>
-              <a:t>Neoplasia II · oncogenes</a:t>
-            </a:r>
-            <a:endParaRPr lang="en-US" sz="850" dirty="0"/>
-          </a:p>
-        </p:txBody>
-      </p:sp>
-      <p:sp>
-        <p:nvSpPr>
-          <p:cNvPr id="62" name="Text 59"/>
-          <p:cNvSpPr/>
-          <p:nvPr/>
-        </p:nvSpPr>
-        <p:spPr>
-          <a:xfrm>
-            <a:off x="6094476" y="5148072"/>
-            <a:ext cx="1540764" cy="274320"/>
-          </a:xfrm>
-          <a:prstGeom prst="rect">
-            <a:avLst/>
-          </a:prstGeom>
-          <a:noFill/>
-          <a:ln/>
-        </p:spPr>
-        <p:txBody>
-          <a:bodyPr wrap="square" lIns="0" tIns="0" rIns="0" bIns="0" rtlCol="0" anchor="ctr"/>
-          <a:lstStyle/>
-          <a:p>
-            <a:pPr indent="0" marL="0">
-              <a:buNone/>
-            </a:pPr>
-            <a:r>
-              <a:rPr lang="en-US" sz="850" b="1" dirty="0">
-                <a:solidFill>
-                  <a:srgbClr val="7C3AED"/>
-                </a:solidFill>
-                <a:latin typeface="Calibri" pitchFamily="34" charset="0"/>
-                <a:ea typeface="Calibri" pitchFamily="34" charset="-122"/>
-                <a:cs typeface="Calibri" pitchFamily="34" charset="-120"/>
-              </a:rPr>
-              <a:t>07  </a:t>
-            </a:r>
-            <a:pPr indent="0" marL="0">
-              <a:buNone/>
-            </a:pPr>
-            <a:r>
-              <a:rPr lang="en-US" sz="850" dirty="0">
-                <a:solidFill>
-                  <a:srgbClr val="345671"/>
-                </a:solidFill>
-                <a:latin typeface="Calibri" pitchFamily="34" charset="0"/>
-                <a:ea typeface="Calibri" pitchFamily="34" charset="-122"/>
-                <a:cs typeface="Calibri" pitchFamily="34" charset="-120"/>
-              </a:rPr>
-              <a:t>Neoplasia III · aging</a:t>
-            </a:r>
-            <a:endParaRPr lang="en-US" sz="850" dirty="0"/>
-          </a:p>
-        </p:txBody>
-      </p:sp>
-      <p:sp>
-        <p:nvSpPr>
-          <p:cNvPr id="63" name="Text 60"/>
-          <p:cNvSpPr/>
-          <p:nvPr/>
-        </p:nvSpPr>
-        <p:spPr>
-          <a:xfrm>
-            <a:off x="6094476" y="5422392"/>
-            <a:ext cx="1540764" cy="274320"/>
-          </a:xfrm>
-          <a:prstGeom prst="rect">
-            <a:avLst/>
-          </a:prstGeom>
-          <a:noFill/>
-          <a:ln/>
-        </p:spPr>
-        <p:txBody>
-          <a:bodyPr wrap="square" lIns="0" tIns="0" rIns="0" bIns="0" rtlCol="0" anchor="ctr"/>
-          <a:lstStyle/>
-          <a:p>
-            <a:pPr indent="0" marL="0">
-              <a:buNone/>
-            </a:pPr>
-            <a:r>
-              <a:rPr lang="en-US" sz="850" b="1" dirty="0">
-                <a:solidFill>
-                  <a:srgbClr val="7C3AED"/>
-                </a:solidFill>
-                <a:latin typeface="Calibri" pitchFamily="34" charset="0"/>
-                <a:ea typeface="Calibri" pitchFamily="34" charset="-122"/>
-                <a:cs typeface="Calibri" pitchFamily="34" charset="-120"/>
-              </a:rPr>
-              <a:t>08  </a:t>
-            </a:r>
-            <a:pPr indent="0" marL="0">
-              <a:buNone/>
-            </a:pPr>
-            <a:r>
-              <a:rPr lang="en-US" sz="850" dirty="0">
-                <a:solidFill>
-                  <a:srgbClr val="345671"/>
-                </a:solidFill>
-                <a:latin typeface="Calibri" pitchFamily="34" charset="0"/>
-                <a:ea typeface="Calibri" pitchFamily="34" charset="-122"/>
-                <a:cs typeface="Calibri" pitchFamily="34" charset="-120"/>
-              </a:rPr>
-              <a:t>Chapter review</a:t>
-            </a:r>
-            <a:endParaRPr lang="en-US" sz="850" dirty="0"/>
-          </a:p>
-        </p:txBody>
-      </p:sp>
-      <p:sp>
-        <p:nvSpPr>
-          <p:cNvPr id="64" name="Shape 61"/>
+              <a:t>General pathology review</a:t>
+            </a:r>
+            <a:endParaRPr lang="en-US" sz="950" dirty="0"/>
+          </a:p>
+        </p:txBody>
+      </p:sp>
+      <p:sp>
+        <p:nvSpPr>
+          <p:cNvPr id="62" name="Shape 59"/>
           <p:cNvSpPr/>
           <p:nvPr/>
         </p:nvSpPr>
@@ -3561,7 +3455,7 @@
       </p:sp>
       <p:sp>
         <p:nvSpPr>
-          <p:cNvPr id="65" name="Text 62"/>
+          <p:cNvPr id="63" name="Text 60"/>
           <p:cNvSpPr/>
           <p:nvPr/>
         </p:nvSpPr>
@@ -3614,7 +3508,7 @@
       </p:sp>
       <p:sp>
         <p:nvSpPr>
-          <p:cNvPr id="66" name="Shape 63"/>
+          <p:cNvPr id="64" name="Shape 61"/>
           <p:cNvSpPr/>
           <p:nvPr/>
         </p:nvSpPr>
@@ -3641,7 +3535,7 @@
       </p:sp>
       <p:pic>
         <p:nvPicPr>
-          <p:cNvPr id="67" name="Image 1" descr="signup_qr.png">    </p:cNvPr>
+          <p:cNvPr id="65" name="Image 1" descr="signup_qr.png">    </p:cNvPr>
           <p:cNvPicPr>
             <a:picLocks noChangeAspect="1"/>
           </p:cNvPicPr>
@@ -3665,7 +3559,7 @@
       </p:pic>
       <p:sp>
         <p:nvSpPr>
-          <p:cNvPr id="68" name="Text 64"/>
+          <p:cNvPr id="66" name="Text 62"/>
           <p:cNvSpPr/>
           <p:nvPr/>
         </p:nvSpPr>
@@ -3704,7 +3598,7 @@
       </p:sp>
       <p:sp>
         <p:nvSpPr>
-          <p:cNvPr id="69" name="Text 65"/>
+          <p:cNvPr id="67" name="Text 63"/>
           <p:cNvSpPr/>
           <p:nvPr/>
         </p:nvSpPr>
@@ -3743,7 +3637,7 @@
       </p:sp>
       <p:sp>
         <p:nvSpPr>
-          <p:cNvPr id="70" name="Text 66"/>
+          <p:cNvPr id="68" name="Text 64"/>
           <p:cNvSpPr/>
           <p:nvPr/>
         </p:nvSpPr>
@@ -3782,7 +3676,7 @@
       </p:sp>
       <p:sp>
         <p:nvSpPr>
-          <p:cNvPr id="71" name="Text 67"/>
+          <p:cNvPr id="69" name="Text 65"/>
           <p:cNvSpPr/>
           <p:nvPr/>
         </p:nvSpPr>
@@ -3835,7 +3729,7 @@
       </p:sp>
       <p:sp>
         <p:nvSpPr>
-          <p:cNvPr id="72" name="Text 68"/>
+          <p:cNvPr id="70" name="Text 66"/>
           <p:cNvSpPr/>
           <p:nvPr/>
         </p:nvSpPr>
@@ -3902,7 +3796,7 @@
       </p:sp>
       <p:sp>
         <p:nvSpPr>
-          <p:cNvPr id="73" name="Shape 69"/>
+          <p:cNvPr id="71" name="Shape 67"/>
           <p:cNvSpPr/>
           <p:nvPr/>
         </p:nvSpPr>
@@ -3925,7 +3819,7 @@
       </p:sp>
       <p:sp>
         <p:nvSpPr>
-          <p:cNvPr id="74" name="Text 70"/>
+          <p:cNvPr id="72" name="Text 68"/>
           <p:cNvSpPr/>
           <p:nvPr/>
         </p:nvSpPr>

</xml_diff>

<commit_message>
Epi block: new Day 2-4 topics; complete 'congenital' wording on flyer
Updates the Epidemiology & Biostatistics block per Allan's
preferred curriculum:
- Day 2: Quantifying risk, demographic transitions, survival analysis
- Day 3: Bias, confounding, and effect modification
- Day 4: Statistical distributions, statistical testing, CIs

Drops the diagnostic test characteristics day (sens/spec/PPV/NPV)
in favor of survival analysis and demographic transitions.

Flyer wording: 'Orientation, embryology & congenital' is completed
to 'congenital heart defects' (CVS) and 'congenital anomalies' (Resp).

Co-Authored-By: Claude Opus 4.7 (1M context) <noreply@anthropic.com>
</commit_message>
<xml_diff>
--- a/outputs/flyers/USMLE_June_Advert.pptx
+++ b/outputs/flyers/USMLE_June_Advert.pptx
@@ -1412,7 +1412,7 @@
                 <a:ea typeface="Calibri" pitchFamily="34" charset="-122"/>
                 <a:cs typeface="Calibri" pitchFamily="34" charset="-120"/>
               </a:rPr>
-              <a:t>Orientation, embryology &amp; congenital</a:t>
+              <a:t>Orientation, embryology &amp; congenital heart defects</a:t>
             </a:r>
             <a:endParaRPr lang="en-US" sz="950" dirty="0"/>
           </a:p>
@@ -2099,7 +2099,7 @@
                 <a:ea typeface="Calibri" pitchFamily="34" charset="-122"/>
                 <a:cs typeface="Calibri" pitchFamily="34" charset="-120"/>
               </a:rPr>
-              <a:t>Embryology, surfactant &amp; congenital</a:t>
+              <a:t>Embryology, surfactant &amp; congenital anomalies</a:t>
             </a:r>
             <a:endParaRPr lang="en-US" sz="950" dirty="0"/>
           </a:p>
@@ -2733,7 +2733,7 @@
                 <a:ea typeface="Calibri" pitchFamily="34" charset="-122"/>
                 <a:cs typeface="Calibri" pitchFamily="34" charset="-120"/>
               </a:rPr>
-              <a:t>Sensitivity, specificity &amp; predictive values</a:t>
+              <a:t>Quantifying risk, transitions &amp; survival analysis</a:t>
             </a:r>
             <a:endParaRPr lang="en-US" sz="1100" dirty="0"/>
           </a:p>
@@ -2786,7 +2786,7 @@
                 <a:ea typeface="Calibri" pitchFamily="34" charset="-122"/>
                 <a:cs typeface="Calibri" pitchFamily="34" charset="-120"/>
               </a:rPr>
-              <a:t>Risk measures, bias &amp; confounding</a:t>
+              <a:t>Bias, confounding &amp; effect modification</a:t>
             </a:r>
             <a:endParaRPr lang="en-US" sz="1100" dirty="0"/>
           </a:p>
@@ -2839,7 +2839,7 @@
                 <a:ea typeface="Calibri" pitchFamily="34" charset="-122"/>
                 <a:cs typeface="Calibri" pitchFamily="34" charset="-120"/>
               </a:rPr>
-              <a:t>Statistical tests &amp; confidence intervals</a:t>
+              <a:t>Statistical distributions, testing &amp; CIs</a:t>
             </a:r>
             <a:endParaRPr lang="en-US" sz="1100" dirty="0"/>
           </a:p>

</xml_diff>

<commit_message>
Flyer: calm white hero, 'JUNE SCHEDULE' kicker, Sens/Spec back on Epi Day 1
- Hero band switches from solid blue to a white tile. Headline in
  deep blue, body in ink, photo gets a thin blue ring.
- Kicker reads 'JUNE SCHEDULE · LIMITED SLOTS' (was 'JUNE COHORT').
- Diagnostic test characteristics (Sens, Spec, PPV, NPV) folded back
  into Epi Day 1 alongside study designs and levels of evidence, so
  they're not dropped from the curriculum.
- Resp Day 8 flyer label completed to 'respiratory pharmacology'.

Co-Authored-By: Claude Opus 4.7 (1M context) <noreply@anthropic.com>
</commit_message>
<xml_diff>
--- a/outputs/flyers/USMLE_June_Advert.pptx
+++ b/outputs/flyers/USMLE_June_Advert.pptx
@@ -883,10 +883,207 @@
         </p:nvSpPr>
         <p:spPr>
           <a:xfrm>
-            <a:off x="0" y="0"/>
-            <a:ext cx="8229600" cy="1828800"/>
-          </a:xfrm>
-          <a:prstGeom prst="rect">
+            <a:off x="0" y="1792224"/>
+            <a:ext cx="8229600" cy="36576"/>
+          </a:xfrm>
+          <a:prstGeom prst="rect">
+            <a:avLst/>
+          </a:prstGeom>
+          <a:solidFill>
+            <a:srgbClr val="D6E8F5"/>
+          </a:solidFill>
+          <a:ln w="12700">
+            <a:solidFill>
+              <a:srgbClr val="D6E8F5"/>
+            </a:solidFill>
+            <a:prstDash val="solid"/>
+          </a:ln>
+        </p:spPr>
+      </p:sp>
+      <p:sp>
+        <p:nvSpPr>
+          <p:cNvPr id="3" name="Shape 1"/>
+          <p:cNvSpPr/>
+          <p:nvPr/>
+        </p:nvSpPr>
+        <p:spPr>
+          <a:xfrm>
+            <a:off x="502920" y="274320"/>
+            <a:ext cx="3337560" cy="329184"/>
+          </a:xfrm>
+          <a:prstGeom prst="roundRect">
+            <a:avLst>
+              <a:gd name="adj" fmla="val 50000"/>
+            </a:avLst>
+          </a:prstGeom>
+          <a:solidFill>
+            <a:srgbClr val="E0F2FE"/>
+          </a:solidFill>
+          <a:ln w="12700">
+            <a:solidFill>
+              <a:srgbClr val="E0F2FE"/>
+            </a:solidFill>
+            <a:prstDash val="solid"/>
+          </a:ln>
+        </p:spPr>
+      </p:sp>
+      <p:sp>
+        <p:nvSpPr>
+          <p:cNvPr id="4" name="Text 2"/>
+          <p:cNvSpPr/>
+          <p:nvPr/>
+        </p:nvSpPr>
+        <p:spPr>
+          <a:xfrm>
+            <a:off x="502920" y="274320"/>
+            <a:ext cx="3337560" cy="329184"/>
+          </a:xfrm>
+          <a:prstGeom prst="rect">
+            <a:avLst/>
+          </a:prstGeom>
+          <a:noFill/>
+          <a:ln/>
+        </p:spPr>
+        <p:txBody>
+          <a:bodyPr wrap="square" lIns="0" tIns="0" rIns="0" bIns="0" rtlCol="0" anchor="ctr"/>
+          <a:lstStyle/>
+          <a:p>
+            <a:pPr algn="ctr" indent="0" marL="0">
+              <a:buNone/>
+            </a:pPr>
+            <a:r>
+              <a:rPr lang="en-US" sz="1050" b="1" spc="200" kern="0" dirty="0">
+                <a:solidFill>
+                  <a:srgbClr val="075985"/>
+                </a:solidFill>
+                <a:latin typeface="Calibri" pitchFamily="34" charset="0"/>
+                <a:ea typeface="Calibri" pitchFamily="34" charset="-122"/>
+                <a:cs typeface="Calibri" pitchFamily="34" charset="-120"/>
+              </a:rPr>
+              <a:t>JUNE SCHEDULE  ·  LIMITED SLOTS</a:t>
+            </a:r>
+            <a:endParaRPr lang="en-US" sz="1050" dirty="0"/>
+          </a:p>
+        </p:txBody>
+      </p:sp>
+      <p:sp>
+        <p:nvSpPr>
+          <p:cNvPr id="5" name="Text 3"/>
+          <p:cNvSpPr/>
+          <p:nvPr/>
+        </p:nvSpPr>
+        <p:spPr>
+          <a:xfrm>
+            <a:off x="502920" y="676656"/>
+            <a:ext cx="5440680" cy="749808"/>
+          </a:xfrm>
+          <a:prstGeom prst="rect">
+            <a:avLst/>
+          </a:prstGeom>
+          <a:noFill/>
+          <a:ln/>
+        </p:spPr>
+        <p:txBody>
+          <a:bodyPr wrap="square" lIns="0" tIns="0" rIns="0" bIns="0" rtlCol="0" anchor="ctr"/>
+          <a:lstStyle/>
+          <a:p>
+            <a:pPr indent="0" marL="0">
+              <a:buNone/>
+            </a:pPr>
+            <a:r>
+              <a:rPr lang="en-US" sz="5200" b="1" spc="-100" kern="0" dirty="0">
+                <a:solidFill>
+                  <a:srgbClr val="075985"/>
+                </a:solidFill>
+                <a:latin typeface="Calibri" pitchFamily="34" charset="0"/>
+                <a:ea typeface="Calibri" pitchFamily="34" charset="-122"/>
+                <a:cs typeface="Calibri" pitchFamily="34" charset="-120"/>
+              </a:rPr>
+              <a:t>STARTS JUNE 1</a:t>
+            </a:r>
+            <a:endParaRPr lang="en-US" sz="5200" dirty="0"/>
+          </a:p>
+        </p:txBody>
+      </p:sp>
+      <p:sp>
+        <p:nvSpPr>
+          <p:cNvPr id="6" name="Text 4"/>
+          <p:cNvSpPr/>
+          <p:nvPr/>
+        </p:nvSpPr>
+        <p:spPr>
+          <a:xfrm>
+            <a:off x="502920" y="1389888"/>
+            <a:ext cx="5440680" cy="365760"/>
+          </a:xfrm>
+          <a:prstGeom prst="rect">
+            <a:avLst/>
+          </a:prstGeom>
+          <a:noFill/>
+          <a:ln/>
+        </p:spPr>
+        <p:txBody>
+          <a:bodyPr wrap="square" lIns="0" tIns="0" rIns="0" bIns="0" rtlCol="0" anchor="ctr"/>
+          <a:lstStyle/>
+          <a:p>
+            <a:pPr indent="0" marL="0">
+              <a:buNone/>
+            </a:pPr>
+            <a:r>
+              <a:rPr lang="en-US" sz="1800" b="1" dirty="0">
+                <a:solidFill>
+                  <a:srgbClr val="0C2A3D"/>
+                </a:solidFill>
+                <a:latin typeface="Calibri" pitchFamily="34" charset="0"/>
+                <a:ea typeface="Calibri" pitchFamily="34" charset="-122"/>
+                <a:cs typeface="Calibri" pitchFamily="34" charset="-120"/>
+              </a:rPr>
+              <a:t>USMLE Step 1</a:t>
+            </a:r>
+            <a:pPr indent="0" marL="0">
+              <a:buNone/>
+            </a:pPr>
+            <a:r>
+              <a:rPr lang="en-US" sz="1800" dirty="0">
+                <a:solidFill>
+                  <a:srgbClr val="6B87A3"/>
+                </a:solidFill>
+                <a:latin typeface="Calibri" pitchFamily="34" charset="0"/>
+                <a:ea typeface="Calibri" pitchFamily="34" charset="-122"/>
+                <a:cs typeface="Calibri" pitchFamily="34" charset="-120"/>
+              </a:rPr>
+              <a:t>   ·   </a:t>
+            </a:r>
+            <a:pPr indent="0" marL="0">
+              <a:buNone/>
+            </a:pPr>
+            <a:r>
+              <a:rPr lang="en-US" sz="1800" dirty="0">
+                <a:solidFill>
+                  <a:srgbClr val="345671"/>
+                </a:solidFill>
+                <a:latin typeface="Calibri" pitchFamily="34" charset="0"/>
+                <a:ea typeface="Calibri" pitchFamily="34" charset="-122"/>
+                <a:cs typeface="Calibri" pitchFamily="34" charset="-120"/>
+              </a:rPr>
+              <a:t>Daily, Mon to Sun</a:t>
+            </a:r>
+            <a:endParaRPr lang="en-US" sz="1800" dirty="0"/>
+          </a:p>
+        </p:txBody>
+      </p:sp>
+      <p:sp>
+        <p:nvSpPr>
+          <p:cNvPr id="7" name="Shape 5"/>
+          <p:cNvSpPr/>
+          <p:nvPr/>
+        </p:nvSpPr>
+        <p:spPr>
+          <a:xfrm>
+            <a:off x="6181344" y="77724"/>
+            <a:ext cx="1581912" cy="1581912"/>
+          </a:xfrm>
+          <a:prstGeom prst="ellipse">
             <a:avLst/>
           </a:prstGeom>
           <a:solidFill>
@@ -900,231 +1097,9 @@
           </a:ln>
         </p:spPr>
       </p:sp>
-      <p:sp>
-        <p:nvSpPr>
-          <p:cNvPr id="3" name="Shape 1"/>
-          <p:cNvSpPr/>
-          <p:nvPr/>
-        </p:nvSpPr>
-        <p:spPr>
-          <a:xfrm>
-            <a:off x="0" y="1664208"/>
-            <a:ext cx="8229600" cy="164592"/>
-          </a:xfrm>
-          <a:prstGeom prst="rect">
-            <a:avLst/>
-          </a:prstGeom>
-          <a:solidFill>
-            <a:srgbClr val="075985"/>
-          </a:solidFill>
-          <a:ln w="12700">
-            <a:solidFill>
-              <a:srgbClr val="075985"/>
-            </a:solidFill>
-            <a:prstDash val="solid"/>
-          </a:ln>
-        </p:spPr>
-      </p:sp>
-      <p:sp>
-        <p:nvSpPr>
-          <p:cNvPr id="4" name="Shape 2"/>
-          <p:cNvSpPr/>
-          <p:nvPr/>
-        </p:nvSpPr>
-        <p:spPr>
-          <a:xfrm>
-            <a:off x="502920" y="274320"/>
-            <a:ext cx="2926080" cy="329184"/>
-          </a:xfrm>
-          <a:prstGeom prst="roundRect">
-            <a:avLst>
-              <a:gd name="adj" fmla="val 50000"/>
-            </a:avLst>
-          </a:prstGeom>
-          <a:solidFill>
-            <a:srgbClr val="FFFFFF"/>
-          </a:solidFill>
-          <a:ln w="12700">
-            <a:solidFill>
-              <a:srgbClr val="FFFFFF"/>
-            </a:solidFill>
-            <a:prstDash val="solid"/>
-          </a:ln>
-        </p:spPr>
-      </p:sp>
-      <p:sp>
-        <p:nvSpPr>
-          <p:cNvPr id="5" name="Text 3"/>
-          <p:cNvSpPr/>
-          <p:nvPr/>
-        </p:nvSpPr>
-        <p:spPr>
-          <a:xfrm>
-            <a:off x="502920" y="274320"/>
-            <a:ext cx="2926080" cy="329184"/>
-          </a:xfrm>
-          <a:prstGeom prst="rect">
-            <a:avLst/>
-          </a:prstGeom>
-          <a:noFill/>
-          <a:ln/>
-        </p:spPr>
-        <p:txBody>
-          <a:bodyPr wrap="square" lIns="0" tIns="0" rIns="0" bIns="0" rtlCol="0" anchor="ctr"/>
-          <a:lstStyle/>
-          <a:p>
-            <a:pPr algn="ctr" indent="0" marL="0">
-              <a:buNone/>
-            </a:pPr>
-            <a:r>
-              <a:rPr lang="en-US" sz="1100" b="1" spc="300" kern="0" dirty="0">
-                <a:solidFill>
-                  <a:srgbClr val="075985"/>
-                </a:solidFill>
-                <a:latin typeface="Calibri" pitchFamily="34" charset="0"/>
-                <a:ea typeface="Calibri" pitchFamily="34" charset="-122"/>
-                <a:cs typeface="Calibri" pitchFamily="34" charset="-120"/>
-              </a:rPr>
-              <a:t>JUNE COHORT  ·  LIMITED SLOTS</a:t>
-            </a:r>
-            <a:endParaRPr lang="en-US" sz="1100" dirty="0"/>
-          </a:p>
-        </p:txBody>
-      </p:sp>
-      <p:sp>
-        <p:nvSpPr>
-          <p:cNvPr id="6" name="Text 4"/>
-          <p:cNvSpPr/>
-          <p:nvPr/>
-        </p:nvSpPr>
-        <p:spPr>
-          <a:xfrm>
-            <a:off x="502920" y="676656"/>
-            <a:ext cx="5440680" cy="749808"/>
-          </a:xfrm>
-          <a:prstGeom prst="rect">
-            <a:avLst/>
-          </a:prstGeom>
-          <a:noFill/>
-          <a:ln/>
-        </p:spPr>
-        <p:txBody>
-          <a:bodyPr wrap="square" lIns="0" tIns="0" rIns="0" bIns="0" rtlCol="0" anchor="ctr"/>
-          <a:lstStyle/>
-          <a:p>
-            <a:pPr indent="0" marL="0">
-              <a:buNone/>
-            </a:pPr>
-            <a:r>
-              <a:rPr lang="en-US" sz="5200" b="1" spc="-100" kern="0" dirty="0">
-                <a:solidFill>
-                  <a:srgbClr val="FFFFFF"/>
-                </a:solidFill>
-                <a:latin typeface="Calibri" pitchFamily="34" charset="0"/>
-                <a:ea typeface="Calibri" pitchFamily="34" charset="-122"/>
-                <a:cs typeface="Calibri" pitchFamily="34" charset="-120"/>
-              </a:rPr>
-              <a:t>STARTS JUNE 1</a:t>
-            </a:r>
-            <a:endParaRPr lang="en-US" sz="5200" dirty="0"/>
-          </a:p>
-        </p:txBody>
-      </p:sp>
-      <p:sp>
-        <p:nvSpPr>
-          <p:cNvPr id="7" name="Text 5"/>
-          <p:cNvSpPr/>
-          <p:nvPr/>
-        </p:nvSpPr>
-        <p:spPr>
-          <a:xfrm>
-            <a:off x="502920" y="1389888"/>
-            <a:ext cx="5440680" cy="365760"/>
-          </a:xfrm>
-          <a:prstGeom prst="rect">
-            <a:avLst/>
-          </a:prstGeom>
-          <a:noFill/>
-          <a:ln/>
-        </p:spPr>
-        <p:txBody>
-          <a:bodyPr wrap="square" lIns="0" tIns="0" rIns="0" bIns="0" rtlCol="0" anchor="ctr"/>
-          <a:lstStyle/>
-          <a:p>
-            <a:pPr indent="0" marL="0">
-              <a:buNone/>
-            </a:pPr>
-            <a:r>
-              <a:rPr lang="en-US" sz="1800" b="1" dirty="0">
-                <a:solidFill>
-                  <a:srgbClr val="FFFFFF"/>
-                </a:solidFill>
-                <a:latin typeface="Calibri" pitchFamily="34" charset="0"/>
-                <a:ea typeface="Calibri" pitchFamily="34" charset="-122"/>
-                <a:cs typeface="Calibri" pitchFamily="34" charset="-120"/>
-              </a:rPr>
-              <a:t>USMLE Step 1</a:t>
-            </a:r>
-            <a:pPr indent="0" marL="0">
-              <a:buNone/>
-            </a:pPr>
-            <a:r>
-              <a:rPr lang="en-US" sz="1800" dirty="0">
-                <a:solidFill>
-                  <a:srgbClr val="BFE3F7"/>
-                </a:solidFill>
-                <a:latin typeface="Calibri" pitchFamily="34" charset="0"/>
-                <a:ea typeface="Calibri" pitchFamily="34" charset="-122"/>
-                <a:cs typeface="Calibri" pitchFamily="34" charset="-120"/>
-              </a:rPr>
-              <a:t>   ·   </a:t>
-            </a:r>
-            <a:pPr indent="0" marL="0">
-              <a:buNone/>
-            </a:pPr>
-            <a:r>
-              <a:rPr lang="en-US" sz="1800" dirty="0">
-                <a:solidFill>
-                  <a:srgbClr val="E0F2FE"/>
-                </a:solidFill>
-                <a:latin typeface="Calibri" pitchFamily="34" charset="0"/>
-                <a:ea typeface="Calibri" pitchFamily="34" charset="-122"/>
-                <a:cs typeface="Calibri" pitchFamily="34" charset="-120"/>
-              </a:rPr>
-              <a:t>Daily, Mon to Sun</a:t>
-            </a:r>
-            <a:endParaRPr lang="en-US" sz="1800" dirty="0"/>
-          </a:p>
-        </p:txBody>
-      </p:sp>
-      <p:sp>
-        <p:nvSpPr>
-          <p:cNvPr id="8" name="Shape 6"/>
-          <p:cNvSpPr/>
-          <p:nvPr/>
-        </p:nvSpPr>
-        <p:spPr>
-          <a:xfrm>
-            <a:off x="6163056" y="59436"/>
-            <a:ext cx="1618488" cy="1618488"/>
-          </a:xfrm>
-          <a:prstGeom prst="ellipse">
-            <a:avLst/>
-          </a:prstGeom>
-          <a:solidFill>
-            <a:srgbClr val="FFFFFF"/>
-          </a:solidFill>
-          <a:ln w="12700">
-            <a:solidFill>
-              <a:srgbClr val="FFFFFF"/>
-            </a:solidFill>
-            <a:prstDash val="solid"/>
-          </a:ln>
-        </p:spPr>
-      </p:sp>
       <p:pic>
         <p:nvPicPr>
-          <p:cNvPr id="9" name="Image 0" descr="allan_circle.png">    </p:cNvPr>
+          <p:cNvPr id="8" name="Image 0" descr="allan_circle.png">    </p:cNvPr>
           <p:cNvPicPr>
             <a:picLocks noChangeAspect="1"/>
           </p:cNvPicPr>
@@ -1148,7 +1123,7 @@
       </p:pic>
       <p:sp>
         <p:nvSpPr>
-          <p:cNvPr id="10" name="Text 7"/>
+          <p:cNvPr id="9" name="Text 6"/>
           <p:cNvSpPr/>
           <p:nvPr/>
         </p:nvSpPr>
@@ -1187,7 +1162,7 @@
       </p:sp>
       <p:sp>
         <p:nvSpPr>
-          <p:cNvPr id="11" name="Shape 8"/>
+          <p:cNvPr id="10" name="Shape 7"/>
           <p:cNvSpPr/>
           <p:nvPr/>
         </p:nvSpPr>
@@ -1210,7 +1185,7 @@
       </p:sp>
       <p:sp>
         <p:nvSpPr>
-          <p:cNvPr id="12" name="Shape 9"/>
+          <p:cNvPr id="11" name="Shape 8"/>
           <p:cNvSpPr/>
           <p:nvPr/>
         </p:nvSpPr>
@@ -1237,7 +1212,7 @@
       </p:sp>
       <p:sp>
         <p:nvSpPr>
-          <p:cNvPr id="13" name="Shape 10"/>
+          <p:cNvPr id="12" name="Shape 9"/>
           <p:cNvSpPr/>
           <p:nvPr/>
         </p:nvSpPr>
@@ -1262,7 +1237,7 @@
       </p:sp>
       <p:sp>
         <p:nvSpPr>
-          <p:cNvPr id="14" name="Shape 11"/>
+          <p:cNvPr id="13" name="Shape 10"/>
           <p:cNvSpPr/>
           <p:nvPr/>
         </p:nvSpPr>
@@ -1289,7 +1264,7 @@
       </p:sp>
       <p:sp>
         <p:nvSpPr>
-          <p:cNvPr id="15" name="Text 12"/>
+          <p:cNvPr id="14" name="Text 11"/>
           <p:cNvSpPr/>
           <p:nvPr/>
         </p:nvSpPr>
@@ -1328,7 +1303,7 @@
       </p:sp>
       <p:sp>
         <p:nvSpPr>
-          <p:cNvPr id="16" name="Text 13"/>
+          <p:cNvPr id="15" name="Text 12"/>
           <p:cNvSpPr/>
           <p:nvPr/>
         </p:nvSpPr>
@@ -1367,7 +1342,7 @@
       </p:sp>
       <p:sp>
         <p:nvSpPr>
-          <p:cNvPr id="17" name="Text 14"/>
+          <p:cNvPr id="16" name="Text 13"/>
           <p:cNvSpPr/>
           <p:nvPr/>
         </p:nvSpPr>
@@ -1420,7 +1395,7 @@
       </p:sp>
       <p:sp>
         <p:nvSpPr>
-          <p:cNvPr id="18" name="Text 15"/>
+          <p:cNvPr id="17" name="Text 14"/>
           <p:cNvSpPr/>
           <p:nvPr/>
         </p:nvSpPr>
@@ -1473,7 +1448,7 @@
       </p:sp>
       <p:sp>
         <p:nvSpPr>
-          <p:cNvPr id="19" name="Text 16"/>
+          <p:cNvPr id="18" name="Text 15"/>
           <p:cNvSpPr/>
           <p:nvPr/>
         </p:nvSpPr>
@@ -1526,7 +1501,7 @@
       </p:sp>
       <p:sp>
         <p:nvSpPr>
-          <p:cNvPr id="20" name="Text 17"/>
+          <p:cNvPr id="19" name="Text 16"/>
           <p:cNvSpPr/>
           <p:nvPr/>
         </p:nvSpPr>
@@ -1579,7 +1554,7 @@
       </p:sp>
       <p:sp>
         <p:nvSpPr>
-          <p:cNvPr id="21" name="Text 18"/>
+          <p:cNvPr id="20" name="Text 17"/>
           <p:cNvSpPr/>
           <p:nvPr/>
         </p:nvSpPr>
@@ -1632,7 +1607,7 @@
       </p:sp>
       <p:sp>
         <p:nvSpPr>
-          <p:cNvPr id="22" name="Text 19"/>
+          <p:cNvPr id="21" name="Text 18"/>
           <p:cNvSpPr/>
           <p:nvPr/>
         </p:nvSpPr>
@@ -1685,7 +1660,7 @@
       </p:sp>
       <p:sp>
         <p:nvSpPr>
-          <p:cNvPr id="23" name="Text 20"/>
+          <p:cNvPr id="22" name="Text 19"/>
           <p:cNvSpPr/>
           <p:nvPr/>
         </p:nvSpPr>
@@ -1738,7 +1713,7 @@
       </p:sp>
       <p:sp>
         <p:nvSpPr>
-          <p:cNvPr id="24" name="Text 21"/>
+          <p:cNvPr id="23" name="Text 20"/>
           <p:cNvSpPr/>
           <p:nvPr/>
         </p:nvSpPr>
@@ -1791,7 +1766,7 @@
       </p:sp>
       <p:sp>
         <p:nvSpPr>
-          <p:cNvPr id="25" name="Text 22"/>
+          <p:cNvPr id="24" name="Text 21"/>
           <p:cNvSpPr/>
           <p:nvPr/>
         </p:nvSpPr>
@@ -1844,7 +1819,7 @@
       </p:sp>
       <p:sp>
         <p:nvSpPr>
-          <p:cNvPr id="26" name="Text 23"/>
+          <p:cNvPr id="25" name="Text 22"/>
           <p:cNvSpPr/>
           <p:nvPr/>
         </p:nvSpPr>
@@ -1897,7 +1872,7 @@
       </p:sp>
       <p:sp>
         <p:nvSpPr>
-          <p:cNvPr id="27" name="Shape 24"/>
+          <p:cNvPr id="26" name="Shape 23"/>
           <p:cNvSpPr/>
           <p:nvPr/>
         </p:nvSpPr>
@@ -1924,7 +1899,7 @@
       </p:sp>
       <p:sp>
         <p:nvSpPr>
-          <p:cNvPr id="28" name="Shape 25"/>
+          <p:cNvPr id="27" name="Shape 24"/>
           <p:cNvSpPr/>
           <p:nvPr/>
         </p:nvSpPr>
@@ -1949,7 +1924,7 @@
       </p:sp>
       <p:sp>
         <p:nvSpPr>
-          <p:cNvPr id="29" name="Shape 26"/>
+          <p:cNvPr id="28" name="Shape 25"/>
           <p:cNvSpPr/>
           <p:nvPr/>
         </p:nvSpPr>
@@ -1976,7 +1951,7 @@
       </p:sp>
       <p:sp>
         <p:nvSpPr>
-          <p:cNvPr id="30" name="Text 27"/>
+          <p:cNvPr id="29" name="Text 26"/>
           <p:cNvSpPr/>
           <p:nvPr/>
         </p:nvSpPr>
@@ -2015,7 +1990,7 @@
       </p:sp>
       <p:sp>
         <p:nvSpPr>
-          <p:cNvPr id="31" name="Text 28"/>
+          <p:cNvPr id="30" name="Text 27"/>
           <p:cNvSpPr/>
           <p:nvPr/>
         </p:nvSpPr>
@@ -2054,7 +2029,7 @@
       </p:sp>
       <p:sp>
         <p:nvSpPr>
-          <p:cNvPr id="32" name="Text 29"/>
+          <p:cNvPr id="31" name="Text 28"/>
           <p:cNvSpPr/>
           <p:nvPr/>
         </p:nvSpPr>
@@ -2107,7 +2082,7 @@
       </p:sp>
       <p:sp>
         <p:nvSpPr>
-          <p:cNvPr id="33" name="Text 30"/>
+          <p:cNvPr id="32" name="Text 29"/>
           <p:cNvSpPr/>
           <p:nvPr/>
         </p:nvSpPr>
@@ -2160,7 +2135,7 @@
       </p:sp>
       <p:sp>
         <p:nvSpPr>
-          <p:cNvPr id="34" name="Text 31"/>
+          <p:cNvPr id="33" name="Text 30"/>
           <p:cNvSpPr/>
           <p:nvPr/>
         </p:nvSpPr>
@@ -2213,7 +2188,7 @@
       </p:sp>
       <p:sp>
         <p:nvSpPr>
-          <p:cNvPr id="35" name="Text 32"/>
+          <p:cNvPr id="34" name="Text 31"/>
           <p:cNvSpPr/>
           <p:nvPr/>
         </p:nvSpPr>
@@ -2266,7 +2241,7 @@
       </p:sp>
       <p:sp>
         <p:nvSpPr>
-          <p:cNvPr id="36" name="Text 33"/>
+          <p:cNvPr id="35" name="Text 32"/>
           <p:cNvSpPr/>
           <p:nvPr/>
         </p:nvSpPr>
@@ -2319,7 +2294,7 @@
       </p:sp>
       <p:sp>
         <p:nvSpPr>
-          <p:cNvPr id="37" name="Text 34"/>
+          <p:cNvPr id="36" name="Text 33"/>
           <p:cNvSpPr/>
           <p:nvPr/>
         </p:nvSpPr>
@@ -2372,7 +2347,7 @@
       </p:sp>
       <p:sp>
         <p:nvSpPr>
-          <p:cNvPr id="38" name="Text 35"/>
+          <p:cNvPr id="37" name="Text 34"/>
           <p:cNvSpPr/>
           <p:nvPr/>
         </p:nvSpPr>
@@ -2425,7 +2400,7 @@
       </p:sp>
       <p:sp>
         <p:nvSpPr>
-          <p:cNvPr id="39" name="Text 36"/>
+          <p:cNvPr id="38" name="Text 35"/>
           <p:cNvSpPr/>
           <p:nvPr/>
         </p:nvSpPr>
@@ -2470,7 +2445,7 @@
                 <a:ea typeface="Calibri" pitchFamily="34" charset="-122"/>
                 <a:cs typeface="Calibri" pitchFamily="34" charset="-120"/>
               </a:rPr>
-              <a:t>TB, lung cancer &amp; pharmacology</a:t>
+              <a:t>TB, lung cancer &amp; respiratory pharmacology</a:t>
             </a:r>
             <a:endParaRPr lang="en-US" sz="950" dirty="0"/>
           </a:p>
@@ -2478,7 +2453,7 @@
       </p:sp>
       <p:sp>
         <p:nvSpPr>
-          <p:cNvPr id="40" name="Shape 37"/>
+          <p:cNvPr id="39" name="Shape 36"/>
           <p:cNvSpPr/>
           <p:nvPr/>
         </p:nvSpPr>
@@ -2505,7 +2480,7 @@
       </p:sp>
       <p:sp>
         <p:nvSpPr>
-          <p:cNvPr id="41" name="Shape 38"/>
+          <p:cNvPr id="40" name="Shape 37"/>
           <p:cNvSpPr/>
           <p:nvPr/>
         </p:nvSpPr>
@@ -2530,7 +2505,7 @@
       </p:sp>
       <p:sp>
         <p:nvSpPr>
-          <p:cNvPr id="42" name="Shape 39"/>
+          <p:cNvPr id="41" name="Shape 38"/>
           <p:cNvSpPr/>
           <p:nvPr/>
         </p:nvSpPr>
@@ -2557,7 +2532,7 @@
       </p:sp>
       <p:sp>
         <p:nvSpPr>
-          <p:cNvPr id="43" name="Text 40"/>
+          <p:cNvPr id="42" name="Text 39"/>
           <p:cNvSpPr/>
           <p:nvPr/>
         </p:nvSpPr>
@@ -2596,7 +2571,7 @@
       </p:sp>
       <p:sp>
         <p:nvSpPr>
-          <p:cNvPr id="44" name="Text 41"/>
+          <p:cNvPr id="43" name="Text 40"/>
           <p:cNvSpPr/>
           <p:nvPr/>
         </p:nvSpPr>
@@ -2635,7 +2610,7 @@
       </p:sp>
       <p:sp>
         <p:nvSpPr>
-          <p:cNvPr id="45" name="Text 42"/>
+          <p:cNvPr id="44" name="Text 41"/>
           <p:cNvSpPr/>
           <p:nvPr/>
         </p:nvSpPr>
@@ -2658,7 +2633,7 @@
               <a:buNone/>
             </a:pPr>
             <a:r>
-              <a:rPr lang="en-US" sz="1100" b="1" dirty="0">
+              <a:rPr lang="en-US" sz="1000" b="1" dirty="0">
                 <a:solidFill>
                   <a:srgbClr val="D97706"/>
                 </a:solidFill>
@@ -2672,7 +2647,7 @@
               <a:buNone/>
             </a:pPr>
             <a:r>
-              <a:rPr lang="en-US" sz="1100" dirty="0">
+              <a:rPr lang="en-US" sz="1000" dirty="0">
                 <a:solidFill>
                   <a:srgbClr val="345671"/>
                 </a:solidFill>
@@ -2680,15 +2655,15 @@
                 <a:ea typeface="Calibri" pitchFamily="34" charset="-122"/>
                 <a:cs typeface="Calibri" pitchFamily="34" charset="-120"/>
               </a:rPr>
-              <a:t>Study designs &amp; levels of evidence</a:t>
-            </a:r>
-            <a:endParaRPr lang="en-US" sz="1100" dirty="0"/>
-          </a:p>
-        </p:txBody>
-      </p:sp>
-      <p:sp>
-        <p:nvSpPr>
-          <p:cNvPr id="46" name="Text 43"/>
+              <a:t>Study designs, evidence, Sens/Spec/PPV/NPV</a:t>
+            </a:r>
+            <a:endParaRPr lang="en-US" sz="1000" dirty="0"/>
+          </a:p>
+        </p:txBody>
+      </p:sp>
+      <p:sp>
+        <p:nvSpPr>
+          <p:cNvPr id="45" name="Text 42"/>
           <p:cNvSpPr/>
           <p:nvPr/>
         </p:nvSpPr>
@@ -2711,7 +2686,7 @@
               <a:buNone/>
             </a:pPr>
             <a:r>
-              <a:rPr lang="en-US" sz="1100" b="1" dirty="0">
+              <a:rPr lang="en-US" sz="1000" b="1" dirty="0">
                 <a:solidFill>
                   <a:srgbClr val="D97706"/>
                 </a:solidFill>
@@ -2725,7 +2700,7 @@
               <a:buNone/>
             </a:pPr>
             <a:r>
-              <a:rPr lang="en-US" sz="1100" dirty="0">
+              <a:rPr lang="en-US" sz="1000" dirty="0">
                 <a:solidFill>
                   <a:srgbClr val="345671"/>
                 </a:solidFill>
@@ -2735,13 +2710,13 @@
               </a:rPr>
               <a:t>Quantifying risk, transitions &amp; survival analysis</a:t>
             </a:r>
-            <a:endParaRPr lang="en-US" sz="1100" dirty="0"/>
-          </a:p>
-        </p:txBody>
-      </p:sp>
-      <p:sp>
-        <p:nvSpPr>
-          <p:cNvPr id="47" name="Text 44"/>
+            <a:endParaRPr lang="en-US" sz="1000" dirty="0"/>
+          </a:p>
+        </p:txBody>
+      </p:sp>
+      <p:sp>
+        <p:nvSpPr>
+          <p:cNvPr id="46" name="Text 43"/>
           <p:cNvSpPr/>
           <p:nvPr/>
         </p:nvSpPr>
@@ -2764,7 +2739,7 @@
               <a:buNone/>
             </a:pPr>
             <a:r>
-              <a:rPr lang="en-US" sz="1100" b="1" dirty="0">
+              <a:rPr lang="en-US" sz="1000" b="1" dirty="0">
                 <a:solidFill>
                   <a:srgbClr val="D97706"/>
                 </a:solidFill>
@@ -2778,7 +2753,7 @@
               <a:buNone/>
             </a:pPr>
             <a:r>
-              <a:rPr lang="en-US" sz="1100" dirty="0">
+              <a:rPr lang="en-US" sz="1000" dirty="0">
                 <a:solidFill>
                   <a:srgbClr val="345671"/>
                 </a:solidFill>
@@ -2788,13 +2763,13 @@
               </a:rPr>
               <a:t>Bias, confounding &amp; effect modification</a:t>
             </a:r>
-            <a:endParaRPr lang="en-US" sz="1100" dirty="0"/>
-          </a:p>
-        </p:txBody>
-      </p:sp>
-      <p:sp>
-        <p:nvSpPr>
-          <p:cNvPr id="48" name="Text 45"/>
+            <a:endParaRPr lang="en-US" sz="1000" dirty="0"/>
+          </a:p>
+        </p:txBody>
+      </p:sp>
+      <p:sp>
+        <p:nvSpPr>
+          <p:cNvPr id="47" name="Text 44"/>
           <p:cNvSpPr/>
           <p:nvPr/>
         </p:nvSpPr>
@@ -2817,7 +2792,7 @@
               <a:buNone/>
             </a:pPr>
             <a:r>
-              <a:rPr lang="en-US" sz="1100" b="1" dirty="0">
+              <a:rPr lang="en-US" sz="1000" b="1" dirty="0">
                 <a:solidFill>
                   <a:srgbClr val="D97706"/>
                 </a:solidFill>
@@ -2831,7 +2806,7 @@
               <a:buNone/>
             </a:pPr>
             <a:r>
-              <a:rPr lang="en-US" sz="1100" dirty="0">
+              <a:rPr lang="en-US" sz="1000" dirty="0">
                 <a:solidFill>
                   <a:srgbClr val="345671"/>
                 </a:solidFill>
@@ -2841,13 +2816,13 @@
               </a:rPr>
               <a:t>Statistical distributions, testing &amp; CIs</a:t>
             </a:r>
-            <a:endParaRPr lang="en-US" sz="1100" dirty="0"/>
-          </a:p>
-        </p:txBody>
-      </p:sp>
-      <p:sp>
-        <p:nvSpPr>
-          <p:cNvPr id="49" name="Shape 46"/>
+            <a:endParaRPr lang="en-US" sz="1000" dirty="0"/>
+          </a:p>
+        </p:txBody>
+      </p:sp>
+      <p:sp>
+        <p:nvSpPr>
+          <p:cNvPr id="48" name="Shape 45"/>
           <p:cNvSpPr/>
           <p:nvPr/>
         </p:nvSpPr>
@@ -2874,7 +2849,7 @@
       </p:sp>
       <p:sp>
         <p:nvSpPr>
-          <p:cNvPr id="50" name="Shape 47"/>
+          <p:cNvPr id="49" name="Shape 46"/>
           <p:cNvSpPr/>
           <p:nvPr/>
         </p:nvSpPr>
@@ -2899,7 +2874,7 @@
       </p:sp>
       <p:sp>
         <p:nvSpPr>
-          <p:cNvPr id="51" name="Shape 48"/>
+          <p:cNvPr id="50" name="Shape 47"/>
           <p:cNvSpPr/>
           <p:nvPr/>
         </p:nvSpPr>
@@ -2926,7 +2901,7 @@
       </p:sp>
       <p:sp>
         <p:nvSpPr>
-          <p:cNvPr id="52" name="Text 49"/>
+          <p:cNvPr id="51" name="Text 48"/>
           <p:cNvSpPr/>
           <p:nvPr/>
         </p:nvSpPr>
@@ -2965,7 +2940,7 @@
       </p:sp>
       <p:sp>
         <p:nvSpPr>
-          <p:cNvPr id="53" name="Text 50"/>
+          <p:cNvPr id="52" name="Text 49"/>
           <p:cNvSpPr/>
           <p:nvPr/>
         </p:nvSpPr>
@@ -3004,7 +2979,7 @@
       </p:sp>
       <p:sp>
         <p:nvSpPr>
-          <p:cNvPr id="54" name="Text 51"/>
+          <p:cNvPr id="53" name="Text 50"/>
           <p:cNvSpPr/>
           <p:nvPr/>
         </p:nvSpPr>
@@ -3057,7 +3032,7 @@
       </p:sp>
       <p:sp>
         <p:nvSpPr>
-          <p:cNvPr id="55" name="Text 52"/>
+          <p:cNvPr id="54" name="Text 51"/>
           <p:cNvSpPr/>
           <p:nvPr/>
         </p:nvSpPr>
@@ -3110,7 +3085,7 @@
       </p:sp>
       <p:sp>
         <p:nvSpPr>
-          <p:cNvPr id="56" name="Text 53"/>
+          <p:cNvPr id="55" name="Text 52"/>
           <p:cNvSpPr/>
           <p:nvPr/>
         </p:nvSpPr>
@@ -3163,7 +3138,7 @@
       </p:sp>
       <p:sp>
         <p:nvSpPr>
-          <p:cNvPr id="57" name="Text 54"/>
+          <p:cNvPr id="56" name="Text 53"/>
           <p:cNvSpPr/>
           <p:nvPr/>
         </p:nvSpPr>
@@ -3216,7 +3191,7 @@
       </p:sp>
       <p:sp>
         <p:nvSpPr>
-          <p:cNvPr id="58" name="Text 55"/>
+          <p:cNvPr id="57" name="Text 54"/>
           <p:cNvSpPr/>
           <p:nvPr/>
         </p:nvSpPr>
@@ -3269,7 +3244,7 @@
       </p:sp>
       <p:sp>
         <p:nvSpPr>
-          <p:cNvPr id="59" name="Text 56"/>
+          <p:cNvPr id="58" name="Text 55"/>
           <p:cNvSpPr/>
           <p:nvPr/>
         </p:nvSpPr>
@@ -3322,7 +3297,7 @@
       </p:sp>
       <p:sp>
         <p:nvSpPr>
-          <p:cNvPr id="60" name="Text 57"/>
+          <p:cNvPr id="59" name="Text 56"/>
           <p:cNvSpPr/>
           <p:nvPr/>
         </p:nvSpPr>
@@ -3375,7 +3350,7 @@
       </p:sp>
       <p:sp>
         <p:nvSpPr>
-          <p:cNvPr id="61" name="Text 58"/>
+          <p:cNvPr id="60" name="Text 57"/>
           <p:cNvSpPr/>
           <p:nvPr/>
         </p:nvSpPr>
@@ -3428,7 +3403,7 @@
       </p:sp>
       <p:sp>
         <p:nvSpPr>
-          <p:cNvPr id="62" name="Shape 59"/>
+          <p:cNvPr id="61" name="Shape 58"/>
           <p:cNvSpPr/>
           <p:nvPr/>
         </p:nvSpPr>
@@ -3455,7 +3430,7 @@
       </p:sp>
       <p:sp>
         <p:nvSpPr>
-          <p:cNvPr id="63" name="Text 60"/>
+          <p:cNvPr id="62" name="Text 59"/>
           <p:cNvSpPr/>
           <p:nvPr/>
         </p:nvSpPr>
@@ -3508,7 +3483,7 @@
       </p:sp>
       <p:sp>
         <p:nvSpPr>
-          <p:cNvPr id="64" name="Shape 61"/>
+          <p:cNvPr id="63" name="Shape 60"/>
           <p:cNvSpPr/>
           <p:nvPr/>
         </p:nvSpPr>
@@ -3535,7 +3510,7 @@
       </p:sp>
       <p:pic>
         <p:nvPicPr>
-          <p:cNvPr id="65" name="Image 1" descr="signup_qr.png">    </p:cNvPr>
+          <p:cNvPr id="64" name="Image 1" descr="signup_qr.png">    </p:cNvPr>
           <p:cNvPicPr>
             <a:picLocks noChangeAspect="1"/>
           </p:cNvPicPr>
@@ -3559,7 +3534,7 @@
       </p:pic>
       <p:sp>
         <p:nvSpPr>
-          <p:cNvPr id="66" name="Text 62"/>
+          <p:cNvPr id="65" name="Text 61"/>
           <p:cNvSpPr/>
           <p:nvPr/>
         </p:nvSpPr>
@@ -3598,7 +3573,7 @@
       </p:sp>
       <p:sp>
         <p:nvSpPr>
-          <p:cNvPr id="67" name="Text 63"/>
+          <p:cNvPr id="66" name="Text 62"/>
           <p:cNvSpPr/>
           <p:nvPr/>
         </p:nvSpPr>
@@ -3637,7 +3612,7 @@
       </p:sp>
       <p:sp>
         <p:nvSpPr>
-          <p:cNvPr id="68" name="Text 64"/>
+          <p:cNvPr id="67" name="Text 63"/>
           <p:cNvSpPr/>
           <p:nvPr/>
         </p:nvSpPr>
@@ -3676,7 +3651,7 @@
       </p:sp>
       <p:sp>
         <p:nvSpPr>
-          <p:cNvPr id="69" name="Text 65"/>
+          <p:cNvPr id="68" name="Text 64"/>
           <p:cNvSpPr/>
           <p:nvPr/>
         </p:nvSpPr>
@@ -3729,7 +3704,7 @@
       </p:sp>
       <p:sp>
         <p:nvSpPr>
-          <p:cNvPr id="70" name="Text 66"/>
+          <p:cNvPr id="69" name="Text 65"/>
           <p:cNvSpPr/>
           <p:nvPr/>
         </p:nvSpPr>
@@ -3796,7 +3771,7 @@
       </p:sp>
       <p:sp>
         <p:nvSpPr>
-          <p:cNvPr id="71" name="Shape 67"/>
+          <p:cNvPr id="70" name="Shape 66"/>
           <p:cNvSpPr/>
           <p:nvPr/>
         </p:nvSpPr>
@@ -3819,7 +3794,7 @@
       </p:sp>
       <p:sp>
         <p:nvSpPr>
-          <p:cNvPr id="72" name="Text 68"/>
+          <p:cNvPr id="71" name="Text 67"/>
           <p:cNvSpPr/>
           <p:nvPr/>
         </p:nvSpPr>

</xml_diff>

<commit_message>
Flyer: rewrite methodology stripe; add email/WA/call contact row
- Methodology stripe drops 'First Aid 2025 + UWorld' and reads
  'HIGH-YIELD MATERIAL + TEST QUESTIONS · similar to exam day,
  every day'. Keeps the promise without naming specific products.
- CTA gains a proper 3-column contact row with icons: email,
  WhatsApp, and US phone — matching the info-session poster style.

Co-Authored-By: Claude Opus 4.7 (1M context) <noreply@anthropic.com>
</commit_message>
<xml_diff>
--- a/outputs/flyers/USMLE_June_Advert.pptx
+++ b/outputs/flyers/USMLE_June_Advert.pptx
@@ -3453,7 +3453,7 @@
               <a:buNone/>
             </a:pPr>
             <a:r>
-              <a:rPr lang="en-US" sz="1500" b="1" spc="200" kern="0" dirty="0">
+              <a:rPr lang="en-US" sz="1400" b="1" spc="200" kern="0" dirty="0">
                 <a:solidFill>
                   <a:srgbClr val="FFFFFF"/>
                 </a:solidFill>
@@ -3461,13 +3461,13 @@
                 <a:ea typeface="Calibri" pitchFamily="34" charset="-122"/>
                 <a:cs typeface="Calibri" pitchFamily="34" charset="-120"/>
               </a:rPr>
-              <a:t>FIRST AID 2025 + UWORLD</a:t>
-            </a:r>
-            <a:pPr indent="0" marL="0">
-              <a:buNone/>
-            </a:pPr>
-            <a:r>
-              <a:rPr lang="en-US" sz="1300" i="1" dirty="0">
+              <a:t>HIGH-YIELD MATERIAL + TEST QUESTIONS</a:t>
+            </a:r>
+            <a:pPr indent="0" marL="0">
+              <a:buNone/>
+            </a:pPr>
+            <a:r>
+              <a:rPr lang="en-US" sz="1200" i="1" dirty="0">
                 <a:solidFill>
                   <a:srgbClr val="BFE3F7"/>
                 </a:solidFill>
@@ -3475,9 +3475,9 @@
                 <a:ea typeface="Calibri" pitchFamily="34" charset="-122"/>
                 <a:cs typeface="Calibri" pitchFamily="34" charset="-120"/>
               </a:rPr>
-              <a:t>  every single day  </a:t>
-            </a:r>
-            <a:endParaRPr lang="en-US" sz="1500" dirty="0"/>
+              <a:t>  similar to exam day  ·  every day</a:t>
+            </a:r>
+            <a:endParaRPr lang="en-US" sz="1400" dirty="0"/>
           </a:p>
         </p:txBody>
       </p:sp>
@@ -3657,38 +3657,24 @@
         </p:nvSpPr>
         <p:spPr>
           <a:xfrm>
-            <a:off x="2057400" y="9006840"/>
-            <a:ext cx="5669280" cy="237744"/>
-          </a:xfrm>
-          <a:prstGeom prst="rect">
-            <a:avLst/>
-          </a:prstGeom>
-          <a:noFill/>
-          <a:ln/>
-        </p:spPr>
-        <p:txBody>
-          <a:bodyPr wrap="square" lIns="0" tIns="0" rIns="0" bIns="0" rtlCol="0" anchor="ctr"/>
-          <a:lstStyle/>
-          <a:p>
-            <a:pPr indent="0" marL="0">
-              <a:buNone/>
-            </a:pPr>
-            <a:r>
-              <a:rPr lang="en-US" sz="1050" dirty="0">
-                <a:solidFill>
-                  <a:srgbClr val="345671"/>
-                </a:solidFill>
-                <a:latin typeface="Calibri" pitchFamily="34" charset="0"/>
-                <a:ea typeface="Calibri" pitchFamily="34" charset="-122"/>
-                <a:cs typeface="Calibri" pitchFamily="34" charset="-120"/>
-              </a:rPr>
-              <a:t>Full plan + class details: </a:t>
-            </a:r>
-            <a:pPr indent="0" marL="0">
-              <a:buNone/>
-            </a:pPr>
-            <a:r>
-              <a:rPr lang="en-US" sz="1050" b="1" dirty="0">
+            <a:off x="2057400" y="8997696"/>
+            <a:ext cx="5669280" cy="219456"/>
+          </a:xfrm>
+          <a:prstGeom prst="rect">
+            <a:avLst/>
+          </a:prstGeom>
+          <a:noFill/>
+          <a:ln/>
+        </p:spPr>
+        <p:txBody>
+          <a:bodyPr wrap="square" lIns="0" tIns="0" rIns="0" bIns="0" rtlCol="0" anchor="ctr"/>
+          <a:lstStyle/>
+          <a:p>
+            <a:pPr indent="0" marL="0">
+              <a:buNone/>
+            </a:pPr>
+            <a:r>
+              <a:rPr lang="en-US" sz="1000" b="1" dirty="0">
                 <a:solidFill>
                   <a:srgbClr val="0284C7"/>
                 </a:solidFill>
@@ -3698,50 +3684,60 @@
               </a:rPr>
               <a:t>bakesiga.github.io/usmle-dashboard</a:t>
             </a:r>
-            <a:endParaRPr lang="en-US" sz="1050" dirty="0"/>
-          </a:p>
-        </p:txBody>
-      </p:sp>
-      <p:sp>
-        <p:nvSpPr>
-          <p:cNvPr id="69" name="Text 65"/>
-          <p:cNvSpPr/>
-          <p:nvPr/>
-        </p:nvSpPr>
-        <p:spPr>
-          <a:xfrm>
-            <a:off x="2057400" y="9253728"/>
-            <a:ext cx="5669280" cy="219456"/>
-          </a:xfrm>
-          <a:prstGeom prst="rect">
-            <a:avLst/>
-          </a:prstGeom>
-          <a:noFill/>
-          <a:ln/>
-        </p:spPr>
-        <p:txBody>
-          <a:bodyPr wrap="square" lIns="0" tIns="0" rIns="0" bIns="0" rtlCol="0" anchor="ctr"/>
-          <a:lstStyle/>
-          <a:p>
-            <a:pPr indent="0" marL="0">
-              <a:buNone/>
-            </a:pPr>
-            <a:r>
-              <a:rPr lang="en-US" sz="1000" dirty="0">
-                <a:solidFill>
-                  <a:srgbClr val="6B87A3"/>
-                </a:solidFill>
-                <a:latin typeface="Calibri" pitchFamily="34" charset="0"/>
-                <a:ea typeface="Calibri" pitchFamily="34" charset="-122"/>
-                <a:cs typeface="Calibri" pitchFamily="34" charset="-120"/>
-              </a:rPr>
-              <a:t>or message </a:t>
-            </a:r>
-            <a:pPr indent="0" marL="0">
-              <a:buNone/>
-            </a:pPr>
-            <a:r>
-              <a:rPr lang="en-US" sz="1000" b="1" dirty="0">
+            <a:endParaRPr lang="en-US" sz="1000" dirty="0"/>
+          </a:p>
+        </p:txBody>
+      </p:sp>
+      <p:pic>
+        <p:nvPicPr>
+          <p:cNvPr id="69" name="Image 2" descr="email-blue.png">    </p:cNvPr>
+          <p:cNvPicPr>
+            <a:picLocks noChangeAspect="1"/>
+          </p:cNvPicPr>
+          <p:nvPr/>
+        </p:nvPicPr>
+        <p:blipFill>
+          <a:blip r:embed="rId3"/>
+          <a:stretch>
+            <a:fillRect/>
+          </a:stretch>
+        </p:blipFill>
+        <p:spPr>
+          <a:xfrm>
+            <a:off x="2057400" y="9308592"/>
+            <a:ext cx="182880" cy="182880"/>
+          </a:xfrm>
+          <a:prstGeom prst="rect">
+            <a:avLst/>
+          </a:prstGeom>
+        </p:spPr>
+      </p:pic>
+      <p:sp>
+        <p:nvSpPr>
+          <p:cNvPr id="70" name="Text 65"/>
+          <p:cNvSpPr/>
+          <p:nvPr/>
+        </p:nvSpPr>
+        <p:spPr>
+          <a:xfrm>
+            <a:off x="2295144" y="9281160"/>
+            <a:ext cx="1615440" cy="256032"/>
+          </a:xfrm>
+          <a:prstGeom prst="rect">
+            <a:avLst/>
+          </a:prstGeom>
+          <a:noFill/>
+          <a:ln/>
+        </p:spPr>
+        <p:txBody>
+          <a:bodyPr wrap="square" lIns="0" tIns="0" rIns="0" bIns="0" rtlCol="0" anchor="ctr"/>
+          <a:lstStyle/>
+          <a:p>
+            <a:pPr indent="0" marL="0">
+              <a:buNone/>
+            </a:pPr>
+            <a:r>
+              <a:rPr lang="en-US" sz="950" b="1" dirty="0">
                 <a:solidFill>
                   <a:srgbClr val="0C2A3D"/>
                 </a:solidFill>
@@ -3749,29 +3745,141 @@
                 <a:ea typeface="Calibri" pitchFamily="34" charset="-122"/>
                 <a:cs typeface="Calibri" pitchFamily="34" charset="-120"/>
               </a:rPr>
+              <a:t>allanbakesiga@gmail.com</a:t>
+            </a:r>
+            <a:endParaRPr lang="en-US" sz="950" dirty="0"/>
+          </a:p>
+        </p:txBody>
+      </p:sp>
+      <p:pic>
+        <p:nvPicPr>
+          <p:cNvPr id="71" name="Image 3" descr="whatsapp.png">    </p:cNvPr>
+          <p:cNvPicPr>
+            <a:picLocks noChangeAspect="1"/>
+          </p:cNvPicPr>
+          <p:nvPr/>
+        </p:nvPicPr>
+        <p:blipFill>
+          <a:blip r:embed="rId4"/>
+          <a:stretch>
+            <a:fillRect/>
+          </a:stretch>
+        </p:blipFill>
+        <p:spPr>
+          <a:xfrm>
+            <a:off x="3947160" y="9308592"/>
+            <a:ext cx="182880" cy="182880"/>
+          </a:xfrm>
+          <a:prstGeom prst="rect">
+            <a:avLst/>
+          </a:prstGeom>
+        </p:spPr>
+      </p:pic>
+      <p:sp>
+        <p:nvSpPr>
+          <p:cNvPr id="72" name="Text 66"/>
+          <p:cNvSpPr/>
+          <p:nvPr/>
+        </p:nvSpPr>
+        <p:spPr>
+          <a:xfrm>
+            <a:off x="4184904" y="9281160"/>
+            <a:ext cx="1615440" cy="256032"/>
+          </a:xfrm>
+          <a:prstGeom prst="rect">
+            <a:avLst/>
+          </a:prstGeom>
+          <a:noFill/>
+          <a:ln/>
+        </p:spPr>
+        <p:txBody>
+          <a:bodyPr wrap="square" lIns="0" tIns="0" rIns="0" bIns="0" rtlCol="0" anchor="ctr"/>
+          <a:lstStyle/>
+          <a:p>
+            <a:pPr indent="0" marL="0">
+              <a:buNone/>
+            </a:pPr>
+            <a:r>
+              <a:rPr lang="en-US" sz="950" b="1" dirty="0">
+                <a:solidFill>
+                  <a:srgbClr val="0C2A3D"/>
+                </a:solidFill>
+                <a:latin typeface="Calibri" pitchFamily="34" charset="0"/>
+                <a:ea typeface="Calibri" pitchFamily="34" charset="-122"/>
+                <a:cs typeface="Calibri" pitchFamily="34" charset="-120"/>
+              </a:rPr>
               <a:t>+256 705 571 443</a:t>
             </a:r>
-            <a:pPr indent="0" marL="0">
-              <a:buNone/>
-            </a:pPr>
-            <a:r>
-              <a:rPr lang="en-US" sz="1000" dirty="0">
-                <a:solidFill>
-                  <a:srgbClr val="6B87A3"/>
-                </a:solidFill>
-                <a:latin typeface="Calibri" pitchFamily="34" charset="0"/>
-                <a:ea typeface="Calibri" pitchFamily="34" charset="-122"/>
-                <a:cs typeface="Calibri" pitchFamily="34" charset="-120"/>
-              </a:rPr>
-              <a:t>  ·  WhatsApp</a:t>
-            </a:r>
-            <a:endParaRPr lang="en-US" sz="1000" dirty="0"/>
-          </a:p>
-        </p:txBody>
-      </p:sp>
-      <p:sp>
-        <p:nvSpPr>
-          <p:cNvPr id="70" name="Shape 66"/>
+            <a:endParaRPr lang="en-US" sz="950" dirty="0"/>
+          </a:p>
+        </p:txBody>
+      </p:sp>
+      <p:pic>
+        <p:nvPicPr>
+          <p:cNvPr id="73" name="Image 4" descr="phone-blue.png">    </p:cNvPr>
+          <p:cNvPicPr>
+            <a:picLocks noChangeAspect="1"/>
+          </p:cNvPicPr>
+          <p:nvPr/>
+        </p:nvPicPr>
+        <p:blipFill>
+          <a:blip r:embed="rId5"/>
+          <a:stretch>
+            <a:fillRect/>
+          </a:stretch>
+        </p:blipFill>
+        <p:spPr>
+          <a:xfrm>
+            <a:off x="5836920" y="9308592"/>
+            <a:ext cx="182880" cy="182880"/>
+          </a:xfrm>
+          <a:prstGeom prst="rect">
+            <a:avLst/>
+          </a:prstGeom>
+        </p:spPr>
+      </p:pic>
+      <p:sp>
+        <p:nvSpPr>
+          <p:cNvPr id="74" name="Text 67"/>
+          <p:cNvSpPr/>
+          <p:nvPr/>
+        </p:nvSpPr>
+        <p:spPr>
+          <a:xfrm>
+            <a:off x="6074664" y="9281160"/>
+            <a:ext cx="1615440" cy="256032"/>
+          </a:xfrm>
+          <a:prstGeom prst="rect">
+            <a:avLst/>
+          </a:prstGeom>
+          <a:noFill/>
+          <a:ln/>
+        </p:spPr>
+        <p:txBody>
+          <a:bodyPr wrap="square" lIns="0" tIns="0" rIns="0" bIns="0" rtlCol="0" anchor="ctr"/>
+          <a:lstStyle/>
+          <a:p>
+            <a:pPr indent="0" marL="0">
+              <a:buNone/>
+            </a:pPr>
+            <a:r>
+              <a:rPr lang="en-US" sz="950" b="1" dirty="0">
+                <a:solidFill>
+                  <a:srgbClr val="0C2A3D"/>
+                </a:solidFill>
+                <a:latin typeface="Calibri" pitchFamily="34" charset="0"/>
+                <a:ea typeface="Calibri" pitchFamily="34" charset="-122"/>
+                <a:cs typeface="Calibri" pitchFamily="34" charset="-120"/>
+              </a:rPr>
+              <a:t>+1 984 710 2902</a:t>
+            </a:r>
+            <a:endParaRPr lang="en-US" sz="950" dirty="0"/>
+          </a:p>
+        </p:txBody>
+      </p:sp>
+      <p:sp>
+        <p:nvSpPr>
+          <p:cNvPr id="75" name="Shape 68"/>
           <p:cNvSpPr/>
           <p:nvPr/>
         </p:nvSpPr>
@@ -3794,7 +3902,7 @@
       </p:sp>
       <p:sp>
         <p:nvSpPr>
-          <p:cNvPr id="71" name="Text 67"/>
+          <p:cNvPr id="76" name="Text 69"/>
           <p:cNvSpPr/>
           <p:nvPr/>
         </p:nvSpPr>

</xml_diff>

<commit_message>
Flyer: move credentials beside the photo; drop footer badge
Allan Bakesiga, MD · MD (Makerere) · MScGH (Duke) · PGY-1 Neurology,
Creighton now appears as a centered caption directly beneath the
headshot in the hero, giving the photo a proper speaker-card feel.
The redundant footer badge is removed.

Co-Authored-By: Claude Opus 4.7 (1M context) <noreply@anthropic.com>
</commit_message>
<xml_diff>
--- a/outputs/flyers/USMLE_June_Advert.pptx
+++ b/outputs/flyers/USMLE_June_Advert.pptx
@@ -883,7 +883,7 @@
         </p:nvSpPr>
         <p:spPr>
           <a:xfrm>
-            <a:off x="0" y="1792224"/>
+            <a:off x="0" y="2203704"/>
             <a:ext cx="8229600" cy="36576"/>
           </a:xfrm>
           <a:prstGeom prst="rect">
@@ -1080,8 +1080,8 @@
         </p:nvSpPr>
         <p:spPr>
           <a:xfrm>
-            <a:off x="6181344" y="77724"/>
-            <a:ext cx="1581912" cy="1581912"/>
+            <a:off x="6199632" y="128016"/>
+            <a:ext cx="1399032" cy="1399032"/>
           </a:xfrm>
           <a:prstGeom prst="ellipse">
             <a:avLst/>
@@ -1113,8 +1113,8 @@
         </p:blipFill>
         <p:spPr>
           <a:xfrm>
-            <a:off x="6217920" y="114300"/>
-            <a:ext cx="1508760" cy="1508760"/>
+            <a:off x="6236208" y="164592"/>
+            <a:ext cx="1325880" cy="1325880"/>
           </a:xfrm>
           <a:prstGeom prst="rect">
             <a:avLst/>
@@ -1129,7 +1129,124 @@
         </p:nvSpPr>
         <p:spPr>
           <a:xfrm>
-            <a:off x="502920" y="2029968"/>
+            <a:off x="5961888" y="1545336"/>
+            <a:ext cx="1874520" cy="201168"/>
+          </a:xfrm>
+          <a:prstGeom prst="rect">
+            <a:avLst/>
+          </a:prstGeom>
+          <a:noFill/>
+          <a:ln/>
+        </p:spPr>
+        <p:txBody>
+          <a:bodyPr wrap="square" lIns="0" tIns="0" rIns="0" bIns="0" rtlCol="0" anchor="ctr"/>
+          <a:lstStyle/>
+          <a:p>
+            <a:pPr algn="ctr" indent="0" marL="0">
+              <a:buNone/>
+            </a:pPr>
+            <a:r>
+              <a:rPr lang="en-US" sz="1100" b="1" dirty="0">
+                <a:solidFill>
+                  <a:srgbClr val="0C2A3D"/>
+                </a:solidFill>
+                <a:latin typeface="Calibri" pitchFamily="34" charset="0"/>
+                <a:ea typeface="Calibri" pitchFamily="34" charset="-122"/>
+                <a:cs typeface="Calibri" pitchFamily="34" charset="-120"/>
+              </a:rPr>
+              <a:t>Allan Bakesiga, MD</a:t>
+            </a:r>
+            <a:endParaRPr lang="en-US" sz="1100" dirty="0"/>
+          </a:p>
+        </p:txBody>
+      </p:sp>
+      <p:sp>
+        <p:nvSpPr>
+          <p:cNvPr id="10" name="Text 7"/>
+          <p:cNvSpPr/>
+          <p:nvPr/>
+        </p:nvSpPr>
+        <p:spPr>
+          <a:xfrm>
+            <a:off x="5961888" y="1746504"/>
+            <a:ext cx="1874520" cy="182880"/>
+          </a:xfrm>
+          <a:prstGeom prst="rect">
+            <a:avLst/>
+          </a:prstGeom>
+          <a:noFill/>
+          <a:ln/>
+        </p:spPr>
+        <p:txBody>
+          <a:bodyPr wrap="square" lIns="0" tIns="0" rIns="0" bIns="0" rtlCol="0" anchor="ctr"/>
+          <a:lstStyle/>
+          <a:p>
+            <a:pPr algn="ctr" indent="0" marL="0">
+              <a:buNone/>
+            </a:pPr>
+            <a:r>
+              <a:rPr lang="en-US" sz="850" dirty="0">
+                <a:solidFill>
+                  <a:srgbClr val="6B87A3"/>
+                </a:solidFill>
+                <a:latin typeface="Calibri" pitchFamily="34" charset="0"/>
+                <a:ea typeface="Calibri" pitchFamily="34" charset="-122"/>
+                <a:cs typeface="Calibri" pitchFamily="34" charset="-120"/>
+              </a:rPr>
+              <a:t>MD (Makerere)  ·  MScGH (Duke)</a:t>
+            </a:r>
+            <a:endParaRPr lang="en-US" sz="850" dirty="0"/>
+          </a:p>
+        </p:txBody>
+      </p:sp>
+      <p:sp>
+        <p:nvSpPr>
+          <p:cNvPr id="11" name="Text 8"/>
+          <p:cNvSpPr/>
+          <p:nvPr/>
+        </p:nvSpPr>
+        <p:spPr>
+          <a:xfrm>
+            <a:off x="5961888" y="1929384"/>
+            <a:ext cx="1874520" cy="182880"/>
+          </a:xfrm>
+          <a:prstGeom prst="rect">
+            <a:avLst/>
+          </a:prstGeom>
+          <a:noFill/>
+          <a:ln/>
+        </p:spPr>
+        <p:txBody>
+          <a:bodyPr wrap="square" lIns="0" tIns="0" rIns="0" bIns="0" rtlCol="0" anchor="ctr"/>
+          <a:lstStyle/>
+          <a:p>
+            <a:pPr algn="ctr" indent="0" marL="0">
+              <a:buNone/>
+            </a:pPr>
+            <a:r>
+              <a:rPr lang="en-US" sz="850" dirty="0">
+                <a:solidFill>
+                  <a:srgbClr val="6B87A3"/>
+                </a:solidFill>
+                <a:latin typeface="Calibri" pitchFamily="34" charset="0"/>
+                <a:ea typeface="Calibri" pitchFamily="34" charset="-122"/>
+                <a:cs typeface="Calibri" pitchFamily="34" charset="-120"/>
+              </a:rPr>
+              <a:t>PGY-1 Neurology, Creighton</a:t>
+            </a:r>
+            <a:endParaRPr lang="en-US" sz="850" dirty="0"/>
+          </a:p>
+        </p:txBody>
+      </p:sp>
+      <p:sp>
+        <p:nvSpPr>
+          <p:cNvPr id="12" name="Text 9"/>
+          <p:cNvSpPr/>
+          <p:nvPr/>
+        </p:nvSpPr>
+        <p:spPr>
+          <a:xfrm>
+            <a:off x="502920" y="2441448"/>
             <a:ext cx="7223760" cy="237744"/>
           </a:xfrm>
           <a:prstGeom prst="rect">
@@ -1162,13 +1279,13 @@
       </p:sp>
       <p:sp>
         <p:nvSpPr>
-          <p:cNvPr id="10" name="Shape 7"/>
-          <p:cNvSpPr/>
-          <p:nvPr/>
-        </p:nvSpPr>
-        <p:spPr>
-          <a:xfrm>
-            <a:off x="502920" y="2331720"/>
+          <p:cNvPr id="13" name="Shape 10"/>
+          <p:cNvSpPr/>
+          <p:nvPr/>
+        </p:nvSpPr>
+        <p:spPr>
+          <a:xfrm>
+            <a:off x="502920" y="2743200"/>
             <a:ext cx="1005840" cy="0"/>
           </a:xfrm>
           <a:prstGeom prst="line">
@@ -1185,13 +1302,13 @@
       </p:sp>
       <p:sp>
         <p:nvSpPr>
-          <p:cNvPr id="11" name="Shape 8"/>
-          <p:cNvSpPr/>
-          <p:nvPr/>
-        </p:nvSpPr>
-        <p:spPr>
-          <a:xfrm>
-            <a:off x="502920" y="2331720"/>
+          <p:cNvPr id="14" name="Shape 11"/>
+          <p:cNvSpPr/>
+          <p:nvPr/>
+        </p:nvSpPr>
+        <p:spPr>
+          <a:xfrm>
+            <a:off x="502920" y="2743200"/>
             <a:ext cx="3543300" cy="2377440"/>
           </a:xfrm>
           <a:prstGeom prst="roundRect">
@@ -1212,13 +1329,13 @@
       </p:sp>
       <p:sp>
         <p:nvSpPr>
-          <p:cNvPr id="12" name="Shape 9"/>
-          <p:cNvSpPr/>
-          <p:nvPr/>
-        </p:nvSpPr>
-        <p:spPr>
-          <a:xfrm>
-            <a:off x="502920" y="2404872"/>
+          <p:cNvPr id="15" name="Shape 12"/>
+          <p:cNvSpPr/>
+          <p:nvPr/>
+        </p:nvSpPr>
+        <p:spPr>
+          <a:xfrm>
+            <a:off x="502920" y="2816352"/>
             <a:ext cx="3543300" cy="493776"/>
           </a:xfrm>
           <a:prstGeom prst="rect">
@@ -1237,13 +1354,13 @@
       </p:sp>
       <p:sp>
         <p:nvSpPr>
-          <p:cNvPr id="13" name="Shape 10"/>
-          <p:cNvSpPr/>
-          <p:nvPr/>
-        </p:nvSpPr>
-        <p:spPr>
-          <a:xfrm>
-            <a:off x="502920" y="2331720"/>
+          <p:cNvPr id="16" name="Shape 13"/>
+          <p:cNvSpPr/>
+          <p:nvPr/>
+        </p:nvSpPr>
+        <p:spPr>
+          <a:xfrm>
+            <a:off x="502920" y="2743200"/>
             <a:ext cx="3543300" cy="566928"/>
           </a:xfrm>
           <a:prstGeom prst="roundRect">
@@ -1264,13 +1381,13 @@
       </p:sp>
       <p:sp>
         <p:nvSpPr>
-          <p:cNvPr id="14" name="Text 11"/>
-          <p:cNvSpPr/>
-          <p:nvPr/>
-        </p:nvSpPr>
-        <p:spPr>
-          <a:xfrm>
-            <a:off x="630936" y="2386584"/>
+          <p:cNvPr id="17" name="Text 14"/>
+          <p:cNvSpPr/>
+          <p:nvPr/>
+        </p:nvSpPr>
+        <p:spPr>
+          <a:xfrm>
+            <a:off x="630936" y="2798064"/>
             <a:ext cx="3287268" cy="256032"/>
           </a:xfrm>
           <a:prstGeom prst="rect">
@@ -1303,13 +1420,13 @@
       </p:sp>
       <p:sp>
         <p:nvSpPr>
-          <p:cNvPr id="15" name="Text 12"/>
-          <p:cNvSpPr/>
-          <p:nvPr/>
-        </p:nvSpPr>
-        <p:spPr>
-          <a:xfrm>
-            <a:off x="630936" y="2642616"/>
+          <p:cNvPr id="18" name="Text 15"/>
+          <p:cNvSpPr/>
+          <p:nvPr/>
+        </p:nvSpPr>
+        <p:spPr>
+          <a:xfrm>
+            <a:off x="630936" y="3054096"/>
             <a:ext cx="3287268" cy="219456"/>
           </a:xfrm>
           <a:prstGeom prst="rect">
@@ -1342,13 +1459,13 @@
       </p:sp>
       <p:sp>
         <p:nvSpPr>
-          <p:cNvPr id="16" name="Text 13"/>
-          <p:cNvSpPr/>
-          <p:nvPr/>
-        </p:nvSpPr>
-        <p:spPr>
-          <a:xfrm>
-            <a:off x="630936" y="2990088"/>
+          <p:cNvPr id="19" name="Text 16"/>
+          <p:cNvSpPr/>
+          <p:nvPr/>
+        </p:nvSpPr>
+        <p:spPr>
+          <a:xfrm>
+            <a:off x="630936" y="3401568"/>
             <a:ext cx="3287268" cy="173736"/>
           </a:xfrm>
           <a:prstGeom prst="rect">
@@ -1395,13 +1512,13 @@
       </p:sp>
       <p:sp>
         <p:nvSpPr>
-          <p:cNvPr id="17" name="Text 14"/>
-          <p:cNvSpPr/>
-          <p:nvPr/>
-        </p:nvSpPr>
-        <p:spPr>
-          <a:xfrm>
-            <a:off x="630936" y="3163824"/>
+          <p:cNvPr id="20" name="Text 17"/>
+          <p:cNvSpPr/>
+          <p:nvPr/>
+        </p:nvSpPr>
+        <p:spPr>
+          <a:xfrm>
+            <a:off x="630936" y="3575304"/>
             <a:ext cx="3287268" cy="173736"/>
           </a:xfrm>
           <a:prstGeom prst="rect">
@@ -1448,13 +1565,13 @@
       </p:sp>
       <p:sp>
         <p:nvSpPr>
-          <p:cNvPr id="18" name="Text 15"/>
-          <p:cNvSpPr/>
-          <p:nvPr/>
-        </p:nvSpPr>
-        <p:spPr>
-          <a:xfrm>
-            <a:off x="630936" y="3337560"/>
+          <p:cNvPr id="21" name="Text 18"/>
+          <p:cNvSpPr/>
+          <p:nvPr/>
+        </p:nvSpPr>
+        <p:spPr>
+          <a:xfrm>
+            <a:off x="630936" y="3749040"/>
             <a:ext cx="3287268" cy="173736"/>
           </a:xfrm>
           <a:prstGeom prst="rect">
@@ -1501,13 +1618,13 @@
       </p:sp>
       <p:sp>
         <p:nvSpPr>
-          <p:cNvPr id="19" name="Text 16"/>
-          <p:cNvSpPr/>
-          <p:nvPr/>
-        </p:nvSpPr>
-        <p:spPr>
-          <a:xfrm>
-            <a:off x="630936" y="3511296"/>
+          <p:cNvPr id="22" name="Text 19"/>
+          <p:cNvSpPr/>
+          <p:nvPr/>
+        </p:nvSpPr>
+        <p:spPr>
+          <a:xfrm>
+            <a:off x="630936" y="3922776"/>
             <a:ext cx="3287268" cy="173736"/>
           </a:xfrm>
           <a:prstGeom prst="rect">
@@ -1554,13 +1671,13 @@
       </p:sp>
       <p:sp>
         <p:nvSpPr>
-          <p:cNvPr id="20" name="Text 17"/>
-          <p:cNvSpPr/>
-          <p:nvPr/>
-        </p:nvSpPr>
-        <p:spPr>
-          <a:xfrm>
-            <a:off x="630936" y="3685032"/>
+          <p:cNvPr id="23" name="Text 20"/>
+          <p:cNvSpPr/>
+          <p:nvPr/>
+        </p:nvSpPr>
+        <p:spPr>
+          <a:xfrm>
+            <a:off x="630936" y="4096512"/>
             <a:ext cx="3287268" cy="173736"/>
           </a:xfrm>
           <a:prstGeom prst="rect">
@@ -1607,13 +1724,13 @@
       </p:sp>
       <p:sp>
         <p:nvSpPr>
-          <p:cNvPr id="21" name="Text 18"/>
-          <p:cNvSpPr/>
-          <p:nvPr/>
-        </p:nvSpPr>
-        <p:spPr>
-          <a:xfrm>
-            <a:off x="630936" y="3858768"/>
+          <p:cNvPr id="24" name="Text 21"/>
+          <p:cNvSpPr/>
+          <p:nvPr/>
+        </p:nvSpPr>
+        <p:spPr>
+          <a:xfrm>
+            <a:off x="630936" y="4270248"/>
             <a:ext cx="3287268" cy="173736"/>
           </a:xfrm>
           <a:prstGeom prst="rect">
@@ -1660,13 +1777,13 @@
       </p:sp>
       <p:sp>
         <p:nvSpPr>
-          <p:cNvPr id="22" name="Text 19"/>
-          <p:cNvSpPr/>
-          <p:nvPr/>
-        </p:nvSpPr>
-        <p:spPr>
-          <a:xfrm>
-            <a:off x="630936" y="4032504"/>
+          <p:cNvPr id="25" name="Text 22"/>
+          <p:cNvSpPr/>
+          <p:nvPr/>
+        </p:nvSpPr>
+        <p:spPr>
+          <a:xfrm>
+            <a:off x="630936" y="4443984"/>
             <a:ext cx="3287268" cy="173736"/>
           </a:xfrm>
           <a:prstGeom prst="rect">
@@ -1713,13 +1830,13 @@
       </p:sp>
       <p:sp>
         <p:nvSpPr>
-          <p:cNvPr id="23" name="Text 20"/>
-          <p:cNvSpPr/>
-          <p:nvPr/>
-        </p:nvSpPr>
-        <p:spPr>
-          <a:xfrm>
-            <a:off x="630936" y="4206240"/>
+          <p:cNvPr id="26" name="Text 23"/>
+          <p:cNvSpPr/>
+          <p:nvPr/>
+        </p:nvSpPr>
+        <p:spPr>
+          <a:xfrm>
+            <a:off x="630936" y="4617720"/>
             <a:ext cx="3287268" cy="173736"/>
           </a:xfrm>
           <a:prstGeom prst="rect">
@@ -1766,13 +1883,13 @@
       </p:sp>
       <p:sp>
         <p:nvSpPr>
-          <p:cNvPr id="24" name="Text 21"/>
-          <p:cNvSpPr/>
-          <p:nvPr/>
-        </p:nvSpPr>
-        <p:spPr>
-          <a:xfrm>
-            <a:off x="630936" y="4379976"/>
+          <p:cNvPr id="27" name="Text 24"/>
+          <p:cNvSpPr/>
+          <p:nvPr/>
+        </p:nvSpPr>
+        <p:spPr>
+          <a:xfrm>
+            <a:off x="630936" y="4791456"/>
             <a:ext cx="3287268" cy="173736"/>
           </a:xfrm>
           <a:prstGeom prst="rect">
@@ -1819,13 +1936,13 @@
       </p:sp>
       <p:sp>
         <p:nvSpPr>
-          <p:cNvPr id="25" name="Text 22"/>
-          <p:cNvSpPr/>
-          <p:nvPr/>
-        </p:nvSpPr>
-        <p:spPr>
-          <a:xfrm>
-            <a:off x="630936" y="4553712"/>
+          <p:cNvPr id="28" name="Text 25"/>
+          <p:cNvSpPr/>
+          <p:nvPr/>
+        </p:nvSpPr>
+        <p:spPr>
+          <a:xfrm>
+            <a:off x="630936" y="4965192"/>
             <a:ext cx="3287268" cy="173736"/>
           </a:xfrm>
           <a:prstGeom prst="rect">
@@ -1872,13 +1989,13 @@
       </p:sp>
       <p:sp>
         <p:nvSpPr>
-          <p:cNvPr id="26" name="Shape 23"/>
-          <p:cNvSpPr/>
-          <p:nvPr/>
-        </p:nvSpPr>
-        <p:spPr>
-          <a:xfrm>
-            <a:off x="4183380" y="2331720"/>
+          <p:cNvPr id="29" name="Shape 26"/>
+          <p:cNvSpPr/>
+          <p:nvPr/>
+        </p:nvSpPr>
+        <p:spPr>
+          <a:xfrm>
+            <a:off x="4183380" y="2743200"/>
             <a:ext cx="3543300" cy="2377440"/>
           </a:xfrm>
           <a:prstGeom prst="roundRect">
@@ -1899,13 +2016,13 @@
       </p:sp>
       <p:sp>
         <p:nvSpPr>
-          <p:cNvPr id="27" name="Shape 24"/>
-          <p:cNvSpPr/>
-          <p:nvPr/>
-        </p:nvSpPr>
-        <p:spPr>
-          <a:xfrm>
-            <a:off x="4183380" y="2404872"/>
+          <p:cNvPr id="30" name="Shape 27"/>
+          <p:cNvSpPr/>
+          <p:nvPr/>
+        </p:nvSpPr>
+        <p:spPr>
+          <a:xfrm>
+            <a:off x="4183380" y="2816352"/>
             <a:ext cx="3543300" cy="493776"/>
           </a:xfrm>
           <a:prstGeom prst="rect">
@@ -1924,13 +2041,13 @@
       </p:sp>
       <p:sp>
         <p:nvSpPr>
-          <p:cNvPr id="28" name="Shape 25"/>
-          <p:cNvSpPr/>
-          <p:nvPr/>
-        </p:nvSpPr>
-        <p:spPr>
-          <a:xfrm>
-            <a:off x="4183380" y="2331720"/>
+          <p:cNvPr id="31" name="Shape 28"/>
+          <p:cNvSpPr/>
+          <p:nvPr/>
+        </p:nvSpPr>
+        <p:spPr>
+          <a:xfrm>
+            <a:off x="4183380" y="2743200"/>
             <a:ext cx="3543300" cy="566928"/>
           </a:xfrm>
           <a:prstGeom prst="roundRect">
@@ -1951,13 +2068,13 @@
       </p:sp>
       <p:sp>
         <p:nvSpPr>
-          <p:cNvPr id="29" name="Text 26"/>
-          <p:cNvSpPr/>
-          <p:nvPr/>
-        </p:nvSpPr>
-        <p:spPr>
-          <a:xfrm>
-            <a:off x="4311396" y="2386584"/>
+          <p:cNvPr id="32" name="Text 29"/>
+          <p:cNvSpPr/>
+          <p:nvPr/>
+        </p:nvSpPr>
+        <p:spPr>
+          <a:xfrm>
+            <a:off x="4311396" y="2798064"/>
             <a:ext cx="3287268" cy="256032"/>
           </a:xfrm>
           <a:prstGeom prst="rect">
@@ -1990,13 +2107,13 @@
       </p:sp>
       <p:sp>
         <p:nvSpPr>
-          <p:cNvPr id="30" name="Text 27"/>
-          <p:cNvSpPr/>
-          <p:nvPr/>
-        </p:nvSpPr>
-        <p:spPr>
-          <a:xfrm>
-            <a:off x="4311396" y="2642616"/>
+          <p:cNvPr id="33" name="Text 30"/>
+          <p:cNvSpPr/>
+          <p:nvPr/>
+        </p:nvSpPr>
+        <p:spPr>
+          <a:xfrm>
+            <a:off x="4311396" y="3054096"/>
             <a:ext cx="3287268" cy="219456"/>
           </a:xfrm>
           <a:prstGeom prst="rect">
@@ -2029,13 +2146,13 @@
       </p:sp>
       <p:sp>
         <p:nvSpPr>
-          <p:cNvPr id="31" name="Text 28"/>
-          <p:cNvSpPr/>
-          <p:nvPr/>
-        </p:nvSpPr>
-        <p:spPr>
-          <a:xfrm>
-            <a:off x="4311396" y="2990088"/>
+          <p:cNvPr id="34" name="Text 31"/>
+          <p:cNvSpPr/>
+          <p:nvPr/>
+        </p:nvSpPr>
+        <p:spPr>
+          <a:xfrm>
+            <a:off x="4311396" y="3401568"/>
             <a:ext cx="3287268" cy="173736"/>
           </a:xfrm>
           <a:prstGeom prst="rect">
@@ -2082,13 +2199,13 @@
       </p:sp>
       <p:sp>
         <p:nvSpPr>
-          <p:cNvPr id="32" name="Text 29"/>
-          <p:cNvSpPr/>
-          <p:nvPr/>
-        </p:nvSpPr>
-        <p:spPr>
-          <a:xfrm>
-            <a:off x="4311396" y="3163824"/>
+          <p:cNvPr id="35" name="Text 32"/>
+          <p:cNvSpPr/>
+          <p:nvPr/>
+        </p:nvSpPr>
+        <p:spPr>
+          <a:xfrm>
+            <a:off x="4311396" y="3575304"/>
             <a:ext cx="3287268" cy="173736"/>
           </a:xfrm>
           <a:prstGeom prst="rect">
@@ -2135,13 +2252,13 @@
       </p:sp>
       <p:sp>
         <p:nvSpPr>
-          <p:cNvPr id="33" name="Text 30"/>
-          <p:cNvSpPr/>
-          <p:nvPr/>
-        </p:nvSpPr>
-        <p:spPr>
-          <a:xfrm>
-            <a:off x="4311396" y="3337560"/>
+          <p:cNvPr id="36" name="Text 33"/>
+          <p:cNvSpPr/>
+          <p:nvPr/>
+        </p:nvSpPr>
+        <p:spPr>
+          <a:xfrm>
+            <a:off x="4311396" y="3749040"/>
             <a:ext cx="3287268" cy="173736"/>
           </a:xfrm>
           <a:prstGeom prst="rect">
@@ -2188,13 +2305,13 @@
       </p:sp>
       <p:sp>
         <p:nvSpPr>
-          <p:cNvPr id="34" name="Text 31"/>
-          <p:cNvSpPr/>
-          <p:nvPr/>
-        </p:nvSpPr>
-        <p:spPr>
-          <a:xfrm>
-            <a:off x="4311396" y="3511296"/>
+          <p:cNvPr id="37" name="Text 34"/>
+          <p:cNvSpPr/>
+          <p:nvPr/>
+        </p:nvSpPr>
+        <p:spPr>
+          <a:xfrm>
+            <a:off x="4311396" y="3922776"/>
             <a:ext cx="3287268" cy="173736"/>
           </a:xfrm>
           <a:prstGeom prst="rect">
@@ -2241,13 +2358,13 @@
       </p:sp>
       <p:sp>
         <p:nvSpPr>
-          <p:cNvPr id="35" name="Text 32"/>
-          <p:cNvSpPr/>
-          <p:nvPr/>
-        </p:nvSpPr>
-        <p:spPr>
-          <a:xfrm>
-            <a:off x="4311396" y="3685032"/>
+          <p:cNvPr id="38" name="Text 35"/>
+          <p:cNvSpPr/>
+          <p:nvPr/>
+        </p:nvSpPr>
+        <p:spPr>
+          <a:xfrm>
+            <a:off x="4311396" y="4096512"/>
             <a:ext cx="3287268" cy="173736"/>
           </a:xfrm>
           <a:prstGeom prst="rect">
@@ -2294,13 +2411,13 @@
       </p:sp>
       <p:sp>
         <p:nvSpPr>
-          <p:cNvPr id="36" name="Text 33"/>
-          <p:cNvSpPr/>
-          <p:nvPr/>
-        </p:nvSpPr>
-        <p:spPr>
-          <a:xfrm>
-            <a:off x="4311396" y="3858768"/>
+          <p:cNvPr id="39" name="Text 36"/>
+          <p:cNvSpPr/>
+          <p:nvPr/>
+        </p:nvSpPr>
+        <p:spPr>
+          <a:xfrm>
+            <a:off x="4311396" y="4270248"/>
             <a:ext cx="3287268" cy="173736"/>
           </a:xfrm>
           <a:prstGeom prst="rect">
@@ -2347,13 +2464,13 @@
       </p:sp>
       <p:sp>
         <p:nvSpPr>
-          <p:cNvPr id="37" name="Text 34"/>
-          <p:cNvSpPr/>
-          <p:nvPr/>
-        </p:nvSpPr>
-        <p:spPr>
-          <a:xfrm>
-            <a:off x="4311396" y="4032504"/>
+          <p:cNvPr id="40" name="Text 37"/>
+          <p:cNvSpPr/>
+          <p:nvPr/>
+        </p:nvSpPr>
+        <p:spPr>
+          <a:xfrm>
+            <a:off x="4311396" y="4443984"/>
             <a:ext cx="3287268" cy="173736"/>
           </a:xfrm>
           <a:prstGeom prst="rect">
@@ -2400,13 +2517,13 @@
       </p:sp>
       <p:sp>
         <p:nvSpPr>
-          <p:cNvPr id="38" name="Text 35"/>
-          <p:cNvSpPr/>
-          <p:nvPr/>
-        </p:nvSpPr>
-        <p:spPr>
-          <a:xfrm>
-            <a:off x="4311396" y="4206240"/>
+          <p:cNvPr id="41" name="Text 38"/>
+          <p:cNvSpPr/>
+          <p:nvPr/>
+        </p:nvSpPr>
+        <p:spPr>
+          <a:xfrm>
+            <a:off x="4311396" y="4617720"/>
             <a:ext cx="3287268" cy="173736"/>
           </a:xfrm>
           <a:prstGeom prst="rect">
@@ -2453,13 +2570,13 @@
       </p:sp>
       <p:sp>
         <p:nvSpPr>
-          <p:cNvPr id="39" name="Shape 36"/>
-          <p:cNvSpPr/>
-          <p:nvPr/>
-        </p:nvSpPr>
-        <p:spPr>
-          <a:xfrm>
-            <a:off x="502920" y="4846320"/>
+          <p:cNvPr id="42" name="Shape 39"/>
+          <p:cNvSpPr/>
+          <p:nvPr/>
+        </p:nvSpPr>
+        <p:spPr>
+          <a:xfrm>
+            <a:off x="502920" y="5257800"/>
             <a:ext cx="3543300" cy="2377440"/>
           </a:xfrm>
           <a:prstGeom prst="roundRect">
@@ -2480,13 +2597,13 @@
       </p:sp>
       <p:sp>
         <p:nvSpPr>
-          <p:cNvPr id="40" name="Shape 37"/>
-          <p:cNvSpPr/>
-          <p:nvPr/>
-        </p:nvSpPr>
-        <p:spPr>
-          <a:xfrm>
-            <a:off x="502920" y="4919472"/>
+          <p:cNvPr id="43" name="Shape 40"/>
+          <p:cNvSpPr/>
+          <p:nvPr/>
+        </p:nvSpPr>
+        <p:spPr>
+          <a:xfrm>
+            <a:off x="502920" y="5330952"/>
             <a:ext cx="3543300" cy="493776"/>
           </a:xfrm>
           <a:prstGeom prst="rect">
@@ -2505,13 +2622,13 @@
       </p:sp>
       <p:sp>
         <p:nvSpPr>
-          <p:cNvPr id="41" name="Shape 38"/>
-          <p:cNvSpPr/>
-          <p:nvPr/>
-        </p:nvSpPr>
-        <p:spPr>
-          <a:xfrm>
-            <a:off x="502920" y="4846320"/>
+          <p:cNvPr id="44" name="Shape 41"/>
+          <p:cNvSpPr/>
+          <p:nvPr/>
+        </p:nvSpPr>
+        <p:spPr>
+          <a:xfrm>
+            <a:off x="502920" y="5257800"/>
             <a:ext cx="3543300" cy="566928"/>
           </a:xfrm>
           <a:prstGeom prst="roundRect">
@@ -2532,13 +2649,13 @@
       </p:sp>
       <p:sp>
         <p:nvSpPr>
-          <p:cNvPr id="42" name="Text 39"/>
-          <p:cNvSpPr/>
-          <p:nvPr/>
-        </p:nvSpPr>
-        <p:spPr>
-          <a:xfrm>
-            <a:off x="630936" y="4901184"/>
+          <p:cNvPr id="45" name="Text 42"/>
+          <p:cNvSpPr/>
+          <p:nvPr/>
+        </p:nvSpPr>
+        <p:spPr>
+          <a:xfrm>
+            <a:off x="630936" y="5312664"/>
             <a:ext cx="3287268" cy="256032"/>
           </a:xfrm>
           <a:prstGeom prst="rect">
@@ -2571,13 +2688,13 @@
       </p:sp>
       <p:sp>
         <p:nvSpPr>
-          <p:cNvPr id="43" name="Text 40"/>
-          <p:cNvSpPr/>
-          <p:nvPr/>
-        </p:nvSpPr>
-        <p:spPr>
-          <a:xfrm>
-            <a:off x="630936" y="5157216"/>
+          <p:cNvPr id="46" name="Text 43"/>
+          <p:cNvSpPr/>
+          <p:nvPr/>
+        </p:nvSpPr>
+        <p:spPr>
+          <a:xfrm>
+            <a:off x="630936" y="5568696"/>
             <a:ext cx="3287268" cy="219456"/>
           </a:xfrm>
           <a:prstGeom prst="rect">
@@ -2610,13 +2727,13 @@
       </p:sp>
       <p:sp>
         <p:nvSpPr>
-          <p:cNvPr id="44" name="Text 41"/>
-          <p:cNvSpPr/>
-          <p:nvPr/>
-        </p:nvSpPr>
-        <p:spPr>
-          <a:xfrm>
-            <a:off x="630936" y="5596128"/>
+          <p:cNvPr id="47" name="Text 44"/>
+          <p:cNvSpPr/>
+          <p:nvPr/>
+        </p:nvSpPr>
+        <p:spPr>
+          <a:xfrm>
+            <a:off x="630936" y="6007608"/>
             <a:ext cx="3287268" cy="384048"/>
           </a:xfrm>
           <a:prstGeom prst="rect">
@@ -2663,13 +2780,13 @@
       </p:sp>
       <p:sp>
         <p:nvSpPr>
-          <p:cNvPr id="45" name="Text 42"/>
-          <p:cNvSpPr/>
-          <p:nvPr/>
-        </p:nvSpPr>
-        <p:spPr>
-          <a:xfrm>
-            <a:off x="630936" y="5980176"/>
+          <p:cNvPr id="48" name="Text 45"/>
+          <p:cNvSpPr/>
+          <p:nvPr/>
+        </p:nvSpPr>
+        <p:spPr>
+          <a:xfrm>
+            <a:off x="630936" y="6391656"/>
             <a:ext cx="3287268" cy="384048"/>
           </a:xfrm>
           <a:prstGeom prst="rect">
@@ -2716,13 +2833,13 @@
       </p:sp>
       <p:sp>
         <p:nvSpPr>
-          <p:cNvPr id="46" name="Text 43"/>
-          <p:cNvSpPr/>
-          <p:nvPr/>
-        </p:nvSpPr>
-        <p:spPr>
-          <a:xfrm>
-            <a:off x="630936" y="6364224"/>
+          <p:cNvPr id="49" name="Text 46"/>
+          <p:cNvSpPr/>
+          <p:nvPr/>
+        </p:nvSpPr>
+        <p:spPr>
+          <a:xfrm>
+            <a:off x="630936" y="6775704"/>
             <a:ext cx="3287268" cy="384048"/>
           </a:xfrm>
           <a:prstGeom prst="rect">
@@ -2769,13 +2886,13 @@
       </p:sp>
       <p:sp>
         <p:nvSpPr>
-          <p:cNvPr id="47" name="Text 44"/>
-          <p:cNvSpPr/>
-          <p:nvPr/>
-        </p:nvSpPr>
-        <p:spPr>
-          <a:xfrm>
-            <a:off x="630936" y="6748272"/>
+          <p:cNvPr id="50" name="Text 47"/>
+          <p:cNvSpPr/>
+          <p:nvPr/>
+        </p:nvSpPr>
+        <p:spPr>
+          <a:xfrm>
+            <a:off x="630936" y="7159752"/>
             <a:ext cx="3287268" cy="384048"/>
           </a:xfrm>
           <a:prstGeom prst="rect">
@@ -2822,13 +2939,13 @@
       </p:sp>
       <p:sp>
         <p:nvSpPr>
-          <p:cNvPr id="48" name="Shape 45"/>
-          <p:cNvSpPr/>
-          <p:nvPr/>
-        </p:nvSpPr>
-        <p:spPr>
-          <a:xfrm>
-            <a:off x="4183380" y="4846320"/>
+          <p:cNvPr id="51" name="Shape 48"/>
+          <p:cNvSpPr/>
+          <p:nvPr/>
+        </p:nvSpPr>
+        <p:spPr>
+          <a:xfrm>
+            <a:off x="4183380" y="5257800"/>
             <a:ext cx="3543300" cy="2377440"/>
           </a:xfrm>
           <a:prstGeom prst="roundRect">
@@ -2849,13 +2966,13 @@
       </p:sp>
       <p:sp>
         <p:nvSpPr>
-          <p:cNvPr id="49" name="Shape 46"/>
-          <p:cNvSpPr/>
-          <p:nvPr/>
-        </p:nvSpPr>
-        <p:spPr>
-          <a:xfrm>
-            <a:off x="4183380" y="4919472"/>
+          <p:cNvPr id="52" name="Shape 49"/>
+          <p:cNvSpPr/>
+          <p:nvPr/>
+        </p:nvSpPr>
+        <p:spPr>
+          <a:xfrm>
+            <a:off x="4183380" y="5330952"/>
             <a:ext cx="3543300" cy="493776"/>
           </a:xfrm>
           <a:prstGeom prst="rect">
@@ -2874,13 +2991,13 @@
       </p:sp>
       <p:sp>
         <p:nvSpPr>
-          <p:cNvPr id="50" name="Shape 47"/>
-          <p:cNvSpPr/>
-          <p:nvPr/>
-        </p:nvSpPr>
-        <p:spPr>
-          <a:xfrm>
-            <a:off x="4183380" y="4846320"/>
+          <p:cNvPr id="53" name="Shape 50"/>
+          <p:cNvSpPr/>
+          <p:nvPr/>
+        </p:nvSpPr>
+        <p:spPr>
+          <a:xfrm>
+            <a:off x="4183380" y="5257800"/>
             <a:ext cx="3543300" cy="566928"/>
           </a:xfrm>
           <a:prstGeom prst="roundRect">
@@ -2901,13 +3018,13 @@
       </p:sp>
       <p:sp>
         <p:nvSpPr>
-          <p:cNvPr id="51" name="Text 48"/>
-          <p:cNvSpPr/>
-          <p:nvPr/>
-        </p:nvSpPr>
-        <p:spPr>
-          <a:xfrm>
-            <a:off x="4311396" y="4901184"/>
+          <p:cNvPr id="54" name="Text 51"/>
+          <p:cNvSpPr/>
+          <p:nvPr/>
+        </p:nvSpPr>
+        <p:spPr>
+          <a:xfrm>
+            <a:off x="4311396" y="5312664"/>
             <a:ext cx="3287268" cy="256032"/>
           </a:xfrm>
           <a:prstGeom prst="rect">
@@ -2940,13 +3057,13 @@
       </p:sp>
       <p:sp>
         <p:nvSpPr>
-          <p:cNvPr id="52" name="Text 49"/>
-          <p:cNvSpPr/>
-          <p:nvPr/>
-        </p:nvSpPr>
-        <p:spPr>
-          <a:xfrm>
-            <a:off x="4311396" y="5157216"/>
+          <p:cNvPr id="55" name="Text 52"/>
+          <p:cNvSpPr/>
+          <p:nvPr/>
+        </p:nvSpPr>
+        <p:spPr>
+          <a:xfrm>
+            <a:off x="4311396" y="5568696"/>
             <a:ext cx="3287268" cy="219456"/>
           </a:xfrm>
           <a:prstGeom prst="rect">
@@ -2979,13 +3096,13 @@
       </p:sp>
       <p:sp>
         <p:nvSpPr>
-          <p:cNvPr id="53" name="Text 50"/>
-          <p:cNvSpPr/>
-          <p:nvPr/>
-        </p:nvSpPr>
-        <p:spPr>
-          <a:xfrm>
-            <a:off x="4311396" y="5504688"/>
+          <p:cNvPr id="56" name="Text 53"/>
+          <p:cNvSpPr/>
+          <p:nvPr/>
+        </p:nvSpPr>
+        <p:spPr>
+          <a:xfrm>
+            <a:off x="4311396" y="5916168"/>
             <a:ext cx="3287268" cy="173736"/>
           </a:xfrm>
           <a:prstGeom prst="rect">
@@ -3032,13 +3149,13 @@
       </p:sp>
       <p:sp>
         <p:nvSpPr>
-          <p:cNvPr id="54" name="Text 51"/>
-          <p:cNvSpPr/>
-          <p:nvPr/>
-        </p:nvSpPr>
-        <p:spPr>
-          <a:xfrm>
-            <a:off x="4311396" y="5678424"/>
+          <p:cNvPr id="57" name="Text 54"/>
+          <p:cNvSpPr/>
+          <p:nvPr/>
+        </p:nvSpPr>
+        <p:spPr>
+          <a:xfrm>
+            <a:off x="4311396" y="6089904"/>
             <a:ext cx="3287268" cy="173736"/>
           </a:xfrm>
           <a:prstGeom prst="rect">
@@ -3085,13 +3202,13 @@
       </p:sp>
       <p:sp>
         <p:nvSpPr>
-          <p:cNvPr id="55" name="Text 52"/>
-          <p:cNvSpPr/>
-          <p:nvPr/>
-        </p:nvSpPr>
-        <p:spPr>
-          <a:xfrm>
-            <a:off x="4311396" y="5852160"/>
+          <p:cNvPr id="58" name="Text 55"/>
+          <p:cNvSpPr/>
+          <p:nvPr/>
+        </p:nvSpPr>
+        <p:spPr>
+          <a:xfrm>
+            <a:off x="4311396" y="6263640"/>
             <a:ext cx="3287268" cy="173736"/>
           </a:xfrm>
           <a:prstGeom prst="rect">
@@ -3138,13 +3255,13 @@
       </p:sp>
       <p:sp>
         <p:nvSpPr>
-          <p:cNvPr id="56" name="Text 53"/>
-          <p:cNvSpPr/>
-          <p:nvPr/>
-        </p:nvSpPr>
-        <p:spPr>
-          <a:xfrm>
-            <a:off x="4311396" y="6025896"/>
+          <p:cNvPr id="59" name="Text 56"/>
+          <p:cNvSpPr/>
+          <p:nvPr/>
+        </p:nvSpPr>
+        <p:spPr>
+          <a:xfrm>
+            <a:off x="4311396" y="6437376"/>
             <a:ext cx="3287268" cy="173736"/>
           </a:xfrm>
           <a:prstGeom prst="rect">
@@ -3191,13 +3308,13 @@
       </p:sp>
       <p:sp>
         <p:nvSpPr>
-          <p:cNvPr id="57" name="Text 54"/>
-          <p:cNvSpPr/>
-          <p:nvPr/>
-        </p:nvSpPr>
-        <p:spPr>
-          <a:xfrm>
-            <a:off x="4311396" y="6199632"/>
+          <p:cNvPr id="60" name="Text 57"/>
+          <p:cNvSpPr/>
+          <p:nvPr/>
+        </p:nvSpPr>
+        <p:spPr>
+          <a:xfrm>
+            <a:off x="4311396" y="6611112"/>
             <a:ext cx="3287268" cy="173736"/>
           </a:xfrm>
           <a:prstGeom prst="rect">
@@ -3244,13 +3361,13 @@
       </p:sp>
       <p:sp>
         <p:nvSpPr>
-          <p:cNvPr id="58" name="Text 55"/>
-          <p:cNvSpPr/>
-          <p:nvPr/>
-        </p:nvSpPr>
-        <p:spPr>
-          <a:xfrm>
-            <a:off x="4311396" y="6373368"/>
+          <p:cNvPr id="61" name="Text 58"/>
+          <p:cNvSpPr/>
+          <p:nvPr/>
+        </p:nvSpPr>
+        <p:spPr>
+          <a:xfrm>
+            <a:off x="4311396" y="6784848"/>
             <a:ext cx="3287268" cy="173736"/>
           </a:xfrm>
           <a:prstGeom prst="rect">
@@ -3297,13 +3414,13 @@
       </p:sp>
       <p:sp>
         <p:nvSpPr>
-          <p:cNvPr id="59" name="Text 56"/>
-          <p:cNvSpPr/>
-          <p:nvPr/>
-        </p:nvSpPr>
-        <p:spPr>
-          <a:xfrm>
-            <a:off x="4311396" y="6547104"/>
+          <p:cNvPr id="62" name="Text 59"/>
+          <p:cNvSpPr/>
+          <p:nvPr/>
+        </p:nvSpPr>
+        <p:spPr>
+          <a:xfrm>
+            <a:off x="4311396" y="6958584"/>
             <a:ext cx="3287268" cy="173736"/>
           </a:xfrm>
           <a:prstGeom prst="rect">
@@ -3350,13 +3467,13 @@
       </p:sp>
       <p:sp>
         <p:nvSpPr>
-          <p:cNvPr id="60" name="Text 57"/>
-          <p:cNvSpPr/>
-          <p:nvPr/>
-        </p:nvSpPr>
-        <p:spPr>
-          <a:xfrm>
-            <a:off x="4311396" y="6720840"/>
+          <p:cNvPr id="63" name="Text 60"/>
+          <p:cNvSpPr/>
+          <p:nvPr/>
+        </p:nvSpPr>
+        <p:spPr>
+          <a:xfrm>
+            <a:off x="4311396" y="7132320"/>
             <a:ext cx="3287268" cy="173736"/>
           </a:xfrm>
           <a:prstGeom prst="rect">
@@ -3403,13 +3520,13 @@
       </p:sp>
       <p:sp>
         <p:nvSpPr>
-          <p:cNvPr id="61" name="Shape 58"/>
-          <p:cNvSpPr/>
-          <p:nvPr/>
-        </p:nvSpPr>
-        <p:spPr>
-          <a:xfrm>
-            <a:off x="502920" y="7388352"/>
+          <p:cNvPr id="64" name="Shape 61"/>
+          <p:cNvSpPr/>
+          <p:nvPr/>
+        </p:nvSpPr>
+        <p:spPr>
+          <a:xfrm>
+            <a:off x="502920" y="7799832"/>
             <a:ext cx="7223760" cy="658368"/>
           </a:xfrm>
           <a:prstGeom prst="roundRect">
@@ -3430,13 +3547,13 @@
       </p:sp>
       <p:sp>
         <p:nvSpPr>
-          <p:cNvPr id="62" name="Text 59"/>
-          <p:cNvSpPr/>
-          <p:nvPr/>
-        </p:nvSpPr>
-        <p:spPr>
-          <a:xfrm>
-            <a:off x="777240" y="7388352"/>
+          <p:cNvPr id="65" name="Text 62"/>
+          <p:cNvSpPr/>
+          <p:nvPr/>
+        </p:nvSpPr>
+        <p:spPr>
+          <a:xfrm>
+            <a:off x="777240" y="7799832"/>
             <a:ext cx="6675120" cy="658368"/>
           </a:xfrm>
           <a:prstGeom prst="rect">
@@ -3483,13 +3600,13 @@
       </p:sp>
       <p:sp>
         <p:nvSpPr>
-          <p:cNvPr id="63" name="Shape 60"/>
-          <p:cNvSpPr/>
-          <p:nvPr/>
-        </p:nvSpPr>
-        <p:spPr>
-          <a:xfrm>
-            <a:off x="502920" y="8229600"/>
+          <p:cNvPr id="66" name="Shape 63"/>
+          <p:cNvSpPr/>
+          <p:nvPr/>
+        </p:nvSpPr>
+        <p:spPr>
+          <a:xfrm>
+            <a:off x="502920" y="8641080"/>
             <a:ext cx="1280160" cy="1280160"/>
           </a:xfrm>
           <a:prstGeom prst="roundRect">
@@ -3510,7 +3627,7 @@
       </p:sp>
       <p:pic>
         <p:nvPicPr>
-          <p:cNvPr id="64" name="Image 1" descr="signup_qr.png">    </p:cNvPr>
+          <p:cNvPr id="67" name="Image 1" descr="signup_qr.png">    </p:cNvPr>
           <p:cNvPicPr>
             <a:picLocks noChangeAspect="1"/>
           </p:cNvPicPr>
@@ -3524,7 +3641,7 @@
         </p:blipFill>
         <p:spPr>
           <a:xfrm>
-            <a:off x="576072" y="8302752"/>
+            <a:off x="576072" y="8714232"/>
             <a:ext cx="1133856" cy="1133856"/>
           </a:xfrm>
           <a:prstGeom prst="rect">
@@ -3534,13 +3651,13 @@
       </p:pic>
       <p:sp>
         <p:nvSpPr>
-          <p:cNvPr id="65" name="Text 61"/>
-          <p:cNvSpPr/>
-          <p:nvPr/>
-        </p:nvSpPr>
-        <p:spPr>
-          <a:xfrm>
-            <a:off x="502920" y="9528048"/>
+          <p:cNvPr id="68" name="Text 64"/>
+          <p:cNvSpPr/>
+          <p:nvPr/>
+        </p:nvSpPr>
+        <p:spPr>
+          <a:xfrm>
+            <a:off x="502920" y="9939528"/>
             <a:ext cx="1280160" cy="201168"/>
           </a:xfrm>
           <a:prstGeom prst="rect">
@@ -3573,13 +3690,13 @@
       </p:sp>
       <p:sp>
         <p:nvSpPr>
-          <p:cNvPr id="66" name="Text 62"/>
-          <p:cNvSpPr/>
-          <p:nvPr/>
-        </p:nvSpPr>
-        <p:spPr>
-          <a:xfrm>
-            <a:off x="2057400" y="8247888"/>
+          <p:cNvPr id="69" name="Text 65"/>
+          <p:cNvSpPr/>
+          <p:nvPr/>
+        </p:nvSpPr>
+        <p:spPr>
+          <a:xfrm>
+            <a:off x="2057400" y="8659368"/>
             <a:ext cx="5669280" cy="457200"/>
           </a:xfrm>
           <a:prstGeom prst="rect">
@@ -3612,13 +3729,13 @@
       </p:sp>
       <p:sp>
         <p:nvSpPr>
-          <p:cNvPr id="67" name="Text 63"/>
-          <p:cNvSpPr/>
-          <p:nvPr/>
-        </p:nvSpPr>
-        <p:spPr>
-          <a:xfrm>
-            <a:off x="2057400" y="8723376"/>
+          <p:cNvPr id="70" name="Text 66"/>
+          <p:cNvSpPr/>
+          <p:nvPr/>
+        </p:nvSpPr>
+        <p:spPr>
+          <a:xfrm>
+            <a:off x="2057400" y="9134856"/>
             <a:ext cx="5669280" cy="237744"/>
           </a:xfrm>
           <a:prstGeom prst="rect">
@@ -3651,13 +3768,13 @@
       </p:sp>
       <p:sp>
         <p:nvSpPr>
-          <p:cNvPr id="68" name="Text 64"/>
-          <p:cNvSpPr/>
-          <p:nvPr/>
-        </p:nvSpPr>
-        <p:spPr>
-          <a:xfrm>
-            <a:off x="2057400" y="8997696"/>
+          <p:cNvPr id="71" name="Text 67"/>
+          <p:cNvSpPr/>
+          <p:nvPr/>
+        </p:nvSpPr>
+        <p:spPr>
+          <a:xfrm>
+            <a:off x="2057400" y="9409176"/>
             <a:ext cx="5669280" cy="219456"/>
           </a:xfrm>
           <a:prstGeom prst="rect">
@@ -3690,7 +3807,7 @@
       </p:sp>
       <p:pic>
         <p:nvPicPr>
-          <p:cNvPr id="69" name="Image 2" descr="email-blue.png">    </p:cNvPr>
+          <p:cNvPr id="72" name="Image 2" descr="email-blue.png">    </p:cNvPr>
           <p:cNvPicPr>
             <a:picLocks noChangeAspect="1"/>
           </p:cNvPicPr>
@@ -3704,7 +3821,7 @@
         </p:blipFill>
         <p:spPr>
           <a:xfrm>
-            <a:off x="2057400" y="9308592"/>
+            <a:off x="2057400" y="9720072"/>
             <a:ext cx="182880" cy="182880"/>
           </a:xfrm>
           <a:prstGeom prst="rect">
@@ -3714,13 +3831,13 @@
       </p:pic>
       <p:sp>
         <p:nvSpPr>
-          <p:cNvPr id="70" name="Text 65"/>
-          <p:cNvSpPr/>
-          <p:nvPr/>
-        </p:nvSpPr>
-        <p:spPr>
-          <a:xfrm>
-            <a:off x="2295144" y="9281160"/>
+          <p:cNvPr id="73" name="Text 68"/>
+          <p:cNvSpPr/>
+          <p:nvPr/>
+        </p:nvSpPr>
+        <p:spPr>
+          <a:xfrm>
+            <a:off x="2295144" y="9692640"/>
             <a:ext cx="1615440" cy="256032"/>
           </a:xfrm>
           <a:prstGeom prst="rect">
@@ -3753,7 +3870,7 @@
       </p:sp>
       <p:pic>
         <p:nvPicPr>
-          <p:cNvPr id="71" name="Image 3" descr="whatsapp.png">    </p:cNvPr>
+          <p:cNvPr id="74" name="Image 3" descr="whatsapp.png">    </p:cNvPr>
           <p:cNvPicPr>
             <a:picLocks noChangeAspect="1"/>
           </p:cNvPicPr>
@@ -3767,7 +3884,7 @@
         </p:blipFill>
         <p:spPr>
           <a:xfrm>
-            <a:off x="3947160" y="9308592"/>
+            <a:off x="3947160" y="9720072"/>
             <a:ext cx="182880" cy="182880"/>
           </a:xfrm>
           <a:prstGeom prst="rect">
@@ -3777,13 +3894,13 @@
       </p:pic>
       <p:sp>
         <p:nvSpPr>
-          <p:cNvPr id="72" name="Text 66"/>
-          <p:cNvSpPr/>
-          <p:nvPr/>
-        </p:nvSpPr>
-        <p:spPr>
-          <a:xfrm>
-            <a:off x="4184904" y="9281160"/>
+          <p:cNvPr id="75" name="Text 69"/>
+          <p:cNvSpPr/>
+          <p:nvPr/>
+        </p:nvSpPr>
+        <p:spPr>
+          <a:xfrm>
+            <a:off x="4184904" y="9692640"/>
             <a:ext cx="1615440" cy="256032"/>
           </a:xfrm>
           <a:prstGeom prst="rect">
@@ -3816,7 +3933,7 @@
       </p:sp>
       <p:pic>
         <p:nvPicPr>
-          <p:cNvPr id="73" name="Image 4" descr="phone-blue.png">    </p:cNvPr>
+          <p:cNvPr id="76" name="Image 4" descr="phone-blue.png">    </p:cNvPr>
           <p:cNvPicPr>
             <a:picLocks noChangeAspect="1"/>
           </p:cNvPicPr>
@@ -3830,7 +3947,7 @@
         </p:blipFill>
         <p:spPr>
           <a:xfrm>
-            <a:off x="5836920" y="9308592"/>
+            <a:off x="5836920" y="9720072"/>
             <a:ext cx="182880" cy="182880"/>
           </a:xfrm>
           <a:prstGeom prst="rect">
@@ -3840,13 +3957,13 @@
       </p:pic>
       <p:sp>
         <p:nvSpPr>
-          <p:cNvPr id="74" name="Text 67"/>
-          <p:cNvSpPr/>
-          <p:nvPr/>
-        </p:nvSpPr>
-        <p:spPr>
-          <a:xfrm>
-            <a:off x="6074664" y="9281160"/>
+          <p:cNvPr id="77" name="Text 70"/>
+          <p:cNvSpPr/>
+          <p:nvPr/>
+        </p:nvSpPr>
+        <p:spPr>
+          <a:xfrm>
+            <a:off x="6074664" y="9692640"/>
             <a:ext cx="1615440" cy="256032"/>
           </a:xfrm>
           <a:prstGeom prst="rect">
@@ -3872,82 +3989,6 @@
                 <a:cs typeface="Calibri" pitchFamily="34" charset="-120"/>
               </a:rPr>
               <a:t>+1 984 710 2902</a:t>
-            </a:r>
-            <a:endParaRPr lang="en-US" sz="950" dirty="0"/>
-          </a:p>
-        </p:txBody>
-      </p:sp>
-      <p:sp>
-        <p:nvSpPr>
-          <p:cNvPr id="75" name="Shape 68"/>
-          <p:cNvSpPr/>
-          <p:nvPr/>
-        </p:nvSpPr>
-        <p:spPr>
-          <a:xfrm>
-            <a:off x="502920" y="9857232"/>
-            <a:ext cx="7223760" cy="0"/>
-          </a:xfrm>
-          <a:prstGeom prst="line">
-            <a:avLst/>
-          </a:prstGeom>
-          <a:noFill/>
-          <a:ln w="9525">
-            <a:solidFill>
-              <a:srgbClr val="D6E8F5"/>
-            </a:solidFill>
-            <a:prstDash val="solid"/>
-          </a:ln>
-        </p:spPr>
-      </p:sp>
-      <p:sp>
-        <p:nvSpPr>
-          <p:cNvPr id="76" name="Text 69"/>
-          <p:cNvSpPr/>
-          <p:nvPr/>
-        </p:nvSpPr>
-        <p:spPr>
-          <a:xfrm>
-            <a:off x="502920" y="9902952"/>
-            <a:ext cx="7223760" cy="292608"/>
-          </a:xfrm>
-          <a:prstGeom prst="rect">
-            <a:avLst/>
-          </a:prstGeom>
-          <a:noFill/>
-          <a:ln/>
-        </p:spPr>
-        <p:txBody>
-          <a:bodyPr wrap="square" lIns="0" tIns="0" rIns="0" bIns="0" rtlCol="0" anchor="ctr"/>
-          <a:lstStyle/>
-          <a:p>
-            <a:pPr indent="0" marL="0">
-              <a:buNone/>
-            </a:pPr>
-            <a:r>
-              <a:rPr lang="en-US" sz="950" b="1" spc="200" kern="0" dirty="0">
-                <a:solidFill>
-                  <a:srgbClr val="0C2A3D"/>
-                </a:solidFill>
-                <a:latin typeface="Calibri" pitchFamily="34" charset="0"/>
-                <a:ea typeface="Calibri" pitchFamily="34" charset="-122"/>
-                <a:cs typeface="Calibri" pitchFamily="34" charset="-120"/>
-              </a:rPr>
-              <a:t>ALLAN BAKESIGA, MD</a:t>
-            </a:r>
-            <a:pPr indent="0" marL="0">
-              <a:buNone/>
-            </a:pPr>
-            <a:r>
-              <a:rPr lang="en-US" sz="950" dirty="0">
-                <a:solidFill>
-                  <a:srgbClr val="6B87A3"/>
-                </a:solidFill>
-                <a:latin typeface="Calibri" pitchFamily="34" charset="0"/>
-                <a:ea typeface="Calibri" pitchFamily="34" charset="-122"/>
-                <a:cs typeface="Calibri" pitchFamily="34" charset="-120"/>
-              </a:rPr>
-              <a:t>   MD (Makerere) · MScGH (Duke) · PGY-1 Neurology, Creighton</a:t>
             </a:r>
             <a:endParaRPr lang="en-US" sz="950" dirty="0"/>
           </a:p>

</xml_diff>

<commit_message>
Flyer: darker muted color + larger small fonts for readability
The previous light-gray (#6B87A3) sub-text was hard to read against
white. Switch all 'muted' uses (credentials, section label, QR
caption, contacts) to the darker ink2 shade and bold them. Bump
card item font from 9.5pt to 10pt and the URL/contacts from 9.5pt
to 10-11pt.

Co-Authored-By: Claude Opus 4.7 (1M context) <noreply@anthropic.com>
</commit_message>
<xml_diff>
--- a/outputs/flyers/USMLE_June_Advert.pptx
+++ b/outputs/flyers/USMLE_June_Advert.pptx
@@ -1046,7 +1046,7 @@
             <a:r>
               <a:rPr lang="en-US" sz="1800" dirty="0">
                 <a:solidFill>
-                  <a:srgbClr val="6B87A3"/>
+                  <a:srgbClr val="3D5E80"/>
                 </a:solidFill>
                 <a:latin typeface="Calibri" pitchFamily="34" charset="0"/>
                 <a:ea typeface="Calibri" pitchFamily="34" charset="-122"/>
@@ -1185,9 +1185,9 @@
               <a:buNone/>
             </a:pPr>
             <a:r>
-              <a:rPr lang="en-US" sz="850" dirty="0">
-                <a:solidFill>
-                  <a:srgbClr val="6B87A3"/>
+              <a:rPr lang="en-US" sz="950" b="1" dirty="0">
+                <a:solidFill>
+                  <a:srgbClr val="345671"/>
                 </a:solidFill>
                 <a:latin typeface="Calibri" pitchFamily="34" charset="0"/>
                 <a:ea typeface="Calibri" pitchFamily="34" charset="-122"/>
@@ -1195,7 +1195,7 @@
               </a:rPr>
               <a:t>MD (Makerere)  ·  MScGH (Duke)</a:t>
             </a:r>
-            <a:endParaRPr lang="en-US" sz="850" dirty="0"/>
+            <a:endParaRPr lang="en-US" sz="950" dirty="0"/>
           </a:p>
         </p:txBody>
       </p:sp>
@@ -1224,9 +1224,9 @@
               <a:buNone/>
             </a:pPr>
             <a:r>
-              <a:rPr lang="en-US" sz="850" dirty="0">
-                <a:solidFill>
-                  <a:srgbClr val="6B87A3"/>
+              <a:rPr lang="en-US" sz="950" b="1" dirty="0">
+                <a:solidFill>
+                  <a:srgbClr val="345671"/>
                 </a:solidFill>
                 <a:latin typeface="Calibri" pitchFamily="34" charset="0"/>
                 <a:ea typeface="Calibri" pitchFamily="34" charset="-122"/>
@@ -1234,7 +1234,7 @@
               </a:rPr>
               <a:t>PGY-1 Neurology, Creighton</a:t>
             </a:r>
-            <a:endParaRPr lang="en-US" sz="850" dirty="0"/>
+            <a:endParaRPr lang="en-US" sz="950" dirty="0"/>
           </a:p>
         </p:txBody>
       </p:sp>
@@ -1265,7 +1265,7 @@
             <a:r>
               <a:rPr lang="en-US" sz="1100" b="1" spc="400" kern="0" dirty="0">
                 <a:solidFill>
-                  <a:srgbClr val="6B87A3"/>
+                  <a:srgbClr val="345671"/>
                 </a:solidFill>
                 <a:latin typeface="Calibri" pitchFamily="34" charset="0"/>
                 <a:ea typeface="Calibri" pitchFamily="34" charset="-122"/>
@@ -1465,7 +1465,7 @@
         </p:nvSpPr>
         <p:spPr>
           <a:xfrm>
-            <a:off x="630936" y="3401568"/>
+            <a:off x="630936" y="3383280"/>
             <a:ext cx="3287268" cy="173736"/>
           </a:xfrm>
           <a:prstGeom prst="rect">
@@ -1482,7 +1482,7 @@
               <a:buNone/>
             </a:pPr>
             <a:r>
-              <a:rPr lang="en-US" sz="950" b="1" dirty="0">
+              <a:rPr lang="en-US" sz="1000" b="1" dirty="0">
                 <a:solidFill>
                   <a:srgbClr val="0284C7"/>
                 </a:solidFill>
@@ -1496,7 +1496,7 @@
               <a:buNone/>
             </a:pPr>
             <a:r>
-              <a:rPr lang="en-US" sz="950" dirty="0">
+              <a:rPr lang="en-US" sz="1000" dirty="0">
                 <a:solidFill>
                   <a:srgbClr val="345671"/>
                 </a:solidFill>
@@ -1506,7 +1506,7 @@
               </a:rPr>
               <a:t>Orientation, embryology &amp; congenital heart defects</a:t>
             </a:r>
-            <a:endParaRPr lang="en-US" sz="950" dirty="0"/>
+            <a:endParaRPr lang="en-US" sz="1000" dirty="0"/>
           </a:p>
         </p:txBody>
       </p:sp>
@@ -1518,7 +1518,7 @@
         </p:nvSpPr>
         <p:spPr>
           <a:xfrm>
-            <a:off x="630936" y="3575304"/>
+            <a:off x="630936" y="3557016"/>
             <a:ext cx="3287268" cy="173736"/>
           </a:xfrm>
           <a:prstGeom prst="rect">
@@ -1535,7 +1535,7 @@
               <a:buNone/>
             </a:pPr>
             <a:r>
-              <a:rPr lang="en-US" sz="950" b="1" dirty="0">
+              <a:rPr lang="en-US" sz="1000" b="1" dirty="0">
                 <a:solidFill>
                   <a:srgbClr val="0284C7"/>
                 </a:solidFill>
@@ -1549,7 +1549,7 @@
               <a:buNone/>
             </a:pPr>
             <a:r>
-              <a:rPr lang="en-US" sz="950" dirty="0">
+              <a:rPr lang="en-US" sz="1000" dirty="0">
                 <a:solidFill>
                   <a:srgbClr val="345671"/>
                 </a:solidFill>
@@ -1559,7 +1559,7 @@
               </a:rPr>
               <a:t>Anatomy &amp; cardiac imaging</a:t>
             </a:r>
-            <a:endParaRPr lang="en-US" sz="950" dirty="0"/>
+            <a:endParaRPr lang="en-US" sz="1000" dirty="0"/>
           </a:p>
         </p:txBody>
       </p:sp>
@@ -1571,7 +1571,7 @@
         </p:nvSpPr>
         <p:spPr>
           <a:xfrm>
-            <a:off x="630936" y="3749040"/>
+            <a:off x="630936" y="3730752"/>
             <a:ext cx="3287268" cy="173736"/>
           </a:xfrm>
           <a:prstGeom prst="rect">
@@ -1588,7 +1588,7 @@
               <a:buNone/>
             </a:pPr>
             <a:r>
-              <a:rPr lang="en-US" sz="950" b="1" dirty="0">
+              <a:rPr lang="en-US" sz="1000" b="1" dirty="0">
                 <a:solidFill>
                   <a:srgbClr val="0284C7"/>
                 </a:solidFill>
@@ -1602,7 +1602,7 @@
               <a:buNone/>
             </a:pPr>
             <a:r>
-              <a:rPr lang="en-US" sz="950" dirty="0">
+              <a:rPr lang="en-US" sz="1000" dirty="0">
                 <a:solidFill>
                   <a:srgbClr val="345671"/>
                 </a:solidFill>
@@ -1612,7 +1612,7 @@
               </a:rPr>
               <a:t>Cardiac output &amp; PV loops</a:t>
             </a:r>
-            <a:endParaRPr lang="en-US" sz="950" dirty="0"/>
+            <a:endParaRPr lang="en-US" sz="1000" dirty="0"/>
           </a:p>
         </p:txBody>
       </p:sp>
@@ -1624,7 +1624,7 @@
         </p:nvSpPr>
         <p:spPr>
           <a:xfrm>
-            <a:off x="630936" y="3922776"/>
+            <a:off x="630936" y="3904488"/>
             <a:ext cx="3287268" cy="173736"/>
           </a:xfrm>
           <a:prstGeom prst="rect">
@@ -1641,7 +1641,7 @@
               <a:buNone/>
             </a:pPr>
             <a:r>
-              <a:rPr lang="en-US" sz="950" b="1" dirty="0">
+              <a:rPr lang="en-US" sz="1000" b="1" dirty="0">
                 <a:solidFill>
                   <a:srgbClr val="0284C7"/>
                 </a:solidFill>
@@ -1655,7 +1655,7 @@
               <a:buNone/>
             </a:pPr>
             <a:r>
-              <a:rPr lang="en-US" sz="950" dirty="0">
+              <a:rPr lang="en-US" sz="1000" dirty="0">
                 <a:solidFill>
                   <a:srgbClr val="345671"/>
                 </a:solidFill>
@@ -1665,7 +1665,7 @@
               </a:rPr>
               <a:t>Heart sounds &amp; murmurs</a:t>
             </a:r>
-            <a:endParaRPr lang="en-US" sz="950" dirty="0"/>
+            <a:endParaRPr lang="en-US" sz="1000" dirty="0"/>
           </a:p>
         </p:txBody>
       </p:sp>
@@ -1677,7 +1677,7 @@
         </p:nvSpPr>
         <p:spPr>
           <a:xfrm>
-            <a:off x="630936" y="4096512"/>
+            <a:off x="630936" y="4078224"/>
             <a:ext cx="3287268" cy="173736"/>
           </a:xfrm>
           <a:prstGeom prst="rect">
@@ -1694,7 +1694,7 @@
               <a:buNone/>
             </a:pPr>
             <a:r>
-              <a:rPr lang="en-US" sz="950" b="1" dirty="0">
+              <a:rPr lang="en-US" sz="1000" b="1" dirty="0">
                 <a:solidFill>
                   <a:srgbClr val="0284C7"/>
                 </a:solidFill>
@@ -1708,7 +1708,7 @@
               <a:buNone/>
             </a:pPr>
             <a:r>
-              <a:rPr lang="en-US" sz="950" dirty="0">
+              <a:rPr lang="en-US" sz="1000" dirty="0">
                 <a:solidFill>
                   <a:srgbClr val="345671"/>
                 </a:solidFill>
@@ -1718,7 +1718,7 @@
               </a:rPr>
               <a:t>ECG &amp; action potentials</a:t>
             </a:r>
-            <a:endParaRPr lang="en-US" sz="950" dirty="0"/>
+            <a:endParaRPr lang="en-US" sz="1000" dirty="0"/>
           </a:p>
         </p:txBody>
       </p:sp>
@@ -1730,7 +1730,7 @@
         </p:nvSpPr>
         <p:spPr>
           <a:xfrm>
-            <a:off x="630936" y="4270248"/>
+            <a:off x="630936" y="4251960"/>
             <a:ext cx="3287268" cy="173736"/>
           </a:xfrm>
           <a:prstGeom prst="rect">
@@ -1747,7 +1747,7 @@
               <a:buNone/>
             </a:pPr>
             <a:r>
-              <a:rPr lang="en-US" sz="950" b="1" dirty="0">
+              <a:rPr lang="en-US" sz="1000" b="1" dirty="0">
                 <a:solidFill>
                   <a:srgbClr val="0284C7"/>
                 </a:solidFill>
@@ -1761,7 +1761,7 @@
               <a:buNone/>
             </a:pPr>
             <a:r>
-              <a:rPr lang="en-US" sz="950" dirty="0">
+              <a:rPr lang="en-US" sz="1000" dirty="0">
                 <a:solidFill>
                   <a:srgbClr val="345671"/>
                 </a:solidFill>
@@ -1771,7 +1771,7 @@
               </a:rPr>
               <a:t>CAD, IHD &amp; myocardial infarction</a:t>
             </a:r>
-            <a:endParaRPr lang="en-US" sz="950" dirty="0"/>
+            <a:endParaRPr lang="en-US" sz="1000" dirty="0"/>
           </a:p>
         </p:txBody>
       </p:sp>
@@ -1783,7 +1783,7 @@
         </p:nvSpPr>
         <p:spPr>
           <a:xfrm>
-            <a:off x="630936" y="4443984"/>
+            <a:off x="630936" y="4425696"/>
             <a:ext cx="3287268" cy="173736"/>
           </a:xfrm>
           <a:prstGeom prst="rect">
@@ -1800,7 +1800,7 @@
               <a:buNone/>
             </a:pPr>
             <a:r>
-              <a:rPr lang="en-US" sz="950" b="1" dirty="0">
+              <a:rPr lang="en-US" sz="1000" b="1" dirty="0">
                 <a:solidFill>
                   <a:srgbClr val="0284C7"/>
                 </a:solidFill>
@@ -1814,7 +1814,7 @@
               <a:buNone/>
             </a:pPr>
             <a:r>
-              <a:rPr lang="en-US" sz="950" dirty="0">
+              <a:rPr lang="en-US" sz="1000" dirty="0">
                 <a:solidFill>
                   <a:srgbClr val="345671"/>
                 </a:solidFill>
@@ -1824,7 +1824,7 @@
               </a:rPr>
               <a:t>Hypertension &amp; atherosclerosis</a:t>
             </a:r>
-            <a:endParaRPr lang="en-US" sz="950" dirty="0"/>
+            <a:endParaRPr lang="en-US" sz="1000" dirty="0"/>
           </a:p>
         </p:txBody>
       </p:sp>
@@ -1836,7 +1836,7 @@
         </p:nvSpPr>
         <p:spPr>
           <a:xfrm>
-            <a:off x="630936" y="4617720"/>
+            <a:off x="630936" y="4599432"/>
             <a:ext cx="3287268" cy="173736"/>
           </a:xfrm>
           <a:prstGeom prst="rect">
@@ -1853,7 +1853,7 @@
               <a:buNone/>
             </a:pPr>
             <a:r>
-              <a:rPr lang="en-US" sz="950" b="1" dirty="0">
+              <a:rPr lang="en-US" sz="1000" b="1" dirty="0">
                 <a:solidFill>
                   <a:srgbClr val="0284C7"/>
                 </a:solidFill>
@@ -1867,7 +1867,7 @@
               <a:buNone/>
             </a:pPr>
             <a:r>
-              <a:rPr lang="en-US" sz="950" dirty="0">
+              <a:rPr lang="en-US" sz="1000" dirty="0">
                 <a:solidFill>
                   <a:srgbClr val="345671"/>
                 </a:solidFill>
@@ -1877,7 +1877,7 @@
               </a:rPr>
               <a:t>Heart failure &amp; cardiomyopathies</a:t>
             </a:r>
-            <a:endParaRPr lang="en-US" sz="950" dirty="0"/>
+            <a:endParaRPr lang="en-US" sz="1000" dirty="0"/>
           </a:p>
         </p:txBody>
       </p:sp>
@@ -1889,7 +1889,7 @@
         </p:nvSpPr>
         <p:spPr>
           <a:xfrm>
-            <a:off x="630936" y="4791456"/>
+            <a:off x="630936" y="4773168"/>
             <a:ext cx="3287268" cy="173736"/>
           </a:xfrm>
           <a:prstGeom prst="rect">
@@ -1906,7 +1906,7 @@
               <a:buNone/>
             </a:pPr>
             <a:r>
-              <a:rPr lang="en-US" sz="950" b="1" dirty="0">
+              <a:rPr lang="en-US" sz="1000" b="1" dirty="0">
                 <a:solidFill>
                   <a:srgbClr val="0284C7"/>
                 </a:solidFill>
@@ -1920,7 +1920,7 @@
               <a:buNone/>
             </a:pPr>
             <a:r>
-              <a:rPr lang="en-US" sz="950" dirty="0">
+              <a:rPr lang="en-US" sz="1000" dirty="0">
                 <a:solidFill>
                   <a:srgbClr val="345671"/>
                 </a:solidFill>
@@ -1930,7 +1930,7 @@
               </a:rPr>
               <a:t>Endocarditis, myocarditis &amp; vasculitis</a:t>
             </a:r>
-            <a:endParaRPr lang="en-US" sz="950" dirty="0"/>
+            <a:endParaRPr lang="en-US" sz="1000" dirty="0"/>
           </a:p>
         </p:txBody>
       </p:sp>
@@ -1942,7 +1942,7 @@
         </p:nvSpPr>
         <p:spPr>
           <a:xfrm>
-            <a:off x="630936" y="4965192"/>
+            <a:off x="630936" y="4946904"/>
             <a:ext cx="3287268" cy="173736"/>
           </a:xfrm>
           <a:prstGeom prst="rect">
@@ -1959,7 +1959,7 @@
               <a:buNone/>
             </a:pPr>
             <a:r>
-              <a:rPr lang="en-US" sz="950" b="1" dirty="0">
+              <a:rPr lang="en-US" sz="1000" b="1" dirty="0">
                 <a:solidFill>
                   <a:srgbClr val="0284C7"/>
                 </a:solidFill>
@@ -1973,7 +1973,7 @@
               <a:buNone/>
             </a:pPr>
             <a:r>
-              <a:rPr lang="en-US" sz="950" dirty="0">
+              <a:rPr lang="en-US" sz="1000" dirty="0">
                 <a:solidFill>
                   <a:srgbClr val="345671"/>
                 </a:solidFill>
@@ -1983,7 +1983,7 @@
               </a:rPr>
               <a:t>Cardiovascular pharmacology</a:t>
             </a:r>
-            <a:endParaRPr lang="en-US" sz="950" dirty="0"/>
+            <a:endParaRPr lang="en-US" sz="1000" dirty="0"/>
           </a:p>
         </p:txBody>
       </p:sp>
@@ -2152,7 +2152,7 @@
         </p:nvSpPr>
         <p:spPr>
           <a:xfrm>
-            <a:off x="4311396" y="3401568"/>
+            <a:off x="4311396" y="3383280"/>
             <a:ext cx="3287268" cy="173736"/>
           </a:xfrm>
           <a:prstGeom prst="rect">
@@ -2169,7 +2169,7 @@
               <a:buNone/>
             </a:pPr>
             <a:r>
-              <a:rPr lang="en-US" sz="950" b="1" dirty="0">
+              <a:rPr lang="en-US" sz="1000" b="1" dirty="0">
                 <a:solidFill>
                   <a:srgbClr val="059669"/>
                 </a:solidFill>
@@ -2183,7 +2183,7 @@
               <a:buNone/>
             </a:pPr>
             <a:r>
-              <a:rPr lang="en-US" sz="950" dirty="0">
+              <a:rPr lang="en-US" sz="1000" dirty="0">
                 <a:solidFill>
                   <a:srgbClr val="345671"/>
                 </a:solidFill>
@@ -2193,7 +2193,7 @@
               </a:rPr>
               <a:t>Embryology, surfactant &amp; congenital anomalies</a:t>
             </a:r>
-            <a:endParaRPr lang="en-US" sz="950" dirty="0"/>
+            <a:endParaRPr lang="en-US" sz="1000" dirty="0"/>
           </a:p>
         </p:txBody>
       </p:sp>
@@ -2205,7 +2205,7 @@
         </p:nvSpPr>
         <p:spPr>
           <a:xfrm>
-            <a:off x="4311396" y="3575304"/>
+            <a:off x="4311396" y="3557016"/>
             <a:ext cx="3287268" cy="173736"/>
           </a:xfrm>
           <a:prstGeom prst="rect">
@@ -2222,7 +2222,7 @@
               <a:buNone/>
             </a:pPr>
             <a:r>
-              <a:rPr lang="en-US" sz="950" b="1" dirty="0">
+              <a:rPr lang="en-US" sz="1000" b="1" dirty="0">
                 <a:solidFill>
                   <a:srgbClr val="059669"/>
                 </a:solidFill>
@@ -2236,7 +2236,7 @@
               <a:buNone/>
             </a:pPr>
             <a:r>
-              <a:rPr lang="en-US" sz="950" dirty="0">
+              <a:rPr lang="en-US" sz="1000" dirty="0">
                 <a:solidFill>
                   <a:srgbClr val="345671"/>
                 </a:solidFill>
@@ -2246,7 +2246,7 @@
               </a:rPr>
               <a:t>Anatomy &amp; muscles of breathing</a:t>
             </a:r>
-            <a:endParaRPr lang="en-US" sz="950" dirty="0"/>
+            <a:endParaRPr lang="en-US" sz="1000" dirty="0"/>
           </a:p>
         </p:txBody>
       </p:sp>
@@ -2258,7 +2258,7 @@
         </p:nvSpPr>
         <p:spPr>
           <a:xfrm>
-            <a:off x="4311396" y="3749040"/>
+            <a:off x="4311396" y="3730752"/>
             <a:ext cx="3287268" cy="173736"/>
           </a:xfrm>
           <a:prstGeom prst="rect">
@@ -2275,7 +2275,7 @@
               <a:buNone/>
             </a:pPr>
             <a:r>
-              <a:rPr lang="en-US" sz="950" b="1" dirty="0">
+              <a:rPr lang="en-US" sz="1000" b="1" dirty="0">
                 <a:solidFill>
                   <a:srgbClr val="059669"/>
                 </a:solidFill>
@@ -2289,7 +2289,7 @@
               <a:buNone/>
             </a:pPr>
             <a:r>
-              <a:rPr lang="en-US" sz="950" dirty="0">
+              <a:rPr lang="en-US" sz="1000" dirty="0">
                 <a:solidFill>
                   <a:srgbClr val="345671"/>
                 </a:solidFill>
@@ -2299,7 +2299,7 @@
               </a:rPr>
               <a:t>Lung volumes &amp; ventilation</a:t>
             </a:r>
-            <a:endParaRPr lang="en-US" sz="950" dirty="0"/>
+            <a:endParaRPr lang="en-US" sz="1000" dirty="0"/>
           </a:p>
         </p:txBody>
       </p:sp>
@@ -2311,7 +2311,7 @@
         </p:nvSpPr>
         <p:spPr>
           <a:xfrm>
-            <a:off x="4311396" y="3922776"/>
+            <a:off x="4311396" y="3904488"/>
             <a:ext cx="3287268" cy="173736"/>
           </a:xfrm>
           <a:prstGeom prst="rect">
@@ -2328,7 +2328,7 @@
               <a:buNone/>
             </a:pPr>
             <a:r>
-              <a:rPr lang="en-US" sz="950" b="1" dirty="0">
+              <a:rPr lang="en-US" sz="1000" b="1" dirty="0">
                 <a:solidFill>
                   <a:srgbClr val="059669"/>
                 </a:solidFill>
@@ -2342,7 +2342,7 @@
               <a:buNone/>
             </a:pPr>
             <a:r>
-              <a:rPr lang="en-US" sz="950" dirty="0">
+              <a:rPr lang="en-US" sz="1000" dirty="0">
                 <a:solidFill>
                   <a:srgbClr val="345671"/>
                 </a:solidFill>
@@ -2352,7 +2352,7 @@
               </a:rPr>
               <a:t>Gas exchange &amp; V/Q mismatch</a:t>
             </a:r>
-            <a:endParaRPr lang="en-US" sz="950" dirty="0"/>
+            <a:endParaRPr lang="en-US" sz="1000" dirty="0"/>
           </a:p>
         </p:txBody>
       </p:sp>
@@ -2364,7 +2364,7 @@
         </p:nvSpPr>
         <p:spPr>
           <a:xfrm>
-            <a:off x="4311396" y="4096512"/>
+            <a:off x="4311396" y="4078224"/>
             <a:ext cx="3287268" cy="173736"/>
           </a:xfrm>
           <a:prstGeom prst="rect">
@@ -2381,7 +2381,7 @@
               <a:buNone/>
             </a:pPr>
             <a:r>
-              <a:rPr lang="en-US" sz="950" b="1" dirty="0">
+              <a:rPr lang="en-US" sz="1000" b="1" dirty="0">
                 <a:solidFill>
                   <a:srgbClr val="059669"/>
                 </a:solidFill>
@@ -2395,7 +2395,7 @@
               <a:buNone/>
             </a:pPr>
             <a:r>
-              <a:rPr lang="en-US" sz="950" dirty="0">
+              <a:rPr lang="en-US" sz="1000" dirty="0">
                 <a:solidFill>
                   <a:srgbClr val="345671"/>
                 </a:solidFill>
@@ -2405,7 +2405,7 @@
               </a:rPr>
               <a:t>Control of breathing &amp; sleep apnea</a:t>
             </a:r>
-            <a:endParaRPr lang="en-US" sz="950" dirty="0"/>
+            <a:endParaRPr lang="en-US" sz="1000" dirty="0"/>
           </a:p>
         </p:txBody>
       </p:sp>
@@ -2417,7 +2417,7 @@
         </p:nvSpPr>
         <p:spPr>
           <a:xfrm>
-            <a:off x="4311396" y="4270248"/>
+            <a:off x="4311396" y="4251960"/>
             <a:ext cx="3287268" cy="173736"/>
           </a:xfrm>
           <a:prstGeom prst="rect">
@@ -2434,7 +2434,7 @@
               <a:buNone/>
             </a:pPr>
             <a:r>
-              <a:rPr lang="en-US" sz="950" b="1" dirty="0">
+              <a:rPr lang="en-US" sz="1000" b="1" dirty="0">
                 <a:solidFill>
                   <a:srgbClr val="059669"/>
                 </a:solidFill>
@@ -2448,7 +2448,7 @@
               <a:buNone/>
             </a:pPr>
             <a:r>
-              <a:rPr lang="en-US" sz="950" dirty="0">
+              <a:rPr lang="en-US" sz="1000" dirty="0">
                 <a:solidFill>
                   <a:srgbClr val="345671"/>
                 </a:solidFill>
@@ -2458,7 +2458,7 @@
               </a:rPr>
               <a:t>Asthma &amp; COPD</a:t>
             </a:r>
-            <a:endParaRPr lang="en-US" sz="950" dirty="0"/>
+            <a:endParaRPr lang="en-US" sz="1000" dirty="0"/>
           </a:p>
         </p:txBody>
       </p:sp>
@@ -2470,7 +2470,7 @@
         </p:nvSpPr>
         <p:spPr>
           <a:xfrm>
-            <a:off x="4311396" y="4443984"/>
+            <a:off x="4311396" y="4425696"/>
             <a:ext cx="3287268" cy="173736"/>
           </a:xfrm>
           <a:prstGeom prst="rect">
@@ -2487,7 +2487,7 @@
               <a:buNone/>
             </a:pPr>
             <a:r>
-              <a:rPr lang="en-US" sz="950" b="1" dirty="0">
+              <a:rPr lang="en-US" sz="1000" b="1" dirty="0">
                 <a:solidFill>
                   <a:srgbClr val="059669"/>
                 </a:solidFill>
@@ -2501,7 +2501,7 @@
               <a:buNone/>
             </a:pPr>
             <a:r>
-              <a:rPr lang="en-US" sz="950" dirty="0">
+              <a:rPr lang="en-US" sz="1000" dirty="0">
                 <a:solidFill>
                   <a:srgbClr val="345671"/>
                 </a:solidFill>
@@ -2511,7 +2511,7 @@
               </a:rPr>
               <a:t>Restrictive disease, ARDS, pneumonia</a:t>
             </a:r>
-            <a:endParaRPr lang="en-US" sz="950" dirty="0"/>
+            <a:endParaRPr lang="en-US" sz="1000" dirty="0"/>
           </a:p>
         </p:txBody>
       </p:sp>
@@ -2523,7 +2523,7 @@
         </p:nvSpPr>
         <p:spPr>
           <a:xfrm>
-            <a:off x="4311396" y="4617720"/>
+            <a:off x="4311396" y="4599432"/>
             <a:ext cx="3287268" cy="173736"/>
           </a:xfrm>
           <a:prstGeom prst="rect">
@@ -2540,7 +2540,7 @@
               <a:buNone/>
             </a:pPr>
             <a:r>
-              <a:rPr lang="en-US" sz="950" b="1" dirty="0">
+              <a:rPr lang="en-US" sz="1000" b="1" dirty="0">
                 <a:solidFill>
                   <a:srgbClr val="059669"/>
                 </a:solidFill>
@@ -2554,7 +2554,7 @@
               <a:buNone/>
             </a:pPr>
             <a:r>
-              <a:rPr lang="en-US" sz="950" dirty="0">
+              <a:rPr lang="en-US" sz="1000" dirty="0">
                 <a:solidFill>
                   <a:srgbClr val="345671"/>
                 </a:solidFill>
@@ -2564,7 +2564,7 @@
               </a:rPr>
               <a:t>TB, lung cancer &amp; respiratory pharmacology</a:t>
             </a:r>
-            <a:endParaRPr lang="en-US" sz="950" dirty="0"/>
+            <a:endParaRPr lang="en-US" sz="1000" dirty="0"/>
           </a:p>
         </p:txBody>
       </p:sp>
@@ -2750,7 +2750,7 @@
               <a:buNone/>
             </a:pPr>
             <a:r>
-              <a:rPr lang="en-US" sz="1000" b="1" dirty="0">
+              <a:rPr lang="en-US" sz="1050" b="1" dirty="0">
                 <a:solidFill>
                   <a:srgbClr val="D97706"/>
                 </a:solidFill>
@@ -2764,7 +2764,7 @@
               <a:buNone/>
             </a:pPr>
             <a:r>
-              <a:rPr lang="en-US" sz="1000" dirty="0">
+              <a:rPr lang="en-US" sz="1050" dirty="0">
                 <a:solidFill>
                   <a:srgbClr val="345671"/>
                 </a:solidFill>
@@ -2774,7 +2774,7 @@
               </a:rPr>
               <a:t>Study designs, evidence &amp; diagnostic testing</a:t>
             </a:r>
-            <a:endParaRPr lang="en-US" sz="1000" dirty="0"/>
+            <a:endParaRPr lang="en-US" sz="1050" dirty="0"/>
           </a:p>
         </p:txBody>
       </p:sp>
@@ -2803,7 +2803,7 @@
               <a:buNone/>
             </a:pPr>
             <a:r>
-              <a:rPr lang="en-US" sz="1000" b="1" dirty="0">
+              <a:rPr lang="en-US" sz="1050" b="1" dirty="0">
                 <a:solidFill>
                   <a:srgbClr val="D97706"/>
                 </a:solidFill>
@@ -2817,7 +2817,7 @@
               <a:buNone/>
             </a:pPr>
             <a:r>
-              <a:rPr lang="en-US" sz="1000" dirty="0">
+              <a:rPr lang="en-US" sz="1050" dirty="0">
                 <a:solidFill>
                   <a:srgbClr val="345671"/>
                 </a:solidFill>
@@ -2827,7 +2827,7 @@
               </a:rPr>
               <a:t>Quantifying risk, transitions &amp; survival analysis</a:t>
             </a:r>
-            <a:endParaRPr lang="en-US" sz="1000" dirty="0"/>
+            <a:endParaRPr lang="en-US" sz="1050" dirty="0"/>
           </a:p>
         </p:txBody>
       </p:sp>
@@ -2856,7 +2856,7 @@
               <a:buNone/>
             </a:pPr>
             <a:r>
-              <a:rPr lang="en-US" sz="1000" b="1" dirty="0">
+              <a:rPr lang="en-US" sz="1050" b="1" dirty="0">
                 <a:solidFill>
                   <a:srgbClr val="D97706"/>
                 </a:solidFill>
@@ -2870,7 +2870,7 @@
               <a:buNone/>
             </a:pPr>
             <a:r>
-              <a:rPr lang="en-US" sz="1000" dirty="0">
+              <a:rPr lang="en-US" sz="1050" dirty="0">
                 <a:solidFill>
                   <a:srgbClr val="345671"/>
                 </a:solidFill>
@@ -2880,7 +2880,7 @@
               </a:rPr>
               <a:t>Bias, confounding &amp; effect modification</a:t>
             </a:r>
-            <a:endParaRPr lang="en-US" sz="1000" dirty="0"/>
+            <a:endParaRPr lang="en-US" sz="1050" dirty="0"/>
           </a:p>
         </p:txBody>
       </p:sp>
@@ -2909,7 +2909,7 @@
               <a:buNone/>
             </a:pPr>
             <a:r>
-              <a:rPr lang="en-US" sz="1000" b="1" dirty="0">
+              <a:rPr lang="en-US" sz="1050" b="1" dirty="0">
                 <a:solidFill>
                   <a:srgbClr val="D97706"/>
                 </a:solidFill>
@@ -2923,7 +2923,7 @@
               <a:buNone/>
             </a:pPr>
             <a:r>
-              <a:rPr lang="en-US" sz="1000" dirty="0">
+              <a:rPr lang="en-US" sz="1050" dirty="0">
                 <a:solidFill>
                   <a:srgbClr val="345671"/>
                 </a:solidFill>
@@ -2933,7 +2933,7 @@
               </a:rPr>
               <a:t>Statistical distributions, testing &amp; CIs</a:t>
             </a:r>
-            <a:endParaRPr lang="en-US" sz="1000" dirty="0"/>
+            <a:endParaRPr lang="en-US" sz="1050" dirty="0"/>
           </a:p>
         </p:txBody>
       </p:sp>
@@ -3102,7 +3102,7 @@
         </p:nvSpPr>
         <p:spPr>
           <a:xfrm>
-            <a:off x="4311396" y="5916168"/>
+            <a:off x="4311396" y="5897880"/>
             <a:ext cx="3287268" cy="173736"/>
           </a:xfrm>
           <a:prstGeom prst="rect">
@@ -3119,7 +3119,7 @@
               <a:buNone/>
             </a:pPr>
             <a:r>
-              <a:rPr lang="en-US" sz="950" b="1" dirty="0">
+              <a:rPr lang="en-US" sz="1000" b="1" dirty="0">
                 <a:solidFill>
                   <a:srgbClr val="7C3AED"/>
                 </a:solidFill>
@@ -3133,7 +3133,7 @@
               <a:buNone/>
             </a:pPr>
             <a:r>
-              <a:rPr lang="en-US" sz="950" dirty="0">
+              <a:rPr lang="en-US" sz="1000" dirty="0">
                 <a:solidFill>
                   <a:srgbClr val="345671"/>
                 </a:solidFill>
@@ -3143,7 +3143,7 @@
               </a:rPr>
               <a:t>Cellular adaptations &amp; apoptosis</a:t>
             </a:r>
-            <a:endParaRPr lang="en-US" sz="950" dirty="0"/>
+            <a:endParaRPr lang="en-US" sz="1000" dirty="0"/>
           </a:p>
         </p:txBody>
       </p:sp>
@@ -3155,7 +3155,7 @@
         </p:nvSpPr>
         <p:spPr>
           <a:xfrm>
-            <a:off x="4311396" y="6089904"/>
+            <a:off x="4311396" y="6071616"/>
             <a:ext cx="3287268" cy="173736"/>
           </a:xfrm>
           <a:prstGeom prst="rect">
@@ -3172,7 +3172,7 @@
               <a:buNone/>
             </a:pPr>
             <a:r>
-              <a:rPr lang="en-US" sz="950" b="1" dirty="0">
+              <a:rPr lang="en-US" sz="1000" b="1" dirty="0">
                 <a:solidFill>
                   <a:srgbClr val="7C3AED"/>
                 </a:solidFill>
@@ -3186,7 +3186,7 @@
               <a:buNone/>
             </a:pPr>
             <a:r>
-              <a:rPr lang="en-US" sz="950" dirty="0">
+              <a:rPr lang="en-US" sz="1000" dirty="0">
                 <a:solidFill>
                   <a:srgbClr val="345671"/>
                 </a:solidFill>
@@ -3196,7 +3196,7 @@
               </a:rPr>
               <a:t>Necrosis, ischemia &amp; free radicals</a:t>
             </a:r>
-            <a:endParaRPr lang="en-US" sz="950" dirty="0"/>
+            <a:endParaRPr lang="en-US" sz="1000" dirty="0"/>
           </a:p>
         </p:txBody>
       </p:sp>
@@ -3208,7 +3208,7 @@
         </p:nvSpPr>
         <p:spPr>
           <a:xfrm>
-            <a:off x="4311396" y="6263640"/>
+            <a:off x="4311396" y="6245352"/>
             <a:ext cx="3287268" cy="173736"/>
           </a:xfrm>
           <a:prstGeom prst="rect">
@@ -3225,7 +3225,7 @@
               <a:buNone/>
             </a:pPr>
             <a:r>
-              <a:rPr lang="en-US" sz="950" b="1" dirty="0">
+              <a:rPr lang="en-US" sz="1000" b="1" dirty="0">
                 <a:solidFill>
                   <a:srgbClr val="7C3AED"/>
                 </a:solidFill>
@@ -3239,7 +3239,7 @@
               <a:buNone/>
             </a:pPr>
             <a:r>
-              <a:rPr lang="en-US" sz="950" dirty="0">
+              <a:rPr lang="en-US" sz="1000" dirty="0">
                 <a:solidFill>
                   <a:srgbClr val="345671"/>
                 </a:solidFill>
@@ -3249,7 +3249,7 @@
               </a:rPr>
               <a:t>Acute inflammation</a:t>
             </a:r>
-            <a:endParaRPr lang="en-US" sz="950" dirty="0"/>
+            <a:endParaRPr lang="en-US" sz="1000" dirty="0"/>
           </a:p>
         </p:txBody>
       </p:sp>
@@ -3261,7 +3261,7 @@
         </p:nvSpPr>
         <p:spPr>
           <a:xfrm>
-            <a:off x="4311396" y="6437376"/>
+            <a:off x="4311396" y="6419088"/>
             <a:ext cx="3287268" cy="173736"/>
           </a:xfrm>
           <a:prstGeom prst="rect">
@@ -3278,7 +3278,7 @@
               <a:buNone/>
             </a:pPr>
             <a:r>
-              <a:rPr lang="en-US" sz="950" b="1" dirty="0">
+              <a:rPr lang="en-US" sz="1000" b="1" dirty="0">
                 <a:solidFill>
                   <a:srgbClr val="7C3AED"/>
                 </a:solidFill>
@@ -3292,7 +3292,7 @@
               <a:buNone/>
             </a:pPr>
             <a:r>
-              <a:rPr lang="en-US" sz="950" dirty="0">
+              <a:rPr lang="en-US" sz="1000" dirty="0">
                 <a:solidFill>
                   <a:srgbClr val="345671"/>
                 </a:solidFill>
@@ -3302,7 +3302,7 @@
               </a:rPr>
               <a:t>Chronic inflammation &amp; repair</a:t>
             </a:r>
-            <a:endParaRPr lang="en-US" sz="950" dirty="0"/>
+            <a:endParaRPr lang="en-US" sz="1000" dirty="0"/>
           </a:p>
         </p:txBody>
       </p:sp>
@@ -3314,7 +3314,7 @@
         </p:nvSpPr>
         <p:spPr>
           <a:xfrm>
-            <a:off x="4311396" y="6611112"/>
+            <a:off x="4311396" y="6592824"/>
             <a:ext cx="3287268" cy="173736"/>
           </a:xfrm>
           <a:prstGeom prst="rect">
@@ -3331,7 +3331,7 @@
               <a:buNone/>
             </a:pPr>
             <a:r>
-              <a:rPr lang="en-US" sz="950" b="1" dirty="0">
+              <a:rPr lang="en-US" sz="1000" b="1" dirty="0">
                 <a:solidFill>
                   <a:srgbClr val="7C3AED"/>
                 </a:solidFill>
@@ -3345,7 +3345,7 @@
               <a:buNone/>
             </a:pPr>
             <a:r>
-              <a:rPr lang="en-US" sz="950" dirty="0">
+              <a:rPr lang="en-US" sz="1000" dirty="0">
                 <a:solidFill>
                   <a:srgbClr val="345671"/>
                 </a:solidFill>
@@ -3355,7 +3355,7 @@
               </a:rPr>
               <a:t>Neoplasia I — hallmarks &amp; metastases</a:t>
             </a:r>
-            <a:endParaRPr lang="en-US" sz="950" dirty="0"/>
+            <a:endParaRPr lang="en-US" sz="1000" dirty="0"/>
           </a:p>
         </p:txBody>
       </p:sp>
@@ -3367,7 +3367,7 @@
         </p:nvSpPr>
         <p:spPr>
           <a:xfrm>
-            <a:off x="4311396" y="6784848"/>
+            <a:off x="4311396" y="6766560"/>
             <a:ext cx="3287268" cy="173736"/>
           </a:xfrm>
           <a:prstGeom prst="rect">
@@ -3384,7 +3384,7 @@
               <a:buNone/>
             </a:pPr>
             <a:r>
-              <a:rPr lang="en-US" sz="950" b="1" dirty="0">
+              <a:rPr lang="en-US" sz="1000" b="1" dirty="0">
                 <a:solidFill>
                   <a:srgbClr val="7C3AED"/>
                 </a:solidFill>
@@ -3398,7 +3398,7 @@
               <a:buNone/>
             </a:pPr>
             <a:r>
-              <a:rPr lang="en-US" sz="950" dirty="0">
+              <a:rPr lang="en-US" sz="1000" dirty="0">
                 <a:solidFill>
                   <a:srgbClr val="345671"/>
                 </a:solidFill>
@@ -3408,7 +3408,7 @@
               </a:rPr>
               <a:t>Neoplasia II — oncogenes &amp; TSGs</a:t>
             </a:r>
-            <a:endParaRPr lang="en-US" sz="950" dirty="0"/>
+            <a:endParaRPr lang="en-US" sz="1000" dirty="0"/>
           </a:p>
         </p:txBody>
       </p:sp>
@@ -3420,7 +3420,7 @@
         </p:nvSpPr>
         <p:spPr>
           <a:xfrm>
-            <a:off x="4311396" y="6958584"/>
+            <a:off x="4311396" y="6940296"/>
             <a:ext cx="3287268" cy="173736"/>
           </a:xfrm>
           <a:prstGeom prst="rect">
@@ -3437,7 +3437,7 @@
               <a:buNone/>
             </a:pPr>
             <a:r>
-              <a:rPr lang="en-US" sz="950" b="1" dirty="0">
+              <a:rPr lang="en-US" sz="1000" b="1" dirty="0">
                 <a:solidFill>
                   <a:srgbClr val="7C3AED"/>
                 </a:solidFill>
@@ -3451,7 +3451,7 @@
               <a:buNone/>
             </a:pPr>
             <a:r>
-              <a:rPr lang="en-US" sz="950" dirty="0">
+              <a:rPr lang="en-US" sz="1000" dirty="0">
                 <a:solidFill>
                   <a:srgbClr val="345671"/>
                 </a:solidFill>
@@ -3461,7 +3461,7 @@
               </a:rPr>
               <a:t>Neoplasia III — markers &amp; aging</a:t>
             </a:r>
-            <a:endParaRPr lang="en-US" sz="950" dirty="0"/>
+            <a:endParaRPr lang="en-US" sz="1000" dirty="0"/>
           </a:p>
         </p:txBody>
       </p:sp>
@@ -3473,7 +3473,7 @@
         </p:nvSpPr>
         <p:spPr>
           <a:xfrm>
-            <a:off x="4311396" y="7132320"/>
+            <a:off x="4311396" y="7114032"/>
             <a:ext cx="3287268" cy="173736"/>
           </a:xfrm>
           <a:prstGeom prst="rect">
@@ -3490,7 +3490,7 @@
               <a:buNone/>
             </a:pPr>
             <a:r>
-              <a:rPr lang="en-US" sz="950" b="1" dirty="0">
+              <a:rPr lang="en-US" sz="1000" b="1" dirty="0">
                 <a:solidFill>
                   <a:srgbClr val="7C3AED"/>
                 </a:solidFill>
@@ -3504,7 +3504,7 @@
               <a:buNone/>
             </a:pPr>
             <a:r>
-              <a:rPr lang="en-US" sz="950" dirty="0">
+              <a:rPr lang="en-US" sz="1000" dirty="0">
                 <a:solidFill>
                   <a:srgbClr val="345671"/>
                 </a:solidFill>
@@ -3514,7 +3514,7 @@
               </a:rPr>
               <a:t>General pathology review</a:t>
             </a:r>
-            <a:endParaRPr lang="en-US" sz="950" dirty="0"/>
+            <a:endParaRPr lang="en-US" sz="1000" dirty="0"/>
           </a:p>
         </p:txBody>
       </p:sp>
@@ -3674,9 +3674,9 @@
               <a:buNone/>
             </a:pPr>
             <a:r>
-              <a:rPr lang="en-US" sz="950" spc="200" kern="0" dirty="0">
-                <a:solidFill>
-                  <a:srgbClr val="6B87A3"/>
+              <a:rPr lang="en-US" sz="1000" b="1" spc="200" kern="0" dirty="0">
+                <a:solidFill>
+                  <a:srgbClr val="345671"/>
                 </a:solidFill>
                 <a:latin typeface="Calibri" pitchFamily="34" charset="0"/>
                 <a:ea typeface="Calibri" pitchFamily="34" charset="-122"/>
@@ -3684,7 +3684,7 @@
               </a:rPr>
               <a:t>scan to sign up</a:t>
             </a:r>
-            <a:endParaRPr lang="en-US" sz="950" dirty="0"/>
+            <a:endParaRPr lang="en-US" sz="1000" dirty="0"/>
           </a:p>
         </p:txBody>
       </p:sp>
@@ -3791,7 +3791,7 @@
               <a:buNone/>
             </a:pPr>
             <a:r>
-              <a:rPr lang="en-US" sz="1000" b="1" dirty="0">
+              <a:rPr lang="en-US" sz="1100" b="1" dirty="0">
                 <a:solidFill>
                   <a:srgbClr val="0284C7"/>
                 </a:solidFill>
@@ -3801,7 +3801,7 @@
               </a:rPr>
               <a:t>bakesiga.github.io/usmle-dashboard</a:t>
             </a:r>
-            <a:endParaRPr lang="en-US" sz="1000" dirty="0"/>
+            <a:endParaRPr lang="en-US" sz="1100" dirty="0"/>
           </a:p>
         </p:txBody>
       </p:sp>
@@ -3854,7 +3854,7 @@
               <a:buNone/>
             </a:pPr>
             <a:r>
-              <a:rPr lang="en-US" sz="950" b="1" dirty="0">
+              <a:rPr lang="en-US" sz="1000" b="1" dirty="0">
                 <a:solidFill>
                   <a:srgbClr val="0C2A3D"/>
                 </a:solidFill>
@@ -3864,7 +3864,7 @@
               </a:rPr>
               <a:t>allanbakesiga@gmail.com</a:t>
             </a:r>
-            <a:endParaRPr lang="en-US" sz="950" dirty="0"/>
+            <a:endParaRPr lang="en-US" sz="1000" dirty="0"/>
           </a:p>
         </p:txBody>
       </p:sp>
@@ -3917,7 +3917,7 @@
               <a:buNone/>
             </a:pPr>
             <a:r>
-              <a:rPr lang="en-US" sz="950" b="1" dirty="0">
+              <a:rPr lang="en-US" sz="1000" b="1" dirty="0">
                 <a:solidFill>
                   <a:srgbClr val="0C2A3D"/>
                 </a:solidFill>
@@ -3927,7 +3927,7 @@
               </a:rPr>
               <a:t>+256 705 571 443</a:t>
             </a:r>
-            <a:endParaRPr lang="en-US" sz="950" dirty="0"/>
+            <a:endParaRPr lang="en-US" sz="1000" dirty="0"/>
           </a:p>
         </p:txBody>
       </p:sp>
@@ -3980,7 +3980,7 @@
               <a:buNone/>
             </a:pPr>
             <a:r>
-              <a:rPr lang="en-US" sz="950" b="1" dirty="0">
+              <a:rPr lang="en-US" sz="1000" b="1" dirty="0">
                 <a:solidFill>
                   <a:srgbClr val="0C2A3D"/>
                 </a:solidFill>
@@ -3990,7 +3990,7 @@
               </a:rPr>
               <a:t>+1 984 710 2902</a:t>
             </a:r>
-            <a:endParaRPr lang="en-US" sz="950" dirty="0"/>
+            <a:endParaRPr lang="en-US" sz="1000" dirty="0"/>
           </a:p>
         </p:txBody>
       </p:sp>

</xml_diff>

<commit_message>
Flyer: distribute card items evenly across each tile
Row height is now computed per card (body_height / item_count)
instead of hardcoded, so Resp (8 items), Epi (4 items) and Path
(8 items) breathe across the same vertical space as CVS (10 items)
without bunching at the top.

Co-Authored-By: Claude Opus 4.7 (1M context) <noreply@anthropic.com>
</commit_message>
<xml_diff>
--- a/outputs/flyers/USMLE_June_Advert.pptx
+++ b/outputs/flyers/USMLE_June_Advert.pptx
@@ -1465,8 +1465,8 @@
         </p:nvSpPr>
         <p:spPr>
           <a:xfrm>
-            <a:off x="630936" y="3383280"/>
-            <a:ext cx="3287268" cy="173736"/>
+            <a:off x="630936" y="3401568"/>
+            <a:ext cx="3287268" cy="164592"/>
           </a:xfrm>
           <a:prstGeom prst="rect">
             <a:avLst/>
@@ -1518,8 +1518,8 @@
         </p:nvSpPr>
         <p:spPr>
           <a:xfrm>
-            <a:off x="630936" y="3557016"/>
-            <a:ext cx="3287268" cy="173736"/>
+            <a:off x="630936" y="3566160"/>
+            <a:ext cx="3287268" cy="164592"/>
           </a:xfrm>
           <a:prstGeom prst="rect">
             <a:avLst/>
@@ -1572,7 +1572,7 @@
         <p:spPr>
           <a:xfrm>
             <a:off x="630936" y="3730752"/>
-            <a:ext cx="3287268" cy="173736"/>
+            <a:ext cx="3287268" cy="164592"/>
           </a:xfrm>
           <a:prstGeom prst="rect">
             <a:avLst/>
@@ -1624,8 +1624,8 @@
         </p:nvSpPr>
         <p:spPr>
           <a:xfrm>
-            <a:off x="630936" y="3904488"/>
-            <a:ext cx="3287268" cy="173736"/>
+            <a:off x="630936" y="3895344"/>
+            <a:ext cx="3287268" cy="164592"/>
           </a:xfrm>
           <a:prstGeom prst="rect">
             <a:avLst/>
@@ -1677,8 +1677,8 @@
         </p:nvSpPr>
         <p:spPr>
           <a:xfrm>
-            <a:off x="630936" y="4078224"/>
-            <a:ext cx="3287268" cy="173736"/>
+            <a:off x="630936" y="4059936"/>
+            <a:ext cx="3287268" cy="164592"/>
           </a:xfrm>
           <a:prstGeom prst="rect">
             <a:avLst/>
@@ -1730,8 +1730,8 @@
         </p:nvSpPr>
         <p:spPr>
           <a:xfrm>
-            <a:off x="630936" y="4251960"/>
-            <a:ext cx="3287268" cy="173736"/>
+            <a:off x="630936" y="4224528"/>
+            <a:ext cx="3287268" cy="164592"/>
           </a:xfrm>
           <a:prstGeom prst="rect">
             <a:avLst/>
@@ -1783,8 +1783,8 @@
         </p:nvSpPr>
         <p:spPr>
           <a:xfrm>
-            <a:off x="630936" y="4425696"/>
-            <a:ext cx="3287268" cy="173736"/>
+            <a:off x="630936" y="4389120"/>
+            <a:ext cx="3287268" cy="164592"/>
           </a:xfrm>
           <a:prstGeom prst="rect">
             <a:avLst/>
@@ -1836,8 +1836,8 @@
         </p:nvSpPr>
         <p:spPr>
           <a:xfrm>
-            <a:off x="630936" y="4599432"/>
-            <a:ext cx="3287268" cy="173736"/>
+            <a:off x="630936" y="4553712"/>
+            <a:ext cx="3287268" cy="164592"/>
           </a:xfrm>
           <a:prstGeom prst="rect">
             <a:avLst/>
@@ -1889,8 +1889,8 @@
         </p:nvSpPr>
         <p:spPr>
           <a:xfrm>
-            <a:off x="630936" y="4773168"/>
-            <a:ext cx="3287268" cy="173736"/>
+            <a:off x="630936" y="4718304"/>
+            <a:ext cx="3287268" cy="164592"/>
           </a:xfrm>
           <a:prstGeom prst="rect">
             <a:avLst/>
@@ -1942,8 +1942,8 @@
         </p:nvSpPr>
         <p:spPr>
           <a:xfrm>
-            <a:off x="630936" y="4946904"/>
-            <a:ext cx="3287268" cy="173736"/>
+            <a:off x="630936" y="4882896"/>
+            <a:ext cx="3287268" cy="164592"/>
           </a:xfrm>
           <a:prstGeom prst="rect">
             <a:avLst/>
@@ -2152,8 +2152,8 @@
         </p:nvSpPr>
         <p:spPr>
           <a:xfrm>
-            <a:off x="4311396" y="3383280"/>
-            <a:ext cx="3287268" cy="173736"/>
+            <a:off x="4311396" y="3401568"/>
+            <a:ext cx="3287268" cy="205740"/>
           </a:xfrm>
           <a:prstGeom prst="rect">
             <a:avLst/>
@@ -2205,8 +2205,8 @@
         </p:nvSpPr>
         <p:spPr>
           <a:xfrm>
-            <a:off x="4311396" y="3557016"/>
-            <a:ext cx="3287268" cy="173736"/>
+            <a:off x="4311396" y="3607308"/>
+            <a:ext cx="3287268" cy="205740"/>
           </a:xfrm>
           <a:prstGeom prst="rect">
             <a:avLst/>
@@ -2258,8 +2258,8 @@
         </p:nvSpPr>
         <p:spPr>
           <a:xfrm>
-            <a:off x="4311396" y="3730752"/>
-            <a:ext cx="3287268" cy="173736"/>
+            <a:off x="4311396" y="3813048"/>
+            <a:ext cx="3287268" cy="205740"/>
           </a:xfrm>
           <a:prstGeom prst="rect">
             <a:avLst/>
@@ -2311,8 +2311,8 @@
         </p:nvSpPr>
         <p:spPr>
           <a:xfrm>
-            <a:off x="4311396" y="3904488"/>
-            <a:ext cx="3287268" cy="173736"/>
+            <a:off x="4311396" y="4018788"/>
+            <a:ext cx="3287268" cy="205740"/>
           </a:xfrm>
           <a:prstGeom prst="rect">
             <a:avLst/>
@@ -2364,8 +2364,8 @@
         </p:nvSpPr>
         <p:spPr>
           <a:xfrm>
-            <a:off x="4311396" y="4078224"/>
-            <a:ext cx="3287268" cy="173736"/>
+            <a:off x="4311396" y="4224528"/>
+            <a:ext cx="3287268" cy="205740"/>
           </a:xfrm>
           <a:prstGeom prst="rect">
             <a:avLst/>
@@ -2417,8 +2417,8 @@
         </p:nvSpPr>
         <p:spPr>
           <a:xfrm>
-            <a:off x="4311396" y="4251960"/>
-            <a:ext cx="3287268" cy="173736"/>
+            <a:off x="4311396" y="4430268"/>
+            <a:ext cx="3287268" cy="205740"/>
           </a:xfrm>
           <a:prstGeom prst="rect">
             <a:avLst/>
@@ -2470,8 +2470,8 @@
         </p:nvSpPr>
         <p:spPr>
           <a:xfrm>
-            <a:off x="4311396" y="4425696"/>
-            <a:ext cx="3287268" cy="173736"/>
+            <a:off x="4311396" y="4636008"/>
+            <a:ext cx="3287268" cy="205740"/>
           </a:xfrm>
           <a:prstGeom prst="rect">
             <a:avLst/>
@@ -2523,8 +2523,8 @@
         </p:nvSpPr>
         <p:spPr>
           <a:xfrm>
-            <a:off x="4311396" y="4599432"/>
-            <a:ext cx="3287268" cy="173736"/>
+            <a:off x="4311396" y="4841748"/>
+            <a:ext cx="3287268" cy="205740"/>
           </a:xfrm>
           <a:prstGeom prst="rect">
             <a:avLst/>
@@ -2733,8 +2733,8 @@
         </p:nvSpPr>
         <p:spPr>
           <a:xfrm>
-            <a:off x="630936" y="6007608"/>
-            <a:ext cx="3287268" cy="384048"/>
+            <a:off x="630936" y="5916168"/>
+            <a:ext cx="3287268" cy="411480"/>
           </a:xfrm>
           <a:prstGeom prst="rect">
             <a:avLst/>
@@ -2786,8 +2786,8 @@
         </p:nvSpPr>
         <p:spPr>
           <a:xfrm>
-            <a:off x="630936" y="6391656"/>
-            <a:ext cx="3287268" cy="384048"/>
+            <a:off x="630936" y="6327648"/>
+            <a:ext cx="3287268" cy="411480"/>
           </a:xfrm>
           <a:prstGeom prst="rect">
             <a:avLst/>
@@ -2839,8 +2839,8 @@
         </p:nvSpPr>
         <p:spPr>
           <a:xfrm>
-            <a:off x="630936" y="6775704"/>
-            <a:ext cx="3287268" cy="384048"/>
+            <a:off x="630936" y="6739128"/>
+            <a:ext cx="3287268" cy="411480"/>
           </a:xfrm>
           <a:prstGeom prst="rect">
             <a:avLst/>
@@ -2892,8 +2892,8 @@
         </p:nvSpPr>
         <p:spPr>
           <a:xfrm>
-            <a:off x="630936" y="7159752"/>
-            <a:ext cx="3287268" cy="384048"/>
+            <a:off x="630936" y="7150608"/>
+            <a:ext cx="3287268" cy="411480"/>
           </a:xfrm>
           <a:prstGeom prst="rect">
             <a:avLst/>
@@ -3102,8 +3102,8 @@
         </p:nvSpPr>
         <p:spPr>
           <a:xfrm>
-            <a:off x="4311396" y="5897880"/>
-            <a:ext cx="3287268" cy="173736"/>
+            <a:off x="4311396" y="5916168"/>
+            <a:ext cx="3287268" cy="205740"/>
           </a:xfrm>
           <a:prstGeom prst="rect">
             <a:avLst/>
@@ -3155,8 +3155,8 @@
         </p:nvSpPr>
         <p:spPr>
           <a:xfrm>
-            <a:off x="4311396" y="6071616"/>
-            <a:ext cx="3287268" cy="173736"/>
+            <a:off x="4311396" y="6121908"/>
+            <a:ext cx="3287268" cy="205740"/>
           </a:xfrm>
           <a:prstGeom prst="rect">
             <a:avLst/>
@@ -3208,8 +3208,8 @@
         </p:nvSpPr>
         <p:spPr>
           <a:xfrm>
-            <a:off x="4311396" y="6245352"/>
-            <a:ext cx="3287268" cy="173736"/>
+            <a:off x="4311396" y="6327648"/>
+            <a:ext cx="3287268" cy="205740"/>
           </a:xfrm>
           <a:prstGeom prst="rect">
             <a:avLst/>
@@ -3261,8 +3261,8 @@
         </p:nvSpPr>
         <p:spPr>
           <a:xfrm>
-            <a:off x="4311396" y="6419088"/>
-            <a:ext cx="3287268" cy="173736"/>
+            <a:off x="4311396" y="6533388"/>
+            <a:ext cx="3287268" cy="205740"/>
           </a:xfrm>
           <a:prstGeom prst="rect">
             <a:avLst/>
@@ -3314,8 +3314,8 @@
         </p:nvSpPr>
         <p:spPr>
           <a:xfrm>
-            <a:off x="4311396" y="6592824"/>
-            <a:ext cx="3287268" cy="173736"/>
+            <a:off x="4311396" y="6739128"/>
+            <a:ext cx="3287268" cy="205740"/>
           </a:xfrm>
           <a:prstGeom prst="rect">
             <a:avLst/>
@@ -3367,8 +3367,8 @@
         </p:nvSpPr>
         <p:spPr>
           <a:xfrm>
-            <a:off x="4311396" y="6766560"/>
-            <a:ext cx="3287268" cy="173736"/>
+            <a:off x="4311396" y="6944868"/>
+            <a:ext cx="3287268" cy="205740"/>
           </a:xfrm>
           <a:prstGeom prst="rect">
             <a:avLst/>
@@ -3420,8 +3420,8 @@
         </p:nvSpPr>
         <p:spPr>
           <a:xfrm>
-            <a:off x="4311396" y="6940296"/>
-            <a:ext cx="3287268" cy="173736"/>
+            <a:off x="4311396" y="7150608"/>
+            <a:ext cx="3287268" cy="205740"/>
           </a:xfrm>
           <a:prstGeom prst="rect">
             <a:avLst/>
@@ -3473,8 +3473,8 @@
         </p:nvSpPr>
         <p:spPr>
           <a:xfrm>
-            <a:off x="4311396" y="7114032"/>
-            <a:ext cx="3287268" cy="173736"/>
+            <a:off x="4311396" y="7356348"/>
+            <a:ext cx="3287268" cy="205740"/>
           </a:xfrm>
           <a:prstGeom prst="rect">
             <a:avLst/>

</xml_diff>

<commit_message>
Flyer: bolden + darken tile item text for stronger contrast
Topic text on the soft-tinted tiles was ink2 (#345671) and regular
weight, which read faint against pastel backgrounds. Switch to ink
(#0C2A3D) and bold, and use each chapter's deep color (cvsDeep,
respDeep, etc.) for the day numbers instead of the lighter accent.

Co-Authored-By: Claude Opus 4.7 (1M context) <noreply@anthropic.com>
</commit_message>
<xml_diff>
--- a/outputs/flyers/USMLE_June_Advert.pptx
+++ b/outputs/flyers/USMLE_June_Advert.pptx
@@ -1484,7 +1484,7 @@
             <a:r>
               <a:rPr lang="en-US" sz="1000" b="1" dirty="0">
                 <a:solidFill>
-                  <a:srgbClr val="0284C7"/>
+                  <a:srgbClr val="075985"/>
                 </a:solidFill>
                 <a:latin typeface="Calibri" pitchFamily="34" charset="0"/>
                 <a:ea typeface="Calibri" pitchFamily="34" charset="-122"/>
@@ -1496,9 +1496,9 @@
               <a:buNone/>
             </a:pPr>
             <a:r>
-              <a:rPr lang="en-US" sz="1000" dirty="0">
-                <a:solidFill>
-                  <a:srgbClr val="345671"/>
+              <a:rPr lang="en-US" sz="1000" b="1" dirty="0">
+                <a:solidFill>
+                  <a:srgbClr val="0C2A3D"/>
                 </a:solidFill>
                 <a:latin typeface="Calibri" pitchFamily="34" charset="0"/>
                 <a:ea typeface="Calibri" pitchFamily="34" charset="-122"/>
@@ -1537,7 +1537,7 @@
             <a:r>
               <a:rPr lang="en-US" sz="1000" b="1" dirty="0">
                 <a:solidFill>
-                  <a:srgbClr val="0284C7"/>
+                  <a:srgbClr val="075985"/>
                 </a:solidFill>
                 <a:latin typeface="Calibri" pitchFamily="34" charset="0"/>
                 <a:ea typeface="Calibri" pitchFamily="34" charset="-122"/>
@@ -1549,9 +1549,9 @@
               <a:buNone/>
             </a:pPr>
             <a:r>
-              <a:rPr lang="en-US" sz="1000" dirty="0">
-                <a:solidFill>
-                  <a:srgbClr val="345671"/>
+              <a:rPr lang="en-US" sz="1000" b="1" dirty="0">
+                <a:solidFill>
+                  <a:srgbClr val="0C2A3D"/>
                 </a:solidFill>
                 <a:latin typeface="Calibri" pitchFamily="34" charset="0"/>
                 <a:ea typeface="Calibri" pitchFamily="34" charset="-122"/>
@@ -1590,7 +1590,7 @@
             <a:r>
               <a:rPr lang="en-US" sz="1000" b="1" dirty="0">
                 <a:solidFill>
-                  <a:srgbClr val="0284C7"/>
+                  <a:srgbClr val="075985"/>
                 </a:solidFill>
                 <a:latin typeface="Calibri" pitchFamily="34" charset="0"/>
                 <a:ea typeface="Calibri" pitchFamily="34" charset="-122"/>
@@ -1602,9 +1602,9 @@
               <a:buNone/>
             </a:pPr>
             <a:r>
-              <a:rPr lang="en-US" sz="1000" dirty="0">
-                <a:solidFill>
-                  <a:srgbClr val="345671"/>
+              <a:rPr lang="en-US" sz="1000" b="1" dirty="0">
+                <a:solidFill>
+                  <a:srgbClr val="0C2A3D"/>
                 </a:solidFill>
                 <a:latin typeface="Calibri" pitchFamily="34" charset="0"/>
                 <a:ea typeface="Calibri" pitchFamily="34" charset="-122"/>
@@ -1643,7 +1643,7 @@
             <a:r>
               <a:rPr lang="en-US" sz="1000" b="1" dirty="0">
                 <a:solidFill>
-                  <a:srgbClr val="0284C7"/>
+                  <a:srgbClr val="075985"/>
                 </a:solidFill>
                 <a:latin typeface="Calibri" pitchFamily="34" charset="0"/>
                 <a:ea typeface="Calibri" pitchFamily="34" charset="-122"/>
@@ -1655,9 +1655,9 @@
               <a:buNone/>
             </a:pPr>
             <a:r>
-              <a:rPr lang="en-US" sz="1000" dirty="0">
-                <a:solidFill>
-                  <a:srgbClr val="345671"/>
+              <a:rPr lang="en-US" sz="1000" b="1" dirty="0">
+                <a:solidFill>
+                  <a:srgbClr val="0C2A3D"/>
                 </a:solidFill>
                 <a:latin typeface="Calibri" pitchFamily="34" charset="0"/>
                 <a:ea typeface="Calibri" pitchFamily="34" charset="-122"/>
@@ -1696,7 +1696,7 @@
             <a:r>
               <a:rPr lang="en-US" sz="1000" b="1" dirty="0">
                 <a:solidFill>
-                  <a:srgbClr val="0284C7"/>
+                  <a:srgbClr val="075985"/>
                 </a:solidFill>
                 <a:latin typeface="Calibri" pitchFamily="34" charset="0"/>
                 <a:ea typeface="Calibri" pitchFamily="34" charset="-122"/>
@@ -1708,9 +1708,9 @@
               <a:buNone/>
             </a:pPr>
             <a:r>
-              <a:rPr lang="en-US" sz="1000" dirty="0">
-                <a:solidFill>
-                  <a:srgbClr val="345671"/>
+              <a:rPr lang="en-US" sz="1000" b="1" dirty="0">
+                <a:solidFill>
+                  <a:srgbClr val="0C2A3D"/>
                 </a:solidFill>
                 <a:latin typeface="Calibri" pitchFamily="34" charset="0"/>
                 <a:ea typeface="Calibri" pitchFamily="34" charset="-122"/>
@@ -1749,7 +1749,7 @@
             <a:r>
               <a:rPr lang="en-US" sz="1000" b="1" dirty="0">
                 <a:solidFill>
-                  <a:srgbClr val="0284C7"/>
+                  <a:srgbClr val="075985"/>
                 </a:solidFill>
                 <a:latin typeface="Calibri" pitchFamily="34" charset="0"/>
                 <a:ea typeface="Calibri" pitchFamily="34" charset="-122"/>
@@ -1761,9 +1761,9 @@
               <a:buNone/>
             </a:pPr>
             <a:r>
-              <a:rPr lang="en-US" sz="1000" dirty="0">
-                <a:solidFill>
-                  <a:srgbClr val="345671"/>
+              <a:rPr lang="en-US" sz="1000" b="1" dirty="0">
+                <a:solidFill>
+                  <a:srgbClr val="0C2A3D"/>
                 </a:solidFill>
                 <a:latin typeface="Calibri" pitchFamily="34" charset="0"/>
                 <a:ea typeface="Calibri" pitchFamily="34" charset="-122"/>
@@ -1802,7 +1802,7 @@
             <a:r>
               <a:rPr lang="en-US" sz="1000" b="1" dirty="0">
                 <a:solidFill>
-                  <a:srgbClr val="0284C7"/>
+                  <a:srgbClr val="075985"/>
                 </a:solidFill>
                 <a:latin typeface="Calibri" pitchFamily="34" charset="0"/>
                 <a:ea typeface="Calibri" pitchFamily="34" charset="-122"/>
@@ -1814,9 +1814,9 @@
               <a:buNone/>
             </a:pPr>
             <a:r>
-              <a:rPr lang="en-US" sz="1000" dirty="0">
-                <a:solidFill>
-                  <a:srgbClr val="345671"/>
+              <a:rPr lang="en-US" sz="1000" b="1" dirty="0">
+                <a:solidFill>
+                  <a:srgbClr val="0C2A3D"/>
                 </a:solidFill>
                 <a:latin typeface="Calibri" pitchFamily="34" charset="0"/>
                 <a:ea typeface="Calibri" pitchFamily="34" charset="-122"/>
@@ -1855,7 +1855,7 @@
             <a:r>
               <a:rPr lang="en-US" sz="1000" b="1" dirty="0">
                 <a:solidFill>
-                  <a:srgbClr val="0284C7"/>
+                  <a:srgbClr val="075985"/>
                 </a:solidFill>
                 <a:latin typeface="Calibri" pitchFamily="34" charset="0"/>
                 <a:ea typeface="Calibri" pitchFamily="34" charset="-122"/>
@@ -1867,9 +1867,9 @@
               <a:buNone/>
             </a:pPr>
             <a:r>
-              <a:rPr lang="en-US" sz="1000" dirty="0">
-                <a:solidFill>
-                  <a:srgbClr val="345671"/>
+              <a:rPr lang="en-US" sz="1000" b="1" dirty="0">
+                <a:solidFill>
+                  <a:srgbClr val="0C2A3D"/>
                 </a:solidFill>
                 <a:latin typeface="Calibri" pitchFamily="34" charset="0"/>
                 <a:ea typeface="Calibri" pitchFamily="34" charset="-122"/>
@@ -1908,7 +1908,7 @@
             <a:r>
               <a:rPr lang="en-US" sz="1000" b="1" dirty="0">
                 <a:solidFill>
-                  <a:srgbClr val="0284C7"/>
+                  <a:srgbClr val="075985"/>
                 </a:solidFill>
                 <a:latin typeface="Calibri" pitchFamily="34" charset="0"/>
                 <a:ea typeface="Calibri" pitchFamily="34" charset="-122"/>
@@ -1920,9 +1920,9 @@
               <a:buNone/>
             </a:pPr>
             <a:r>
-              <a:rPr lang="en-US" sz="1000" dirty="0">
-                <a:solidFill>
-                  <a:srgbClr val="345671"/>
+              <a:rPr lang="en-US" sz="1000" b="1" dirty="0">
+                <a:solidFill>
+                  <a:srgbClr val="0C2A3D"/>
                 </a:solidFill>
                 <a:latin typeface="Calibri" pitchFamily="34" charset="0"/>
                 <a:ea typeface="Calibri" pitchFamily="34" charset="-122"/>
@@ -1961,7 +1961,7 @@
             <a:r>
               <a:rPr lang="en-US" sz="1000" b="1" dirty="0">
                 <a:solidFill>
-                  <a:srgbClr val="0284C7"/>
+                  <a:srgbClr val="075985"/>
                 </a:solidFill>
                 <a:latin typeface="Calibri" pitchFamily="34" charset="0"/>
                 <a:ea typeface="Calibri" pitchFamily="34" charset="-122"/>
@@ -1973,9 +1973,9 @@
               <a:buNone/>
             </a:pPr>
             <a:r>
-              <a:rPr lang="en-US" sz="1000" dirty="0">
-                <a:solidFill>
-                  <a:srgbClr val="345671"/>
+              <a:rPr lang="en-US" sz="1000" b="1" dirty="0">
+                <a:solidFill>
+                  <a:srgbClr val="0C2A3D"/>
                 </a:solidFill>
                 <a:latin typeface="Calibri" pitchFamily="34" charset="0"/>
                 <a:ea typeface="Calibri" pitchFamily="34" charset="-122"/>
@@ -2171,7 +2171,7 @@
             <a:r>
               <a:rPr lang="en-US" sz="1000" b="1" dirty="0">
                 <a:solidFill>
-                  <a:srgbClr val="059669"/>
+                  <a:srgbClr val="065F46"/>
                 </a:solidFill>
                 <a:latin typeface="Calibri" pitchFamily="34" charset="0"/>
                 <a:ea typeface="Calibri" pitchFamily="34" charset="-122"/>
@@ -2183,9 +2183,9 @@
               <a:buNone/>
             </a:pPr>
             <a:r>
-              <a:rPr lang="en-US" sz="1000" dirty="0">
-                <a:solidFill>
-                  <a:srgbClr val="345671"/>
+              <a:rPr lang="en-US" sz="1000" b="1" dirty="0">
+                <a:solidFill>
+                  <a:srgbClr val="0C2A3D"/>
                 </a:solidFill>
                 <a:latin typeface="Calibri" pitchFamily="34" charset="0"/>
                 <a:ea typeface="Calibri" pitchFamily="34" charset="-122"/>
@@ -2224,7 +2224,7 @@
             <a:r>
               <a:rPr lang="en-US" sz="1000" b="1" dirty="0">
                 <a:solidFill>
-                  <a:srgbClr val="059669"/>
+                  <a:srgbClr val="065F46"/>
                 </a:solidFill>
                 <a:latin typeface="Calibri" pitchFamily="34" charset="0"/>
                 <a:ea typeface="Calibri" pitchFamily="34" charset="-122"/>
@@ -2236,9 +2236,9 @@
               <a:buNone/>
             </a:pPr>
             <a:r>
-              <a:rPr lang="en-US" sz="1000" dirty="0">
-                <a:solidFill>
-                  <a:srgbClr val="345671"/>
+              <a:rPr lang="en-US" sz="1000" b="1" dirty="0">
+                <a:solidFill>
+                  <a:srgbClr val="0C2A3D"/>
                 </a:solidFill>
                 <a:latin typeface="Calibri" pitchFamily="34" charset="0"/>
                 <a:ea typeface="Calibri" pitchFamily="34" charset="-122"/>
@@ -2277,7 +2277,7 @@
             <a:r>
               <a:rPr lang="en-US" sz="1000" b="1" dirty="0">
                 <a:solidFill>
-                  <a:srgbClr val="059669"/>
+                  <a:srgbClr val="065F46"/>
                 </a:solidFill>
                 <a:latin typeface="Calibri" pitchFamily="34" charset="0"/>
                 <a:ea typeface="Calibri" pitchFamily="34" charset="-122"/>
@@ -2289,9 +2289,9 @@
               <a:buNone/>
             </a:pPr>
             <a:r>
-              <a:rPr lang="en-US" sz="1000" dirty="0">
-                <a:solidFill>
-                  <a:srgbClr val="345671"/>
+              <a:rPr lang="en-US" sz="1000" b="1" dirty="0">
+                <a:solidFill>
+                  <a:srgbClr val="0C2A3D"/>
                 </a:solidFill>
                 <a:latin typeface="Calibri" pitchFamily="34" charset="0"/>
                 <a:ea typeface="Calibri" pitchFamily="34" charset="-122"/>
@@ -2330,7 +2330,7 @@
             <a:r>
               <a:rPr lang="en-US" sz="1000" b="1" dirty="0">
                 <a:solidFill>
-                  <a:srgbClr val="059669"/>
+                  <a:srgbClr val="065F46"/>
                 </a:solidFill>
                 <a:latin typeface="Calibri" pitchFamily="34" charset="0"/>
                 <a:ea typeface="Calibri" pitchFamily="34" charset="-122"/>
@@ -2342,9 +2342,9 @@
               <a:buNone/>
             </a:pPr>
             <a:r>
-              <a:rPr lang="en-US" sz="1000" dirty="0">
-                <a:solidFill>
-                  <a:srgbClr val="345671"/>
+              <a:rPr lang="en-US" sz="1000" b="1" dirty="0">
+                <a:solidFill>
+                  <a:srgbClr val="0C2A3D"/>
                 </a:solidFill>
                 <a:latin typeface="Calibri" pitchFamily="34" charset="0"/>
                 <a:ea typeface="Calibri" pitchFamily="34" charset="-122"/>
@@ -2383,7 +2383,7 @@
             <a:r>
               <a:rPr lang="en-US" sz="1000" b="1" dirty="0">
                 <a:solidFill>
-                  <a:srgbClr val="059669"/>
+                  <a:srgbClr val="065F46"/>
                 </a:solidFill>
                 <a:latin typeface="Calibri" pitchFamily="34" charset="0"/>
                 <a:ea typeface="Calibri" pitchFamily="34" charset="-122"/>
@@ -2395,9 +2395,9 @@
               <a:buNone/>
             </a:pPr>
             <a:r>
-              <a:rPr lang="en-US" sz="1000" dirty="0">
-                <a:solidFill>
-                  <a:srgbClr val="345671"/>
+              <a:rPr lang="en-US" sz="1000" b="1" dirty="0">
+                <a:solidFill>
+                  <a:srgbClr val="0C2A3D"/>
                 </a:solidFill>
                 <a:latin typeface="Calibri" pitchFamily="34" charset="0"/>
                 <a:ea typeface="Calibri" pitchFamily="34" charset="-122"/>
@@ -2436,7 +2436,7 @@
             <a:r>
               <a:rPr lang="en-US" sz="1000" b="1" dirty="0">
                 <a:solidFill>
-                  <a:srgbClr val="059669"/>
+                  <a:srgbClr val="065F46"/>
                 </a:solidFill>
                 <a:latin typeface="Calibri" pitchFamily="34" charset="0"/>
                 <a:ea typeface="Calibri" pitchFamily="34" charset="-122"/>
@@ -2448,9 +2448,9 @@
               <a:buNone/>
             </a:pPr>
             <a:r>
-              <a:rPr lang="en-US" sz="1000" dirty="0">
-                <a:solidFill>
-                  <a:srgbClr val="345671"/>
+              <a:rPr lang="en-US" sz="1000" b="1" dirty="0">
+                <a:solidFill>
+                  <a:srgbClr val="0C2A3D"/>
                 </a:solidFill>
                 <a:latin typeface="Calibri" pitchFamily="34" charset="0"/>
                 <a:ea typeface="Calibri" pitchFamily="34" charset="-122"/>
@@ -2489,7 +2489,7 @@
             <a:r>
               <a:rPr lang="en-US" sz="1000" b="1" dirty="0">
                 <a:solidFill>
-                  <a:srgbClr val="059669"/>
+                  <a:srgbClr val="065F46"/>
                 </a:solidFill>
                 <a:latin typeface="Calibri" pitchFamily="34" charset="0"/>
                 <a:ea typeface="Calibri" pitchFamily="34" charset="-122"/>
@@ -2501,9 +2501,9 @@
               <a:buNone/>
             </a:pPr>
             <a:r>
-              <a:rPr lang="en-US" sz="1000" dirty="0">
-                <a:solidFill>
-                  <a:srgbClr val="345671"/>
+              <a:rPr lang="en-US" sz="1000" b="1" dirty="0">
+                <a:solidFill>
+                  <a:srgbClr val="0C2A3D"/>
                 </a:solidFill>
                 <a:latin typeface="Calibri" pitchFamily="34" charset="0"/>
                 <a:ea typeface="Calibri" pitchFamily="34" charset="-122"/>
@@ -2542,7 +2542,7 @@
             <a:r>
               <a:rPr lang="en-US" sz="1000" b="1" dirty="0">
                 <a:solidFill>
-                  <a:srgbClr val="059669"/>
+                  <a:srgbClr val="065F46"/>
                 </a:solidFill>
                 <a:latin typeface="Calibri" pitchFamily="34" charset="0"/>
                 <a:ea typeface="Calibri" pitchFamily="34" charset="-122"/>
@@ -2554,9 +2554,9 @@
               <a:buNone/>
             </a:pPr>
             <a:r>
-              <a:rPr lang="en-US" sz="1000" dirty="0">
-                <a:solidFill>
-                  <a:srgbClr val="345671"/>
+              <a:rPr lang="en-US" sz="1000" b="1" dirty="0">
+                <a:solidFill>
+                  <a:srgbClr val="0C2A3D"/>
                 </a:solidFill>
                 <a:latin typeface="Calibri" pitchFamily="34" charset="0"/>
                 <a:ea typeface="Calibri" pitchFamily="34" charset="-122"/>
@@ -2752,7 +2752,7 @@
             <a:r>
               <a:rPr lang="en-US" sz="1050" b="1" dirty="0">
                 <a:solidFill>
-                  <a:srgbClr val="D97706"/>
+                  <a:srgbClr val="B45309"/>
                 </a:solidFill>
                 <a:latin typeface="Calibri" pitchFamily="34" charset="0"/>
                 <a:ea typeface="Calibri" pitchFamily="34" charset="-122"/>
@@ -2764,9 +2764,9 @@
               <a:buNone/>
             </a:pPr>
             <a:r>
-              <a:rPr lang="en-US" sz="1050" dirty="0">
-                <a:solidFill>
-                  <a:srgbClr val="345671"/>
+              <a:rPr lang="en-US" sz="1050" b="1" dirty="0">
+                <a:solidFill>
+                  <a:srgbClr val="0C2A3D"/>
                 </a:solidFill>
                 <a:latin typeface="Calibri" pitchFamily="34" charset="0"/>
                 <a:ea typeface="Calibri" pitchFamily="34" charset="-122"/>
@@ -2805,7 +2805,7 @@
             <a:r>
               <a:rPr lang="en-US" sz="1050" b="1" dirty="0">
                 <a:solidFill>
-                  <a:srgbClr val="D97706"/>
+                  <a:srgbClr val="B45309"/>
                 </a:solidFill>
                 <a:latin typeface="Calibri" pitchFamily="34" charset="0"/>
                 <a:ea typeface="Calibri" pitchFamily="34" charset="-122"/>
@@ -2817,9 +2817,9 @@
               <a:buNone/>
             </a:pPr>
             <a:r>
-              <a:rPr lang="en-US" sz="1050" dirty="0">
-                <a:solidFill>
-                  <a:srgbClr val="345671"/>
+              <a:rPr lang="en-US" sz="1050" b="1" dirty="0">
+                <a:solidFill>
+                  <a:srgbClr val="0C2A3D"/>
                 </a:solidFill>
                 <a:latin typeface="Calibri" pitchFamily="34" charset="0"/>
                 <a:ea typeface="Calibri" pitchFamily="34" charset="-122"/>
@@ -2858,7 +2858,7 @@
             <a:r>
               <a:rPr lang="en-US" sz="1050" b="1" dirty="0">
                 <a:solidFill>
-                  <a:srgbClr val="D97706"/>
+                  <a:srgbClr val="B45309"/>
                 </a:solidFill>
                 <a:latin typeface="Calibri" pitchFamily="34" charset="0"/>
                 <a:ea typeface="Calibri" pitchFamily="34" charset="-122"/>
@@ -2870,9 +2870,9 @@
               <a:buNone/>
             </a:pPr>
             <a:r>
-              <a:rPr lang="en-US" sz="1050" dirty="0">
-                <a:solidFill>
-                  <a:srgbClr val="345671"/>
+              <a:rPr lang="en-US" sz="1050" b="1" dirty="0">
+                <a:solidFill>
+                  <a:srgbClr val="0C2A3D"/>
                 </a:solidFill>
                 <a:latin typeface="Calibri" pitchFamily="34" charset="0"/>
                 <a:ea typeface="Calibri" pitchFamily="34" charset="-122"/>
@@ -2911,7 +2911,7 @@
             <a:r>
               <a:rPr lang="en-US" sz="1050" b="1" dirty="0">
                 <a:solidFill>
-                  <a:srgbClr val="D97706"/>
+                  <a:srgbClr val="B45309"/>
                 </a:solidFill>
                 <a:latin typeface="Calibri" pitchFamily="34" charset="0"/>
                 <a:ea typeface="Calibri" pitchFamily="34" charset="-122"/>
@@ -2923,9 +2923,9 @@
               <a:buNone/>
             </a:pPr>
             <a:r>
-              <a:rPr lang="en-US" sz="1050" dirty="0">
-                <a:solidFill>
-                  <a:srgbClr val="345671"/>
+              <a:rPr lang="en-US" sz="1050" b="1" dirty="0">
+                <a:solidFill>
+                  <a:srgbClr val="0C2A3D"/>
                 </a:solidFill>
                 <a:latin typeface="Calibri" pitchFamily="34" charset="0"/>
                 <a:ea typeface="Calibri" pitchFamily="34" charset="-122"/>
@@ -3121,7 +3121,7 @@
             <a:r>
               <a:rPr lang="en-US" sz="1000" b="1" dirty="0">
                 <a:solidFill>
-                  <a:srgbClr val="7C3AED"/>
+                  <a:srgbClr val="5B21B6"/>
                 </a:solidFill>
                 <a:latin typeface="Calibri" pitchFamily="34" charset="0"/>
                 <a:ea typeface="Calibri" pitchFamily="34" charset="-122"/>
@@ -3133,9 +3133,9 @@
               <a:buNone/>
             </a:pPr>
             <a:r>
-              <a:rPr lang="en-US" sz="1000" dirty="0">
-                <a:solidFill>
-                  <a:srgbClr val="345671"/>
+              <a:rPr lang="en-US" sz="1000" b="1" dirty="0">
+                <a:solidFill>
+                  <a:srgbClr val="0C2A3D"/>
                 </a:solidFill>
                 <a:latin typeface="Calibri" pitchFamily="34" charset="0"/>
                 <a:ea typeface="Calibri" pitchFamily="34" charset="-122"/>
@@ -3174,7 +3174,7 @@
             <a:r>
               <a:rPr lang="en-US" sz="1000" b="1" dirty="0">
                 <a:solidFill>
-                  <a:srgbClr val="7C3AED"/>
+                  <a:srgbClr val="5B21B6"/>
                 </a:solidFill>
                 <a:latin typeface="Calibri" pitchFamily="34" charset="0"/>
                 <a:ea typeface="Calibri" pitchFamily="34" charset="-122"/>
@@ -3186,9 +3186,9 @@
               <a:buNone/>
             </a:pPr>
             <a:r>
-              <a:rPr lang="en-US" sz="1000" dirty="0">
-                <a:solidFill>
-                  <a:srgbClr val="345671"/>
+              <a:rPr lang="en-US" sz="1000" b="1" dirty="0">
+                <a:solidFill>
+                  <a:srgbClr val="0C2A3D"/>
                 </a:solidFill>
                 <a:latin typeface="Calibri" pitchFamily="34" charset="0"/>
                 <a:ea typeface="Calibri" pitchFamily="34" charset="-122"/>
@@ -3227,7 +3227,7 @@
             <a:r>
               <a:rPr lang="en-US" sz="1000" b="1" dirty="0">
                 <a:solidFill>
-                  <a:srgbClr val="7C3AED"/>
+                  <a:srgbClr val="5B21B6"/>
                 </a:solidFill>
                 <a:latin typeface="Calibri" pitchFamily="34" charset="0"/>
                 <a:ea typeface="Calibri" pitchFamily="34" charset="-122"/>
@@ -3239,9 +3239,9 @@
               <a:buNone/>
             </a:pPr>
             <a:r>
-              <a:rPr lang="en-US" sz="1000" dirty="0">
-                <a:solidFill>
-                  <a:srgbClr val="345671"/>
+              <a:rPr lang="en-US" sz="1000" b="1" dirty="0">
+                <a:solidFill>
+                  <a:srgbClr val="0C2A3D"/>
                 </a:solidFill>
                 <a:latin typeface="Calibri" pitchFamily="34" charset="0"/>
                 <a:ea typeface="Calibri" pitchFamily="34" charset="-122"/>
@@ -3280,7 +3280,7 @@
             <a:r>
               <a:rPr lang="en-US" sz="1000" b="1" dirty="0">
                 <a:solidFill>
-                  <a:srgbClr val="7C3AED"/>
+                  <a:srgbClr val="5B21B6"/>
                 </a:solidFill>
                 <a:latin typeface="Calibri" pitchFamily="34" charset="0"/>
                 <a:ea typeface="Calibri" pitchFamily="34" charset="-122"/>
@@ -3292,9 +3292,9 @@
               <a:buNone/>
             </a:pPr>
             <a:r>
-              <a:rPr lang="en-US" sz="1000" dirty="0">
-                <a:solidFill>
-                  <a:srgbClr val="345671"/>
+              <a:rPr lang="en-US" sz="1000" b="1" dirty="0">
+                <a:solidFill>
+                  <a:srgbClr val="0C2A3D"/>
                 </a:solidFill>
                 <a:latin typeface="Calibri" pitchFamily="34" charset="0"/>
                 <a:ea typeface="Calibri" pitchFamily="34" charset="-122"/>
@@ -3333,7 +3333,7 @@
             <a:r>
               <a:rPr lang="en-US" sz="1000" b="1" dirty="0">
                 <a:solidFill>
-                  <a:srgbClr val="7C3AED"/>
+                  <a:srgbClr val="5B21B6"/>
                 </a:solidFill>
                 <a:latin typeface="Calibri" pitchFamily="34" charset="0"/>
                 <a:ea typeface="Calibri" pitchFamily="34" charset="-122"/>
@@ -3345,9 +3345,9 @@
               <a:buNone/>
             </a:pPr>
             <a:r>
-              <a:rPr lang="en-US" sz="1000" dirty="0">
-                <a:solidFill>
-                  <a:srgbClr val="345671"/>
+              <a:rPr lang="en-US" sz="1000" b="1" dirty="0">
+                <a:solidFill>
+                  <a:srgbClr val="0C2A3D"/>
                 </a:solidFill>
                 <a:latin typeface="Calibri" pitchFamily="34" charset="0"/>
                 <a:ea typeface="Calibri" pitchFamily="34" charset="-122"/>
@@ -3386,7 +3386,7 @@
             <a:r>
               <a:rPr lang="en-US" sz="1000" b="1" dirty="0">
                 <a:solidFill>
-                  <a:srgbClr val="7C3AED"/>
+                  <a:srgbClr val="5B21B6"/>
                 </a:solidFill>
                 <a:latin typeface="Calibri" pitchFamily="34" charset="0"/>
                 <a:ea typeface="Calibri" pitchFamily="34" charset="-122"/>
@@ -3398,9 +3398,9 @@
               <a:buNone/>
             </a:pPr>
             <a:r>
-              <a:rPr lang="en-US" sz="1000" dirty="0">
-                <a:solidFill>
-                  <a:srgbClr val="345671"/>
+              <a:rPr lang="en-US" sz="1000" b="1" dirty="0">
+                <a:solidFill>
+                  <a:srgbClr val="0C2A3D"/>
                 </a:solidFill>
                 <a:latin typeface="Calibri" pitchFamily="34" charset="0"/>
                 <a:ea typeface="Calibri" pitchFamily="34" charset="-122"/>
@@ -3439,7 +3439,7 @@
             <a:r>
               <a:rPr lang="en-US" sz="1000" b="1" dirty="0">
                 <a:solidFill>
-                  <a:srgbClr val="7C3AED"/>
+                  <a:srgbClr val="5B21B6"/>
                 </a:solidFill>
                 <a:latin typeface="Calibri" pitchFamily="34" charset="0"/>
                 <a:ea typeface="Calibri" pitchFamily="34" charset="-122"/>
@@ -3451,9 +3451,9 @@
               <a:buNone/>
             </a:pPr>
             <a:r>
-              <a:rPr lang="en-US" sz="1000" dirty="0">
-                <a:solidFill>
-                  <a:srgbClr val="345671"/>
+              <a:rPr lang="en-US" sz="1000" b="1" dirty="0">
+                <a:solidFill>
+                  <a:srgbClr val="0C2A3D"/>
                 </a:solidFill>
                 <a:latin typeface="Calibri" pitchFamily="34" charset="0"/>
                 <a:ea typeface="Calibri" pitchFamily="34" charset="-122"/>
@@ -3492,7 +3492,7 @@
             <a:r>
               <a:rPr lang="en-US" sz="1000" b="1" dirty="0">
                 <a:solidFill>
-                  <a:srgbClr val="7C3AED"/>
+                  <a:srgbClr val="5B21B6"/>
                 </a:solidFill>
                 <a:latin typeface="Calibri" pitchFamily="34" charset="0"/>
                 <a:ea typeface="Calibri" pitchFamily="34" charset="-122"/>
@@ -3504,9 +3504,9 @@
               <a:buNone/>
             </a:pPr>
             <a:r>
-              <a:rPr lang="en-US" sz="1000" dirty="0">
-                <a:solidFill>
-                  <a:srgbClr val="345671"/>
+              <a:rPr lang="en-US" sz="1000" b="1" dirty="0">
+                <a:solidFill>
+                  <a:srgbClr val="0C2A3D"/>
                 </a:solidFill>
                 <a:latin typeface="Calibri" pitchFamily="34" charset="0"/>
                 <a:ea typeface="Calibri" pitchFamily="34" charset="-122"/>

</xml_diff>

<commit_message>
Flyer: CTA now points to the sign-up link on the website too
Previously the URL just appeared standalone. Wrap it with a short
instruction so readers know they can also reach the form from
bakesiga.github.io/usmle-dashboard, not only the QR code.

Co-Authored-By: Claude Opus 4.7 (1M context) <noreply@anthropic.com>
</commit_message>
<xml_diff>
--- a/outputs/flyers/USMLE_June_Advert.pptx
+++ b/outputs/flyers/USMLE_June_Advert.pptx
@@ -3791,7 +3791,21 @@
               <a:buNone/>
             </a:pPr>
             <a:r>
-              <a:rPr lang="en-US" sz="1100" b="1" dirty="0">
+              <a:rPr lang="en-US" sz="1050" dirty="0">
+                <a:solidFill>
+                  <a:srgbClr val="0C2A3D"/>
+                </a:solidFill>
+                <a:latin typeface="Calibri" pitchFamily="34" charset="0"/>
+                <a:ea typeface="Calibri" pitchFamily="34" charset="-122"/>
+                <a:cs typeface="Calibri" pitchFamily="34" charset="-120"/>
+              </a:rPr>
+              <a:t>Or find the sign-up link on </a:t>
+            </a:r>
+            <a:pPr indent="0" marL="0">
+              <a:buNone/>
+            </a:pPr>
+            <a:r>
+              <a:rPr lang="en-US" sz="1050" b="1" dirty="0">
                 <a:solidFill>
                   <a:srgbClr val="0284C7"/>
                 </a:solidFill>
@@ -3801,7 +3815,7 @@
               </a:rPr>
               <a:t>bakesiga.github.io/usmle-dashboard</a:t>
             </a:r>
-            <a:endParaRPr lang="en-US" sz="1100" dirty="0"/>
+            <a:endParaRPr lang="en-US" sz="1050" dirty="0"/>
           </a:p>
         </p:txBody>
       </p:sp>

</xml_diff>

<commit_message>
Add 'Past TA — Epi & Biostats (Duke GHI)' to bio
Allan's Duke teaching assistantship in Epidemiology & Biostatistics
wraps as he transitions into residency. Reflect that as past tense
in both surfaces that show his bio:

- Flyer caption gains a 4th line 'Past TA · Epi & Biostats (Duke)'.
  Hero bumps 0.15 to fit, kicker stays single-line.
- Website hero photo caption updates from 'Teaching Assistant' to
  'Past Teaching Assistant'; also drops the redundant ', MD' after
  the name (same fix that already shipped on the flyer).

Co-Authored-By: Claude Opus 4.7 (1M context) <noreply@anthropic.com>
</commit_message>
<xml_diff>
--- a/outputs/flyers/USMLE_June_Advert.pptx
+++ b/outputs/flyers/USMLE_June_Advert.pptx
@@ -883,7 +883,7 @@
         </p:nvSpPr>
         <p:spPr>
           <a:xfrm>
-            <a:off x="0" y="2203704"/>
+            <a:off x="0" y="2340864"/>
             <a:ext cx="8229600" cy="36576"/>
           </a:xfrm>
           <a:prstGeom prst="rect">
@@ -1169,7 +1169,7 @@
         <p:spPr>
           <a:xfrm>
             <a:off x="5961888" y="1746504"/>
-            <a:ext cx="1874520" cy="182880"/>
+            <a:ext cx="1874520" cy="173736"/>
           </a:xfrm>
           <a:prstGeom prst="rect">
             <a:avLst/>
@@ -1185,7 +1185,7 @@
               <a:buNone/>
             </a:pPr>
             <a:r>
-              <a:rPr lang="en-US" sz="950" b="1" dirty="0">
+              <a:rPr lang="en-US" sz="900" b="1" dirty="0">
                 <a:solidFill>
                   <a:srgbClr val="345671"/>
                 </a:solidFill>
@@ -1195,7 +1195,7 @@
               </a:rPr>
               <a:t>MD (Makerere)  ·  MScGH (Duke)</a:t>
             </a:r>
-            <a:endParaRPr lang="en-US" sz="950" dirty="0"/>
+            <a:endParaRPr lang="en-US" sz="900" dirty="0"/>
           </a:p>
         </p:txBody>
       </p:sp>
@@ -1207,8 +1207,8 @@
         </p:nvSpPr>
         <p:spPr>
           <a:xfrm>
-            <a:off x="5961888" y="1929384"/>
-            <a:ext cx="1874520" cy="182880"/>
+            <a:off x="5961888" y="1920240"/>
+            <a:ext cx="1874520" cy="173736"/>
           </a:xfrm>
           <a:prstGeom prst="rect">
             <a:avLst/>
@@ -1224,7 +1224,7 @@
               <a:buNone/>
             </a:pPr>
             <a:r>
-              <a:rPr lang="en-US" sz="950" b="1" dirty="0">
+              <a:rPr lang="en-US" sz="900" b="1" dirty="0">
                 <a:solidFill>
                   <a:srgbClr val="345671"/>
                 </a:solidFill>
@@ -1232,21 +1232,60 @@
                 <a:ea typeface="Calibri" pitchFamily="34" charset="-122"/>
                 <a:cs typeface="Calibri" pitchFamily="34" charset="-120"/>
               </a:rPr>
+              <a:t>Past TA · Epi &amp; Biostats (Duke)</a:t>
+            </a:r>
+            <a:endParaRPr lang="en-US" sz="900" dirty="0"/>
+          </a:p>
+        </p:txBody>
+      </p:sp>
+      <p:sp>
+        <p:nvSpPr>
+          <p:cNvPr id="12" name="Text 9"/>
+          <p:cNvSpPr/>
+          <p:nvPr/>
+        </p:nvSpPr>
+        <p:spPr>
+          <a:xfrm>
+            <a:off x="5961888" y="2093976"/>
+            <a:ext cx="1874520" cy="173736"/>
+          </a:xfrm>
+          <a:prstGeom prst="rect">
+            <a:avLst/>
+          </a:prstGeom>
+          <a:noFill/>
+          <a:ln/>
+        </p:spPr>
+        <p:txBody>
+          <a:bodyPr wrap="square" lIns="0" tIns="0" rIns="0" bIns="0" rtlCol="0" anchor="ctr"/>
+          <a:lstStyle/>
+          <a:p>
+            <a:pPr algn="ctr" indent="0" marL="0">
+              <a:buNone/>
+            </a:pPr>
+            <a:r>
+              <a:rPr lang="en-US" sz="900" b="1" dirty="0">
+                <a:solidFill>
+                  <a:srgbClr val="345671"/>
+                </a:solidFill>
+                <a:latin typeface="Calibri" pitchFamily="34" charset="0"/>
+                <a:ea typeface="Calibri" pitchFamily="34" charset="-122"/>
+                <a:cs typeface="Calibri" pitchFamily="34" charset="-120"/>
+              </a:rPr>
               <a:t>PGY-1 Neurology, Creighton</a:t>
             </a:r>
-            <a:endParaRPr lang="en-US" sz="950" dirty="0"/>
-          </a:p>
-        </p:txBody>
-      </p:sp>
-      <p:sp>
-        <p:nvSpPr>
-          <p:cNvPr id="12" name="Text 9"/>
-          <p:cNvSpPr/>
-          <p:nvPr/>
-        </p:nvSpPr>
-        <p:spPr>
-          <a:xfrm>
-            <a:off x="502920" y="2441448"/>
+            <a:endParaRPr lang="en-US" sz="900" dirty="0"/>
+          </a:p>
+        </p:txBody>
+      </p:sp>
+      <p:sp>
+        <p:nvSpPr>
+          <p:cNvPr id="13" name="Text 10"/>
+          <p:cNvSpPr/>
+          <p:nvPr/>
+        </p:nvSpPr>
+        <p:spPr>
+          <a:xfrm>
+            <a:off x="502920" y="2578608"/>
             <a:ext cx="7223760" cy="237744"/>
           </a:xfrm>
           <a:prstGeom prst="rect">
@@ -1279,13 +1318,13 @@
       </p:sp>
       <p:sp>
         <p:nvSpPr>
-          <p:cNvPr id="13" name="Shape 10"/>
-          <p:cNvSpPr/>
-          <p:nvPr/>
-        </p:nvSpPr>
-        <p:spPr>
-          <a:xfrm>
-            <a:off x="502920" y="2743200"/>
+          <p:cNvPr id="14" name="Shape 11"/>
+          <p:cNvSpPr/>
+          <p:nvPr/>
+        </p:nvSpPr>
+        <p:spPr>
+          <a:xfrm>
+            <a:off x="502920" y="2880360"/>
             <a:ext cx="1005840" cy="0"/>
           </a:xfrm>
           <a:prstGeom prst="line">
@@ -1302,13 +1341,13 @@
       </p:sp>
       <p:sp>
         <p:nvSpPr>
-          <p:cNvPr id="14" name="Shape 11"/>
-          <p:cNvSpPr/>
-          <p:nvPr/>
-        </p:nvSpPr>
-        <p:spPr>
-          <a:xfrm>
-            <a:off x="502920" y="2743200"/>
+          <p:cNvPr id="15" name="Shape 12"/>
+          <p:cNvSpPr/>
+          <p:nvPr/>
+        </p:nvSpPr>
+        <p:spPr>
+          <a:xfrm>
+            <a:off x="502920" y="2880360"/>
             <a:ext cx="3543300" cy="2377440"/>
           </a:xfrm>
           <a:prstGeom prst="roundRect">
@@ -1329,13 +1368,13 @@
       </p:sp>
       <p:sp>
         <p:nvSpPr>
-          <p:cNvPr id="15" name="Shape 12"/>
-          <p:cNvSpPr/>
-          <p:nvPr/>
-        </p:nvSpPr>
-        <p:spPr>
-          <a:xfrm>
-            <a:off x="502920" y="2816352"/>
+          <p:cNvPr id="16" name="Shape 13"/>
+          <p:cNvSpPr/>
+          <p:nvPr/>
+        </p:nvSpPr>
+        <p:spPr>
+          <a:xfrm>
+            <a:off x="502920" y="2953512"/>
             <a:ext cx="3543300" cy="493776"/>
           </a:xfrm>
           <a:prstGeom prst="rect">
@@ -1354,13 +1393,13 @@
       </p:sp>
       <p:sp>
         <p:nvSpPr>
-          <p:cNvPr id="16" name="Shape 13"/>
-          <p:cNvSpPr/>
-          <p:nvPr/>
-        </p:nvSpPr>
-        <p:spPr>
-          <a:xfrm>
-            <a:off x="502920" y="2743200"/>
+          <p:cNvPr id="17" name="Shape 14"/>
+          <p:cNvSpPr/>
+          <p:nvPr/>
+        </p:nvSpPr>
+        <p:spPr>
+          <a:xfrm>
+            <a:off x="502920" y="2880360"/>
             <a:ext cx="3543300" cy="566928"/>
           </a:xfrm>
           <a:prstGeom prst="roundRect">
@@ -1381,13 +1420,13 @@
       </p:sp>
       <p:sp>
         <p:nvSpPr>
-          <p:cNvPr id="17" name="Text 14"/>
-          <p:cNvSpPr/>
-          <p:nvPr/>
-        </p:nvSpPr>
-        <p:spPr>
-          <a:xfrm>
-            <a:off x="630936" y="2798064"/>
+          <p:cNvPr id="18" name="Text 15"/>
+          <p:cNvSpPr/>
+          <p:nvPr/>
+        </p:nvSpPr>
+        <p:spPr>
+          <a:xfrm>
+            <a:off x="630936" y="2935224"/>
             <a:ext cx="3287268" cy="256032"/>
           </a:xfrm>
           <a:prstGeom prst="rect">
@@ -1420,13 +1459,13 @@
       </p:sp>
       <p:sp>
         <p:nvSpPr>
-          <p:cNvPr id="18" name="Text 15"/>
-          <p:cNvSpPr/>
-          <p:nvPr/>
-        </p:nvSpPr>
-        <p:spPr>
-          <a:xfrm>
-            <a:off x="630936" y="3054096"/>
+          <p:cNvPr id="19" name="Text 16"/>
+          <p:cNvSpPr/>
+          <p:nvPr/>
+        </p:nvSpPr>
+        <p:spPr>
+          <a:xfrm>
+            <a:off x="630936" y="3191256"/>
             <a:ext cx="3287268" cy="219456"/>
           </a:xfrm>
           <a:prstGeom prst="rect">
@@ -1459,13 +1498,13 @@
       </p:sp>
       <p:sp>
         <p:nvSpPr>
-          <p:cNvPr id="19" name="Text 16"/>
-          <p:cNvSpPr/>
-          <p:nvPr/>
-        </p:nvSpPr>
-        <p:spPr>
-          <a:xfrm>
-            <a:off x="630936" y="3401568"/>
+          <p:cNvPr id="20" name="Text 17"/>
+          <p:cNvSpPr/>
+          <p:nvPr/>
+        </p:nvSpPr>
+        <p:spPr>
+          <a:xfrm>
+            <a:off x="630936" y="3538728"/>
             <a:ext cx="3287268" cy="164592"/>
           </a:xfrm>
           <a:prstGeom prst="rect">
@@ -1512,13 +1551,13 @@
       </p:sp>
       <p:sp>
         <p:nvSpPr>
-          <p:cNvPr id="20" name="Text 17"/>
-          <p:cNvSpPr/>
-          <p:nvPr/>
-        </p:nvSpPr>
-        <p:spPr>
-          <a:xfrm>
-            <a:off x="630936" y="3566160"/>
+          <p:cNvPr id="21" name="Text 18"/>
+          <p:cNvSpPr/>
+          <p:nvPr/>
+        </p:nvSpPr>
+        <p:spPr>
+          <a:xfrm>
+            <a:off x="630936" y="3703320"/>
             <a:ext cx="3287268" cy="164592"/>
           </a:xfrm>
           <a:prstGeom prst="rect">
@@ -1565,13 +1604,13 @@
       </p:sp>
       <p:sp>
         <p:nvSpPr>
-          <p:cNvPr id="21" name="Text 18"/>
-          <p:cNvSpPr/>
-          <p:nvPr/>
-        </p:nvSpPr>
-        <p:spPr>
-          <a:xfrm>
-            <a:off x="630936" y="3730752"/>
+          <p:cNvPr id="22" name="Text 19"/>
+          <p:cNvSpPr/>
+          <p:nvPr/>
+        </p:nvSpPr>
+        <p:spPr>
+          <a:xfrm>
+            <a:off x="630936" y="3867912"/>
             <a:ext cx="3287268" cy="164592"/>
           </a:xfrm>
           <a:prstGeom prst="rect">
@@ -1618,13 +1657,13 @@
       </p:sp>
       <p:sp>
         <p:nvSpPr>
-          <p:cNvPr id="22" name="Text 19"/>
-          <p:cNvSpPr/>
-          <p:nvPr/>
-        </p:nvSpPr>
-        <p:spPr>
-          <a:xfrm>
-            <a:off x="630936" y="3895344"/>
+          <p:cNvPr id="23" name="Text 20"/>
+          <p:cNvSpPr/>
+          <p:nvPr/>
+        </p:nvSpPr>
+        <p:spPr>
+          <a:xfrm>
+            <a:off x="630936" y="4032504"/>
             <a:ext cx="3287268" cy="164592"/>
           </a:xfrm>
           <a:prstGeom prst="rect">
@@ -1671,13 +1710,13 @@
       </p:sp>
       <p:sp>
         <p:nvSpPr>
-          <p:cNvPr id="23" name="Text 20"/>
-          <p:cNvSpPr/>
-          <p:nvPr/>
-        </p:nvSpPr>
-        <p:spPr>
-          <a:xfrm>
-            <a:off x="630936" y="4059936"/>
+          <p:cNvPr id="24" name="Text 21"/>
+          <p:cNvSpPr/>
+          <p:nvPr/>
+        </p:nvSpPr>
+        <p:spPr>
+          <a:xfrm>
+            <a:off x="630936" y="4197096"/>
             <a:ext cx="3287268" cy="164592"/>
           </a:xfrm>
           <a:prstGeom prst="rect">
@@ -1724,13 +1763,13 @@
       </p:sp>
       <p:sp>
         <p:nvSpPr>
-          <p:cNvPr id="24" name="Text 21"/>
-          <p:cNvSpPr/>
-          <p:nvPr/>
-        </p:nvSpPr>
-        <p:spPr>
-          <a:xfrm>
-            <a:off x="630936" y="4224528"/>
+          <p:cNvPr id="25" name="Text 22"/>
+          <p:cNvSpPr/>
+          <p:nvPr/>
+        </p:nvSpPr>
+        <p:spPr>
+          <a:xfrm>
+            <a:off x="630936" y="4361688"/>
             <a:ext cx="3287268" cy="164592"/>
           </a:xfrm>
           <a:prstGeom prst="rect">
@@ -1777,13 +1816,13 @@
       </p:sp>
       <p:sp>
         <p:nvSpPr>
-          <p:cNvPr id="25" name="Text 22"/>
-          <p:cNvSpPr/>
-          <p:nvPr/>
-        </p:nvSpPr>
-        <p:spPr>
-          <a:xfrm>
-            <a:off x="630936" y="4389120"/>
+          <p:cNvPr id="26" name="Text 23"/>
+          <p:cNvSpPr/>
+          <p:nvPr/>
+        </p:nvSpPr>
+        <p:spPr>
+          <a:xfrm>
+            <a:off x="630936" y="4526280"/>
             <a:ext cx="3287268" cy="164592"/>
           </a:xfrm>
           <a:prstGeom prst="rect">
@@ -1830,13 +1869,13 @@
       </p:sp>
       <p:sp>
         <p:nvSpPr>
-          <p:cNvPr id="26" name="Text 23"/>
-          <p:cNvSpPr/>
-          <p:nvPr/>
-        </p:nvSpPr>
-        <p:spPr>
-          <a:xfrm>
-            <a:off x="630936" y="4553712"/>
+          <p:cNvPr id="27" name="Text 24"/>
+          <p:cNvSpPr/>
+          <p:nvPr/>
+        </p:nvSpPr>
+        <p:spPr>
+          <a:xfrm>
+            <a:off x="630936" y="4690872"/>
             <a:ext cx="3287268" cy="164592"/>
           </a:xfrm>
           <a:prstGeom prst="rect">
@@ -1883,13 +1922,13 @@
       </p:sp>
       <p:sp>
         <p:nvSpPr>
-          <p:cNvPr id="27" name="Text 24"/>
-          <p:cNvSpPr/>
-          <p:nvPr/>
-        </p:nvSpPr>
-        <p:spPr>
-          <a:xfrm>
-            <a:off x="630936" y="4718304"/>
+          <p:cNvPr id="28" name="Text 25"/>
+          <p:cNvSpPr/>
+          <p:nvPr/>
+        </p:nvSpPr>
+        <p:spPr>
+          <a:xfrm>
+            <a:off x="630936" y="4855464"/>
             <a:ext cx="3287268" cy="164592"/>
           </a:xfrm>
           <a:prstGeom prst="rect">
@@ -1936,13 +1975,13 @@
       </p:sp>
       <p:sp>
         <p:nvSpPr>
-          <p:cNvPr id="28" name="Text 25"/>
-          <p:cNvSpPr/>
-          <p:nvPr/>
-        </p:nvSpPr>
-        <p:spPr>
-          <a:xfrm>
-            <a:off x="630936" y="4882896"/>
+          <p:cNvPr id="29" name="Text 26"/>
+          <p:cNvSpPr/>
+          <p:nvPr/>
+        </p:nvSpPr>
+        <p:spPr>
+          <a:xfrm>
+            <a:off x="630936" y="5020056"/>
             <a:ext cx="3287268" cy="164592"/>
           </a:xfrm>
           <a:prstGeom prst="rect">
@@ -1989,13 +2028,13 @@
       </p:sp>
       <p:sp>
         <p:nvSpPr>
-          <p:cNvPr id="29" name="Shape 26"/>
-          <p:cNvSpPr/>
-          <p:nvPr/>
-        </p:nvSpPr>
-        <p:spPr>
-          <a:xfrm>
-            <a:off x="4183380" y="2743200"/>
+          <p:cNvPr id="30" name="Shape 27"/>
+          <p:cNvSpPr/>
+          <p:nvPr/>
+        </p:nvSpPr>
+        <p:spPr>
+          <a:xfrm>
+            <a:off x="4183380" y="2880360"/>
             <a:ext cx="3543300" cy="2377440"/>
           </a:xfrm>
           <a:prstGeom prst="roundRect">
@@ -2016,13 +2055,13 @@
       </p:sp>
       <p:sp>
         <p:nvSpPr>
-          <p:cNvPr id="30" name="Shape 27"/>
-          <p:cNvSpPr/>
-          <p:nvPr/>
-        </p:nvSpPr>
-        <p:spPr>
-          <a:xfrm>
-            <a:off x="4183380" y="2816352"/>
+          <p:cNvPr id="31" name="Shape 28"/>
+          <p:cNvSpPr/>
+          <p:nvPr/>
+        </p:nvSpPr>
+        <p:spPr>
+          <a:xfrm>
+            <a:off x="4183380" y="2953512"/>
             <a:ext cx="3543300" cy="493776"/>
           </a:xfrm>
           <a:prstGeom prst="rect">
@@ -2041,13 +2080,13 @@
       </p:sp>
       <p:sp>
         <p:nvSpPr>
-          <p:cNvPr id="31" name="Shape 28"/>
-          <p:cNvSpPr/>
-          <p:nvPr/>
-        </p:nvSpPr>
-        <p:spPr>
-          <a:xfrm>
-            <a:off x="4183380" y="2743200"/>
+          <p:cNvPr id="32" name="Shape 29"/>
+          <p:cNvSpPr/>
+          <p:nvPr/>
+        </p:nvSpPr>
+        <p:spPr>
+          <a:xfrm>
+            <a:off x="4183380" y="2880360"/>
             <a:ext cx="3543300" cy="566928"/>
           </a:xfrm>
           <a:prstGeom prst="roundRect">
@@ -2068,13 +2107,13 @@
       </p:sp>
       <p:sp>
         <p:nvSpPr>
-          <p:cNvPr id="32" name="Text 29"/>
-          <p:cNvSpPr/>
-          <p:nvPr/>
-        </p:nvSpPr>
-        <p:spPr>
-          <a:xfrm>
-            <a:off x="4311396" y="2798064"/>
+          <p:cNvPr id="33" name="Text 30"/>
+          <p:cNvSpPr/>
+          <p:nvPr/>
+        </p:nvSpPr>
+        <p:spPr>
+          <a:xfrm>
+            <a:off x="4311396" y="2935224"/>
             <a:ext cx="3287268" cy="256032"/>
           </a:xfrm>
           <a:prstGeom prst="rect">
@@ -2107,13 +2146,13 @@
       </p:sp>
       <p:sp>
         <p:nvSpPr>
-          <p:cNvPr id="33" name="Text 30"/>
-          <p:cNvSpPr/>
-          <p:nvPr/>
-        </p:nvSpPr>
-        <p:spPr>
-          <a:xfrm>
-            <a:off x="4311396" y="3054096"/>
+          <p:cNvPr id="34" name="Text 31"/>
+          <p:cNvSpPr/>
+          <p:nvPr/>
+        </p:nvSpPr>
+        <p:spPr>
+          <a:xfrm>
+            <a:off x="4311396" y="3191256"/>
             <a:ext cx="3287268" cy="219456"/>
           </a:xfrm>
           <a:prstGeom prst="rect">
@@ -2146,13 +2185,13 @@
       </p:sp>
       <p:sp>
         <p:nvSpPr>
-          <p:cNvPr id="34" name="Text 31"/>
-          <p:cNvSpPr/>
-          <p:nvPr/>
-        </p:nvSpPr>
-        <p:spPr>
-          <a:xfrm>
-            <a:off x="4311396" y="3401568"/>
+          <p:cNvPr id="35" name="Text 32"/>
+          <p:cNvSpPr/>
+          <p:nvPr/>
+        </p:nvSpPr>
+        <p:spPr>
+          <a:xfrm>
+            <a:off x="4311396" y="3538728"/>
             <a:ext cx="3287268" cy="205740"/>
           </a:xfrm>
           <a:prstGeom prst="rect">
@@ -2199,13 +2238,13 @@
       </p:sp>
       <p:sp>
         <p:nvSpPr>
-          <p:cNvPr id="35" name="Text 32"/>
-          <p:cNvSpPr/>
-          <p:nvPr/>
-        </p:nvSpPr>
-        <p:spPr>
-          <a:xfrm>
-            <a:off x="4311396" y="3607308"/>
+          <p:cNvPr id="36" name="Text 33"/>
+          <p:cNvSpPr/>
+          <p:nvPr/>
+        </p:nvSpPr>
+        <p:spPr>
+          <a:xfrm>
+            <a:off x="4311396" y="3744468"/>
             <a:ext cx="3287268" cy="205740"/>
           </a:xfrm>
           <a:prstGeom prst="rect">
@@ -2252,13 +2291,13 @@
       </p:sp>
       <p:sp>
         <p:nvSpPr>
-          <p:cNvPr id="36" name="Text 33"/>
-          <p:cNvSpPr/>
-          <p:nvPr/>
-        </p:nvSpPr>
-        <p:spPr>
-          <a:xfrm>
-            <a:off x="4311396" y="3813048"/>
+          <p:cNvPr id="37" name="Text 34"/>
+          <p:cNvSpPr/>
+          <p:nvPr/>
+        </p:nvSpPr>
+        <p:spPr>
+          <a:xfrm>
+            <a:off x="4311396" y="3950208"/>
             <a:ext cx="3287268" cy="205740"/>
           </a:xfrm>
           <a:prstGeom prst="rect">
@@ -2305,13 +2344,13 @@
       </p:sp>
       <p:sp>
         <p:nvSpPr>
-          <p:cNvPr id="37" name="Text 34"/>
-          <p:cNvSpPr/>
-          <p:nvPr/>
-        </p:nvSpPr>
-        <p:spPr>
-          <a:xfrm>
-            <a:off x="4311396" y="4018788"/>
+          <p:cNvPr id="38" name="Text 35"/>
+          <p:cNvSpPr/>
+          <p:nvPr/>
+        </p:nvSpPr>
+        <p:spPr>
+          <a:xfrm>
+            <a:off x="4311396" y="4155948"/>
             <a:ext cx="3287268" cy="205740"/>
           </a:xfrm>
           <a:prstGeom prst="rect">
@@ -2358,13 +2397,13 @@
       </p:sp>
       <p:sp>
         <p:nvSpPr>
-          <p:cNvPr id="38" name="Text 35"/>
-          <p:cNvSpPr/>
-          <p:nvPr/>
-        </p:nvSpPr>
-        <p:spPr>
-          <a:xfrm>
-            <a:off x="4311396" y="4224528"/>
+          <p:cNvPr id="39" name="Text 36"/>
+          <p:cNvSpPr/>
+          <p:nvPr/>
+        </p:nvSpPr>
+        <p:spPr>
+          <a:xfrm>
+            <a:off x="4311396" y="4361688"/>
             <a:ext cx="3287268" cy="205740"/>
           </a:xfrm>
           <a:prstGeom prst="rect">
@@ -2411,13 +2450,13 @@
       </p:sp>
       <p:sp>
         <p:nvSpPr>
-          <p:cNvPr id="39" name="Text 36"/>
-          <p:cNvSpPr/>
-          <p:nvPr/>
-        </p:nvSpPr>
-        <p:spPr>
-          <a:xfrm>
-            <a:off x="4311396" y="4430268"/>
+          <p:cNvPr id="40" name="Text 37"/>
+          <p:cNvSpPr/>
+          <p:nvPr/>
+        </p:nvSpPr>
+        <p:spPr>
+          <a:xfrm>
+            <a:off x="4311396" y="4567428"/>
             <a:ext cx="3287268" cy="205740"/>
           </a:xfrm>
           <a:prstGeom prst="rect">
@@ -2464,13 +2503,13 @@
       </p:sp>
       <p:sp>
         <p:nvSpPr>
-          <p:cNvPr id="40" name="Text 37"/>
-          <p:cNvSpPr/>
-          <p:nvPr/>
-        </p:nvSpPr>
-        <p:spPr>
-          <a:xfrm>
-            <a:off x="4311396" y="4636008"/>
+          <p:cNvPr id="41" name="Text 38"/>
+          <p:cNvSpPr/>
+          <p:nvPr/>
+        </p:nvSpPr>
+        <p:spPr>
+          <a:xfrm>
+            <a:off x="4311396" y="4773168"/>
             <a:ext cx="3287268" cy="205740"/>
           </a:xfrm>
           <a:prstGeom prst="rect">
@@ -2517,13 +2556,13 @@
       </p:sp>
       <p:sp>
         <p:nvSpPr>
-          <p:cNvPr id="41" name="Text 38"/>
-          <p:cNvSpPr/>
-          <p:nvPr/>
-        </p:nvSpPr>
-        <p:spPr>
-          <a:xfrm>
-            <a:off x="4311396" y="4841748"/>
+          <p:cNvPr id="42" name="Text 39"/>
+          <p:cNvSpPr/>
+          <p:nvPr/>
+        </p:nvSpPr>
+        <p:spPr>
+          <a:xfrm>
+            <a:off x="4311396" y="4978908"/>
             <a:ext cx="3287268" cy="205740"/>
           </a:xfrm>
           <a:prstGeom prst="rect">
@@ -2570,13 +2609,13 @@
       </p:sp>
       <p:sp>
         <p:nvSpPr>
-          <p:cNvPr id="42" name="Shape 39"/>
-          <p:cNvSpPr/>
-          <p:nvPr/>
-        </p:nvSpPr>
-        <p:spPr>
-          <a:xfrm>
-            <a:off x="502920" y="5257800"/>
+          <p:cNvPr id="43" name="Shape 40"/>
+          <p:cNvSpPr/>
+          <p:nvPr/>
+        </p:nvSpPr>
+        <p:spPr>
+          <a:xfrm>
+            <a:off x="502920" y="5394960"/>
             <a:ext cx="3543300" cy="2377440"/>
           </a:xfrm>
           <a:prstGeom prst="roundRect">
@@ -2597,13 +2636,13 @@
       </p:sp>
       <p:sp>
         <p:nvSpPr>
-          <p:cNvPr id="43" name="Shape 40"/>
-          <p:cNvSpPr/>
-          <p:nvPr/>
-        </p:nvSpPr>
-        <p:spPr>
-          <a:xfrm>
-            <a:off x="502920" y="5330952"/>
+          <p:cNvPr id="44" name="Shape 41"/>
+          <p:cNvSpPr/>
+          <p:nvPr/>
+        </p:nvSpPr>
+        <p:spPr>
+          <a:xfrm>
+            <a:off x="502920" y="5468112"/>
             <a:ext cx="3543300" cy="493776"/>
           </a:xfrm>
           <a:prstGeom prst="rect">
@@ -2622,13 +2661,13 @@
       </p:sp>
       <p:sp>
         <p:nvSpPr>
-          <p:cNvPr id="44" name="Shape 41"/>
-          <p:cNvSpPr/>
-          <p:nvPr/>
-        </p:nvSpPr>
-        <p:spPr>
-          <a:xfrm>
-            <a:off x="502920" y="5257800"/>
+          <p:cNvPr id="45" name="Shape 42"/>
+          <p:cNvSpPr/>
+          <p:nvPr/>
+        </p:nvSpPr>
+        <p:spPr>
+          <a:xfrm>
+            <a:off x="502920" y="5394960"/>
             <a:ext cx="3543300" cy="566928"/>
           </a:xfrm>
           <a:prstGeom prst="roundRect">
@@ -2649,13 +2688,13 @@
       </p:sp>
       <p:sp>
         <p:nvSpPr>
-          <p:cNvPr id="45" name="Text 42"/>
-          <p:cNvSpPr/>
-          <p:nvPr/>
-        </p:nvSpPr>
-        <p:spPr>
-          <a:xfrm>
-            <a:off x="630936" y="5312664"/>
+          <p:cNvPr id="46" name="Text 43"/>
+          <p:cNvSpPr/>
+          <p:nvPr/>
+        </p:nvSpPr>
+        <p:spPr>
+          <a:xfrm>
+            <a:off x="630936" y="5449824"/>
             <a:ext cx="3287268" cy="256032"/>
           </a:xfrm>
           <a:prstGeom prst="rect">
@@ -2688,13 +2727,13 @@
       </p:sp>
       <p:sp>
         <p:nvSpPr>
-          <p:cNvPr id="46" name="Text 43"/>
-          <p:cNvSpPr/>
-          <p:nvPr/>
-        </p:nvSpPr>
-        <p:spPr>
-          <a:xfrm>
-            <a:off x="630936" y="5568696"/>
+          <p:cNvPr id="47" name="Text 44"/>
+          <p:cNvSpPr/>
+          <p:nvPr/>
+        </p:nvSpPr>
+        <p:spPr>
+          <a:xfrm>
+            <a:off x="630936" y="5705856"/>
             <a:ext cx="3287268" cy="219456"/>
           </a:xfrm>
           <a:prstGeom prst="rect">
@@ -2727,13 +2766,13 @@
       </p:sp>
       <p:sp>
         <p:nvSpPr>
-          <p:cNvPr id="47" name="Text 44"/>
-          <p:cNvSpPr/>
-          <p:nvPr/>
-        </p:nvSpPr>
-        <p:spPr>
-          <a:xfrm>
-            <a:off x="630936" y="5916168"/>
+          <p:cNvPr id="48" name="Text 45"/>
+          <p:cNvSpPr/>
+          <p:nvPr/>
+        </p:nvSpPr>
+        <p:spPr>
+          <a:xfrm>
+            <a:off x="630936" y="6053328"/>
             <a:ext cx="3287268" cy="411480"/>
           </a:xfrm>
           <a:prstGeom prst="rect">
@@ -2780,13 +2819,13 @@
       </p:sp>
       <p:sp>
         <p:nvSpPr>
-          <p:cNvPr id="48" name="Text 45"/>
-          <p:cNvSpPr/>
-          <p:nvPr/>
-        </p:nvSpPr>
-        <p:spPr>
-          <a:xfrm>
-            <a:off x="630936" y="6327648"/>
+          <p:cNvPr id="49" name="Text 46"/>
+          <p:cNvSpPr/>
+          <p:nvPr/>
+        </p:nvSpPr>
+        <p:spPr>
+          <a:xfrm>
+            <a:off x="630936" y="6464808"/>
             <a:ext cx="3287268" cy="411480"/>
           </a:xfrm>
           <a:prstGeom prst="rect">
@@ -2833,13 +2872,13 @@
       </p:sp>
       <p:sp>
         <p:nvSpPr>
-          <p:cNvPr id="49" name="Text 46"/>
-          <p:cNvSpPr/>
-          <p:nvPr/>
-        </p:nvSpPr>
-        <p:spPr>
-          <a:xfrm>
-            <a:off x="630936" y="6739128"/>
+          <p:cNvPr id="50" name="Text 47"/>
+          <p:cNvSpPr/>
+          <p:nvPr/>
+        </p:nvSpPr>
+        <p:spPr>
+          <a:xfrm>
+            <a:off x="630936" y="6876288"/>
             <a:ext cx="3287268" cy="411480"/>
           </a:xfrm>
           <a:prstGeom prst="rect">
@@ -2886,13 +2925,13 @@
       </p:sp>
       <p:sp>
         <p:nvSpPr>
-          <p:cNvPr id="50" name="Text 47"/>
-          <p:cNvSpPr/>
-          <p:nvPr/>
-        </p:nvSpPr>
-        <p:spPr>
-          <a:xfrm>
-            <a:off x="630936" y="7150608"/>
+          <p:cNvPr id="51" name="Text 48"/>
+          <p:cNvSpPr/>
+          <p:nvPr/>
+        </p:nvSpPr>
+        <p:spPr>
+          <a:xfrm>
+            <a:off x="630936" y="7287768"/>
             <a:ext cx="3287268" cy="411480"/>
           </a:xfrm>
           <a:prstGeom prst="rect">
@@ -2939,13 +2978,13 @@
       </p:sp>
       <p:sp>
         <p:nvSpPr>
-          <p:cNvPr id="51" name="Shape 48"/>
-          <p:cNvSpPr/>
-          <p:nvPr/>
-        </p:nvSpPr>
-        <p:spPr>
-          <a:xfrm>
-            <a:off x="4183380" y="5257800"/>
+          <p:cNvPr id="52" name="Shape 49"/>
+          <p:cNvSpPr/>
+          <p:nvPr/>
+        </p:nvSpPr>
+        <p:spPr>
+          <a:xfrm>
+            <a:off x="4183380" y="5394960"/>
             <a:ext cx="3543300" cy="2377440"/>
           </a:xfrm>
           <a:prstGeom prst="roundRect">
@@ -2966,13 +3005,13 @@
       </p:sp>
       <p:sp>
         <p:nvSpPr>
-          <p:cNvPr id="52" name="Shape 49"/>
-          <p:cNvSpPr/>
-          <p:nvPr/>
-        </p:nvSpPr>
-        <p:spPr>
-          <a:xfrm>
-            <a:off x="4183380" y="5330952"/>
+          <p:cNvPr id="53" name="Shape 50"/>
+          <p:cNvSpPr/>
+          <p:nvPr/>
+        </p:nvSpPr>
+        <p:spPr>
+          <a:xfrm>
+            <a:off x="4183380" y="5468112"/>
             <a:ext cx="3543300" cy="493776"/>
           </a:xfrm>
           <a:prstGeom prst="rect">
@@ -2991,13 +3030,13 @@
       </p:sp>
       <p:sp>
         <p:nvSpPr>
-          <p:cNvPr id="53" name="Shape 50"/>
-          <p:cNvSpPr/>
-          <p:nvPr/>
-        </p:nvSpPr>
-        <p:spPr>
-          <a:xfrm>
-            <a:off x="4183380" y="5257800"/>
+          <p:cNvPr id="54" name="Shape 51"/>
+          <p:cNvSpPr/>
+          <p:nvPr/>
+        </p:nvSpPr>
+        <p:spPr>
+          <a:xfrm>
+            <a:off x="4183380" y="5394960"/>
             <a:ext cx="3543300" cy="566928"/>
           </a:xfrm>
           <a:prstGeom prst="roundRect">
@@ -3018,13 +3057,13 @@
       </p:sp>
       <p:sp>
         <p:nvSpPr>
-          <p:cNvPr id="54" name="Text 51"/>
-          <p:cNvSpPr/>
-          <p:nvPr/>
-        </p:nvSpPr>
-        <p:spPr>
-          <a:xfrm>
-            <a:off x="4311396" y="5312664"/>
+          <p:cNvPr id="55" name="Text 52"/>
+          <p:cNvSpPr/>
+          <p:nvPr/>
+        </p:nvSpPr>
+        <p:spPr>
+          <a:xfrm>
+            <a:off x="4311396" y="5449824"/>
             <a:ext cx="3287268" cy="256032"/>
           </a:xfrm>
           <a:prstGeom prst="rect">
@@ -3057,13 +3096,13 @@
       </p:sp>
       <p:sp>
         <p:nvSpPr>
-          <p:cNvPr id="55" name="Text 52"/>
-          <p:cNvSpPr/>
-          <p:nvPr/>
-        </p:nvSpPr>
-        <p:spPr>
-          <a:xfrm>
-            <a:off x="4311396" y="5568696"/>
+          <p:cNvPr id="56" name="Text 53"/>
+          <p:cNvSpPr/>
+          <p:nvPr/>
+        </p:nvSpPr>
+        <p:spPr>
+          <a:xfrm>
+            <a:off x="4311396" y="5705856"/>
             <a:ext cx="3287268" cy="219456"/>
           </a:xfrm>
           <a:prstGeom prst="rect">
@@ -3096,13 +3135,13 @@
       </p:sp>
       <p:sp>
         <p:nvSpPr>
-          <p:cNvPr id="56" name="Text 53"/>
-          <p:cNvSpPr/>
-          <p:nvPr/>
-        </p:nvSpPr>
-        <p:spPr>
-          <a:xfrm>
-            <a:off x="4311396" y="5916168"/>
+          <p:cNvPr id="57" name="Text 54"/>
+          <p:cNvSpPr/>
+          <p:nvPr/>
+        </p:nvSpPr>
+        <p:spPr>
+          <a:xfrm>
+            <a:off x="4311396" y="6053328"/>
             <a:ext cx="3287268" cy="205740"/>
           </a:xfrm>
           <a:prstGeom prst="rect">
@@ -3149,13 +3188,13 @@
       </p:sp>
       <p:sp>
         <p:nvSpPr>
-          <p:cNvPr id="57" name="Text 54"/>
-          <p:cNvSpPr/>
-          <p:nvPr/>
-        </p:nvSpPr>
-        <p:spPr>
-          <a:xfrm>
-            <a:off x="4311396" y="6121908"/>
+          <p:cNvPr id="58" name="Text 55"/>
+          <p:cNvSpPr/>
+          <p:nvPr/>
+        </p:nvSpPr>
+        <p:spPr>
+          <a:xfrm>
+            <a:off x="4311396" y="6259068"/>
             <a:ext cx="3287268" cy="205740"/>
           </a:xfrm>
           <a:prstGeom prst="rect">
@@ -3202,13 +3241,13 @@
       </p:sp>
       <p:sp>
         <p:nvSpPr>
-          <p:cNvPr id="58" name="Text 55"/>
-          <p:cNvSpPr/>
-          <p:nvPr/>
-        </p:nvSpPr>
-        <p:spPr>
-          <a:xfrm>
-            <a:off x="4311396" y="6327648"/>
+          <p:cNvPr id="59" name="Text 56"/>
+          <p:cNvSpPr/>
+          <p:nvPr/>
+        </p:nvSpPr>
+        <p:spPr>
+          <a:xfrm>
+            <a:off x="4311396" y="6464808"/>
             <a:ext cx="3287268" cy="205740"/>
           </a:xfrm>
           <a:prstGeom prst="rect">
@@ -3255,13 +3294,13 @@
       </p:sp>
       <p:sp>
         <p:nvSpPr>
-          <p:cNvPr id="59" name="Text 56"/>
-          <p:cNvSpPr/>
-          <p:nvPr/>
-        </p:nvSpPr>
-        <p:spPr>
-          <a:xfrm>
-            <a:off x="4311396" y="6533388"/>
+          <p:cNvPr id="60" name="Text 57"/>
+          <p:cNvSpPr/>
+          <p:nvPr/>
+        </p:nvSpPr>
+        <p:spPr>
+          <a:xfrm>
+            <a:off x="4311396" y="6670548"/>
             <a:ext cx="3287268" cy="205740"/>
           </a:xfrm>
           <a:prstGeom prst="rect">
@@ -3308,13 +3347,13 @@
       </p:sp>
       <p:sp>
         <p:nvSpPr>
-          <p:cNvPr id="60" name="Text 57"/>
-          <p:cNvSpPr/>
-          <p:nvPr/>
-        </p:nvSpPr>
-        <p:spPr>
-          <a:xfrm>
-            <a:off x="4311396" y="6739128"/>
+          <p:cNvPr id="61" name="Text 58"/>
+          <p:cNvSpPr/>
+          <p:nvPr/>
+        </p:nvSpPr>
+        <p:spPr>
+          <a:xfrm>
+            <a:off x="4311396" y="6876288"/>
             <a:ext cx="3287268" cy="205740"/>
           </a:xfrm>
           <a:prstGeom prst="rect">
@@ -3361,13 +3400,13 @@
       </p:sp>
       <p:sp>
         <p:nvSpPr>
-          <p:cNvPr id="61" name="Text 58"/>
-          <p:cNvSpPr/>
-          <p:nvPr/>
-        </p:nvSpPr>
-        <p:spPr>
-          <a:xfrm>
-            <a:off x="4311396" y="6944868"/>
+          <p:cNvPr id="62" name="Text 59"/>
+          <p:cNvSpPr/>
+          <p:nvPr/>
+        </p:nvSpPr>
+        <p:spPr>
+          <a:xfrm>
+            <a:off x="4311396" y="7082028"/>
             <a:ext cx="3287268" cy="205740"/>
           </a:xfrm>
           <a:prstGeom prst="rect">
@@ -3414,13 +3453,13 @@
       </p:sp>
       <p:sp>
         <p:nvSpPr>
-          <p:cNvPr id="62" name="Text 59"/>
-          <p:cNvSpPr/>
-          <p:nvPr/>
-        </p:nvSpPr>
-        <p:spPr>
-          <a:xfrm>
-            <a:off x="4311396" y="7150608"/>
+          <p:cNvPr id="63" name="Text 60"/>
+          <p:cNvSpPr/>
+          <p:nvPr/>
+        </p:nvSpPr>
+        <p:spPr>
+          <a:xfrm>
+            <a:off x="4311396" y="7287768"/>
             <a:ext cx="3287268" cy="205740"/>
           </a:xfrm>
           <a:prstGeom prst="rect">
@@ -3467,13 +3506,13 @@
       </p:sp>
       <p:sp>
         <p:nvSpPr>
-          <p:cNvPr id="63" name="Text 60"/>
-          <p:cNvSpPr/>
-          <p:nvPr/>
-        </p:nvSpPr>
-        <p:spPr>
-          <a:xfrm>
-            <a:off x="4311396" y="7356348"/>
+          <p:cNvPr id="64" name="Text 61"/>
+          <p:cNvSpPr/>
+          <p:nvPr/>
+        </p:nvSpPr>
+        <p:spPr>
+          <a:xfrm>
+            <a:off x="4311396" y="7493508"/>
             <a:ext cx="3287268" cy="205740"/>
           </a:xfrm>
           <a:prstGeom prst="rect">
@@ -3520,13 +3559,13 @@
       </p:sp>
       <p:sp>
         <p:nvSpPr>
-          <p:cNvPr id="64" name="Shape 61"/>
-          <p:cNvSpPr/>
-          <p:nvPr/>
-        </p:nvSpPr>
-        <p:spPr>
-          <a:xfrm>
-            <a:off x="502920" y="7799832"/>
+          <p:cNvPr id="65" name="Shape 62"/>
+          <p:cNvSpPr/>
+          <p:nvPr/>
+        </p:nvSpPr>
+        <p:spPr>
+          <a:xfrm>
+            <a:off x="502920" y="7936992"/>
             <a:ext cx="7223760" cy="658368"/>
           </a:xfrm>
           <a:prstGeom prst="roundRect">
@@ -3547,13 +3586,13 @@
       </p:sp>
       <p:sp>
         <p:nvSpPr>
-          <p:cNvPr id="65" name="Text 62"/>
-          <p:cNvSpPr/>
-          <p:nvPr/>
-        </p:nvSpPr>
-        <p:spPr>
-          <a:xfrm>
-            <a:off x="777240" y="7799832"/>
+          <p:cNvPr id="66" name="Text 63"/>
+          <p:cNvSpPr/>
+          <p:nvPr/>
+        </p:nvSpPr>
+        <p:spPr>
+          <a:xfrm>
+            <a:off x="777240" y="7936992"/>
             <a:ext cx="6675120" cy="658368"/>
           </a:xfrm>
           <a:prstGeom prst="rect">
@@ -3600,13 +3639,13 @@
       </p:sp>
       <p:sp>
         <p:nvSpPr>
-          <p:cNvPr id="66" name="Shape 63"/>
-          <p:cNvSpPr/>
-          <p:nvPr/>
-        </p:nvSpPr>
-        <p:spPr>
-          <a:xfrm>
-            <a:off x="502920" y="8641080"/>
+          <p:cNvPr id="67" name="Shape 64"/>
+          <p:cNvSpPr/>
+          <p:nvPr/>
+        </p:nvSpPr>
+        <p:spPr>
+          <a:xfrm>
+            <a:off x="502920" y="8778240"/>
             <a:ext cx="1280160" cy="1280160"/>
           </a:xfrm>
           <a:prstGeom prst="roundRect">
@@ -3627,7 +3666,7 @@
       </p:sp>
       <p:pic>
         <p:nvPicPr>
-          <p:cNvPr id="67" name="Image 1" descr="signup_qr.png">    </p:cNvPr>
+          <p:cNvPr id="68" name="Image 1" descr="signup_qr.png">    </p:cNvPr>
           <p:cNvPicPr>
             <a:picLocks noChangeAspect="1"/>
           </p:cNvPicPr>
@@ -3641,7 +3680,7 @@
         </p:blipFill>
         <p:spPr>
           <a:xfrm>
-            <a:off x="576072" y="8714232"/>
+            <a:off x="576072" y="8851392"/>
             <a:ext cx="1133856" cy="1133856"/>
           </a:xfrm>
           <a:prstGeom prst="rect">
@@ -3651,13 +3690,13 @@
       </p:pic>
       <p:sp>
         <p:nvSpPr>
-          <p:cNvPr id="68" name="Text 64"/>
-          <p:cNvSpPr/>
-          <p:nvPr/>
-        </p:nvSpPr>
-        <p:spPr>
-          <a:xfrm>
-            <a:off x="502920" y="9939528"/>
+          <p:cNvPr id="69" name="Text 65"/>
+          <p:cNvSpPr/>
+          <p:nvPr/>
+        </p:nvSpPr>
+        <p:spPr>
+          <a:xfrm>
+            <a:off x="502920" y="10076688"/>
             <a:ext cx="1280160" cy="201168"/>
           </a:xfrm>
           <a:prstGeom prst="rect">
@@ -3690,13 +3729,13 @@
       </p:sp>
       <p:sp>
         <p:nvSpPr>
-          <p:cNvPr id="69" name="Text 65"/>
-          <p:cNvSpPr/>
-          <p:nvPr/>
-        </p:nvSpPr>
-        <p:spPr>
-          <a:xfrm>
-            <a:off x="2057400" y="8659368"/>
+          <p:cNvPr id="70" name="Text 66"/>
+          <p:cNvSpPr/>
+          <p:nvPr/>
+        </p:nvSpPr>
+        <p:spPr>
+          <a:xfrm>
+            <a:off x="2057400" y="8796528"/>
             <a:ext cx="5669280" cy="457200"/>
           </a:xfrm>
           <a:prstGeom prst="rect">
@@ -3729,13 +3768,13 @@
       </p:sp>
       <p:sp>
         <p:nvSpPr>
-          <p:cNvPr id="70" name="Text 66"/>
-          <p:cNvSpPr/>
-          <p:nvPr/>
-        </p:nvSpPr>
-        <p:spPr>
-          <a:xfrm>
-            <a:off x="2057400" y="9134856"/>
+          <p:cNvPr id="71" name="Text 67"/>
+          <p:cNvSpPr/>
+          <p:nvPr/>
+        </p:nvSpPr>
+        <p:spPr>
+          <a:xfrm>
+            <a:off x="2057400" y="9272016"/>
             <a:ext cx="5669280" cy="237744"/>
           </a:xfrm>
           <a:prstGeom prst="rect">
@@ -3768,13 +3807,13 @@
       </p:sp>
       <p:sp>
         <p:nvSpPr>
-          <p:cNvPr id="71" name="Text 67"/>
-          <p:cNvSpPr/>
-          <p:nvPr/>
-        </p:nvSpPr>
-        <p:spPr>
-          <a:xfrm>
-            <a:off x="2057400" y="9409176"/>
+          <p:cNvPr id="72" name="Text 68"/>
+          <p:cNvSpPr/>
+          <p:nvPr/>
+        </p:nvSpPr>
+        <p:spPr>
+          <a:xfrm>
+            <a:off x="2057400" y="9546336"/>
             <a:ext cx="5669280" cy="219456"/>
           </a:xfrm>
           <a:prstGeom prst="rect">
@@ -3821,7 +3860,7 @@
       </p:sp>
       <p:pic>
         <p:nvPicPr>
-          <p:cNvPr id="72" name="Image 2" descr="email-blue.png">    </p:cNvPr>
+          <p:cNvPr id="73" name="Image 2" descr="email-blue.png">    </p:cNvPr>
           <p:cNvPicPr>
             <a:picLocks noChangeAspect="1"/>
           </p:cNvPicPr>
@@ -3835,7 +3874,7 @@
         </p:blipFill>
         <p:spPr>
           <a:xfrm>
-            <a:off x="2057400" y="9720072"/>
+            <a:off x="2057400" y="9857232"/>
             <a:ext cx="182880" cy="182880"/>
           </a:xfrm>
           <a:prstGeom prst="rect">
@@ -3845,13 +3884,13 @@
       </p:pic>
       <p:sp>
         <p:nvSpPr>
-          <p:cNvPr id="73" name="Text 68"/>
-          <p:cNvSpPr/>
-          <p:nvPr/>
-        </p:nvSpPr>
-        <p:spPr>
-          <a:xfrm>
-            <a:off x="2295144" y="9692640"/>
+          <p:cNvPr id="74" name="Text 69"/>
+          <p:cNvSpPr/>
+          <p:nvPr/>
+        </p:nvSpPr>
+        <p:spPr>
+          <a:xfrm>
+            <a:off x="2295144" y="9829800"/>
             <a:ext cx="1615440" cy="256032"/>
           </a:xfrm>
           <a:prstGeom prst="rect">
@@ -3884,7 +3923,7 @@
       </p:sp>
       <p:pic>
         <p:nvPicPr>
-          <p:cNvPr id="74" name="Image 3" descr="whatsapp.png">    </p:cNvPr>
+          <p:cNvPr id="75" name="Image 3" descr="whatsapp.png">    </p:cNvPr>
           <p:cNvPicPr>
             <a:picLocks noChangeAspect="1"/>
           </p:cNvPicPr>
@@ -3898,7 +3937,7 @@
         </p:blipFill>
         <p:spPr>
           <a:xfrm>
-            <a:off x="3947160" y="9720072"/>
+            <a:off x="3947160" y="9857232"/>
             <a:ext cx="182880" cy="182880"/>
           </a:xfrm>
           <a:prstGeom prst="rect">
@@ -3908,13 +3947,13 @@
       </p:pic>
       <p:sp>
         <p:nvSpPr>
-          <p:cNvPr id="75" name="Text 69"/>
-          <p:cNvSpPr/>
-          <p:nvPr/>
-        </p:nvSpPr>
-        <p:spPr>
-          <a:xfrm>
-            <a:off x="4184904" y="9692640"/>
+          <p:cNvPr id="76" name="Text 70"/>
+          <p:cNvSpPr/>
+          <p:nvPr/>
+        </p:nvSpPr>
+        <p:spPr>
+          <a:xfrm>
+            <a:off x="4184904" y="9829800"/>
             <a:ext cx="1615440" cy="256032"/>
           </a:xfrm>
           <a:prstGeom prst="rect">
@@ -3947,7 +3986,7 @@
       </p:sp>
       <p:pic>
         <p:nvPicPr>
-          <p:cNvPr id="76" name="Image 4" descr="phone-blue.png">    </p:cNvPr>
+          <p:cNvPr id="77" name="Image 4" descr="phone-blue.png">    </p:cNvPr>
           <p:cNvPicPr>
             <a:picLocks noChangeAspect="1"/>
           </p:cNvPicPr>
@@ -3961,7 +4000,7 @@
         </p:blipFill>
         <p:spPr>
           <a:xfrm>
-            <a:off x="5836920" y="9720072"/>
+            <a:off x="5836920" y="9857232"/>
             <a:ext cx="182880" cy="182880"/>
           </a:xfrm>
           <a:prstGeom prst="rect">
@@ -3971,13 +4010,13 @@
       </p:pic>
       <p:sp>
         <p:nvSpPr>
-          <p:cNvPr id="77" name="Text 70"/>
-          <p:cNvSpPr/>
-          <p:nvPr/>
-        </p:nvSpPr>
-        <p:spPr>
-          <a:xfrm>
-            <a:off x="6074664" y="9692640"/>
+          <p:cNvPr id="78" name="Text 71"/>
+          <p:cNvSpPr/>
+          <p:nvPr/>
+        </p:nvSpPr>
+        <p:spPr>
+          <a:xfrm>
+            <a:off x="6074664" y="9829800"/>
             <a:ext cx="1615440" cy="256032"/>
           </a:xfrm>
           <a:prstGeom prst="rect">

</xml_diff>